<commit_message>
Add six-month launch roadmap slide
</commit_message>
<xml_diff>
--- a/outputs/HIT2_일본_런칭_6개월전_로드맵_초안.pptx
+++ b/outputs/HIT2_일본_런칭_6개월전_로드맵_초안.pptx
@@ -2,13 +2,14 @@
 <file path=ppt/presentation.xml><?xml version="1.0" encoding="utf-8"?>
 <p:presentation xmlns:p="http://schemas.openxmlformats.org/presentationml/2006/main">
   <p:sldMasterIdLst>
-    <p:sldMasterId xmlns:r="http://schemas.openxmlformats.org/officeDocument/2006/relationships" id="2147483648" r:id="R862491ddb63243c0"/>
+    <p:sldMasterId xmlns:r="http://schemas.openxmlformats.org/officeDocument/2006/relationships" id="2147483648" r:id="Ra73ca0284a5045bb"/>
   </p:sldMasterIdLst>
   <p:notesMasterIdLst>
-    <p:notesMasterId xmlns:r="http://schemas.openxmlformats.org/officeDocument/2006/relationships" r:id="R10e58742bff54142"/>
+    <p:notesMasterId xmlns:r="http://schemas.openxmlformats.org/officeDocument/2006/relationships" r:id="Rd05d2d6db90245b2"/>
   </p:notesMasterIdLst>
   <p:sldIdLst>
-    <p:sldId xmlns:r="http://schemas.openxmlformats.org/officeDocument/2006/relationships" id="256" r:id="Rde8df3105faa408a"/>
+    <p:sldId xmlns:r="http://schemas.openxmlformats.org/officeDocument/2006/relationships" id="256" r:id="Rcabe6be937b54c9b"/>
+    <p:sldId xmlns:r="http://schemas.openxmlformats.org/officeDocument/2006/relationships" id="257" r:id="Rafd15bd06e254ca0"/>
   </p:sldIdLst>
   <p:sldSz cx="12192000" cy="6858000"/>
   <p:notesSz cx="6858000" cy="9144000"/>
@@ -563,6 +564,72 @@
 </p:notes>
 </file>
 
+<file path=ppt/notesSlides/notesSlide2.xml><?xml version="1.0" encoding="utf-8"?>
+<p:notes xmlns:p="http://schemas.openxmlformats.org/presentationml/2006/main">
+  <p:cSld>
+    <p:spTree>
+      <p:nvGrpSpPr>
+        <p:cNvPr id="1" name=""/>
+        <p:cNvGrpSpPr/>
+        <p:nvPr/>
+      </p:nvGrpSpPr>
+      <p:grpSpPr>
+        <a:xfrm xmlns:a="http://schemas.openxmlformats.org/drawingml/2006/main"/>
+      </p:grpSpPr>
+      <p:sp>
+        <p:nvSpPr>
+          <p:cNvPr id="2" name="Slide Image Placeholder 1"/>
+          <p:cNvSpPr>
+            <a:spLocks xmlns:a="http://schemas.openxmlformats.org/drawingml/2006/main" noGrp="1"/>
+          </p:cNvSpPr>
+          <p:nvPr>
+            <p:ph type="sldImg" idx="0"/>
+          </p:nvPr>
+        </p:nvSpPr>
+        <p:spPr/>
+      </p:sp>
+      <p:sp>
+        <p:nvSpPr>
+          <p:cNvPr id="3" name="Notes Placeholder 2"/>
+          <p:cNvSpPr>
+            <a:spLocks xmlns:a="http://schemas.openxmlformats.org/drawingml/2006/main" noGrp="1"/>
+          </p:cNvSpPr>
+          <p:nvPr>
+            <p:ph type="body" idx="1"/>
+          </p:nvPr>
+        </p:nvSpPr>
+        <p:spPr/>
+        <p:txBody>
+          <a:bodyPr xmlns:a="http://schemas.openxmlformats.org/drawingml/2006/main"/>
+          <a:lstStyle xmlns:a="http://schemas.openxmlformats.org/drawingml/2006/main"/>
+          <a:p xmlns:a="http://schemas.openxmlformats.org/drawingml/2006/main"/>
+        </p:txBody>
+      </p:sp>
+      <p:sp>
+        <p:nvSpPr>
+          <p:cNvPr id="4" name="Slide Number Placeholder 3"/>
+          <p:cNvSpPr>
+            <a:spLocks xmlns:a="http://schemas.openxmlformats.org/drawingml/2006/main" noGrp="1"/>
+          </p:cNvSpPr>
+          <p:nvPr>
+            <p:ph type="sldNum" idx="5"/>
+          </p:nvPr>
+        </p:nvSpPr>
+        <p:spPr/>
+        <p:txBody>
+          <a:bodyPr xmlns:a="http://schemas.openxmlformats.org/drawingml/2006/main"/>
+          <a:lstStyle xmlns:a="http://schemas.openxmlformats.org/drawingml/2006/main"/>
+          <a:p xmlns:a="http://schemas.openxmlformats.org/drawingml/2006/main"/>
+        </p:txBody>
+      </p:sp>
+    </p:spTree>
+  </p:cSld>
+  <p:clrMapOvr>
+    <a:masterClrMapping xmlns:a="http://schemas.openxmlformats.org/drawingml/2006/main"/>
+  </p:clrMapOvr>
+</p:notes>
+</file>
+
 <file path=ppt/slideLayouts/slideLayout1.xml><?xml version="1.0" encoding="utf-8"?>
 <p:sldLayout xmlns:p="http://schemas.openxmlformats.org/presentationml/2006/main" type="title">
   <p:cSld name="Title Slide">
@@ -601,7 +668,7 @@
   </p:cSld>
   <p:clrMap bg1="lt1" tx1="dk1" bg2="lt2" tx2="dk2" accent1="accent1" accent2="accent2" accent3="accent3" accent4="accent4" accent5="accent5" accent6="accent6" hlink="hlink" folHlink="folHlink"/>
   <p:sldLayoutIdLst>
-    <p:sldLayoutId xmlns:r="http://schemas.openxmlformats.org/officeDocument/2006/relationships" id="2147483649" r:id="R0a59564abe494e98"/>
+    <p:sldLayoutId xmlns:r="http://schemas.openxmlformats.org/officeDocument/2006/relationships" id="2147483649" r:id="Reae83263f9e94357"/>
   </p:sldLayoutIdLst>
   <p:txStyles>
     <p:titleStyle>
@@ -1152,7 +1219,7 @@
           <p:cNvPr id="1" name="top-accent">
             <a:extLst xmlns:a="http://schemas.openxmlformats.org/drawingml/2006/main">
               <a:ext uri="{FF2B5EF4-FFF2-40B4-BE49-F238E27FC236}">
-                <a16:creationId xmlns:a16="http://schemas.microsoft.com/office/drawing/2014/main" id="{7485DD3D-49CA-4E11-95BA-C0B0B4E3A417}"/>
+                <a16:creationId xmlns:a16="http://schemas.microsoft.com/office/drawing/2014/main" id="{BA9FC31A-24E2-4404-8D73-0C0E94D66413}"/>
               </a:ext>
             </a:extLst>
           </p:cNvPr>
@@ -1185,7 +1252,7 @@
           <p:cNvPr id="2" name="left-accent">
             <a:extLst xmlns:a="http://schemas.openxmlformats.org/drawingml/2006/main">
               <a:ext uri="{FF2B5EF4-FFF2-40B4-BE49-F238E27FC236}">
-                <a16:creationId xmlns:a16="http://schemas.microsoft.com/office/drawing/2014/main" id="{9C6457F4-349D-4CCF-8069-2EFF64D2122D}"/>
+                <a16:creationId xmlns:a16="http://schemas.microsoft.com/office/drawing/2014/main" id="{318ECBE9-8C22-4F3C-A00A-0DBDAB7CC6BA}"/>
               </a:ext>
             </a:extLst>
           </p:cNvPr>
@@ -1218,7 +1285,7 @@
           <p:cNvPr id="3" name="eyebrow">
             <a:extLst xmlns:a="http://schemas.openxmlformats.org/drawingml/2006/main">
               <a:ext uri="{FF2B5EF4-FFF2-40B4-BE49-F238E27FC236}">
-                <a16:creationId xmlns:a16="http://schemas.microsoft.com/office/drawing/2014/main" id="{F48689D7-D6BF-415F-A133-BB57B809815E}"/>
+                <a16:creationId xmlns:a16="http://schemas.microsoft.com/office/drawing/2014/main" id="{A1088874-0181-4485-8D4B-6D337C2D4B34}"/>
               </a:ext>
             </a:extLst>
           </p:cNvPr>
@@ -1230,7 +1297,7 @@
         <p:spPr>
           <a:xfrm xmlns:a="http://schemas.openxmlformats.org/drawingml/2006/main">
             <a:off x="514350" y="361950"/>
-            <a:ext cx="5334000" cy="285750"/>
+            <a:ext cx="5905500" cy="285750"/>
           </a:xfrm>
           <a:prstGeom xmlns:a="http://schemas.openxmlformats.org/drawingml/2006/main" prst="rect">
             <a:avLst/>
@@ -1268,7 +1335,7 @@
           <p:cNvPr id="4" name="footer">
             <a:extLst xmlns:a="http://schemas.openxmlformats.org/drawingml/2006/main">
               <a:ext uri="{FF2B5EF4-FFF2-40B4-BE49-F238E27FC236}">
-                <a16:creationId xmlns:a16="http://schemas.microsoft.com/office/drawing/2014/main" id="{7C4C45AF-1FDA-423C-A59F-42E878CC96BC}"/>
+                <a16:creationId xmlns:a16="http://schemas.microsoft.com/office/drawing/2014/main" id="{F27946D4-1325-49F4-A7C7-396F3A828558}"/>
               </a:ext>
             </a:extLst>
           </p:cNvPr>
@@ -1318,7 +1385,7 @@
           <p:cNvPr id="5" name="page-no">
             <a:extLst xmlns:a="http://schemas.openxmlformats.org/drawingml/2006/main">
               <a:ext uri="{FF2B5EF4-FFF2-40B4-BE49-F238E27FC236}">
-                <a16:creationId xmlns:a16="http://schemas.microsoft.com/office/drawing/2014/main" id="{01DFE2D1-3011-4265-AEA9-0BC99D584093}"/>
+                <a16:creationId xmlns:a16="http://schemas.microsoft.com/office/drawing/2014/main" id="{03285238-2862-4D0E-AA45-748D870B772A}"/>
               </a:ext>
             </a:extLst>
           </p:cNvPr>
@@ -1368,7 +1435,7 @@
           <p:cNvPr id="6" name="hero-panel">
             <a:extLst xmlns:a="http://schemas.openxmlformats.org/drawingml/2006/main">
               <a:ext uri="{FF2B5EF4-FFF2-40B4-BE49-F238E27FC236}">
-                <a16:creationId xmlns:a16="http://schemas.microsoft.com/office/drawing/2014/main" id="{4383C236-DB54-4097-B3D1-747EDA50822A}"/>
+                <a16:creationId xmlns:a16="http://schemas.microsoft.com/office/drawing/2014/main" id="{FD609226-52E0-494C-8185-45B80C8E88E0}"/>
               </a:ext>
             </a:extLst>
           </p:cNvPr>
@@ -1401,7 +1468,7 @@
           <p:cNvPr id="7" name="hero-kicker">
             <a:extLst xmlns:a="http://schemas.openxmlformats.org/drawingml/2006/main">
               <a:ext uri="{FF2B5EF4-FFF2-40B4-BE49-F238E27FC236}">
-                <a16:creationId xmlns:a16="http://schemas.microsoft.com/office/drawing/2014/main" id="{E4DC28E6-1B95-42A5-B8A2-419BDD63F818}"/>
+                <a16:creationId xmlns:a16="http://schemas.microsoft.com/office/drawing/2014/main" id="{7D29E825-A250-42CC-93B2-2582FB102106}"/>
               </a:ext>
             </a:extLst>
           </p:cNvPr>
@@ -1451,7 +1518,7 @@
           <p:cNvPr id="8" name="hero-title">
             <a:extLst xmlns:a="http://schemas.openxmlformats.org/drawingml/2006/main">
               <a:ext uri="{FF2B5EF4-FFF2-40B4-BE49-F238E27FC236}">
-                <a16:creationId xmlns:a16="http://schemas.microsoft.com/office/drawing/2014/main" id="{C055DF5B-91F6-404C-9970-3DC7A1F038FA}"/>
+                <a16:creationId xmlns:a16="http://schemas.microsoft.com/office/drawing/2014/main" id="{CEBCDEA0-AB34-49D3-B587-18E4B8685E76}"/>
               </a:ext>
             </a:extLst>
           </p:cNvPr>
@@ -1501,7 +1568,7 @@
           <p:cNvPr id="9" name="hero-subtitle">
             <a:extLst xmlns:a="http://schemas.openxmlformats.org/drawingml/2006/main">
               <a:ext uri="{FF2B5EF4-FFF2-40B4-BE49-F238E27FC236}">
-                <a16:creationId xmlns:a16="http://schemas.microsoft.com/office/drawing/2014/main" id="{3301D87B-D90F-4F89-8249-A4C263C83C23}"/>
+                <a16:creationId xmlns:a16="http://schemas.microsoft.com/office/drawing/2014/main" id="{F36DB0B3-40AF-4C87-80C1-DD45C1636414}"/>
               </a:ext>
             </a:extLst>
           </p:cNvPr>
@@ -1551,7 +1618,7 @@
           <p:cNvPr id="10" name="tag-1">
             <a:extLst xmlns:a="http://schemas.openxmlformats.org/drawingml/2006/main">
               <a:ext uri="{FF2B5EF4-FFF2-40B4-BE49-F238E27FC236}">
-                <a16:creationId xmlns:a16="http://schemas.microsoft.com/office/drawing/2014/main" id="{365480EB-F0C6-442B-9531-4D0C261F5C8E}"/>
+                <a16:creationId xmlns:a16="http://schemas.microsoft.com/office/drawing/2014/main" id="{3C230F18-95ED-4475-8E79-85CE2E583DA2}"/>
               </a:ext>
             </a:extLst>
           </p:cNvPr>
@@ -1607,7 +1674,7 @@
           <p:cNvPr id="11" name="tag-2">
             <a:extLst xmlns:a="http://schemas.openxmlformats.org/drawingml/2006/main">
               <a:ext uri="{FF2B5EF4-FFF2-40B4-BE49-F238E27FC236}">
-                <a16:creationId xmlns:a16="http://schemas.microsoft.com/office/drawing/2014/main" id="{C0DC44E7-5115-4875-9791-118A84076625}"/>
+                <a16:creationId xmlns:a16="http://schemas.microsoft.com/office/drawing/2014/main" id="{51E654B1-2B53-4070-8AAD-BC79C07BE457}"/>
               </a:ext>
             </a:extLst>
           </p:cNvPr>
@@ -1663,7 +1730,7 @@
           <p:cNvPr id="12" name="tag-3">
             <a:extLst xmlns:a="http://schemas.openxmlformats.org/drawingml/2006/main">
               <a:ext uri="{FF2B5EF4-FFF2-40B4-BE49-F238E27FC236}">
-                <a16:creationId xmlns:a16="http://schemas.microsoft.com/office/drawing/2014/main" id="{BEAF8971-35C2-49D2-8039-35949799BB8D}"/>
+                <a16:creationId xmlns:a16="http://schemas.microsoft.com/office/drawing/2014/main" id="{F9DEF68A-91EE-4212-AD10-F7BF4B3B98A2}"/>
               </a:ext>
             </a:extLst>
           </p:cNvPr>
@@ -1719,7 +1786,7 @@
           <p:cNvPr id="13" name="scope-title">
             <a:extLst xmlns:a="http://schemas.openxmlformats.org/drawingml/2006/main">
               <a:ext uri="{FF2B5EF4-FFF2-40B4-BE49-F238E27FC236}">
-                <a16:creationId xmlns:a16="http://schemas.microsoft.com/office/drawing/2014/main" id="{959997CE-44A4-4CFD-8D8F-713495787B13}"/>
+                <a16:creationId xmlns:a16="http://schemas.microsoft.com/office/drawing/2014/main" id="{DE00ADF5-937B-4350-97C0-4F09F1B3A46A}"/>
               </a:ext>
             </a:extLst>
           </p:cNvPr>
@@ -1769,7 +1836,7 @@
           <p:cNvPr id="14" name="scope-note">
             <a:extLst xmlns:a="http://schemas.openxmlformats.org/drawingml/2006/main">
               <a:ext uri="{FF2B5EF4-FFF2-40B4-BE49-F238E27FC236}">
-                <a16:creationId xmlns:a16="http://schemas.microsoft.com/office/drawing/2014/main" id="{119295B3-927C-4E41-95E3-CEC9F5D6AD8D}"/>
+                <a16:creationId xmlns:a16="http://schemas.microsoft.com/office/drawing/2014/main" id="{F4A25A1E-BD60-434D-949D-46F03D72D672}"/>
               </a:ext>
             </a:extLst>
           </p:cNvPr>
@@ -1819,7 +1886,7 @@
           <p:cNvPr id="15" name="scope-row-1">
             <a:extLst xmlns:a="http://schemas.openxmlformats.org/drawingml/2006/main">
               <a:ext uri="{FF2B5EF4-FFF2-40B4-BE49-F238E27FC236}">
-                <a16:creationId xmlns:a16="http://schemas.microsoft.com/office/drawing/2014/main" id="{A1F78B5B-9D2E-409B-BFC8-D8AD951C5499}"/>
+                <a16:creationId xmlns:a16="http://schemas.microsoft.com/office/drawing/2014/main" id="{57A04C4A-D67B-4AE3-8A04-3D58CF5483ED}"/>
               </a:ext>
             </a:extLst>
           </p:cNvPr>
@@ -1852,7 +1919,7 @@
           <p:cNvPr id="16" name="scope-label-1">
             <a:extLst xmlns:a="http://schemas.openxmlformats.org/drawingml/2006/main">
               <a:ext uri="{FF2B5EF4-FFF2-40B4-BE49-F238E27FC236}">
-                <a16:creationId xmlns:a16="http://schemas.microsoft.com/office/drawing/2014/main" id="{26DBA780-AAC7-4A81-AFEF-51C1EC8609EA}"/>
+                <a16:creationId xmlns:a16="http://schemas.microsoft.com/office/drawing/2014/main" id="{658382CF-33F6-449F-A938-CE6049F75E7F}"/>
               </a:ext>
             </a:extLst>
           </p:cNvPr>
@@ -1902,7 +1969,7 @@
           <p:cNvPr id="17" name="scope-value-1">
             <a:extLst xmlns:a="http://schemas.openxmlformats.org/drawingml/2006/main">
               <a:ext uri="{FF2B5EF4-FFF2-40B4-BE49-F238E27FC236}">
-                <a16:creationId xmlns:a16="http://schemas.microsoft.com/office/drawing/2014/main" id="{75A3B9C4-2580-4C86-AAD7-65DF9D51BB94}"/>
+                <a16:creationId xmlns:a16="http://schemas.microsoft.com/office/drawing/2014/main" id="{958A698B-FB6D-408A-A016-79A50C0A600D}"/>
               </a:ext>
             </a:extLst>
           </p:cNvPr>
@@ -1952,7 +2019,7 @@
           <p:cNvPr id="18" name="scope-row-2">
             <a:extLst xmlns:a="http://schemas.openxmlformats.org/drawingml/2006/main">
               <a:ext uri="{FF2B5EF4-FFF2-40B4-BE49-F238E27FC236}">
-                <a16:creationId xmlns:a16="http://schemas.microsoft.com/office/drawing/2014/main" id="{747A003F-0026-4D2B-A143-B2ADFE300204}"/>
+                <a16:creationId xmlns:a16="http://schemas.microsoft.com/office/drawing/2014/main" id="{FAA8AA22-D23C-4662-BFC3-342F8D78C932}"/>
               </a:ext>
             </a:extLst>
           </p:cNvPr>
@@ -1985,7 +2052,7 @@
           <p:cNvPr id="19" name="scope-label-2">
             <a:extLst xmlns:a="http://schemas.openxmlformats.org/drawingml/2006/main">
               <a:ext uri="{FF2B5EF4-FFF2-40B4-BE49-F238E27FC236}">
-                <a16:creationId xmlns:a16="http://schemas.microsoft.com/office/drawing/2014/main" id="{808832D2-3436-4749-970A-B5B007F7FA90}"/>
+                <a16:creationId xmlns:a16="http://schemas.microsoft.com/office/drawing/2014/main" id="{857210C4-0BD7-481A-B085-0C863E570C78}"/>
               </a:ext>
             </a:extLst>
           </p:cNvPr>
@@ -2035,7 +2102,7 @@
           <p:cNvPr id="20" name="scope-value-2">
             <a:extLst xmlns:a="http://schemas.openxmlformats.org/drawingml/2006/main">
               <a:ext uri="{FF2B5EF4-FFF2-40B4-BE49-F238E27FC236}">
-                <a16:creationId xmlns:a16="http://schemas.microsoft.com/office/drawing/2014/main" id="{AB0E592C-E904-46BE-8C60-BD1028AC7219}"/>
+                <a16:creationId xmlns:a16="http://schemas.microsoft.com/office/drawing/2014/main" id="{1F4EC4FE-49C0-48C7-9317-6B5EE8F9D505}"/>
               </a:ext>
             </a:extLst>
           </p:cNvPr>
@@ -2085,7 +2152,7 @@
           <p:cNvPr id="21" name="scope-row-3">
             <a:extLst xmlns:a="http://schemas.openxmlformats.org/drawingml/2006/main">
               <a:ext uri="{FF2B5EF4-FFF2-40B4-BE49-F238E27FC236}">
-                <a16:creationId xmlns:a16="http://schemas.microsoft.com/office/drawing/2014/main" id="{254FE3C6-141F-4041-AB83-3CE1C1C789F2}"/>
+                <a16:creationId xmlns:a16="http://schemas.microsoft.com/office/drawing/2014/main" id="{DCEDB403-193A-4FDA-8B1C-C3528D274A9D}"/>
               </a:ext>
             </a:extLst>
           </p:cNvPr>
@@ -2118,7 +2185,7 @@
           <p:cNvPr id="22" name="scope-label-3">
             <a:extLst xmlns:a="http://schemas.openxmlformats.org/drawingml/2006/main">
               <a:ext uri="{FF2B5EF4-FFF2-40B4-BE49-F238E27FC236}">
-                <a16:creationId xmlns:a16="http://schemas.microsoft.com/office/drawing/2014/main" id="{9882EFD8-FB8B-4FFF-B718-5D03D887B25E}"/>
+                <a16:creationId xmlns:a16="http://schemas.microsoft.com/office/drawing/2014/main" id="{EF8A8527-2333-4FE1-BDB5-85394A0F0672}"/>
               </a:ext>
             </a:extLst>
           </p:cNvPr>
@@ -2168,7 +2235,7 @@
           <p:cNvPr id="23" name="scope-value-3">
             <a:extLst xmlns:a="http://schemas.openxmlformats.org/drawingml/2006/main">
               <a:ext uri="{FF2B5EF4-FFF2-40B4-BE49-F238E27FC236}">
-                <a16:creationId xmlns:a16="http://schemas.microsoft.com/office/drawing/2014/main" id="{0CF421D7-5E14-4E69-BE94-1A8A5BC8ED5A}"/>
+                <a16:creationId xmlns:a16="http://schemas.microsoft.com/office/drawing/2014/main" id="{BD0BA77F-1F53-4CD9-8D29-03B1205F2629}"/>
               </a:ext>
             </a:extLst>
           </p:cNvPr>
@@ -2218,7 +2285,7 @@
           <p:cNvPr id="24" name="scope-row-4">
             <a:extLst xmlns:a="http://schemas.openxmlformats.org/drawingml/2006/main">
               <a:ext uri="{FF2B5EF4-FFF2-40B4-BE49-F238E27FC236}">
-                <a16:creationId xmlns:a16="http://schemas.microsoft.com/office/drawing/2014/main" id="{A0706CBB-BF16-40D8-B0C1-445582E53533}"/>
+                <a16:creationId xmlns:a16="http://schemas.microsoft.com/office/drawing/2014/main" id="{4E5E8517-434A-4200-98FF-3A61BF8C2793}"/>
               </a:ext>
             </a:extLst>
           </p:cNvPr>
@@ -2251,7 +2318,7 @@
           <p:cNvPr id="25" name="scope-label-4">
             <a:extLst xmlns:a="http://schemas.openxmlformats.org/drawingml/2006/main">
               <a:ext uri="{FF2B5EF4-FFF2-40B4-BE49-F238E27FC236}">
-                <a16:creationId xmlns:a16="http://schemas.microsoft.com/office/drawing/2014/main" id="{A14FBE55-DF5D-40A9-A6F2-F5BC6BE86B13}"/>
+                <a16:creationId xmlns:a16="http://schemas.microsoft.com/office/drawing/2014/main" id="{3FD7D3B8-F3D6-4D8C-BF9C-25E80BD4B53D}"/>
               </a:ext>
             </a:extLst>
           </p:cNvPr>
@@ -2301,7 +2368,7 @@
           <p:cNvPr id="26" name="scope-value-4">
             <a:extLst xmlns:a="http://schemas.openxmlformats.org/drawingml/2006/main">
               <a:ext uri="{FF2B5EF4-FFF2-40B4-BE49-F238E27FC236}">
-                <a16:creationId xmlns:a16="http://schemas.microsoft.com/office/drawing/2014/main" id="{F82D48E4-4143-4C36-94F7-86C385E34E16}"/>
+                <a16:creationId xmlns:a16="http://schemas.microsoft.com/office/drawing/2014/main" id="{2FE173D4-F179-413D-89B6-DEA695318E05}"/>
               </a:ext>
             </a:extLst>
           </p:cNvPr>
@@ -2351,7 +2418,7 @@
           <p:cNvPr id="27" name="evidence-title">
             <a:extLst xmlns:a="http://schemas.openxmlformats.org/drawingml/2006/main">
               <a:ext uri="{FF2B5EF4-FFF2-40B4-BE49-F238E27FC236}">
-                <a16:creationId xmlns:a16="http://schemas.microsoft.com/office/drawing/2014/main" id="{62873B73-2344-4B83-A008-5A5CEE7E46C7}"/>
+                <a16:creationId xmlns:a16="http://schemas.microsoft.com/office/drawing/2014/main" id="{A69FE48F-F86B-42D3-AAEE-9148AE6AEE7D}"/>
               </a:ext>
             </a:extLst>
           </p:cNvPr>
@@ -2401,7 +2468,7 @@
           <p:cNvPr id="28" name="evidence-card-1">
             <a:extLst xmlns:a="http://schemas.openxmlformats.org/drawingml/2006/main">
               <a:ext uri="{FF2B5EF4-FFF2-40B4-BE49-F238E27FC236}">
-                <a16:creationId xmlns:a16="http://schemas.microsoft.com/office/drawing/2014/main" id="{AF39F80D-3B67-49C1-9E44-B669E8E66D09}"/>
+                <a16:creationId xmlns:a16="http://schemas.microsoft.com/office/drawing/2014/main" id="{8F8751F5-E4BD-4F7C-9DBE-C1AD8DEAD100}"/>
               </a:ext>
             </a:extLst>
           </p:cNvPr>
@@ -2436,7 +2503,7 @@
           <p:cNvPr id="29" name="evidence-bar-1">
             <a:extLst xmlns:a="http://schemas.openxmlformats.org/drawingml/2006/main">
               <a:ext uri="{FF2B5EF4-FFF2-40B4-BE49-F238E27FC236}">
-                <a16:creationId xmlns:a16="http://schemas.microsoft.com/office/drawing/2014/main" id="{5F88EE19-D4B3-4DBA-82B6-25BC3C81C1F6}"/>
+                <a16:creationId xmlns:a16="http://schemas.microsoft.com/office/drawing/2014/main" id="{D3946514-A71F-4A76-93AE-E9B8436F774F}"/>
               </a:ext>
             </a:extLst>
           </p:cNvPr>
@@ -2469,7 +2536,7 @@
           <p:cNvPr id="30" name="evidence-title-1">
             <a:extLst xmlns:a="http://schemas.openxmlformats.org/drawingml/2006/main">
               <a:ext uri="{FF2B5EF4-FFF2-40B4-BE49-F238E27FC236}">
-                <a16:creationId xmlns:a16="http://schemas.microsoft.com/office/drawing/2014/main" id="{25B6F673-939D-468E-BE28-F9BBE8BD8B10}"/>
+                <a16:creationId xmlns:a16="http://schemas.microsoft.com/office/drawing/2014/main" id="{0ACB3B3B-5594-4D6D-A20C-2CDFDB9E3494}"/>
               </a:ext>
             </a:extLst>
           </p:cNvPr>
@@ -2519,7 +2586,7 @@
           <p:cNvPr id="31" name="evidence-body-1">
             <a:extLst xmlns:a="http://schemas.openxmlformats.org/drawingml/2006/main">
               <a:ext uri="{FF2B5EF4-FFF2-40B4-BE49-F238E27FC236}">
-                <a16:creationId xmlns:a16="http://schemas.microsoft.com/office/drawing/2014/main" id="{62DCB257-1096-4A46-9A60-E9FC97AE22B6}"/>
+                <a16:creationId xmlns:a16="http://schemas.microsoft.com/office/drawing/2014/main" id="{1864AB51-8B78-4549-A3C4-5DF3A917A8A9}"/>
               </a:ext>
             </a:extLst>
           </p:cNvPr>
@@ -2569,7 +2636,7 @@
           <p:cNvPr id="32" name="evidence-card-2">
             <a:extLst xmlns:a="http://schemas.openxmlformats.org/drawingml/2006/main">
               <a:ext uri="{FF2B5EF4-FFF2-40B4-BE49-F238E27FC236}">
-                <a16:creationId xmlns:a16="http://schemas.microsoft.com/office/drawing/2014/main" id="{AD4DE1F4-A875-4355-A636-0DFC8534AF1C}"/>
+                <a16:creationId xmlns:a16="http://schemas.microsoft.com/office/drawing/2014/main" id="{7181B067-7D75-44B3-B434-7135E72E6C7D}"/>
               </a:ext>
             </a:extLst>
           </p:cNvPr>
@@ -2604,7 +2671,7 @@
           <p:cNvPr id="33" name="evidence-bar-2">
             <a:extLst xmlns:a="http://schemas.openxmlformats.org/drawingml/2006/main">
               <a:ext uri="{FF2B5EF4-FFF2-40B4-BE49-F238E27FC236}">
-                <a16:creationId xmlns:a16="http://schemas.microsoft.com/office/drawing/2014/main" id="{743832EF-A64B-49A4-90B1-F46221B5170A}"/>
+                <a16:creationId xmlns:a16="http://schemas.microsoft.com/office/drawing/2014/main" id="{0618AE7F-A349-4F0B-9F29-5A8D5E4E7064}"/>
               </a:ext>
             </a:extLst>
           </p:cNvPr>
@@ -2637,7 +2704,7 @@
           <p:cNvPr id="34" name="evidence-title-2">
             <a:extLst xmlns:a="http://schemas.openxmlformats.org/drawingml/2006/main">
               <a:ext uri="{FF2B5EF4-FFF2-40B4-BE49-F238E27FC236}">
-                <a16:creationId xmlns:a16="http://schemas.microsoft.com/office/drawing/2014/main" id="{0FC03D62-297D-43F6-9384-8E94EBBA6946}"/>
+                <a16:creationId xmlns:a16="http://schemas.microsoft.com/office/drawing/2014/main" id="{C84310C6-A1C5-4E24-8066-794B43ACA04E}"/>
               </a:ext>
             </a:extLst>
           </p:cNvPr>
@@ -2687,7 +2754,7 @@
           <p:cNvPr id="35" name="evidence-body-2">
             <a:extLst xmlns:a="http://schemas.openxmlformats.org/drawingml/2006/main">
               <a:ext uri="{FF2B5EF4-FFF2-40B4-BE49-F238E27FC236}">
-                <a16:creationId xmlns:a16="http://schemas.microsoft.com/office/drawing/2014/main" id="{6AFAB91C-4411-414D-A82A-132515F544BF}"/>
+                <a16:creationId xmlns:a16="http://schemas.microsoft.com/office/drawing/2014/main" id="{C510D274-6E8C-4EC0-BCBB-657D6A37ED45}"/>
               </a:ext>
             </a:extLst>
           </p:cNvPr>
@@ -2737,7 +2804,7 @@
           <p:cNvPr id="36" name="evidence-card-3">
             <a:extLst xmlns:a="http://schemas.openxmlformats.org/drawingml/2006/main">
               <a:ext uri="{FF2B5EF4-FFF2-40B4-BE49-F238E27FC236}">
-                <a16:creationId xmlns:a16="http://schemas.microsoft.com/office/drawing/2014/main" id="{A440D78A-F75F-4943-A706-D461B0977506}"/>
+                <a16:creationId xmlns:a16="http://schemas.microsoft.com/office/drawing/2014/main" id="{0879F31C-1545-4B71-8D1C-4E182904FE4B}"/>
               </a:ext>
             </a:extLst>
           </p:cNvPr>
@@ -2772,7 +2839,7 @@
           <p:cNvPr id="37" name="evidence-bar-3">
             <a:extLst xmlns:a="http://schemas.openxmlformats.org/drawingml/2006/main">
               <a:ext uri="{FF2B5EF4-FFF2-40B4-BE49-F238E27FC236}">
-                <a16:creationId xmlns:a16="http://schemas.microsoft.com/office/drawing/2014/main" id="{20A6A53C-1810-4C04-8763-18C335DA4215}"/>
+                <a16:creationId xmlns:a16="http://schemas.microsoft.com/office/drawing/2014/main" id="{869906C6-9186-42F5-A2E2-B131D7AE65FF}"/>
               </a:ext>
             </a:extLst>
           </p:cNvPr>
@@ -2805,7 +2872,7 @@
           <p:cNvPr id="38" name="evidence-title-3">
             <a:extLst xmlns:a="http://schemas.openxmlformats.org/drawingml/2006/main">
               <a:ext uri="{FF2B5EF4-FFF2-40B4-BE49-F238E27FC236}">
-                <a16:creationId xmlns:a16="http://schemas.microsoft.com/office/drawing/2014/main" id="{265EE72B-1E94-40F3-84A4-3AA7E58BE4ED}"/>
+                <a16:creationId xmlns:a16="http://schemas.microsoft.com/office/drawing/2014/main" id="{A42996BC-EB0E-493F-857E-9582E1ADAE12}"/>
               </a:ext>
             </a:extLst>
           </p:cNvPr>
@@ -2855,7 +2922,7 @@
           <p:cNvPr id="39" name="evidence-body-3">
             <a:extLst xmlns:a="http://schemas.openxmlformats.org/drawingml/2006/main">
               <a:ext uri="{FF2B5EF4-FFF2-40B4-BE49-F238E27FC236}">
-                <a16:creationId xmlns:a16="http://schemas.microsoft.com/office/drawing/2014/main" id="{00051384-EDBE-4D35-B627-573CCE107221}"/>
+                <a16:creationId xmlns:a16="http://schemas.microsoft.com/office/drawing/2014/main" id="{6112007E-216F-4F3F-B515-F92FA3BF0777}"/>
               </a:ext>
             </a:extLst>
           </p:cNvPr>
@@ -2903,7 +2970,3965 @@
     </p:spTree>
     <p:extLst>
       <p:ext uri="{BB962C8B-B14F-4D97-AF65-F5344CB8AC3E}">
-        <p14:creationId xmlns:p14="http://schemas.microsoft.com/office/powerpoint/2010/main" val="503259153"/>
+        <p14:creationId xmlns:p14="http://schemas.microsoft.com/office/powerpoint/2010/main" val="1814583000"/>
+      </p:ext>
+    </p:extLst>
+  </p:cSld>
+</p:sld>
+</file>
+
+<file path=ppt/slides/slide2.xml><?xml version="1.0" encoding="utf-8"?>
+<p:sld xmlns:p="http://schemas.openxmlformats.org/presentationml/2006/main">
+  <p:cSld>
+    <p:bg>
+      <p:bgPr>
+        <a:solidFill xmlns:a="http://schemas.openxmlformats.org/drawingml/2006/main">
+          <a:srgbClr val="0B1020"/>
+        </a:solidFill>
+      </p:bgPr>
+    </p:bg>
+    <p:spTree>
+      <p:nvGrpSpPr>
+        <p:cNvPr id="1" name=""/>
+        <p:cNvGrpSpPr/>
+        <p:nvPr/>
+      </p:nvGrpSpPr>
+      <p:grpSpPr>
+        <a:xfrm xmlns:a="http://schemas.openxmlformats.org/drawingml/2006/main"/>
+      </p:grpSpPr>
+      <p:sp>
+        <p:nvSpPr>
+          <p:cNvPr id="1" name="top-accent">
+            <a:extLst xmlns:a="http://schemas.openxmlformats.org/drawingml/2006/main">
+              <a:ext uri="{FF2B5EF4-FFF2-40B4-BE49-F238E27FC236}">
+                <a16:creationId xmlns:a16="http://schemas.microsoft.com/office/drawing/2014/main" id="{EBB80E51-0ED0-49EC-8FE2-B00791127130}"/>
+              </a:ext>
+            </a:extLst>
+          </p:cNvPr>
+          <p:cNvSpPr>
+            <a:spLocks xmlns:a="http://schemas.openxmlformats.org/drawingml/2006/main" noGrp="1"/>
+          </p:cNvSpPr>
+          <p:nvPr/>
+        </p:nvSpPr>
+        <p:spPr>
+          <a:xfrm xmlns:a="http://schemas.openxmlformats.org/drawingml/2006/main">
+            <a:off x="0" y="0"/>
+            <a:ext cx="12192000" cy="95250"/>
+          </a:xfrm>
+          <a:prstGeom xmlns:a="http://schemas.openxmlformats.org/drawingml/2006/main" prst="rect">
+            <a:avLst/>
+          </a:prstGeom>
+          <a:solidFill xmlns:a="http://schemas.openxmlformats.org/drawingml/2006/main">
+            <a:srgbClr val="00B8D9"/>
+          </a:solidFill>
+          <a:ln xmlns:a="http://schemas.openxmlformats.org/drawingml/2006/main" w="0">
+            <a:solidFill>
+              <a:srgbClr val="00B8D9"/>
+            </a:solidFill>
+            <a:prstDash val="solid"/>
+          </a:ln>
+        </p:spPr>
+      </p:sp>
+      <p:sp>
+        <p:nvSpPr>
+          <p:cNvPr id="2" name="left-accent">
+            <a:extLst xmlns:a="http://schemas.openxmlformats.org/drawingml/2006/main">
+              <a:ext uri="{FF2B5EF4-FFF2-40B4-BE49-F238E27FC236}">
+                <a16:creationId xmlns:a16="http://schemas.microsoft.com/office/drawing/2014/main" id="{C24A0E22-DBDD-40F8-9CE4-B7DE98CA4311}"/>
+              </a:ext>
+            </a:extLst>
+          </p:cNvPr>
+          <p:cNvSpPr>
+            <a:spLocks xmlns:a="http://schemas.openxmlformats.org/drawingml/2006/main" noGrp="1"/>
+          </p:cNvSpPr>
+          <p:nvPr/>
+        </p:nvSpPr>
+        <p:spPr>
+          <a:xfrm xmlns:a="http://schemas.openxmlformats.org/drawingml/2006/main">
+            <a:off x="0" y="0"/>
+            <a:ext cx="152400" cy="6858000"/>
+          </a:xfrm>
+          <a:prstGeom xmlns:a="http://schemas.openxmlformats.org/drawingml/2006/main" prst="rect">
+            <a:avLst/>
+          </a:prstGeom>
+          <a:solidFill xmlns:a="http://schemas.openxmlformats.org/drawingml/2006/main">
+            <a:srgbClr val="FF6B35"/>
+          </a:solidFill>
+          <a:ln xmlns:a="http://schemas.openxmlformats.org/drawingml/2006/main" w="0">
+            <a:solidFill>
+              <a:srgbClr val="FF6B35"/>
+            </a:solidFill>
+            <a:prstDash val="solid"/>
+          </a:ln>
+        </p:spPr>
+      </p:sp>
+      <p:sp>
+        <p:nvSpPr>
+          <p:cNvPr id="3" name="eyebrow">
+            <a:extLst xmlns:a="http://schemas.openxmlformats.org/drawingml/2006/main">
+              <a:ext uri="{FF2B5EF4-FFF2-40B4-BE49-F238E27FC236}">
+                <a16:creationId xmlns:a16="http://schemas.microsoft.com/office/drawing/2014/main" id="{ACE46DBE-529B-45B7-9DDB-08AB9C00C335}"/>
+              </a:ext>
+            </a:extLst>
+          </p:cNvPr>
+          <p:cNvSpPr>
+            <a:spLocks xmlns:a="http://schemas.openxmlformats.org/drawingml/2006/main" noGrp="1"/>
+          </p:cNvSpPr>
+          <p:nvPr/>
+        </p:nvSpPr>
+        <p:spPr>
+          <a:xfrm xmlns:a="http://schemas.openxmlformats.org/drawingml/2006/main">
+            <a:off x="514350" y="361950"/>
+            <a:ext cx="5905500" cy="285750"/>
+          </a:xfrm>
+          <a:prstGeom xmlns:a="http://schemas.openxmlformats.org/drawingml/2006/main" prst="rect">
+            <a:avLst/>
+          </a:prstGeom>
+          <a:noFill xmlns:a="http://schemas.openxmlformats.org/drawingml/2006/main"/>
+          <a:ln xmlns:a="http://schemas.openxmlformats.org/drawingml/2006/main" w="0">
+            <a:noFill/>
+            <a:prstDash val="solid"/>
+          </a:ln>
+        </p:spPr>
+        <p:txBody>
+          <a:bodyPr xmlns:a="http://schemas.openxmlformats.org/drawingml/2006/main"/>
+          <a:lstStyle xmlns:a="http://schemas.openxmlformats.org/drawingml/2006/main"/>
+          <a:p xmlns:a="http://schemas.openxmlformats.org/drawingml/2006/main">
+            <a:pPr>
+              <a:defRPr sz="1125" b="1">
+                <a:solidFill>
+                  <a:srgbClr val="8BD9E8"/>
+                </a:solidFill>
+              </a:defRPr>
+            </a:pPr>
+            <a:r>
+              <a:rPr sz="1125" b="1">
+                <a:solidFill>
+                  <a:srgbClr val="8BD9E8"/>
+                </a:solidFill>
+              </a:rPr>
+              <a:t>SIX-MONTH LAUNCH ROADMAP | PAGE 02</a:t>
+            </a:r>
+          </a:p>
+        </p:txBody>
+      </p:sp>
+      <p:sp>
+        <p:nvSpPr>
+          <p:cNvPr id="4" name="footer">
+            <a:extLst xmlns:a="http://schemas.openxmlformats.org/drawingml/2006/main">
+              <a:ext uri="{FF2B5EF4-FFF2-40B4-BE49-F238E27FC236}">
+                <a16:creationId xmlns:a16="http://schemas.microsoft.com/office/drawing/2014/main" id="{4912B251-6BBA-4BA2-A2DF-E4F5BC0CDB98}"/>
+              </a:ext>
+            </a:extLst>
+          </p:cNvPr>
+          <p:cNvSpPr>
+            <a:spLocks xmlns:a="http://schemas.openxmlformats.org/drawingml/2006/main" noGrp="1"/>
+          </p:cNvSpPr>
+          <p:nvPr/>
+        </p:nvSpPr>
+        <p:spPr>
+          <a:xfrm xmlns:a="http://schemas.openxmlformats.org/drawingml/2006/main">
+            <a:off x="514350" y="6457950"/>
+            <a:ext cx="4953000" cy="266700"/>
+          </a:xfrm>
+          <a:prstGeom xmlns:a="http://schemas.openxmlformats.org/drawingml/2006/main" prst="rect">
+            <a:avLst/>
+          </a:prstGeom>
+          <a:noFill xmlns:a="http://schemas.openxmlformats.org/drawingml/2006/main"/>
+          <a:ln xmlns:a="http://schemas.openxmlformats.org/drawingml/2006/main" w="0">
+            <a:noFill/>
+            <a:prstDash val="solid"/>
+          </a:ln>
+        </p:spPr>
+        <p:txBody>
+          <a:bodyPr xmlns:a="http://schemas.openxmlformats.org/drawingml/2006/main"/>
+          <a:lstStyle xmlns:a="http://schemas.openxmlformats.org/drawingml/2006/main"/>
+          <a:p xmlns:a="http://schemas.openxmlformats.org/drawingml/2006/main">
+            <a:pPr>
+              <a:defRPr sz="1125">
+                <a:solidFill>
+                  <a:srgbClr val="94A3B8"/>
+                </a:solidFill>
+              </a:defRPr>
+            </a:pPr>
+            <a:r>
+              <a:rPr sz="1125">
+                <a:solidFill>
+                  <a:srgbClr val="94A3B8"/>
+                </a:solidFill>
+              </a:rPr>
+              <a:t>HIT2 일본 서비스 런칭 6개월 전 로드맵</a:t>
+            </a:r>
+          </a:p>
+        </p:txBody>
+      </p:sp>
+      <p:sp>
+        <p:nvSpPr>
+          <p:cNvPr id="5" name="page-no">
+            <a:extLst xmlns:a="http://schemas.openxmlformats.org/drawingml/2006/main">
+              <a:ext uri="{FF2B5EF4-FFF2-40B4-BE49-F238E27FC236}">
+                <a16:creationId xmlns:a16="http://schemas.microsoft.com/office/drawing/2014/main" id="{2F44404A-D74F-4723-A909-5A7426041865}"/>
+              </a:ext>
+            </a:extLst>
+          </p:cNvPr>
+          <p:cNvSpPr>
+            <a:spLocks xmlns:a="http://schemas.openxmlformats.org/drawingml/2006/main" noGrp="1"/>
+          </p:cNvSpPr>
+          <p:nvPr/>
+        </p:nvSpPr>
+        <p:spPr>
+          <a:xfrm xmlns:a="http://schemas.openxmlformats.org/drawingml/2006/main">
+            <a:off x="10953750" y="6457950"/>
+            <a:ext cx="419100" cy="266700"/>
+          </a:xfrm>
+          <a:prstGeom xmlns:a="http://schemas.openxmlformats.org/drawingml/2006/main" prst="rect">
+            <a:avLst/>
+          </a:prstGeom>
+          <a:noFill xmlns:a="http://schemas.openxmlformats.org/drawingml/2006/main"/>
+          <a:ln xmlns:a="http://schemas.openxmlformats.org/drawingml/2006/main" w="0">
+            <a:noFill/>
+            <a:prstDash val="solid"/>
+          </a:ln>
+        </p:spPr>
+        <p:txBody>
+          <a:bodyPr xmlns:a="http://schemas.openxmlformats.org/drawingml/2006/main"/>
+          <a:lstStyle xmlns:a="http://schemas.openxmlformats.org/drawingml/2006/main"/>
+          <a:p xmlns:a="http://schemas.openxmlformats.org/drawingml/2006/main">
+            <a:pPr algn="r">
+              <a:defRPr sz="1200" b="1">
+                <a:solidFill>
+                  <a:srgbClr val="94A3B8"/>
+                </a:solidFill>
+              </a:defRPr>
+            </a:pPr>
+            <a:r>
+              <a:rPr sz="1200" b="1">
+                <a:solidFill>
+                  <a:srgbClr val="94A3B8"/>
+                </a:solidFill>
+              </a:rPr>
+              <a:t>02</a:t>
+            </a:r>
+          </a:p>
+        </p:txBody>
+      </p:sp>
+      <p:sp>
+        <p:nvSpPr>
+          <p:cNvPr id="6" name="title-02">
+            <a:extLst xmlns:a="http://schemas.openxmlformats.org/drawingml/2006/main">
+              <a:ext uri="{FF2B5EF4-FFF2-40B4-BE49-F238E27FC236}">
+                <a16:creationId xmlns:a16="http://schemas.microsoft.com/office/drawing/2014/main" id="{AD090A17-AB26-44C5-AE0A-9FF3F5451184}"/>
+              </a:ext>
+            </a:extLst>
+          </p:cNvPr>
+          <p:cNvSpPr>
+            <a:spLocks xmlns:a="http://schemas.openxmlformats.org/drawingml/2006/main" noGrp="1"/>
+          </p:cNvSpPr>
+          <p:nvPr/>
+        </p:nvSpPr>
+        <p:spPr>
+          <a:xfrm xmlns:a="http://schemas.openxmlformats.org/drawingml/2006/main">
+            <a:off x="514350" y="781050"/>
+            <a:ext cx="10572750" cy="533400"/>
+          </a:xfrm>
+          <a:prstGeom xmlns:a="http://schemas.openxmlformats.org/drawingml/2006/main" prst="rect">
+            <a:avLst/>
+          </a:prstGeom>
+          <a:noFill xmlns:a="http://schemas.openxmlformats.org/drawingml/2006/main"/>
+          <a:ln xmlns:a="http://schemas.openxmlformats.org/drawingml/2006/main" w="0">
+            <a:noFill/>
+            <a:prstDash val="solid"/>
+          </a:ln>
+        </p:spPr>
+        <p:txBody>
+          <a:bodyPr xmlns:a="http://schemas.openxmlformats.org/drawingml/2006/main"/>
+          <a:lstStyle xmlns:a="http://schemas.openxmlformats.org/drawingml/2006/main"/>
+          <a:p xmlns:a="http://schemas.openxmlformats.org/drawingml/2006/main">
+            <a:pPr>
+              <a:defRPr sz="2550" b="1">
+                <a:solidFill>
+                  <a:srgbClr val="FFFFFF"/>
+                </a:solidFill>
+              </a:defRPr>
+            </a:pPr>
+            <a:r>
+              <a:rPr sz="2550" b="1">
+                <a:solidFill>
+                  <a:srgbClr val="FFFFFF"/>
+                </a:solidFill>
+              </a:rPr>
+              <a:t>6개월 런칭 준비는 네 축이 병렬로 움직입니다</a:t>
+            </a:r>
+          </a:p>
+        </p:txBody>
+      </p:sp>
+      <p:sp>
+        <p:nvSpPr>
+          <p:cNvPr id="7" name="subtitle-02">
+            <a:extLst xmlns:a="http://schemas.openxmlformats.org/drawingml/2006/main">
+              <a:ext uri="{FF2B5EF4-FFF2-40B4-BE49-F238E27FC236}">
+                <a16:creationId xmlns:a16="http://schemas.microsoft.com/office/drawing/2014/main" id="{3F87A94A-29D3-4C6A-AAD5-A2EB499DF463}"/>
+              </a:ext>
+            </a:extLst>
+          </p:cNvPr>
+          <p:cNvSpPr>
+            <a:spLocks xmlns:a="http://schemas.openxmlformats.org/drawingml/2006/main" noGrp="1"/>
+          </p:cNvSpPr>
+          <p:nvPr/>
+        </p:nvSpPr>
+        <p:spPr>
+          <a:xfrm xmlns:a="http://schemas.openxmlformats.org/drawingml/2006/main">
+            <a:off x="533400" y="1371600"/>
+            <a:ext cx="10287000" cy="323850"/>
+          </a:xfrm>
+          <a:prstGeom xmlns:a="http://schemas.openxmlformats.org/drawingml/2006/main" prst="rect">
+            <a:avLst/>
+          </a:prstGeom>
+          <a:noFill xmlns:a="http://schemas.openxmlformats.org/drawingml/2006/main"/>
+          <a:ln xmlns:a="http://schemas.openxmlformats.org/drawingml/2006/main" w="0">
+            <a:noFill/>
+            <a:prstDash val="solid"/>
+          </a:ln>
+        </p:spPr>
+        <p:txBody>
+          <a:bodyPr xmlns:a="http://schemas.openxmlformats.org/drawingml/2006/main"/>
+          <a:lstStyle xmlns:a="http://schemas.openxmlformats.org/drawingml/2006/main"/>
+          <a:p xmlns:a="http://schemas.openxmlformats.org/drawingml/2006/main">
+            <a:pPr>
+              <a:defRPr sz="1275">
+                <a:solidFill>
+                  <a:srgbClr val="CBD5E1"/>
+                </a:solidFill>
+              </a:defRPr>
+            </a:pPr>
+            <a:r>
+              <a:rPr sz="1275">
+                <a:solidFill>
+                  <a:srgbClr val="CBD5E1"/>
+                </a:solidFill>
+              </a:rPr>
+              <a:t>월별 단계는 순차 진행처럼 보이지만, PM 관점에서는 범위·버전·검수 기준을 동시에 맞춰야 합니다.</a:t>
+            </a:r>
+          </a:p>
+        </p:txBody>
+      </p:sp>
+      <p:sp>
+        <p:nvSpPr>
+          <p:cNvPr id="8" name="timeline-line">
+            <a:extLst xmlns:a="http://schemas.openxmlformats.org/drawingml/2006/main">
+              <a:ext uri="{FF2B5EF4-FFF2-40B4-BE49-F238E27FC236}">
+                <a16:creationId xmlns:a16="http://schemas.microsoft.com/office/drawing/2014/main" id="{1AF8BC8D-223B-43A2-9E68-EF004A05E248}"/>
+              </a:ext>
+            </a:extLst>
+          </p:cNvPr>
+          <p:cNvSpPr>
+            <a:spLocks xmlns:a="http://schemas.openxmlformats.org/drawingml/2006/main" noGrp="1"/>
+          </p:cNvSpPr>
+          <p:nvPr/>
+        </p:nvSpPr>
+        <p:spPr>
+          <a:xfrm xmlns:a="http://schemas.openxmlformats.org/drawingml/2006/main">
+            <a:off x="781050" y="3400425"/>
+            <a:ext cx="9963150" cy="28575"/>
+          </a:xfrm>
+          <a:prstGeom xmlns:a="http://schemas.openxmlformats.org/drawingml/2006/main" prst="rect">
+            <a:avLst/>
+          </a:prstGeom>
+          <a:solidFill xmlns:a="http://schemas.openxmlformats.org/drawingml/2006/main">
+            <a:srgbClr val="2F3B55"/>
+          </a:solidFill>
+          <a:ln xmlns:a="http://schemas.openxmlformats.org/drawingml/2006/main" w="0">
+            <a:solidFill>
+              <a:srgbClr val="2F3B55"/>
+            </a:solidFill>
+            <a:prstDash val="solid"/>
+          </a:ln>
+        </p:spPr>
+      </p:sp>
+      <p:sp>
+        <p:nvSpPr>
+          <p:cNvPr id="9" name="timeline-card-1">
+            <a:extLst xmlns:a="http://schemas.openxmlformats.org/drawingml/2006/main">
+              <a:ext uri="{FF2B5EF4-FFF2-40B4-BE49-F238E27FC236}">
+                <a16:creationId xmlns:a16="http://schemas.microsoft.com/office/drawing/2014/main" id="{EFBFFD49-DD52-4A22-8ADE-37BE131635FA}"/>
+              </a:ext>
+            </a:extLst>
+          </p:cNvPr>
+          <p:cNvSpPr>
+            <a:spLocks xmlns:a="http://schemas.openxmlformats.org/drawingml/2006/main" noGrp="1"/>
+          </p:cNvSpPr>
+          <p:nvPr/>
+        </p:nvSpPr>
+        <p:spPr>
+          <a:xfrm xmlns:a="http://schemas.openxmlformats.org/drawingml/2006/main">
+            <a:off x="514350" y="2209800"/>
+            <a:ext cx="1581150" cy="2381250"/>
+          </a:xfrm>
+          <a:prstGeom xmlns:a="http://schemas.openxmlformats.org/drawingml/2006/main" prst="roundRect">
+            <a:avLst>
+              <a:gd name="adj" fmla="val 4819"/>
+            </a:avLst>
+          </a:prstGeom>
+          <a:solidFill xmlns:a="http://schemas.openxmlformats.org/drawingml/2006/main">
+            <a:srgbClr val="111827"/>
+          </a:solidFill>
+          <a:ln xmlns:a="http://schemas.openxmlformats.org/drawingml/2006/main" w="9525">
+            <a:solidFill>
+              <a:srgbClr val="2F3B55"/>
+            </a:solidFill>
+            <a:prstDash val="solid"/>
+          </a:ln>
+        </p:spPr>
+      </p:sp>
+      <p:sp>
+        <p:nvSpPr>
+          <p:cNvPr id="10" name="timeline-bar-1">
+            <a:extLst xmlns:a="http://schemas.openxmlformats.org/drawingml/2006/main">
+              <a:ext uri="{FF2B5EF4-FFF2-40B4-BE49-F238E27FC236}">
+                <a16:creationId xmlns:a16="http://schemas.microsoft.com/office/drawing/2014/main" id="{5A3401E8-7500-4EB5-8E2C-BB27C1F4A13A}"/>
+              </a:ext>
+            </a:extLst>
+          </p:cNvPr>
+          <p:cNvSpPr>
+            <a:spLocks xmlns:a="http://schemas.openxmlformats.org/drawingml/2006/main" noGrp="1"/>
+          </p:cNvSpPr>
+          <p:nvPr/>
+        </p:nvSpPr>
+        <p:spPr>
+          <a:xfrm xmlns:a="http://schemas.openxmlformats.org/drawingml/2006/main">
+            <a:off x="514350" y="2209800"/>
+            <a:ext cx="1581150" cy="66675"/>
+          </a:xfrm>
+          <a:prstGeom xmlns:a="http://schemas.openxmlformats.org/drawingml/2006/main" prst="rect">
+            <a:avLst/>
+          </a:prstGeom>
+          <a:solidFill xmlns:a="http://schemas.openxmlformats.org/drawingml/2006/main">
+            <a:srgbClr val="00B8D9"/>
+          </a:solidFill>
+          <a:ln xmlns:a="http://schemas.openxmlformats.org/drawingml/2006/main" w="0">
+            <a:solidFill>
+              <a:srgbClr val="00B8D9"/>
+            </a:solidFill>
+            <a:prstDash val="solid"/>
+          </a:ln>
+        </p:spPr>
+      </p:sp>
+      <p:sp>
+        <p:nvSpPr>
+          <p:cNvPr id="11" name="timeline-month-1">
+            <a:extLst xmlns:a="http://schemas.openxmlformats.org/drawingml/2006/main">
+              <a:ext uri="{FF2B5EF4-FFF2-40B4-BE49-F238E27FC236}">
+                <a16:creationId xmlns:a16="http://schemas.microsoft.com/office/drawing/2014/main" id="{703AAC99-3161-44FF-9822-7B87989DDD58}"/>
+              </a:ext>
+            </a:extLst>
+          </p:cNvPr>
+          <p:cNvSpPr>
+            <a:spLocks xmlns:a="http://schemas.openxmlformats.org/drawingml/2006/main" noGrp="1"/>
+          </p:cNvSpPr>
+          <p:nvPr/>
+        </p:nvSpPr>
+        <p:spPr>
+          <a:xfrm xmlns:a="http://schemas.openxmlformats.org/drawingml/2006/main">
+            <a:off x="666750" y="2438400"/>
+            <a:ext cx="666750" cy="228600"/>
+          </a:xfrm>
+          <a:prstGeom xmlns:a="http://schemas.openxmlformats.org/drawingml/2006/main" prst="rect">
+            <a:avLst/>
+          </a:prstGeom>
+          <a:noFill xmlns:a="http://schemas.openxmlformats.org/drawingml/2006/main"/>
+          <a:ln xmlns:a="http://schemas.openxmlformats.org/drawingml/2006/main" w="0">
+            <a:noFill/>
+            <a:prstDash val="solid"/>
+          </a:ln>
+        </p:spPr>
+        <p:txBody>
+          <a:bodyPr xmlns:a="http://schemas.openxmlformats.org/drawingml/2006/main"/>
+          <a:lstStyle xmlns:a="http://schemas.openxmlformats.org/drawingml/2006/main"/>
+          <a:p xmlns:a="http://schemas.openxmlformats.org/drawingml/2006/main">
+            <a:pPr>
+              <a:defRPr sz="1275" b="1">
+                <a:solidFill>
+                  <a:srgbClr val="00B8D9"/>
+                </a:solidFill>
+              </a:defRPr>
+            </a:pPr>
+            <a:r>
+              <a:rPr sz="1275" b="1">
+                <a:solidFill>
+                  <a:srgbClr val="00B8D9"/>
+                </a:solidFill>
+              </a:rPr>
+              <a:t>D-6M</a:t>
+            </a:r>
+          </a:p>
+        </p:txBody>
+      </p:sp>
+      <p:sp>
+        <p:nvSpPr>
+          <p:cNvPr id="12" name="timeline-title-1">
+            <a:extLst xmlns:a="http://schemas.openxmlformats.org/drawingml/2006/main">
+              <a:ext uri="{FF2B5EF4-FFF2-40B4-BE49-F238E27FC236}">
+                <a16:creationId xmlns:a16="http://schemas.microsoft.com/office/drawing/2014/main" id="{310E51D9-78D8-41E2-BD52-A6D90BB6F05E}"/>
+              </a:ext>
+            </a:extLst>
+          </p:cNvPr>
+          <p:cNvSpPr>
+            <a:spLocks xmlns:a="http://schemas.openxmlformats.org/drawingml/2006/main" noGrp="1"/>
+          </p:cNvSpPr>
+          <p:nvPr/>
+        </p:nvSpPr>
+        <p:spPr>
+          <a:xfrm xmlns:a="http://schemas.openxmlformats.org/drawingml/2006/main">
+            <a:off x="666750" y="2762250"/>
+            <a:ext cx="1257300" cy="457200"/>
+          </a:xfrm>
+          <a:prstGeom xmlns:a="http://schemas.openxmlformats.org/drawingml/2006/main" prst="rect">
+            <a:avLst/>
+          </a:prstGeom>
+          <a:noFill xmlns:a="http://schemas.openxmlformats.org/drawingml/2006/main"/>
+          <a:ln xmlns:a="http://schemas.openxmlformats.org/drawingml/2006/main" w="0">
+            <a:noFill/>
+            <a:prstDash val="solid"/>
+          </a:ln>
+        </p:spPr>
+        <p:txBody>
+          <a:bodyPr xmlns:a="http://schemas.openxmlformats.org/drawingml/2006/main"/>
+          <a:lstStyle xmlns:a="http://schemas.openxmlformats.org/drawingml/2006/main"/>
+          <a:p xmlns:a="http://schemas.openxmlformats.org/drawingml/2006/main">
+            <a:pPr>
+              <a:defRPr sz="1350" b="1">
+                <a:solidFill>
+                  <a:srgbClr val="FFFFFF"/>
+                </a:solidFill>
+              </a:defRPr>
+            </a:pPr>
+            <a:r>
+              <a:rPr sz="1350" b="1">
+                <a:solidFill>
+                  <a:srgbClr val="FFFFFF"/>
+                </a:solidFill>
+              </a:rPr>
+              <a:t>런칭 범위 확정</a:t>
+            </a:r>
+          </a:p>
+        </p:txBody>
+      </p:sp>
+      <p:sp>
+        <p:nvSpPr>
+          <p:cNvPr id="13" name="timeline-dot-1-1">
+            <a:extLst xmlns:a="http://schemas.openxmlformats.org/drawingml/2006/main">
+              <a:ext uri="{FF2B5EF4-FFF2-40B4-BE49-F238E27FC236}">
+                <a16:creationId xmlns:a16="http://schemas.microsoft.com/office/drawing/2014/main" id="{2545BA35-18C3-4855-B268-0F93E7310E76}"/>
+              </a:ext>
+            </a:extLst>
+          </p:cNvPr>
+          <p:cNvSpPr>
+            <a:spLocks xmlns:a="http://schemas.openxmlformats.org/drawingml/2006/main" noGrp="1"/>
+          </p:cNvSpPr>
+          <p:nvPr/>
+        </p:nvSpPr>
+        <p:spPr>
+          <a:xfrm xmlns:a="http://schemas.openxmlformats.org/drawingml/2006/main">
+            <a:off x="666750" y="3371850"/>
+            <a:ext cx="114300" cy="209550"/>
+          </a:xfrm>
+          <a:prstGeom xmlns:a="http://schemas.openxmlformats.org/drawingml/2006/main" prst="rect">
+            <a:avLst/>
+          </a:prstGeom>
+          <a:noFill xmlns:a="http://schemas.openxmlformats.org/drawingml/2006/main"/>
+          <a:ln xmlns:a="http://schemas.openxmlformats.org/drawingml/2006/main" w="0">
+            <a:noFill/>
+            <a:prstDash val="solid"/>
+          </a:ln>
+        </p:spPr>
+        <p:txBody>
+          <a:bodyPr xmlns:a="http://schemas.openxmlformats.org/drawingml/2006/main"/>
+          <a:lstStyle xmlns:a="http://schemas.openxmlformats.org/drawingml/2006/main"/>
+          <a:p xmlns:a="http://schemas.openxmlformats.org/drawingml/2006/main">
+            <a:pPr>
+              <a:defRPr sz="1350" b="1">
+                <a:solidFill>
+                  <a:srgbClr val="00B8D9"/>
+                </a:solidFill>
+              </a:defRPr>
+            </a:pPr>
+            <a:r>
+              <a:rPr sz="1350" b="1">
+                <a:solidFill>
+                  <a:srgbClr val="00B8D9"/>
+                </a:solidFill>
+              </a:rPr>
+              <a:t>·</a:t>
+            </a:r>
+          </a:p>
+        </p:txBody>
+      </p:sp>
+      <p:sp>
+        <p:nvSpPr>
+          <p:cNvPr id="14" name="timeline-item-1-1">
+            <a:extLst xmlns:a="http://schemas.openxmlformats.org/drawingml/2006/main">
+              <a:ext uri="{FF2B5EF4-FFF2-40B4-BE49-F238E27FC236}">
+                <a16:creationId xmlns:a16="http://schemas.microsoft.com/office/drawing/2014/main" id="{C3BF3712-6DCB-452E-9361-31439A5109C9}"/>
+              </a:ext>
+            </a:extLst>
+          </p:cNvPr>
+          <p:cNvSpPr>
+            <a:spLocks xmlns:a="http://schemas.openxmlformats.org/drawingml/2006/main" noGrp="1"/>
+          </p:cNvSpPr>
+          <p:nvPr/>
+        </p:nvSpPr>
+        <p:spPr>
+          <a:xfrm xmlns:a="http://schemas.openxmlformats.org/drawingml/2006/main">
+            <a:off x="800100" y="3400425"/>
+            <a:ext cx="1123950" cy="285750"/>
+          </a:xfrm>
+          <a:prstGeom xmlns:a="http://schemas.openxmlformats.org/drawingml/2006/main" prst="rect">
+            <a:avLst/>
+          </a:prstGeom>
+          <a:noFill xmlns:a="http://schemas.openxmlformats.org/drawingml/2006/main"/>
+          <a:ln xmlns:a="http://schemas.openxmlformats.org/drawingml/2006/main" w="0">
+            <a:noFill/>
+            <a:prstDash val="solid"/>
+          </a:ln>
+        </p:spPr>
+        <p:txBody>
+          <a:bodyPr xmlns:a="http://schemas.openxmlformats.org/drawingml/2006/main"/>
+          <a:lstStyle xmlns:a="http://schemas.openxmlformats.org/drawingml/2006/main"/>
+          <a:p xmlns:a="http://schemas.openxmlformats.org/drawingml/2006/main">
+            <a:pPr>
+              <a:defRPr sz="938">
+                <a:solidFill>
+                  <a:srgbClr val="CBD5E1"/>
+                </a:solidFill>
+              </a:defRPr>
+            </a:pPr>
+            <a:r>
+              <a:rPr sz="938">
+                <a:solidFill>
+                  <a:srgbClr val="CBD5E1"/>
+                </a:solidFill>
+              </a:rPr>
+              <a:t>일본 서비스 범위</a:t>
+            </a:r>
+          </a:p>
+        </p:txBody>
+      </p:sp>
+      <p:sp>
+        <p:nvSpPr>
+          <p:cNvPr id="15" name="timeline-dot-1-2">
+            <a:extLst xmlns:a="http://schemas.openxmlformats.org/drawingml/2006/main">
+              <a:ext uri="{FF2B5EF4-FFF2-40B4-BE49-F238E27FC236}">
+                <a16:creationId xmlns:a16="http://schemas.microsoft.com/office/drawing/2014/main" id="{BAE03365-4177-4DBF-93B3-32C74B6B9703}"/>
+              </a:ext>
+            </a:extLst>
+          </p:cNvPr>
+          <p:cNvSpPr>
+            <a:spLocks xmlns:a="http://schemas.openxmlformats.org/drawingml/2006/main" noGrp="1"/>
+          </p:cNvSpPr>
+          <p:nvPr/>
+        </p:nvSpPr>
+        <p:spPr>
+          <a:xfrm xmlns:a="http://schemas.openxmlformats.org/drawingml/2006/main">
+            <a:off x="666750" y="3695700"/>
+            <a:ext cx="114300" cy="209550"/>
+          </a:xfrm>
+          <a:prstGeom xmlns:a="http://schemas.openxmlformats.org/drawingml/2006/main" prst="rect">
+            <a:avLst/>
+          </a:prstGeom>
+          <a:noFill xmlns:a="http://schemas.openxmlformats.org/drawingml/2006/main"/>
+          <a:ln xmlns:a="http://schemas.openxmlformats.org/drawingml/2006/main" w="0">
+            <a:noFill/>
+            <a:prstDash val="solid"/>
+          </a:ln>
+        </p:spPr>
+        <p:txBody>
+          <a:bodyPr xmlns:a="http://schemas.openxmlformats.org/drawingml/2006/main"/>
+          <a:lstStyle xmlns:a="http://schemas.openxmlformats.org/drawingml/2006/main"/>
+          <a:p xmlns:a="http://schemas.openxmlformats.org/drawingml/2006/main">
+            <a:pPr>
+              <a:defRPr sz="1350" b="1">
+                <a:solidFill>
+                  <a:srgbClr val="00B8D9"/>
+                </a:solidFill>
+              </a:defRPr>
+            </a:pPr>
+            <a:r>
+              <a:rPr sz="1350" b="1">
+                <a:solidFill>
+                  <a:srgbClr val="00B8D9"/>
+                </a:solidFill>
+              </a:rPr>
+              <a:t>·</a:t>
+            </a:r>
+          </a:p>
+        </p:txBody>
+      </p:sp>
+      <p:sp>
+        <p:nvSpPr>
+          <p:cNvPr id="16" name="timeline-item-1-2">
+            <a:extLst xmlns:a="http://schemas.openxmlformats.org/drawingml/2006/main">
+              <a:ext uri="{FF2B5EF4-FFF2-40B4-BE49-F238E27FC236}">
+                <a16:creationId xmlns:a16="http://schemas.microsoft.com/office/drawing/2014/main" id="{C72E1EAB-6587-4DFC-A7E0-5CA9317DFCF4}"/>
+              </a:ext>
+            </a:extLst>
+          </p:cNvPr>
+          <p:cNvSpPr>
+            <a:spLocks xmlns:a="http://schemas.openxmlformats.org/drawingml/2006/main" noGrp="1"/>
+          </p:cNvSpPr>
+          <p:nvPr/>
+        </p:nvSpPr>
+        <p:spPr>
+          <a:xfrm xmlns:a="http://schemas.openxmlformats.org/drawingml/2006/main">
+            <a:off x="800100" y="3724275"/>
+            <a:ext cx="1123950" cy="285750"/>
+          </a:xfrm>
+          <a:prstGeom xmlns:a="http://schemas.openxmlformats.org/drawingml/2006/main" prst="rect">
+            <a:avLst/>
+          </a:prstGeom>
+          <a:noFill xmlns:a="http://schemas.openxmlformats.org/drawingml/2006/main"/>
+          <a:ln xmlns:a="http://schemas.openxmlformats.org/drawingml/2006/main" w="0">
+            <a:noFill/>
+            <a:prstDash val="solid"/>
+          </a:ln>
+        </p:spPr>
+        <p:txBody>
+          <a:bodyPr xmlns:a="http://schemas.openxmlformats.org/drawingml/2006/main"/>
+          <a:lstStyle xmlns:a="http://schemas.openxmlformats.org/drawingml/2006/main"/>
+          <a:p xmlns:a="http://schemas.openxmlformats.org/drawingml/2006/main">
+            <a:pPr>
+              <a:defRPr sz="938">
+                <a:solidFill>
+                  <a:srgbClr val="CBD5E1"/>
+                </a:solidFill>
+              </a:defRPr>
+            </a:pPr>
+            <a:r>
+              <a:rPr sz="938">
+                <a:solidFill>
+                  <a:srgbClr val="CBD5E1"/>
+                </a:solidFill>
+              </a:rPr>
+              <a:t>주요 콘텐츠 기준</a:t>
+            </a:r>
+          </a:p>
+        </p:txBody>
+      </p:sp>
+      <p:sp>
+        <p:nvSpPr>
+          <p:cNvPr id="17" name="timeline-dot-1-3">
+            <a:extLst xmlns:a="http://schemas.openxmlformats.org/drawingml/2006/main">
+              <a:ext uri="{FF2B5EF4-FFF2-40B4-BE49-F238E27FC236}">
+                <a16:creationId xmlns:a16="http://schemas.microsoft.com/office/drawing/2014/main" id="{4EB239D0-99D9-478C-AB5A-4C3346BBCB5E}"/>
+              </a:ext>
+            </a:extLst>
+          </p:cNvPr>
+          <p:cNvSpPr>
+            <a:spLocks xmlns:a="http://schemas.openxmlformats.org/drawingml/2006/main" noGrp="1"/>
+          </p:cNvSpPr>
+          <p:nvPr/>
+        </p:nvSpPr>
+        <p:spPr>
+          <a:xfrm xmlns:a="http://schemas.openxmlformats.org/drawingml/2006/main">
+            <a:off x="666750" y="4019550"/>
+            <a:ext cx="114300" cy="209550"/>
+          </a:xfrm>
+          <a:prstGeom xmlns:a="http://schemas.openxmlformats.org/drawingml/2006/main" prst="rect">
+            <a:avLst/>
+          </a:prstGeom>
+          <a:noFill xmlns:a="http://schemas.openxmlformats.org/drawingml/2006/main"/>
+          <a:ln xmlns:a="http://schemas.openxmlformats.org/drawingml/2006/main" w="0">
+            <a:noFill/>
+            <a:prstDash val="solid"/>
+          </a:ln>
+        </p:spPr>
+        <p:txBody>
+          <a:bodyPr xmlns:a="http://schemas.openxmlformats.org/drawingml/2006/main"/>
+          <a:lstStyle xmlns:a="http://schemas.openxmlformats.org/drawingml/2006/main"/>
+          <a:p xmlns:a="http://schemas.openxmlformats.org/drawingml/2006/main">
+            <a:pPr>
+              <a:defRPr sz="1350" b="1">
+                <a:solidFill>
+                  <a:srgbClr val="00B8D9"/>
+                </a:solidFill>
+              </a:defRPr>
+            </a:pPr>
+            <a:r>
+              <a:rPr sz="1350" b="1">
+                <a:solidFill>
+                  <a:srgbClr val="00B8D9"/>
+                </a:solidFill>
+              </a:rPr>
+              <a:t>·</a:t>
+            </a:r>
+          </a:p>
+        </p:txBody>
+      </p:sp>
+      <p:sp>
+        <p:nvSpPr>
+          <p:cNvPr id="18" name="timeline-item-1-3">
+            <a:extLst xmlns:a="http://schemas.openxmlformats.org/drawingml/2006/main">
+              <a:ext uri="{FF2B5EF4-FFF2-40B4-BE49-F238E27FC236}">
+                <a16:creationId xmlns:a16="http://schemas.microsoft.com/office/drawing/2014/main" id="{CD947CD6-1804-424A-A055-55F33C68C8E0}"/>
+              </a:ext>
+            </a:extLst>
+          </p:cNvPr>
+          <p:cNvSpPr>
+            <a:spLocks xmlns:a="http://schemas.openxmlformats.org/drawingml/2006/main" noGrp="1"/>
+          </p:cNvSpPr>
+          <p:nvPr/>
+        </p:nvSpPr>
+        <p:spPr>
+          <a:xfrm xmlns:a="http://schemas.openxmlformats.org/drawingml/2006/main">
+            <a:off x="800100" y="4048125"/>
+            <a:ext cx="1123950" cy="285750"/>
+          </a:xfrm>
+          <a:prstGeom xmlns:a="http://schemas.openxmlformats.org/drawingml/2006/main" prst="rect">
+            <a:avLst/>
+          </a:prstGeom>
+          <a:noFill xmlns:a="http://schemas.openxmlformats.org/drawingml/2006/main"/>
+          <a:ln xmlns:a="http://schemas.openxmlformats.org/drawingml/2006/main" w="0">
+            <a:noFill/>
+            <a:prstDash val="solid"/>
+          </a:ln>
+        </p:spPr>
+        <p:txBody>
+          <a:bodyPr xmlns:a="http://schemas.openxmlformats.org/drawingml/2006/main"/>
+          <a:lstStyle xmlns:a="http://schemas.openxmlformats.org/drawingml/2006/main"/>
+          <a:p xmlns:a="http://schemas.openxmlformats.org/drawingml/2006/main">
+            <a:pPr>
+              <a:defRPr sz="938">
+                <a:solidFill>
+                  <a:srgbClr val="CBD5E1"/>
+                </a:solidFill>
+              </a:defRPr>
+            </a:pPr>
+            <a:r>
+              <a:rPr sz="938">
+                <a:solidFill>
+                  <a:srgbClr val="CBD5E1"/>
+                </a:solidFill>
+              </a:rPr>
+              <a:t>브랜치 운영 원칙</a:t>
+            </a:r>
+          </a:p>
+        </p:txBody>
+      </p:sp>
+      <p:sp>
+        <p:nvSpPr>
+          <p:cNvPr id="19" name="timeline-card-2">
+            <a:extLst xmlns:a="http://schemas.openxmlformats.org/drawingml/2006/main">
+              <a:ext uri="{FF2B5EF4-FFF2-40B4-BE49-F238E27FC236}">
+                <a16:creationId xmlns:a16="http://schemas.microsoft.com/office/drawing/2014/main" id="{A6A5FF29-6E45-4EAB-9E78-33592C55CDE7}"/>
+              </a:ext>
+            </a:extLst>
+          </p:cNvPr>
+          <p:cNvSpPr>
+            <a:spLocks xmlns:a="http://schemas.openxmlformats.org/drawingml/2006/main" noGrp="1"/>
+          </p:cNvSpPr>
+          <p:nvPr/>
+        </p:nvSpPr>
+        <p:spPr>
+          <a:xfrm xmlns:a="http://schemas.openxmlformats.org/drawingml/2006/main">
+            <a:off x="2324100" y="2209800"/>
+            <a:ext cx="1581150" cy="2381250"/>
+          </a:xfrm>
+          <a:prstGeom xmlns:a="http://schemas.openxmlformats.org/drawingml/2006/main" prst="roundRect">
+            <a:avLst>
+              <a:gd name="adj" fmla="val 4819"/>
+            </a:avLst>
+          </a:prstGeom>
+          <a:solidFill xmlns:a="http://schemas.openxmlformats.org/drawingml/2006/main">
+            <a:srgbClr val="111827"/>
+          </a:solidFill>
+          <a:ln xmlns:a="http://schemas.openxmlformats.org/drawingml/2006/main" w="9525">
+            <a:solidFill>
+              <a:srgbClr val="2F3B55"/>
+            </a:solidFill>
+            <a:prstDash val="solid"/>
+          </a:ln>
+        </p:spPr>
+      </p:sp>
+      <p:sp>
+        <p:nvSpPr>
+          <p:cNvPr id="20" name="timeline-bar-2">
+            <a:extLst xmlns:a="http://schemas.openxmlformats.org/drawingml/2006/main">
+              <a:ext uri="{FF2B5EF4-FFF2-40B4-BE49-F238E27FC236}">
+                <a16:creationId xmlns:a16="http://schemas.microsoft.com/office/drawing/2014/main" id="{195578C6-DF0A-417B-8993-D858D5074EFE}"/>
+              </a:ext>
+            </a:extLst>
+          </p:cNvPr>
+          <p:cNvSpPr>
+            <a:spLocks xmlns:a="http://schemas.openxmlformats.org/drawingml/2006/main" noGrp="1"/>
+          </p:cNvSpPr>
+          <p:nvPr/>
+        </p:nvSpPr>
+        <p:spPr>
+          <a:xfrm xmlns:a="http://schemas.openxmlformats.org/drawingml/2006/main">
+            <a:off x="2324100" y="2209800"/>
+            <a:ext cx="1581150" cy="66675"/>
+          </a:xfrm>
+          <a:prstGeom xmlns:a="http://schemas.openxmlformats.org/drawingml/2006/main" prst="rect">
+            <a:avLst/>
+          </a:prstGeom>
+          <a:solidFill xmlns:a="http://schemas.openxmlformats.org/drawingml/2006/main">
+            <a:srgbClr val="FF6B35"/>
+          </a:solidFill>
+          <a:ln xmlns:a="http://schemas.openxmlformats.org/drawingml/2006/main" w="0">
+            <a:solidFill>
+              <a:srgbClr val="FF6B35"/>
+            </a:solidFill>
+            <a:prstDash val="solid"/>
+          </a:ln>
+        </p:spPr>
+      </p:sp>
+      <p:sp>
+        <p:nvSpPr>
+          <p:cNvPr id="21" name="timeline-month-2">
+            <a:extLst xmlns:a="http://schemas.openxmlformats.org/drawingml/2006/main">
+              <a:ext uri="{FF2B5EF4-FFF2-40B4-BE49-F238E27FC236}">
+                <a16:creationId xmlns:a16="http://schemas.microsoft.com/office/drawing/2014/main" id="{2F94A874-4DB0-4CA3-83CA-394EFD5BA16E}"/>
+              </a:ext>
+            </a:extLst>
+          </p:cNvPr>
+          <p:cNvSpPr>
+            <a:spLocks xmlns:a="http://schemas.openxmlformats.org/drawingml/2006/main" noGrp="1"/>
+          </p:cNvSpPr>
+          <p:nvPr/>
+        </p:nvSpPr>
+        <p:spPr>
+          <a:xfrm xmlns:a="http://schemas.openxmlformats.org/drawingml/2006/main">
+            <a:off x="2476500" y="2438400"/>
+            <a:ext cx="666750" cy="228600"/>
+          </a:xfrm>
+          <a:prstGeom xmlns:a="http://schemas.openxmlformats.org/drawingml/2006/main" prst="rect">
+            <a:avLst/>
+          </a:prstGeom>
+          <a:noFill xmlns:a="http://schemas.openxmlformats.org/drawingml/2006/main"/>
+          <a:ln xmlns:a="http://schemas.openxmlformats.org/drawingml/2006/main" w="0">
+            <a:noFill/>
+            <a:prstDash val="solid"/>
+          </a:ln>
+        </p:spPr>
+        <p:txBody>
+          <a:bodyPr xmlns:a="http://schemas.openxmlformats.org/drawingml/2006/main"/>
+          <a:lstStyle xmlns:a="http://schemas.openxmlformats.org/drawingml/2006/main"/>
+          <a:p xmlns:a="http://schemas.openxmlformats.org/drawingml/2006/main">
+            <a:pPr>
+              <a:defRPr sz="1275" b="1">
+                <a:solidFill>
+                  <a:srgbClr val="FF6B35"/>
+                </a:solidFill>
+              </a:defRPr>
+            </a:pPr>
+            <a:r>
+              <a:rPr sz="1275" b="1">
+                <a:solidFill>
+                  <a:srgbClr val="FF6B35"/>
+                </a:solidFill>
+              </a:rPr>
+              <a:t>D-5M</a:t>
+            </a:r>
+          </a:p>
+        </p:txBody>
+      </p:sp>
+      <p:sp>
+        <p:nvSpPr>
+          <p:cNvPr id="22" name="timeline-title-2">
+            <a:extLst xmlns:a="http://schemas.openxmlformats.org/drawingml/2006/main">
+              <a:ext uri="{FF2B5EF4-FFF2-40B4-BE49-F238E27FC236}">
+                <a16:creationId xmlns:a16="http://schemas.microsoft.com/office/drawing/2014/main" id="{76C5231A-93DB-45B9-86B3-CEFBF886ACEB}"/>
+              </a:ext>
+            </a:extLst>
+          </p:cNvPr>
+          <p:cNvSpPr>
+            <a:spLocks xmlns:a="http://schemas.openxmlformats.org/drawingml/2006/main" noGrp="1"/>
+          </p:cNvSpPr>
+          <p:nvPr/>
+        </p:nvSpPr>
+        <p:spPr>
+          <a:xfrm xmlns:a="http://schemas.openxmlformats.org/drawingml/2006/main">
+            <a:off x="2476500" y="2762250"/>
+            <a:ext cx="1257300" cy="457200"/>
+          </a:xfrm>
+          <a:prstGeom xmlns:a="http://schemas.openxmlformats.org/drawingml/2006/main" prst="rect">
+            <a:avLst/>
+          </a:prstGeom>
+          <a:noFill xmlns:a="http://schemas.openxmlformats.org/drawingml/2006/main"/>
+          <a:ln xmlns:a="http://schemas.openxmlformats.org/drawingml/2006/main" w="0">
+            <a:noFill/>
+            <a:prstDash val="solid"/>
+          </a:ln>
+        </p:spPr>
+        <p:txBody>
+          <a:bodyPr xmlns:a="http://schemas.openxmlformats.org/drawingml/2006/main"/>
+          <a:lstStyle xmlns:a="http://schemas.openxmlformats.org/drawingml/2006/main"/>
+          <a:p xmlns:a="http://schemas.openxmlformats.org/drawingml/2006/main">
+            <a:pPr>
+              <a:defRPr sz="1350" b="1">
+                <a:solidFill>
+                  <a:srgbClr val="FFFFFF"/>
+                </a:solidFill>
+              </a:defRPr>
+            </a:pPr>
+            <a:r>
+              <a:rPr sz="1350" b="1">
+                <a:solidFill>
+                  <a:srgbClr val="FFFFFF"/>
+                </a:solidFill>
+              </a:rPr>
+              <a:t>개발·현지화 동기화</a:t>
+            </a:r>
+          </a:p>
+        </p:txBody>
+      </p:sp>
+      <p:sp>
+        <p:nvSpPr>
+          <p:cNvPr id="23" name="timeline-dot-2-1">
+            <a:extLst xmlns:a="http://schemas.openxmlformats.org/drawingml/2006/main">
+              <a:ext uri="{FF2B5EF4-FFF2-40B4-BE49-F238E27FC236}">
+                <a16:creationId xmlns:a16="http://schemas.microsoft.com/office/drawing/2014/main" id="{020463C6-BC47-48BF-8E26-D5597B163F5B}"/>
+              </a:ext>
+            </a:extLst>
+          </p:cNvPr>
+          <p:cNvSpPr>
+            <a:spLocks xmlns:a="http://schemas.openxmlformats.org/drawingml/2006/main" noGrp="1"/>
+          </p:cNvSpPr>
+          <p:nvPr/>
+        </p:nvSpPr>
+        <p:spPr>
+          <a:xfrm xmlns:a="http://schemas.openxmlformats.org/drawingml/2006/main">
+            <a:off x="2476500" y="3371850"/>
+            <a:ext cx="114300" cy="209550"/>
+          </a:xfrm>
+          <a:prstGeom xmlns:a="http://schemas.openxmlformats.org/drawingml/2006/main" prst="rect">
+            <a:avLst/>
+          </a:prstGeom>
+          <a:noFill xmlns:a="http://schemas.openxmlformats.org/drawingml/2006/main"/>
+          <a:ln xmlns:a="http://schemas.openxmlformats.org/drawingml/2006/main" w="0">
+            <a:noFill/>
+            <a:prstDash val="solid"/>
+          </a:ln>
+        </p:spPr>
+        <p:txBody>
+          <a:bodyPr xmlns:a="http://schemas.openxmlformats.org/drawingml/2006/main"/>
+          <a:lstStyle xmlns:a="http://schemas.openxmlformats.org/drawingml/2006/main"/>
+          <a:p xmlns:a="http://schemas.openxmlformats.org/drawingml/2006/main">
+            <a:pPr>
+              <a:defRPr sz="1350" b="1">
+                <a:solidFill>
+                  <a:srgbClr val="FF6B35"/>
+                </a:solidFill>
+              </a:defRPr>
+            </a:pPr>
+            <a:r>
+              <a:rPr sz="1350" b="1">
+                <a:solidFill>
+                  <a:srgbClr val="FF6B35"/>
+                </a:solidFill>
+              </a:rPr>
+              <a:t>·</a:t>
+            </a:r>
+          </a:p>
+        </p:txBody>
+      </p:sp>
+      <p:sp>
+        <p:nvSpPr>
+          <p:cNvPr id="24" name="timeline-item-2-1">
+            <a:extLst xmlns:a="http://schemas.openxmlformats.org/drawingml/2006/main">
+              <a:ext uri="{FF2B5EF4-FFF2-40B4-BE49-F238E27FC236}">
+                <a16:creationId xmlns:a16="http://schemas.microsoft.com/office/drawing/2014/main" id="{3601A83A-6A0D-4219-922A-88584211CE82}"/>
+              </a:ext>
+            </a:extLst>
+          </p:cNvPr>
+          <p:cNvSpPr>
+            <a:spLocks xmlns:a="http://schemas.openxmlformats.org/drawingml/2006/main" noGrp="1"/>
+          </p:cNvSpPr>
+          <p:nvPr/>
+        </p:nvSpPr>
+        <p:spPr>
+          <a:xfrm xmlns:a="http://schemas.openxmlformats.org/drawingml/2006/main">
+            <a:off x="2609850" y="3400425"/>
+            <a:ext cx="1123950" cy="285750"/>
+          </a:xfrm>
+          <a:prstGeom xmlns:a="http://schemas.openxmlformats.org/drawingml/2006/main" prst="rect">
+            <a:avLst/>
+          </a:prstGeom>
+          <a:noFill xmlns:a="http://schemas.openxmlformats.org/drawingml/2006/main"/>
+          <a:ln xmlns:a="http://schemas.openxmlformats.org/drawingml/2006/main" w="0">
+            <a:noFill/>
+            <a:prstDash val="solid"/>
+          </a:ln>
+        </p:spPr>
+        <p:txBody>
+          <a:bodyPr xmlns:a="http://schemas.openxmlformats.org/drawingml/2006/main"/>
+          <a:lstStyle xmlns:a="http://schemas.openxmlformats.org/drawingml/2006/main"/>
+          <a:p xmlns:a="http://schemas.openxmlformats.org/drawingml/2006/main">
+            <a:pPr>
+              <a:defRPr sz="938">
+                <a:solidFill>
+                  <a:srgbClr val="CBD5E1"/>
+                </a:solidFill>
+              </a:defRPr>
+            </a:pPr>
+            <a:r>
+              <a:rPr sz="938">
+                <a:solidFill>
+                  <a:srgbClr val="CBD5E1"/>
+                </a:solidFill>
+              </a:rPr>
+              <a:t>번역·리소스 반영</a:t>
+            </a:r>
+          </a:p>
+        </p:txBody>
+      </p:sp>
+      <p:sp>
+        <p:nvSpPr>
+          <p:cNvPr id="25" name="timeline-dot-2-2">
+            <a:extLst xmlns:a="http://schemas.openxmlformats.org/drawingml/2006/main">
+              <a:ext uri="{FF2B5EF4-FFF2-40B4-BE49-F238E27FC236}">
+                <a16:creationId xmlns:a16="http://schemas.microsoft.com/office/drawing/2014/main" id="{DBCA3854-95EB-4A81-8013-74D58CFF98D3}"/>
+              </a:ext>
+            </a:extLst>
+          </p:cNvPr>
+          <p:cNvSpPr>
+            <a:spLocks xmlns:a="http://schemas.openxmlformats.org/drawingml/2006/main" noGrp="1"/>
+          </p:cNvSpPr>
+          <p:nvPr/>
+        </p:nvSpPr>
+        <p:spPr>
+          <a:xfrm xmlns:a="http://schemas.openxmlformats.org/drawingml/2006/main">
+            <a:off x="2476500" y="3695700"/>
+            <a:ext cx="114300" cy="209550"/>
+          </a:xfrm>
+          <a:prstGeom xmlns:a="http://schemas.openxmlformats.org/drawingml/2006/main" prst="rect">
+            <a:avLst/>
+          </a:prstGeom>
+          <a:noFill xmlns:a="http://schemas.openxmlformats.org/drawingml/2006/main"/>
+          <a:ln xmlns:a="http://schemas.openxmlformats.org/drawingml/2006/main" w="0">
+            <a:noFill/>
+            <a:prstDash val="solid"/>
+          </a:ln>
+        </p:spPr>
+        <p:txBody>
+          <a:bodyPr xmlns:a="http://schemas.openxmlformats.org/drawingml/2006/main"/>
+          <a:lstStyle xmlns:a="http://schemas.openxmlformats.org/drawingml/2006/main"/>
+          <a:p xmlns:a="http://schemas.openxmlformats.org/drawingml/2006/main">
+            <a:pPr>
+              <a:defRPr sz="1350" b="1">
+                <a:solidFill>
+                  <a:srgbClr val="FF6B35"/>
+                </a:solidFill>
+              </a:defRPr>
+            </a:pPr>
+            <a:r>
+              <a:rPr sz="1350" b="1">
+                <a:solidFill>
+                  <a:srgbClr val="FF6B35"/>
+                </a:solidFill>
+              </a:rPr>
+              <a:t>·</a:t>
+            </a:r>
+          </a:p>
+        </p:txBody>
+      </p:sp>
+      <p:sp>
+        <p:nvSpPr>
+          <p:cNvPr id="26" name="timeline-item-2-2">
+            <a:extLst xmlns:a="http://schemas.openxmlformats.org/drawingml/2006/main">
+              <a:ext uri="{FF2B5EF4-FFF2-40B4-BE49-F238E27FC236}">
+                <a16:creationId xmlns:a16="http://schemas.microsoft.com/office/drawing/2014/main" id="{95A3EB83-2426-4D0C-9654-94ECA511AC99}"/>
+              </a:ext>
+            </a:extLst>
+          </p:cNvPr>
+          <p:cNvSpPr>
+            <a:spLocks xmlns:a="http://schemas.openxmlformats.org/drawingml/2006/main" noGrp="1"/>
+          </p:cNvSpPr>
+          <p:nvPr/>
+        </p:nvSpPr>
+        <p:spPr>
+          <a:xfrm xmlns:a="http://schemas.openxmlformats.org/drawingml/2006/main">
+            <a:off x="2609850" y="3724275"/>
+            <a:ext cx="1123950" cy="285750"/>
+          </a:xfrm>
+          <a:prstGeom xmlns:a="http://schemas.openxmlformats.org/drawingml/2006/main" prst="rect">
+            <a:avLst/>
+          </a:prstGeom>
+          <a:noFill xmlns:a="http://schemas.openxmlformats.org/drawingml/2006/main"/>
+          <a:ln xmlns:a="http://schemas.openxmlformats.org/drawingml/2006/main" w="0">
+            <a:noFill/>
+            <a:prstDash val="solid"/>
+          </a:ln>
+        </p:spPr>
+        <p:txBody>
+          <a:bodyPr xmlns:a="http://schemas.openxmlformats.org/drawingml/2006/main"/>
+          <a:lstStyle xmlns:a="http://schemas.openxmlformats.org/drawingml/2006/main"/>
+          <a:p xmlns:a="http://schemas.openxmlformats.org/drawingml/2006/main">
+            <a:pPr>
+              <a:defRPr sz="938">
+                <a:solidFill>
+                  <a:srgbClr val="CBD5E1"/>
+                </a:solidFill>
+              </a:defRPr>
+            </a:pPr>
+            <a:r>
+              <a:rPr sz="938">
+                <a:solidFill>
+                  <a:srgbClr val="CBD5E1"/>
+                </a:solidFill>
+              </a:rPr>
+              <a:t>퍼블리셔 요청 정리</a:t>
+            </a:r>
+          </a:p>
+        </p:txBody>
+      </p:sp>
+      <p:sp>
+        <p:nvSpPr>
+          <p:cNvPr id="27" name="timeline-dot-2-3">
+            <a:extLst xmlns:a="http://schemas.openxmlformats.org/drawingml/2006/main">
+              <a:ext uri="{FF2B5EF4-FFF2-40B4-BE49-F238E27FC236}">
+                <a16:creationId xmlns:a16="http://schemas.microsoft.com/office/drawing/2014/main" id="{E89A61DA-D74F-4394-AA66-6EAC342B81E2}"/>
+              </a:ext>
+            </a:extLst>
+          </p:cNvPr>
+          <p:cNvSpPr>
+            <a:spLocks xmlns:a="http://schemas.openxmlformats.org/drawingml/2006/main" noGrp="1"/>
+          </p:cNvSpPr>
+          <p:nvPr/>
+        </p:nvSpPr>
+        <p:spPr>
+          <a:xfrm xmlns:a="http://schemas.openxmlformats.org/drawingml/2006/main">
+            <a:off x="2476500" y="4019550"/>
+            <a:ext cx="114300" cy="209550"/>
+          </a:xfrm>
+          <a:prstGeom xmlns:a="http://schemas.openxmlformats.org/drawingml/2006/main" prst="rect">
+            <a:avLst/>
+          </a:prstGeom>
+          <a:noFill xmlns:a="http://schemas.openxmlformats.org/drawingml/2006/main"/>
+          <a:ln xmlns:a="http://schemas.openxmlformats.org/drawingml/2006/main" w="0">
+            <a:noFill/>
+            <a:prstDash val="solid"/>
+          </a:ln>
+        </p:spPr>
+        <p:txBody>
+          <a:bodyPr xmlns:a="http://schemas.openxmlformats.org/drawingml/2006/main"/>
+          <a:lstStyle xmlns:a="http://schemas.openxmlformats.org/drawingml/2006/main"/>
+          <a:p xmlns:a="http://schemas.openxmlformats.org/drawingml/2006/main">
+            <a:pPr>
+              <a:defRPr sz="1350" b="1">
+                <a:solidFill>
+                  <a:srgbClr val="FF6B35"/>
+                </a:solidFill>
+              </a:defRPr>
+            </a:pPr>
+            <a:r>
+              <a:rPr sz="1350" b="1">
+                <a:solidFill>
+                  <a:srgbClr val="FF6B35"/>
+                </a:solidFill>
+              </a:rPr>
+              <a:t>·</a:t>
+            </a:r>
+          </a:p>
+        </p:txBody>
+      </p:sp>
+      <p:sp>
+        <p:nvSpPr>
+          <p:cNvPr id="28" name="timeline-item-2-3">
+            <a:extLst xmlns:a="http://schemas.openxmlformats.org/drawingml/2006/main">
+              <a:ext uri="{FF2B5EF4-FFF2-40B4-BE49-F238E27FC236}">
+                <a16:creationId xmlns:a16="http://schemas.microsoft.com/office/drawing/2014/main" id="{5B3A70E0-2073-4398-AA10-6696199C42FE}"/>
+              </a:ext>
+            </a:extLst>
+          </p:cNvPr>
+          <p:cNvSpPr>
+            <a:spLocks xmlns:a="http://schemas.openxmlformats.org/drawingml/2006/main" noGrp="1"/>
+          </p:cNvSpPr>
+          <p:nvPr/>
+        </p:nvSpPr>
+        <p:spPr>
+          <a:xfrm xmlns:a="http://schemas.openxmlformats.org/drawingml/2006/main">
+            <a:off x="2609850" y="4048125"/>
+            <a:ext cx="1123950" cy="285750"/>
+          </a:xfrm>
+          <a:prstGeom xmlns:a="http://schemas.openxmlformats.org/drawingml/2006/main" prst="rect">
+            <a:avLst/>
+          </a:prstGeom>
+          <a:noFill xmlns:a="http://schemas.openxmlformats.org/drawingml/2006/main"/>
+          <a:ln xmlns:a="http://schemas.openxmlformats.org/drawingml/2006/main" w="0">
+            <a:noFill/>
+            <a:prstDash val="solid"/>
+          </a:ln>
+        </p:spPr>
+        <p:txBody>
+          <a:bodyPr xmlns:a="http://schemas.openxmlformats.org/drawingml/2006/main"/>
+          <a:lstStyle xmlns:a="http://schemas.openxmlformats.org/drawingml/2006/main"/>
+          <a:p xmlns:a="http://schemas.openxmlformats.org/drawingml/2006/main">
+            <a:pPr>
+              <a:defRPr sz="938">
+                <a:solidFill>
+                  <a:srgbClr val="CBD5E1"/>
+                </a:solidFill>
+              </a:defRPr>
+            </a:pPr>
+            <a:r>
+              <a:rPr sz="938">
+                <a:solidFill>
+                  <a:srgbClr val="CBD5E1"/>
+                </a:solidFill>
+              </a:rPr>
+              <a:t>기능 마감 기준</a:t>
+            </a:r>
+          </a:p>
+        </p:txBody>
+      </p:sp>
+      <p:sp>
+        <p:nvSpPr>
+          <p:cNvPr id="29" name="timeline-card-3">
+            <a:extLst xmlns:a="http://schemas.openxmlformats.org/drawingml/2006/main">
+              <a:ext uri="{FF2B5EF4-FFF2-40B4-BE49-F238E27FC236}">
+                <a16:creationId xmlns:a16="http://schemas.microsoft.com/office/drawing/2014/main" id="{8136DCB9-7B16-4913-B210-019306A147DF}"/>
+              </a:ext>
+            </a:extLst>
+          </p:cNvPr>
+          <p:cNvSpPr>
+            <a:spLocks xmlns:a="http://schemas.openxmlformats.org/drawingml/2006/main" noGrp="1"/>
+          </p:cNvSpPr>
+          <p:nvPr/>
+        </p:nvSpPr>
+        <p:spPr>
+          <a:xfrm xmlns:a="http://schemas.openxmlformats.org/drawingml/2006/main">
+            <a:off x="4133850" y="2209800"/>
+            <a:ext cx="1581150" cy="2381250"/>
+          </a:xfrm>
+          <a:prstGeom xmlns:a="http://schemas.openxmlformats.org/drawingml/2006/main" prst="roundRect">
+            <a:avLst>
+              <a:gd name="adj" fmla="val 4819"/>
+            </a:avLst>
+          </a:prstGeom>
+          <a:solidFill xmlns:a="http://schemas.openxmlformats.org/drawingml/2006/main">
+            <a:srgbClr val="111827"/>
+          </a:solidFill>
+          <a:ln xmlns:a="http://schemas.openxmlformats.org/drawingml/2006/main" w="9525">
+            <a:solidFill>
+              <a:srgbClr val="2F3B55"/>
+            </a:solidFill>
+            <a:prstDash val="solid"/>
+          </a:ln>
+        </p:spPr>
+      </p:sp>
+      <p:sp>
+        <p:nvSpPr>
+          <p:cNvPr id="30" name="timeline-bar-3">
+            <a:extLst xmlns:a="http://schemas.openxmlformats.org/drawingml/2006/main">
+              <a:ext uri="{FF2B5EF4-FFF2-40B4-BE49-F238E27FC236}">
+                <a16:creationId xmlns:a16="http://schemas.microsoft.com/office/drawing/2014/main" id="{B2144D0E-8254-4CB6-B9A8-ABDA7373B5B3}"/>
+              </a:ext>
+            </a:extLst>
+          </p:cNvPr>
+          <p:cNvSpPr>
+            <a:spLocks xmlns:a="http://schemas.openxmlformats.org/drawingml/2006/main" noGrp="1"/>
+          </p:cNvSpPr>
+          <p:nvPr/>
+        </p:nvSpPr>
+        <p:spPr>
+          <a:xfrm xmlns:a="http://schemas.openxmlformats.org/drawingml/2006/main">
+            <a:off x="4133850" y="2209800"/>
+            <a:ext cx="1581150" cy="66675"/>
+          </a:xfrm>
+          <a:prstGeom xmlns:a="http://schemas.openxmlformats.org/drawingml/2006/main" prst="rect">
+            <a:avLst/>
+          </a:prstGeom>
+          <a:solidFill xmlns:a="http://schemas.openxmlformats.org/drawingml/2006/main">
+            <a:srgbClr val="7C3AED"/>
+          </a:solidFill>
+          <a:ln xmlns:a="http://schemas.openxmlformats.org/drawingml/2006/main" w="0">
+            <a:solidFill>
+              <a:srgbClr val="7C3AED"/>
+            </a:solidFill>
+            <a:prstDash val="solid"/>
+          </a:ln>
+        </p:spPr>
+      </p:sp>
+      <p:sp>
+        <p:nvSpPr>
+          <p:cNvPr id="31" name="timeline-month-3">
+            <a:extLst xmlns:a="http://schemas.openxmlformats.org/drawingml/2006/main">
+              <a:ext uri="{FF2B5EF4-FFF2-40B4-BE49-F238E27FC236}">
+                <a16:creationId xmlns:a16="http://schemas.microsoft.com/office/drawing/2014/main" id="{77674FC3-5C2A-4F69-A853-0FED66BEE363}"/>
+              </a:ext>
+            </a:extLst>
+          </p:cNvPr>
+          <p:cNvSpPr>
+            <a:spLocks xmlns:a="http://schemas.openxmlformats.org/drawingml/2006/main" noGrp="1"/>
+          </p:cNvSpPr>
+          <p:nvPr/>
+        </p:nvSpPr>
+        <p:spPr>
+          <a:xfrm xmlns:a="http://schemas.openxmlformats.org/drawingml/2006/main">
+            <a:off x="4286250" y="2438400"/>
+            <a:ext cx="666750" cy="228600"/>
+          </a:xfrm>
+          <a:prstGeom xmlns:a="http://schemas.openxmlformats.org/drawingml/2006/main" prst="rect">
+            <a:avLst/>
+          </a:prstGeom>
+          <a:noFill xmlns:a="http://schemas.openxmlformats.org/drawingml/2006/main"/>
+          <a:ln xmlns:a="http://schemas.openxmlformats.org/drawingml/2006/main" w="0">
+            <a:noFill/>
+            <a:prstDash val="solid"/>
+          </a:ln>
+        </p:spPr>
+        <p:txBody>
+          <a:bodyPr xmlns:a="http://schemas.openxmlformats.org/drawingml/2006/main"/>
+          <a:lstStyle xmlns:a="http://schemas.openxmlformats.org/drawingml/2006/main"/>
+          <a:p xmlns:a="http://schemas.openxmlformats.org/drawingml/2006/main">
+            <a:pPr>
+              <a:defRPr sz="1275" b="1">
+                <a:solidFill>
+                  <a:srgbClr val="7C3AED"/>
+                </a:solidFill>
+              </a:defRPr>
+            </a:pPr>
+            <a:r>
+              <a:rPr sz="1275" b="1">
+                <a:solidFill>
+                  <a:srgbClr val="7C3AED"/>
+                </a:solidFill>
+              </a:rPr>
+              <a:t>D-4M</a:t>
+            </a:r>
+          </a:p>
+        </p:txBody>
+      </p:sp>
+      <p:sp>
+        <p:nvSpPr>
+          <p:cNvPr id="32" name="timeline-title-3">
+            <a:extLst xmlns:a="http://schemas.openxmlformats.org/drawingml/2006/main">
+              <a:ext uri="{FF2B5EF4-FFF2-40B4-BE49-F238E27FC236}">
+                <a16:creationId xmlns:a16="http://schemas.microsoft.com/office/drawing/2014/main" id="{E5C1CD1D-8EE7-48FC-8C18-ED01B85A7784}"/>
+              </a:ext>
+            </a:extLst>
+          </p:cNvPr>
+          <p:cNvSpPr>
+            <a:spLocks xmlns:a="http://schemas.openxmlformats.org/drawingml/2006/main" noGrp="1"/>
+          </p:cNvSpPr>
+          <p:nvPr/>
+        </p:nvSpPr>
+        <p:spPr>
+          <a:xfrm xmlns:a="http://schemas.openxmlformats.org/drawingml/2006/main">
+            <a:off x="4286250" y="2762250"/>
+            <a:ext cx="1257300" cy="457200"/>
+          </a:xfrm>
+          <a:prstGeom xmlns:a="http://schemas.openxmlformats.org/drawingml/2006/main" prst="rect">
+            <a:avLst/>
+          </a:prstGeom>
+          <a:noFill xmlns:a="http://schemas.openxmlformats.org/drawingml/2006/main"/>
+          <a:ln xmlns:a="http://schemas.openxmlformats.org/drawingml/2006/main" w="0">
+            <a:noFill/>
+            <a:prstDash val="solid"/>
+          </a:ln>
+        </p:spPr>
+        <p:txBody>
+          <a:bodyPr xmlns:a="http://schemas.openxmlformats.org/drawingml/2006/main"/>
+          <a:lstStyle xmlns:a="http://schemas.openxmlformats.org/drawingml/2006/main"/>
+          <a:p xmlns:a="http://schemas.openxmlformats.org/drawingml/2006/main">
+            <a:pPr>
+              <a:defRPr sz="1350" b="1">
+                <a:solidFill>
+                  <a:srgbClr val="FFFFFF"/>
+                </a:solidFill>
+              </a:defRPr>
+            </a:pPr>
+            <a:r>
+              <a:rPr sz="1350" b="1">
+                <a:solidFill>
+                  <a:srgbClr val="FFFFFF"/>
+                </a:solidFill>
+              </a:rPr>
+              <a:t>내부 QA 진입</a:t>
+            </a:r>
+          </a:p>
+        </p:txBody>
+      </p:sp>
+      <p:sp>
+        <p:nvSpPr>
+          <p:cNvPr id="33" name="timeline-dot-3-1">
+            <a:extLst xmlns:a="http://schemas.openxmlformats.org/drawingml/2006/main">
+              <a:ext uri="{FF2B5EF4-FFF2-40B4-BE49-F238E27FC236}">
+                <a16:creationId xmlns:a16="http://schemas.microsoft.com/office/drawing/2014/main" id="{E646D37B-A309-43BD-9623-BEB634A2106B}"/>
+              </a:ext>
+            </a:extLst>
+          </p:cNvPr>
+          <p:cNvSpPr>
+            <a:spLocks xmlns:a="http://schemas.openxmlformats.org/drawingml/2006/main" noGrp="1"/>
+          </p:cNvSpPr>
+          <p:nvPr/>
+        </p:nvSpPr>
+        <p:spPr>
+          <a:xfrm xmlns:a="http://schemas.openxmlformats.org/drawingml/2006/main">
+            <a:off x="4286250" y="3371850"/>
+            <a:ext cx="114300" cy="209550"/>
+          </a:xfrm>
+          <a:prstGeom xmlns:a="http://schemas.openxmlformats.org/drawingml/2006/main" prst="rect">
+            <a:avLst/>
+          </a:prstGeom>
+          <a:noFill xmlns:a="http://schemas.openxmlformats.org/drawingml/2006/main"/>
+          <a:ln xmlns:a="http://schemas.openxmlformats.org/drawingml/2006/main" w="0">
+            <a:noFill/>
+            <a:prstDash val="solid"/>
+          </a:ln>
+        </p:spPr>
+        <p:txBody>
+          <a:bodyPr xmlns:a="http://schemas.openxmlformats.org/drawingml/2006/main"/>
+          <a:lstStyle xmlns:a="http://schemas.openxmlformats.org/drawingml/2006/main"/>
+          <a:p xmlns:a="http://schemas.openxmlformats.org/drawingml/2006/main">
+            <a:pPr>
+              <a:defRPr sz="1350" b="1">
+                <a:solidFill>
+                  <a:srgbClr val="7C3AED"/>
+                </a:solidFill>
+              </a:defRPr>
+            </a:pPr>
+            <a:r>
+              <a:rPr sz="1350" b="1">
+                <a:solidFill>
+                  <a:srgbClr val="7C3AED"/>
+                </a:solidFill>
+              </a:rPr>
+              <a:t>·</a:t>
+            </a:r>
+          </a:p>
+        </p:txBody>
+      </p:sp>
+      <p:sp>
+        <p:nvSpPr>
+          <p:cNvPr id="34" name="timeline-item-3-1">
+            <a:extLst xmlns:a="http://schemas.openxmlformats.org/drawingml/2006/main">
+              <a:ext uri="{FF2B5EF4-FFF2-40B4-BE49-F238E27FC236}">
+                <a16:creationId xmlns:a16="http://schemas.microsoft.com/office/drawing/2014/main" id="{F2439954-C73C-450D-B0BA-31CA66C854E3}"/>
+              </a:ext>
+            </a:extLst>
+          </p:cNvPr>
+          <p:cNvSpPr>
+            <a:spLocks xmlns:a="http://schemas.openxmlformats.org/drawingml/2006/main" noGrp="1"/>
+          </p:cNvSpPr>
+          <p:nvPr/>
+        </p:nvSpPr>
+        <p:spPr>
+          <a:xfrm xmlns:a="http://schemas.openxmlformats.org/drawingml/2006/main">
+            <a:off x="4419600" y="3400425"/>
+            <a:ext cx="1123950" cy="285750"/>
+          </a:xfrm>
+          <a:prstGeom xmlns:a="http://schemas.openxmlformats.org/drawingml/2006/main" prst="rect">
+            <a:avLst/>
+          </a:prstGeom>
+          <a:noFill xmlns:a="http://schemas.openxmlformats.org/drawingml/2006/main"/>
+          <a:ln xmlns:a="http://schemas.openxmlformats.org/drawingml/2006/main" w="0">
+            <a:noFill/>
+            <a:prstDash val="solid"/>
+          </a:ln>
+        </p:spPr>
+        <p:txBody>
+          <a:bodyPr xmlns:a="http://schemas.openxmlformats.org/drawingml/2006/main"/>
+          <a:lstStyle xmlns:a="http://schemas.openxmlformats.org/drawingml/2006/main"/>
+          <a:p xmlns:a="http://schemas.openxmlformats.org/drawingml/2006/main">
+            <a:pPr>
+              <a:defRPr sz="938">
+                <a:solidFill>
+                  <a:srgbClr val="CBD5E1"/>
+                </a:solidFill>
+              </a:defRPr>
+            </a:pPr>
+            <a:r>
+              <a:rPr sz="938">
+                <a:solidFill>
+                  <a:srgbClr val="CBD5E1"/>
+                </a:solidFill>
+              </a:rPr>
+              <a:t>일본향 빌드 점검</a:t>
+            </a:r>
+          </a:p>
+        </p:txBody>
+      </p:sp>
+      <p:sp>
+        <p:nvSpPr>
+          <p:cNvPr id="35" name="timeline-dot-3-2">
+            <a:extLst xmlns:a="http://schemas.openxmlformats.org/drawingml/2006/main">
+              <a:ext uri="{FF2B5EF4-FFF2-40B4-BE49-F238E27FC236}">
+                <a16:creationId xmlns:a16="http://schemas.microsoft.com/office/drawing/2014/main" id="{819E8031-7889-44B8-A34D-0CC7BDAA3DF4}"/>
+              </a:ext>
+            </a:extLst>
+          </p:cNvPr>
+          <p:cNvSpPr>
+            <a:spLocks xmlns:a="http://schemas.openxmlformats.org/drawingml/2006/main" noGrp="1"/>
+          </p:cNvSpPr>
+          <p:nvPr/>
+        </p:nvSpPr>
+        <p:spPr>
+          <a:xfrm xmlns:a="http://schemas.openxmlformats.org/drawingml/2006/main">
+            <a:off x="4286250" y="3695700"/>
+            <a:ext cx="114300" cy="209550"/>
+          </a:xfrm>
+          <a:prstGeom xmlns:a="http://schemas.openxmlformats.org/drawingml/2006/main" prst="rect">
+            <a:avLst/>
+          </a:prstGeom>
+          <a:noFill xmlns:a="http://schemas.openxmlformats.org/drawingml/2006/main"/>
+          <a:ln xmlns:a="http://schemas.openxmlformats.org/drawingml/2006/main" w="0">
+            <a:noFill/>
+            <a:prstDash val="solid"/>
+          </a:ln>
+        </p:spPr>
+        <p:txBody>
+          <a:bodyPr xmlns:a="http://schemas.openxmlformats.org/drawingml/2006/main"/>
+          <a:lstStyle xmlns:a="http://schemas.openxmlformats.org/drawingml/2006/main"/>
+          <a:p xmlns:a="http://schemas.openxmlformats.org/drawingml/2006/main">
+            <a:pPr>
+              <a:defRPr sz="1350" b="1">
+                <a:solidFill>
+                  <a:srgbClr val="7C3AED"/>
+                </a:solidFill>
+              </a:defRPr>
+            </a:pPr>
+            <a:r>
+              <a:rPr sz="1350" b="1">
+                <a:solidFill>
+                  <a:srgbClr val="7C3AED"/>
+                </a:solidFill>
+              </a:rPr>
+              <a:t>·</a:t>
+            </a:r>
+          </a:p>
+        </p:txBody>
+      </p:sp>
+      <p:sp>
+        <p:nvSpPr>
+          <p:cNvPr id="36" name="timeline-item-3-2">
+            <a:extLst xmlns:a="http://schemas.openxmlformats.org/drawingml/2006/main">
+              <a:ext uri="{FF2B5EF4-FFF2-40B4-BE49-F238E27FC236}">
+                <a16:creationId xmlns:a16="http://schemas.microsoft.com/office/drawing/2014/main" id="{DB62570B-87A0-4119-A730-3E2AE8C291AE}"/>
+              </a:ext>
+            </a:extLst>
+          </p:cNvPr>
+          <p:cNvSpPr>
+            <a:spLocks xmlns:a="http://schemas.openxmlformats.org/drawingml/2006/main" noGrp="1"/>
+          </p:cNvSpPr>
+          <p:nvPr/>
+        </p:nvSpPr>
+        <p:spPr>
+          <a:xfrm xmlns:a="http://schemas.openxmlformats.org/drawingml/2006/main">
+            <a:off x="4419600" y="3724275"/>
+            <a:ext cx="1123950" cy="285750"/>
+          </a:xfrm>
+          <a:prstGeom xmlns:a="http://schemas.openxmlformats.org/drawingml/2006/main" prst="rect">
+            <a:avLst/>
+          </a:prstGeom>
+          <a:noFill xmlns:a="http://schemas.openxmlformats.org/drawingml/2006/main"/>
+          <a:ln xmlns:a="http://schemas.openxmlformats.org/drawingml/2006/main" w="0">
+            <a:noFill/>
+            <a:prstDash val="solid"/>
+          </a:ln>
+        </p:spPr>
+        <p:txBody>
+          <a:bodyPr xmlns:a="http://schemas.openxmlformats.org/drawingml/2006/main"/>
+          <a:lstStyle xmlns:a="http://schemas.openxmlformats.org/drawingml/2006/main"/>
+          <a:p xmlns:a="http://schemas.openxmlformats.org/drawingml/2006/main">
+            <a:pPr>
+              <a:defRPr sz="938">
+                <a:solidFill>
+                  <a:srgbClr val="CBD5E1"/>
+                </a:solidFill>
+              </a:defRPr>
+            </a:pPr>
+            <a:r>
+              <a:rPr sz="938">
+                <a:solidFill>
+                  <a:srgbClr val="CBD5E1"/>
+                </a:solidFill>
+              </a:rPr>
+              <a:t>결함 등급 분류</a:t>
+            </a:r>
+          </a:p>
+        </p:txBody>
+      </p:sp>
+      <p:sp>
+        <p:nvSpPr>
+          <p:cNvPr id="37" name="timeline-dot-3-3">
+            <a:extLst xmlns:a="http://schemas.openxmlformats.org/drawingml/2006/main">
+              <a:ext uri="{FF2B5EF4-FFF2-40B4-BE49-F238E27FC236}">
+                <a16:creationId xmlns:a16="http://schemas.microsoft.com/office/drawing/2014/main" id="{CA12C054-94C1-404C-9508-DE304EC1F921}"/>
+              </a:ext>
+            </a:extLst>
+          </p:cNvPr>
+          <p:cNvSpPr>
+            <a:spLocks xmlns:a="http://schemas.openxmlformats.org/drawingml/2006/main" noGrp="1"/>
+          </p:cNvSpPr>
+          <p:nvPr/>
+        </p:nvSpPr>
+        <p:spPr>
+          <a:xfrm xmlns:a="http://schemas.openxmlformats.org/drawingml/2006/main">
+            <a:off x="4286250" y="4019550"/>
+            <a:ext cx="114300" cy="209550"/>
+          </a:xfrm>
+          <a:prstGeom xmlns:a="http://schemas.openxmlformats.org/drawingml/2006/main" prst="rect">
+            <a:avLst/>
+          </a:prstGeom>
+          <a:noFill xmlns:a="http://schemas.openxmlformats.org/drawingml/2006/main"/>
+          <a:ln xmlns:a="http://schemas.openxmlformats.org/drawingml/2006/main" w="0">
+            <a:noFill/>
+            <a:prstDash val="solid"/>
+          </a:ln>
+        </p:spPr>
+        <p:txBody>
+          <a:bodyPr xmlns:a="http://schemas.openxmlformats.org/drawingml/2006/main"/>
+          <a:lstStyle xmlns:a="http://schemas.openxmlformats.org/drawingml/2006/main"/>
+          <a:p xmlns:a="http://schemas.openxmlformats.org/drawingml/2006/main">
+            <a:pPr>
+              <a:defRPr sz="1350" b="1">
+                <a:solidFill>
+                  <a:srgbClr val="7C3AED"/>
+                </a:solidFill>
+              </a:defRPr>
+            </a:pPr>
+            <a:r>
+              <a:rPr sz="1350" b="1">
+                <a:solidFill>
+                  <a:srgbClr val="7C3AED"/>
+                </a:solidFill>
+              </a:rPr>
+              <a:t>·</a:t>
+            </a:r>
+          </a:p>
+        </p:txBody>
+      </p:sp>
+      <p:sp>
+        <p:nvSpPr>
+          <p:cNvPr id="38" name="timeline-item-3-3">
+            <a:extLst xmlns:a="http://schemas.openxmlformats.org/drawingml/2006/main">
+              <a:ext uri="{FF2B5EF4-FFF2-40B4-BE49-F238E27FC236}">
+                <a16:creationId xmlns:a16="http://schemas.microsoft.com/office/drawing/2014/main" id="{46D63C6A-6226-4AFA-ABC5-56C1A671A8B0}"/>
+              </a:ext>
+            </a:extLst>
+          </p:cNvPr>
+          <p:cNvSpPr>
+            <a:spLocks xmlns:a="http://schemas.openxmlformats.org/drawingml/2006/main" noGrp="1"/>
+          </p:cNvSpPr>
+          <p:nvPr/>
+        </p:nvSpPr>
+        <p:spPr>
+          <a:xfrm xmlns:a="http://schemas.openxmlformats.org/drawingml/2006/main">
+            <a:off x="4419600" y="4048125"/>
+            <a:ext cx="1123950" cy="285750"/>
+          </a:xfrm>
+          <a:prstGeom xmlns:a="http://schemas.openxmlformats.org/drawingml/2006/main" prst="rect">
+            <a:avLst/>
+          </a:prstGeom>
+          <a:noFill xmlns:a="http://schemas.openxmlformats.org/drawingml/2006/main"/>
+          <a:ln xmlns:a="http://schemas.openxmlformats.org/drawingml/2006/main" w="0">
+            <a:noFill/>
+            <a:prstDash val="solid"/>
+          </a:ln>
+        </p:spPr>
+        <p:txBody>
+          <a:bodyPr xmlns:a="http://schemas.openxmlformats.org/drawingml/2006/main"/>
+          <a:lstStyle xmlns:a="http://schemas.openxmlformats.org/drawingml/2006/main"/>
+          <a:p xmlns:a="http://schemas.openxmlformats.org/drawingml/2006/main">
+            <a:pPr>
+              <a:defRPr sz="938">
+                <a:solidFill>
+                  <a:srgbClr val="CBD5E1"/>
+                </a:solidFill>
+              </a:defRPr>
+            </a:pPr>
+            <a:r>
+              <a:rPr sz="938">
+                <a:solidFill>
+                  <a:srgbClr val="CBD5E1"/>
+                </a:solidFill>
+              </a:rPr>
+              <a:t>수정 우선순위</a:t>
+            </a:r>
+          </a:p>
+        </p:txBody>
+      </p:sp>
+      <p:sp>
+        <p:nvSpPr>
+          <p:cNvPr id="39" name="timeline-card-4">
+            <a:extLst xmlns:a="http://schemas.openxmlformats.org/drawingml/2006/main">
+              <a:ext uri="{FF2B5EF4-FFF2-40B4-BE49-F238E27FC236}">
+                <a16:creationId xmlns:a16="http://schemas.microsoft.com/office/drawing/2014/main" id="{BBAFE33F-817D-45E3-BA76-8DFBDF1F5E32}"/>
+              </a:ext>
+            </a:extLst>
+          </p:cNvPr>
+          <p:cNvSpPr>
+            <a:spLocks xmlns:a="http://schemas.openxmlformats.org/drawingml/2006/main" noGrp="1"/>
+          </p:cNvSpPr>
+          <p:nvPr/>
+        </p:nvSpPr>
+        <p:spPr>
+          <a:xfrm xmlns:a="http://schemas.openxmlformats.org/drawingml/2006/main">
+            <a:off x="5943600" y="2209800"/>
+            <a:ext cx="1581150" cy="2381250"/>
+          </a:xfrm>
+          <a:prstGeom xmlns:a="http://schemas.openxmlformats.org/drawingml/2006/main" prst="roundRect">
+            <a:avLst>
+              <a:gd name="adj" fmla="val 4819"/>
+            </a:avLst>
+          </a:prstGeom>
+          <a:solidFill xmlns:a="http://schemas.openxmlformats.org/drawingml/2006/main">
+            <a:srgbClr val="111827"/>
+          </a:solidFill>
+          <a:ln xmlns:a="http://schemas.openxmlformats.org/drawingml/2006/main" w="9525">
+            <a:solidFill>
+              <a:srgbClr val="2F3B55"/>
+            </a:solidFill>
+            <a:prstDash val="solid"/>
+          </a:ln>
+        </p:spPr>
+      </p:sp>
+      <p:sp>
+        <p:nvSpPr>
+          <p:cNvPr id="40" name="timeline-bar-4">
+            <a:extLst xmlns:a="http://schemas.openxmlformats.org/drawingml/2006/main">
+              <a:ext uri="{FF2B5EF4-FFF2-40B4-BE49-F238E27FC236}">
+                <a16:creationId xmlns:a16="http://schemas.microsoft.com/office/drawing/2014/main" id="{62CDFD11-7E16-4C63-974C-8DC49757E0B0}"/>
+              </a:ext>
+            </a:extLst>
+          </p:cNvPr>
+          <p:cNvSpPr>
+            <a:spLocks xmlns:a="http://schemas.openxmlformats.org/drawingml/2006/main" noGrp="1"/>
+          </p:cNvSpPr>
+          <p:nvPr/>
+        </p:nvSpPr>
+        <p:spPr>
+          <a:xfrm xmlns:a="http://schemas.openxmlformats.org/drawingml/2006/main">
+            <a:off x="5943600" y="2209800"/>
+            <a:ext cx="1581150" cy="66675"/>
+          </a:xfrm>
+          <a:prstGeom xmlns:a="http://schemas.openxmlformats.org/drawingml/2006/main" prst="rect">
+            <a:avLst/>
+          </a:prstGeom>
+          <a:solidFill xmlns:a="http://schemas.openxmlformats.org/drawingml/2006/main">
+            <a:srgbClr val="8BD9E8"/>
+          </a:solidFill>
+          <a:ln xmlns:a="http://schemas.openxmlformats.org/drawingml/2006/main" w="0">
+            <a:solidFill>
+              <a:srgbClr val="8BD9E8"/>
+            </a:solidFill>
+            <a:prstDash val="solid"/>
+          </a:ln>
+        </p:spPr>
+      </p:sp>
+      <p:sp>
+        <p:nvSpPr>
+          <p:cNvPr id="41" name="timeline-month-4">
+            <a:extLst xmlns:a="http://schemas.openxmlformats.org/drawingml/2006/main">
+              <a:ext uri="{FF2B5EF4-FFF2-40B4-BE49-F238E27FC236}">
+                <a16:creationId xmlns:a16="http://schemas.microsoft.com/office/drawing/2014/main" id="{D3AEAB97-9726-4D3F-982F-7A6DB28ED4BB}"/>
+              </a:ext>
+            </a:extLst>
+          </p:cNvPr>
+          <p:cNvSpPr>
+            <a:spLocks xmlns:a="http://schemas.openxmlformats.org/drawingml/2006/main" noGrp="1"/>
+          </p:cNvSpPr>
+          <p:nvPr/>
+        </p:nvSpPr>
+        <p:spPr>
+          <a:xfrm xmlns:a="http://schemas.openxmlformats.org/drawingml/2006/main">
+            <a:off x="6096000" y="2438400"/>
+            <a:ext cx="666750" cy="228600"/>
+          </a:xfrm>
+          <a:prstGeom xmlns:a="http://schemas.openxmlformats.org/drawingml/2006/main" prst="rect">
+            <a:avLst/>
+          </a:prstGeom>
+          <a:noFill xmlns:a="http://schemas.openxmlformats.org/drawingml/2006/main"/>
+          <a:ln xmlns:a="http://schemas.openxmlformats.org/drawingml/2006/main" w="0">
+            <a:noFill/>
+            <a:prstDash val="solid"/>
+          </a:ln>
+        </p:spPr>
+        <p:txBody>
+          <a:bodyPr xmlns:a="http://schemas.openxmlformats.org/drawingml/2006/main"/>
+          <a:lstStyle xmlns:a="http://schemas.openxmlformats.org/drawingml/2006/main"/>
+          <a:p xmlns:a="http://schemas.openxmlformats.org/drawingml/2006/main">
+            <a:pPr>
+              <a:defRPr sz="1275" b="1">
+                <a:solidFill>
+                  <a:srgbClr val="8BD9E8"/>
+                </a:solidFill>
+              </a:defRPr>
+            </a:pPr>
+            <a:r>
+              <a:rPr sz="1275" b="1">
+                <a:solidFill>
+                  <a:srgbClr val="8BD9E8"/>
+                </a:solidFill>
+              </a:rPr>
+              <a:t>D-3M</a:t>
+            </a:r>
+          </a:p>
+        </p:txBody>
+      </p:sp>
+      <p:sp>
+        <p:nvSpPr>
+          <p:cNvPr id="42" name="timeline-title-4">
+            <a:extLst xmlns:a="http://schemas.openxmlformats.org/drawingml/2006/main">
+              <a:ext uri="{FF2B5EF4-FFF2-40B4-BE49-F238E27FC236}">
+                <a16:creationId xmlns:a16="http://schemas.microsoft.com/office/drawing/2014/main" id="{E5B6B059-0906-4D60-8B2C-7B5FEF746CA5}"/>
+              </a:ext>
+            </a:extLst>
+          </p:cNvPr>
+          <p:cNvSpPr>
+            <a:spLocks xmlns:a="http://schemas.openxmlformats.org/drawingml/2006/main" noGrp="1"/>
+          </p:cNvSpPr>
+          <p:nvPr/>
+        </p:nvSpPr>
+        <p:spPr>
+          <a:xfrm xmlns:a="http://schemas.openxmlformats.org/drawingml/2006/main">
+            <a:off x="6096000" y="2762250"/>
+            <a:ext cx="1257300" cy="457200"/>
+          </a:xfrm>
+          <a:prstGeom xmlns:a="http://schemas.openxmlformats.org/drawingml/2006/main" prst="rect">
+            <a:avLst/>
+          </a:prstGeom>
+          <a:noFill xmlns:a="http://schemas.openxmlformats.org/drawingml/2006/main"/>
+          <a:ln xmlns:a="http://schemas.openxmlformats.org/drawingml/2006/main" w="0">
+            <a:noFill/>
+            <a:prstDash val="solid"/>
+          </a:ln>
+        </p:spPr>
+        <p:txBody>
+          <a:bodyPr xmlns:a="http://schemas.openxmlformats.org/drawingml/2006/main"/>
+          <a:lstStyle xmlns:a="http://schemas.openxmlformats.org/drawingml/2006/main"/>
+          <a:p xmlns:a="http://schemas.openxmlformats.org/drawingml/2006/main">
+            <a:pPr>
+              <a:defRPr sz="1350" b="1">
+                <a:solidFill>
+                  <a:srgbClr val="FFFFFF"/>
+                </a:solidFill>
+              </a:defRPr>
+            </a:pPr>
+            <a:r>
+              <a:rPr sz="1350" b="1">
+                <a:solidFill>
+                  <a:srgbClr val="FFFFFF"/>
+                </a:solidFill>
+              </a:rPr>
+              <a:t>검수·CBT 준비</a:t>
+            </a:r>
+          </a:p>
+        </p:txBody>
+      </p:sp>
+      <p:sp>
+        <p:nvSpPr>
+          <p:cNvPr id="43" name="timeline-dot-4-1">
+            <a:extLst xmlns:a="http://schemas.openxmlformats.org/drawingml/2006/main">
+              <a:ext uri="{FF2B5EF4-FFF2-40B4-BE49-F238E27FC236}">
+                <a16:creationId xmlns:a16="http://schemas.microsoft.com/office/drawing/2014/main" id="{22471788-1676-4C04-A2C5-F8A8E0230848}"/>
+              </a:ext>
+            </a:extLst>
+          </p:cNvPr>
+          <p:cNvSpPr>
+            <a:spLocks xmlns:a="http://schemas.openxmlformats.org/drawingml/2006/main" noGrp="1"/>
+          </p:cNvSpPr>
+          <p:nvPr/>
+        </p:nvSpPr>
+        <p:spPr>
+          <a:xfrm xmlns:a="http://schemas.openxmlformats.org/drawingml/2006/main">
+            <a:off x="6096000" y="3371850"/>
+            <a:ext cx="114300" cy="209550"/>
+          </a:xfrm>
+          <a:prstGeom xmlns:a="http://schemas.openxmlformats.org/drawingml/2006/main" prst="rect">
+            <a:avLst/>
+          </a:prstGeom>
+          <a:noFill xmlns:a="http://schemas.openxmlformats.org/drawingml/2006/main"/>
+          <a:ln xmlns:a="http://schemas.openxmlformats.org/drawingml/2006/main" w="0">
+            <a:noFill/>
+            <a:prstDash val="solid"/>
+          </a:ln>
+        </p:spPr>
+        <p:txBody>
+          <a:bodyPr xmlns:a="http://schemas.openxmlformats.org/drawingml/2006/main"/>
+          <a:lstStyle xmlns:a="http://schemas.openxmlformats.org/drawingml/2006/main"/>
+          <a:p xmlns:a="http://schemas.openxmlformats.org/drawingml/2006/main">
+            <a:pPr>
+              <a:defRPr sz="1350" b="1">
+                <a:solidFill>
+                  <a:srgbClr val="8BD9E8"/>
+                </a:solidFill>
+              </a:defRPr>
+            </a:pPr>
+            <a:r>
+              <a:rPr sz="1350" b="1">
+                <a:solidFill>
+                  <a:srgbClr val="8BD9E8"/>
+                </a:solidFill>
+              </a:rPr>
+              <a:t>·</a:t>
+            </a:r>
+          </a:p>
+        </p:txBody>
+      </p:sp>
+      <p:sp>
+        <p:nvSpPr>
+          <p:cNvPr id="44" name="timeline-item-4-1">
+            <a:extLst xmlns:a="http://schemas.openxmlformats.org/drawingml/2006/main">
+              <a:ext uri="{FF2B5EF4-FFF2-40B4-BE49-F238E27FC236}">
+                <a16:creationId xmlns:a16="http://schemas.microsoft.com/office/drawing/2014/main" id="{CC168F41-406A-4B99-904D-2DE9BA834DE5}"/>
+              </a:ext>
+            </a:extLst>
+          </p:cNvPr>
+          <p:cNvSpPr>
+            <a:spLocks xmlns:a="http://schemas.openxmlformats.org/drawingml/2006/main" noGrp="1"/>
+          </p:cNvSpPr>
+          <p:nvPr/>
+        </p:nvSpPr>
+        <p:spPr>
+          <a:xfrm xmlns:a="http://schemas.openxmlformats.org/drawingml/2006/main">
+            <a:off x="6229350" y="3400425"/>
+            <a:ext cx="1123950" cy="285750"/>
+          </a:xfrm>
+          <a:prstGeom xmlns:a="http://schemas.openxmlformats.org/drawingml/2006/main" prst="rect">
+            <a:avLst/>
+          </a:prstGeom>
+          <a:noFill xmlns:a="http://schemas.openxmlformats.org/drawingml/2006/main"/>
+          <a:ln xmlns:a="http://schemas.openxmlformats.org/drawingml/2006/main" w="0">
+            <a:noFill/>
+            <a:prstDash val="solid"/>
+          </a:ln>
+        </p:spPr>
+        <p:txBody>
+          <a:bodyPr xmlns:a="http://schemas.openxmlformats.org/drawingml/2006/main"/>
+          <a:lstStyle xmlns:a="http://schemas.openxmlformats.org/drawingml/2006/main"/>
+          <a:p xmlns:a="http://schemas.openxmlformats.org/drawingml/2006/main">
+            <a:pPr>
+              <a:defRPr sz="938">
+                <a:solidFill>
+                  <a:srgbClr val="CBD5E1"/>
+                </a:solidFill>
+              </a:defRPr>
+            </a:pPr>
+            <a:r>
+              <a:rPr sz="938">
+                <a:solidFill>
+                  <a:srgbClr val="CBD5E1"/>
+                </a:solidFill>
+              </a:rPr>
+              <a:t>퍼블리셔 검수 대응</a:t>
+            </a:r>
+          </a:p>
+        </p:txBody>
+      </p:sp>
+      <p:sp>
+        <p:nvSpPr>
+          <p:cNvPr id="45" name="timeline-dot-4-2">
+            <a:extLst xmlns:a="http://schemas.openxmlformats.org/drawingml/2006/main">
+              <a:ext uri="{FF2B5EF4-FFF2-40B4-BE49-F238E27FC236}">
+                <a16:creationId xmlns:a16="http://schemas.microsoft.com/office/drawing/2014/main" id="{8C1DB313-AEAD-4331-A234-19185727C628}"/>
+              </a:ext>
+            </a:extLst>
+          </p:cNvPr>
+          <p:cNvSpPr>
+            <a:spLocks xmlns:a="http://schemas.openxmlformats.org/drawingml/2006/main" noGrp="1"/>
+          </p:cNvSpPr>
+          <p:nvPr/>
+        </p:nvSpPr>
+        <p:spPr>
+          <a:xfrm xmlns:a="http://schemas.openxmlformats.org/drawingml/2006/main">
+            <a:off x="6096000" y="3695700"/>
+            <a:ext cx="114300" cy="209550"/>
+          </a:xfrm>
+          <a:prstGeom xmlns:a="http://schemas.openxmlformats.org/drawingml/2006/main" prst="rect">
+            <a:avLst/>
+          </a:prstGeom>
+          <a:noFill xmlns:a="http://schemas.openxmlformats.org/drawingml/2006/main"/>
+          <a:ln xmlns:a="http://schemas.openxmlformats.org/drawingml/2006/main" w="0">
+            <a:noFill/>
+            <a:prstDash val="solid"/>
+          </a:ln>
+        </p:spPr>
+        <p:txBody>
+          <a:bodyPr xmlns:a="http://schemas.openxmlformats.org/drawingml/2006/main"/>
+          <a:lstStyle xmlns:a="http://schemas.openxmlformats.org/drawingml/2006/main"/>
+          <a:p xmlns:a="http://schemas.openxmlformats.org/drawingml/2006/main">
+            <a:pPr>
+              <a:defRPr sz="1350" b="1">
+                <a:solidFill>
+                  <a:srgbClr val="8BD9E8"/>
+                </a:solidFill>
+              </a:defRPr>
+            </a:pPr>
+            <a:r>
+              <a:rPr sz="1350" b="1">
+                <a:solidFill>
+                  <a:srgbClr val="8BD9E8"/>
+                </a:solidFill>
+              </a:rPr>
+              <a:t>·</a:t>
+            </a:r>
+          </a:p>
+        </p:txBody>
+      </p:sp>
+      <p:sp>
+        <p:nvSpPr>
+          <p:cNvPr id="46" name="timeline-item-4-2">
+            <a:extLst xmlns:a="http://schemas.openxmlformats.org/drawingml/2006/main">
+              <a:ext uri="{FF2B5EF4-FFF2-40B4-BE49-F238E27FC236}">
+                <a16:creationId xmlns:a16="http://schemas.microsoft.com/office/drawing/2014/main" id="{41F72C9B-9C28-4CE7-9B7C-BFDD8458A1D5}"/>
+              </a:ext>
+            </a:extLst>
+          </p:cNvPr>
+          <p:cNvSpPr>
+            <a:spLocks xmlns:a="http://schemas.openxmlformats.org/drawingml/2006/main" noGrp="1"/>
+          </p:cNvSpPr>
+          <p:nvPr/>
+        </p:nvSpPr>
+        <p:spPr>
+          <a:xfrm xmlns:a="http://schemas.openxmlformats.org/drawingml/2006/main">
+            <a:off x="6229350" y="3724275"/>
+            <a:ext cx="1123950" cy="285750"/>
+          </a:xfrm>
+          <a:prstGeom xmlns:a="http://schemas.openxmlformats.org/drawingml/2006/main" prst="rect">
+            <a:avLst/>
+          </a:prstGeom>
+          <a:noFill xmlns:a="http://schemas.openxmlformats.org/drawingml/2006/main"/>
+          <a:ln xmlns:a="http://schemas.openxmlformats.org/drawingml/2006/main" w="0">
+            <a:noFill/>
+            <a:prstDash val="solid"/>
+          </a:ln>
+        </p:spPr>
+        <p:txBody>
+          <a:bodyPr xmlns:a="http://schemas.openxmlformats.org/drawingml/2006/main"/>
+          <a:lstStyle xmlns:a="http://schemas.openxmlformats.org/drawingml/2006/main"/>
+          <a:p xmlns:a="http://schemas.openxmlformats.org/drawingml/2006/main">
+            <a:pPr>
+              <a:defRPr sz="938">
+                <a:solidFill>
+                  <a:srgbClr val="CBD5E1"/>
+                </a:solidFill>
+              </a:defRPr>
+            </a:pPr>
+            <a:r>
+              <a:rPr sz="938">
+                <a:solidFill>
+                  <a:srgbClr val="CBD5E1"/>
+                </a:solidFill>
+              </a:rPr>
+              <a:t>CBT 빌드 기준</a:t>
+            </a:r>
+          </a:p>
+        </p:txBody>
+      </p:sp>
+      <p:sp>
+        <p:nvSpPr>
+          <p:cNvPr id="47" name="timeline-dot-4-3">
+            <a:extLst xmlns:a="http://schemas.openxmlformats.org/drawingml/2006/main">
+              <a:ext uri="{FF2B5EF4-FFF2-40B4-BE49-F238E27FC236}">
+                <a16:creationId xmlns:a16="http://schemas.microsoft.com/office/drawing/2014/main" id="{5DFA0259-D8C2-4D21-990D-3E7344EA1C19}"/>
+              </a:ext>
+            </a:extLst>
+          </p:cNvPr>
+          <p:cNvSpPr>
+            <a:spLocks xmlns:a="http://schemas.openxmlformats.org/drawingml/2006/main" noGrp="1"/>
+          </p:cNvSpPr>
+          <p:nvPr/>
+        </p:nvSpPr>
+        <p:spPr>
+          <a:xfrm xmlns:a="http://schemas.openxmlformats.org/drawingml/2006/main">
+            <a:off x="6096000" y="4019550"/>
+            <a:ext cx="114300" cy="209550"/>
+          </a:xfrm>
+          <a:prstGeom xmlns:a="http://schemas.openxmlformats.org/drawingml/2006/main" prst="rect">
+            <a:avLst/>
+          </a:prstGeom>
+          <a:noFill xmlns:a="http://schemas.openxmlformats.org/drawingml/2006/main"/>
+          <a:ln xmlns:a="http://schemas.openxmlformats.org/drawingml/2006/main" w="0">
+            <a:noFill/>
+            <a:prstDash val="solid"/>
+          </a:ln>
+        </p:spPr>
+        <p:txBody>
+          <a:bodyPr xmlns:a="http://schemas.openxmlformats.org/drawingml/2006/main"/>
+          <a:lstStyle xmlns:a="http://schemas.openxmlformats.org/drawingml/2006/main"/>
+          <a:p xmlns:a="http://schemas.openxmlformats.org/drawingml/2006/main">
+            <a:pPr>
+              <a:defRPr sz="1350" b="1">
+                <a:solidFill>
+                  <a:srgbClr val="8BD9E8"/>
+                </a:solidFill>
+              </a:defRPr>
+            </a:pPr>
+            <a:r>
+              <a:rPr sz="1350" b="1">
+                <a:solidFill>
+                  <a:srgbClr val="8BD9E8"/>
+                </a:solidFill>
+              </a:rPr>
+              <a:t>·</a:t>
+            </a:r>
+          </a:p>
+        </p:txBody>
+      </p:sp>
+      <p:sp>
+        <p:nvSpPr>
+          <p:cNvPr id="48" name="timeline-item-4-3">
+            <a:extLst xmlns:a="http://schemas.openxmlformats.org/drawingml/2006/main">
+              <a:ext uri="{FF2B5EF4-FFF2-40B4-BE49-F238E27FC236}">
+                <a16:creationId xmlns:a16="http://schemas.microsoft.com/office/drawing/2014/main" id="{96EE19D7-C07E-402A-9C45-DF64809023B2}"/>
+              </a:ext>
+            </a:extLst>
+          </p:cNvPr>
+          <p:cNvSpPr>
+            <a:spLocks xmlns:a="http://schemas.openxmlformats.org/drawingml/2006/main" noGrp="1"/>
+          </p:cNvSpPr>
+          <p:nvPr/>
+        </p:nvSpPr>
+        <p:spPr>
+          <a:xfrm xmlns:a="http://schemas.openxmlformats.org/drawingml/2006/main">
+            <a:off x="6229350" y="4048125"/>
+            <a:ext cx="1123950" cy="285750"/>
+          </a:xfrm>
+          <a:prstGeom xmlns:a="http://schemas.openxmlformats.org/drawingml/2006/main" prst="rect">
+            <a:avLst/>
+          </a:prstGeom>
+          <a:noFill xmlns:a="http://schemas.openxmlformats.org/drawingml/2006/main"/>
+          <a:ln xmlns:a="http://schemas.openxmlformats.org/drawingml/2006/main" w="0">
+            <a:noFill/>
+            <a:prstDash val="solid"/>
+          </a:ln>
+        </p:spPr>
+        <p:txBody>
+          <a:bodyPr xmlns:a="http://schemas.openxmlformats.org/drawingml/2006/main"/>
+          <a:lstStyle xmlns:a="http://schemas.openxmlformats.org/drawingml/2006/main"/>
+          <a:p xmlns:a="http://schemas.openxmlformats.org/drawingml/2006/main">
+            <a:pPr>
+              <a:defRPr sz="938">
+                <a:solidFill>
+                  <a:srgbClr val="CBD5E1"/>
+                </a:solidFill>
+              </a:defRPr>
+            </a:pPr>
+            <a:r>
+              <a:rPr sz="938">
+                <a:solidFill>
+                  <a:srgbClr val="CBD5E1"/>
+                </a:solidFill>
+              </a:rPr>
+              <a:t>운영 시나리오</a:t>
+            </a:r>
+          </a:p>
+        </p:txBody>
+      </p:sp>
+      <p:sp>
+        <p:nvSpPr>
+          <p:cNvPr id="49" name="timeline-card-5">
+            <a:extLst xmlns:a="http://schemas.openxmlformats.org/drawingml/2006/main">
+              <a:ext uri="{FF2B5EF4-FFF2-40B4-BE49-F238E27FC236}">
+                <a16:creationId xmlns:a16="http://schemas.microsoft.com/office/drawing/2014/main" id="{178273AE-828F-483A-864D-368840254D40}"/>
+              </a:ext>
+            </a:extLst>
+          </p:cNvPr>
+          <p:cNvSpPr>
+            <a:spLocks xmlns:a="http://schemas.openxmlformats.org/drawingml/2006/main" noGrp="1"/>
+          </p:cNvSpPr>
+          <p:nvPr/>
+        </p:nvSpPr>
+        <p:spPr>
+          <a:xfrm xmlns:a="http://schemas.openxmlformats.org/drawingml/2006/main">
+            <a:off x="7753350" y="2209800"/>
+            <a:ext cx="1581150" cy="2381250"/>
+          </a:xfrm>
+          <a:prstGeom xmlns:a="http://schemas.openxmlformats.org/drawingml/2006/main" prst="roundRect">
+            <a:avLst>
+              <a:gd name="adj" fmla="val 4819"/>
+            </a:avLst>
+          </a:prstGeom>
+          <a:solidFill xmlns:a="http://schemas.openxmlformats.org/drawingml/2006/main">
+            <a:srgbClr val="111827"/>
+          </a:solidFill>
+          <a:ln xmlns:a="http://schemas.openxmlformats.org/drawingml/2006/main" w="9525">
+            <a:solidFill>
+              <a:srgbClr val="2F3B55"/>
+            </a:solidFill>
+            <a:prstDash val="solid"/>
+          </a:ln>
+        </p:spPr>
+      </p:sp>
+      <p:sp>
+        <p:nvSpPr>
+          <p:cNvPr id="50" name="timeline-bar-5">
+            <a:extLst xmlns:a="http://schemas.openxmlformats.org/drawingml/2006/main">
+              <a:ext uri="{FF2B5EF4-FFF2-40B4-BE49-F238E27FC236}">
+                <a16:creationId xmlns:a16="http://schemas.microsoft.com/office/drawing/2014/main" id="{44E61251-C9A2-4BC4-987B-821C6687A3C4}"/>
+              </a:ext>
+            </a:extLst>
+          </p:cNvPr>
+          <p:cNvSpPr>
+            <a:spLocks xmlns:a="http://schemas.openxmlformats.org/drawingml/2006/main" noGrp="1"/>
+          </p:cNvSpPr>
+          <p:nvPr/>
+        </p:nvSpPr>
+        <p:spPr>
+          <a:xfrm xmlns:a="http://schemas.openxmlformats.org/drawingml/2006/main">
+            <a:off x="7753350" y="2209800"/>
+            <a:ext cx="1581150" cy="66675"/>
+          </a:xfrm>
+          <a:prstGeom xmlns:a="http://schemas.openxmlformats.org/drawingml/2006/main" prst="rect">
+            <a:avLst/>
+          </a:prstGeom>
+          <a:solidFill xmlns:a="http://schemas.openxmlformats.org/drawingml/2006/main">
+            <a:srgbClr val="FF6B35"/>
+          </a:solidFill>
+          <a:ln xmlns:a="http://schemas.openxmlformats.org/drawingml/2006/main" w="0">
+            <a:solidFill>
+              <a:srgbClr val="FF6B35"/>
+            </a:solidFill>
+            <a:prstDash val="solid"/>
+          </a:ln>
+        </p:spPr>
+      </p:sp>
+      <p:sp>
+        <p:nvSpPr>
+          <p:cNvPr id="51" name="timeline-month-5">
+            <a:extLst xmlns:a="http://schemas.openxmlformats.org/drawingml/2006/main">
+              <a:ext uri="{FF2B5EF4-FFF2-40B4-BE49-F238E27FC236}">
+                <a16:creationId xmlns:a16="http://schemas.microsoft.com/office/drawing/2014/main" id="{C1C4B18B-32B9-42FF-8FB7-9F02F4077960}"/>
+              </a:ext>
+            </a:extLst>
+          </p:cNvPr>
+          <p:cNvSpPr>
+            <a:spLocks xmlns:a="http://schemas.openxmlformats.org/drawingml/2006/main" noGrp="1"/>
+          </p:cNvSpPr>
+          <p:nvPr/>
+        </p:nvSpPr>
+        <p:spPr>
+          <a:xfrm xmlns:a="http://schemas.openxmlformats.org/drawingml/2006/main">
+            <a:off x="7905750" y="2438400"/>
+            <a:ext cx="666750" cy="228600"/>
+          </a:xfrm>
+          <a:prstGeom xmlns:a="http://schemas.openxmlformats.org/drawingml/2006/main" prst="rect">
+            <a:avLst/>
+          </a:prstGeom>
+          <a:noFill xmlns:a="http://schemas.openxmlformats.org/drawingml/2006/main"/>
+          <a:ln xmlns:a="http://schemas.openxmlformats.org/drawingml/2006/main" w="0">
+            <a:noFill/>
+            <a:prstDash val="solid"/>
+          </a:ln>
+        </p:spPr>
+        <p:txBody>
+          <a:bodyPr xmlns:a="http://schemas.openxmlformats.org/drawingml/2006/main"/>
+          <a:lstStyle xmlns:a="http://schemas.openxmlformats.org/drawingml/2006/main"/>
+          <a:p xmlns:a="http://schemas.openxmlformats.org/drawingml/2006/main">
+            <a:pPr>
+              <a:defRPr sz="1275" b="1">
+                <a:solidFill>
+                  <a:srgbClr val="FF6B35"/>
+                </a:solidFill>
+              </a:defRPr>
+            </a:pPr>
+            <a:r>
+              <a:rPr sz="1275" b="1">
+                <a:solidFill>
+                  <a:srgbClr val="FF6B35"/>
+                </a:solidFill>
+              </a:rPr>
+              <a:t>D-2M</a:t>
+            </a:r>
+          </a:p>
+        </p:txBody>
+      </p:sp>
+      <p:sp>
+        <p:nvSpPr>
+          <p:cNvPr id="52" name="timeline-title-5">
+            <a:extLst xmlns:a="http://schemas.openxmlformats.org/drawingml/2006/main">
+              <a:ext uri="{FF2B5EF4-FFF2-40B4-BE49-F238E27FC236}">
+                <a16:creationId xmlns:a16="http://schemas.microsoft.com/office/drawing/2014/main" id="{0784565D-925E-4DE6-8186-6715B52BB3D6}"/>
+              </a:ext>
+            </a:extLst>
+          </p:cNvPr>
+          <p:cNvSpPr>
+            <a:spLocks xmlns:a="http://schemas.openxmlformats.org/drawingml/2006/main" noGrp="1"/>
+          </p:cNvSpPr>
+          <p:nvPr/>
+        </p:nvSpPr>
+        <p:spPr>
+          <a:xfrm xmlns:a="http://schemas.openxmlformats.org/drawingml/2006/main">
+            <a:off x="7905750" y="2762250"/>
+            <a:ext cx="1257300" cy="457200"/>
+          </a:xfrm>
+          <a:prstGeom xmlns:a="http://schemas.openxmlformats.org/drawingml/2006/main" prst="rect">
+            <a:avLst/>
+          </a:prstGeom>
+          <a:noFill xmlns:a="http://schemas.openxmlformats.org/drawingml/2006/main"/>
+          <a:ln xmlns:a="http://schemas.openxmlformats.org/drawingml/2006/main" w="0">
+            <a:noFill/>
+            <a:prstDash val="solid"/>
+          </a:ln>
+        </p:spPr>
+        <p:txBody>
+          <a:bodyPr xmlns:a="http://schemas.openxmlformats.org/drawingml/2006/main"/>
+          <a:lstStyle xmlns:a="http://schemas.openxmlformats.org/drawingml/2006/main"/>
+          <a:p xmlns:a="http://schemas.openxmlformats.org/drawingml/2006/main">
+            <a:pPr>
+              <a:defRPr sz="1350" b="1">
+                <a:solidFill>
+                  <a:srgbClr val="FFFFFF"/>
+                </a:solidFill>
+              </a:defRPr>
+            </a:pPr>
+            <a:r>
+              <a:rPr sz="1350" b="1">
+                <a:solidFill>
+                  <a:srgbClr val="FFFFFF"/>
+                </a:solidFill>
+              </a:rPr>
+              <a:t>후보 빌드 안정화</a:t>
+            </a:r>
+          </a:p>
+        </p:txBody>
+      </p:sp>
+      <p:sp>
+        <p:nvSpPr>
+          <p:cNvPr id="53" name="timeline-dot-5-1">
+            <a:extLst xmlns:a="http://schemas.openxmlformats.org/drawingml/2006/main">
+              <a:ext uri="{FF2B5EF4-FFF2-40B4-BE49-F238E27FC236}">
+                <a16:creationId xmlns:a16="http://schemas.microsoft.com/office/drawing/2014/main" id="{368FE6CF-3F55-49D3-AC08-67F2EF7DAA97}"/>
+              </a:ext>
+            </a:extLst>
+          </p:cNvPr>
+          <p:cNvSpPr>
+            <a:spLocks xmlns:a="http://schemas.openxmlformats.org/drawingml/2006/main" noGrp="1"/>
+          </p:cNvSpPr>
+          <p:nvPr/>
+        </p:nvSpPr>
+        <p:spPr>
+          <a:xfrm xmlns:a="http://schemas.openxmlformats.org/drawingml/2006/main">
+            <a:off x="7905750" y="3371850"/>
+            <a:ext cx="114300" cy="209550"/>
+          </a:xfrm>
+          <a:prstGeom xmlns:a="http://schemas.openxmlformats.org/drawingml/2006/main" prst="rect">
+            <a:avLst/>
+          </a:prstGeom>
+          <a:noFill xmlns:a="http://schemas.openxmlformats.org/drawingml/2006/main"/>
+          <a:ln xmlns:a="http://schemas.openxmlformats.org/drawingml/2006/main" w="0">
+            <a:noFill/>
+            <a:prstDash val="solid"/>
+          </a:ln>
+        </p:spPr>
+        <p:txBody>
+          <a:bodyPr xmlns:a="http://schemas.openxmlformats.org/drawingml/2006/main"/>
+          <a:lstStyle xmlns:a="http://schemas.openxmlformats.org/drawingml/2006/main"/>
+          <a:p xmlns:a="http://schemas.openxmlformats.org/drawingml/2006/main">
+            <a:pPr>
+              <a:defRPr sz="1350" b="1">
+                <a:solidFill>
+                  <a:srgbClr val="FF6B35"/>
+                </a:solidFill>
+              </a:defRPr>
+            </a:pPr>
+            <a:r>
+              <a:rPr sz="1350" b="1">
+                <a:solidFill>
+                  <a:srgbClr val="FF6B35"/>
+                </a:solidFill>
+              </a:rPr>
+              <a:t>·</a:t>
+            </a:r>
+          </a:p>
+        </p:txBody>
+      </p:sp>
+      <p:sp>
+        <p:nvSpPr>
+          <p:cNvPr id="54" name="timeline-item-5-1">
+            <a:extLst xmlns:a="http://schemas.openxmlformats.org/drawingml/2006/main">
+              <a:ext uri="{FF2B5EF4-FFF2-40B4-BE49-F238E27FC236}">
+                <a16:creationId xmlns:a16="http://schemas.microsoft.com/office/drawing/2014/main" id="{E16AC7F9-5689-42BF-8F30-C51E557F3836}"/>
+              </a:ext>
+            </a:extLst>
+          </p:cNvPr>
+          <p:cNvSpPr>
+            <a:spLocks xmlns:a="http://schemas.openxmlformats.org/drawingml/2006/main" noGrp="1"/>
+          </p:cNvSpPr>
+          <p:nvPr/>
+        </p:nvSpPr>
+        <p:spPr>
+          <a:xfrm xmlns:a="http://schemas.openxmlformats.org/drawingml/2006/main">
+            <a:off x="8039100" y="3400425"/>
+            <a:ext cx="1123950" cy="285750"/>
+          </a:xfrm>
+          <a:prstGeom xmlns:a="http://schemas.openxmlformats.org/drawingml/2006/main" prst="rect">
+            <a:avLst/>
+          </a:prstGeom>
+          <a:noFill xmlns:a="http://schemas.openxmlformats.org/drawingml/2006/main"/>
+          <a:ln xmlns:a="http://schemas.openxmlformats.org/drawingml/2006/main" w="0">
+            <a:noFill/>
+            <a:prstDash val="solid"/>
+          </a:ln>
+        </p:spPr>
+        <p:txBody>
+          <a:bodyPr xmlns:a="http://schemas.openxmlformats.org/drawingml/2006/main"/>
+          <a:lstStyle xmlns:a="http://schemas.openxmlformats.org/drawingml/2006/main"/>
+          <a:p xmlns:a="http://schemas.openxmlformats.org/drawingml/2006/main">
+            <a:pPr>
+              <a:defRPr sz="938">
+                <a:solidFill>
+                  <a:srgbClr val="CBD5E1"/>
+                </a:solidFill>
+              </a:defRPr>
+            </a:pPr>
+            <a:r>
+              <a:rPr sz="938">
+                <a:solidFill>
+                  <a:srgbClr val="CBD5E1"/>
+                </a:solidFill>
+              </a:rPr>
+              <a:t>릴리즈 후보 관리</a:t>
+            </a:r>
+          </a:p>
+        </p:txBody>
+      </p:sp>
+      <p:sp>
+        <p:nvSpPr>
+          <p:cNvPr id="55" name="timeline-dot-5-2">
+            <a:extLst xmlns:a="http://schemas.openxmlformats.org/drawingml/2006/main">
+              <a:ext uri="{FF2B5EF4-FFF2-40B4-BE49-F238E27FC236}">
+                <a16:creationId xmlns:a16="http://schemas.microsoft.com/office/drawing/2014/main" id="{19D62180-B89D-4575-BD80-AEB35A81D074}"/>
+              </a:ext>
+            </a:extLst>
+          </p:cNvPr>
+          <p:cNvSpPr>
+            <a:spLocks xmlns:a="http://schemas.openxmlformats.org/drawingml/2006/main" noGrp="1"/>
+          </p:cNvSpPr>
+          <p:nvPr/>
+        </p:nvSpPr>
+        <p:spPr>
+          <a:xfrm xmlns:a="http://schemas.openxmlformats.org/drawingml/2006/main">
+            <a:off x="7905750" y="3695700"/>
+            <a:ext cx="114300" cy="209550"/>
+          </a:xfrm>
+          <a:prstGeom xmlns:a="http://schemas.openxmlformats.org/drawingml/2006/main" prst="rect">
+            <a:avLst/>
+          </a:prstGeom>
+          <a:noFill xmlns:a="http://schemas.openxmlformats.org/drawingml/2006/main"/>
+          <a:ln xmlns:a="http://schemas.openxmlformats.org/drawingml/2006/main" w="0">
+            <a:noFill/>
+            <a:prstDash val="solid"/>
+          </a:ln>
+        </p:spPr>
+        <p:txBody>
+          <a:bodyPr xmlns:a="http://schemas.openxmlformats.org/drawingml/2006/main"/>
+          <a:lstStyle xmlns:a="http://schemas.openxmlformats.org/drawingml/2006/main"/>
+          <a:p xmlns:a="http://schemas.openxmlformats.org/drawingml/2006/main">
+            <a:pPr>
+              <a:defRPr sz="1350" b="1">
+                <a:solidFill>
+                  <a:srgbClr val="FF6B35"/>
+                </a:solidFill>
+              </a:defRPr>
+            </a:pPr>
+            <a:r>
+              <a:rPr sz="1350" b="1">
+                <a:solidFill>
+                  <a:srgbClr val="FF6B35"/>
+                </a:solidFill>
+              </a:rPr>
+              <a:t>·</a:t>
+            </a:r>
+          </a:p>
+        </p:txBody>
+      </p:sp>
+      <p:sp>
+        <p:nvSpPr>
+          <p:cNvPr id="56" name="timeline-item-5-2">
+            <a:extLst xmlns:a="http://schemas.openxmlformats.org/drawingml/2006/main">
+              <a:ext uri="{FF2B5EF4-FFF2-40B4-BE49-F238E27FC236}">
+                <a16:creationId xmlns:a16="http://schemas.microsoft.com/office/drawing/2014/main" id="{8A040A55-7FF4-49E4-BB19-E9D24DEF3BAF}"/>
+              </a:ext>
+            </a:extLst>
+          </p:cNvPr>
+          <p:cNvSpPr>
+            <a:spLocks xmlns:a="http://schemas.openxmlformats.org/drawingml/2006/main" noGrp="1"/>
+          </p:cNvSpPr>
+          <p:nvPr/>
+        </p:nvSpPr>
+        <p:spPr>
+          <a:xfrm xmlns:a="http://schemas.openxmlformats.org/drawingml/2006/main">
+            <a:off x="8039100" y="3724275"/>
+            <a:ext cx="1123950" cy="285750"/>
+          </a:xfrm>
+          <a:prstGeom xmlns:a="http://schemas.openxmlformats.org/drawingml/2006/main" prst="rect">
+            <a:avLst/>
+          </a:prstGeom>
+          <a:noFill xmlns:a="http://schemas.openxmlformats.org/drawingml/2006/main"/>
+          <a:ln xmlns:a="http://schemas.openxmlformats.org/drawingml/2006/main" w="0">
+            <a:noFill/>
+            <a:prstDash val="solid"/>
+          </a:ln>
+        </p:spPr>
+        <p:txBody>
+          <a:bodyPr xmlns:a="http://schemas.openxmlformats.org/drawingml/2006/main"/>
+          <a:lstStyle xmlns:a="http://schemas.openxmlformats.org/drawingml/2006/main"/>
+          <a:p xmlns:a="http://schemas.openxmlformats.org/drawingml/2006/main">
+            <a:pPr>
+              <a:defRPr sz="938">
+                <a:solidFill>
+                  <a:srgbClr val="CBD5E1"/>
+                </a:solidFill>
+              </a:defRPr>
+            </a:pPr>
+            <a:r>
+              <a:rPr sz="938">
+                <a:solidFill>
+                  <a:srgbClr val="CBD5E1"/>
+                </a:solidFill>
+              </a:rPr>
+              <a:t>잔여 이슈 추적</a:t>
+            </a:r>
+          </a:p>
+        </p:txBody>
+      </p:sp>
+      <p:sp>
+        <p:nvSpPr>
+          <p:cNvPr id="57" name="timeline-dot-5-3">
+            <a:extLst xmlns:a="http://schemas.openxmlformats.org/drawingml/2006/main">
+              <a:ext uri="{FF2B5EF4-FFF2-40B4-BE49-F238E27FC236}">
+                <a16:creationId xmlns:a16="http://schemas.microsoft.com/office/drawing/2014/main" id="{FAD2EAFF-1EBD-475C-A77D-00797D2C45AE}"/>
+              </a:ext>
+            </a:extLst>
+          </p:cNvPr>
+          <p:cNvSpPr>
+            <a:spLocks xmlns:a="http://schemas.openxmlformats.org/drawingml/2006/main" noGrp="1"/>
+          </p:cNvSpPr>
+          <p:nvPr/>
+        </p:nvSpPr>
+        <p:spPr>
+          <a:xfrm xmlns:a="http://schemas.openxmlformats.org/drawingml/2006/main">
+            <a:off x="7905750" y="4019550"/>
+            <a:ext cx="114300" cy="209550"/>
+          </a:xfrm>
+          <a:prstGeom xmlns:a="http://schemas.openxmlformats.org/drawingml/2006/main" prst="rect">
+            <a:avLst/>
+          </a:prstGeom>
+          <a:noFill xmlns:a="http://schemas.openxmlformats.org/drawingml/2006/main"/>
+          <a:ln xmlns:a="http://schemas.openxmlformats.org/drawingml/2006/main" w="0">
+            <a:noFill/>
+            <a:prstDash val="solid"/>
+          </a:ln>
+        </p:spPr>
+        <p:txBody>
+          <a:bodyPr xmlns:a="http://schemas.openxmlformats.org/drawingml/2006/main"/>
+          <a:lstStyle xmlns:a="http://schemas.openxmlformats.org/drawingml/2006/main"/>
+          <a:p xmlns:a="http://schemas.openxmlformats.org/drawingml/2006/main">
+            <a:pPr>
+              <a:defRPr sz="1350" b="1">
+                <a:solidFill>
+                  <a:srgbClr val="FF6B35"/>
+                </a:solidFill>
+              </a:defRPr>
+            </a:pPr>
+            <a:r>
+              <a:rPr sz="1350" b="1">
+                <a:solidFill>
+                  <a:srgbClr val="FF6B35"/>
+                </a:solidFill>
+              </a:rPr>
+              <a:t>·</a:t>
+            </a:r>
+          </a:p>
+        </p:txBody>
+      </p:sp>
+      <p:sp>
+        <p:nvSpPr>
+          <p:cNvPr id="58" name="timeline-item-5-3">
+            <a:extLst xmlns:a="http://schemas.openxmlformats.org/drawingml/2006/main">
+              <a:ext uri="{FF2B5EF4-FFF2-40B4-BE49-F238E27FC236}">
+                <a16:creationId xmlns:a16="http://schemas.microsoft.com/office/drawing/2014/main" id="{5D39F1B2-7C29-4BE1-87B3-1D69E437FABC}"/>
+              </a:ext>
+            </a:extLst>
+          </p:cNvPr>
+          <p:cNvSpPr>
+            <a:spLocks xmlns:a="http://schemas.openxmlformats.org/drawingml/2006/main" noGrp="1"/>
+          </p:cNvSpPr>
+          <p:nvPr/>
+        </p:nvSpPr>
+        <p:spPr>
+          <a:xfrm xmlns:a="http://schemas.openxmlformats.org/drawingml/2006/main">
+            <a:off x="8039100" y="4048125"/>
+            <a:ext cx="1123950" cy="285750"/>
+          </a:xfrm>
+          <a:prstGeom xmlns:a="http://schemas.openxmlformats.org/drawingml/2006/main" prst="rect">
+            <a:avLst/>
+          </a:prstGeom>
+          <a:noFill xmlns:a="http://schemas.openxmlformats.org/drawingml/2006/main"/>
+          <a:ln xmlns:a="http://schemas.openxmlformats.org/drawingml/2006/main" w="0">
+            <a:noFill/>
+            <a:prstDash val="solid"/>
+          </a:ln>
+        </p:spPr>
+        <p:txBody>
+          <a:bodyPr xmlns:a="http://schemas.openxmlformats.org/drawingml/2006/main"/>
+          <a:lstStyle xmlns:a="http://schemas.openxmlformats.org/drawingml/2006/main"/>
+          <a:p xmlns:a="http://schemas.openxmlformats.org/drawingml/2006/main">
+            <a:pPr>
+              <a:defRPr sz="938">
+                <a:solidFill>
+                  <a:srgbClr val="CBD5E1"/>
+                </a:solidFill>
+              </a:defRPr>
+            </a:pPr>
+            <a:r>
+              <a:rPr sz="938">
+                <a:solidFill>
+                  <a:srgbClr val="CBD5E1"/>
+                </a:solidFill>
+              </a:rPr>
+              <a:t>스토어·심의 체크</a:t>
+            </a:r>
+          </a:p>
+        </p:txBody>
+      </p:sp>
+      <p:sp>
+        <p:nvSpPr>
+          <p:cNvPr id="59" name="timeline-card-6">
+            <a:extLst xmlns:a="http://schemas.openxmlformats.org/drawingml/2006/main">
+              <a:ext uri="{FF2B5EF4-FFF2-40B4-BE49-F238E27FC236}">
+                <a16:creationId xmlns:a16="http://schemas.microsoft.com/office/drawing/2014/main" id="{D8A66099-8B7F-4D6E-8D39-2BE63B1D141D}"/>
+              </a:ext>
+            </a:extLst>
+          </p:cNvPr>
+          <p:cNvSpPr>
+            <a:spLocks xmlns:a="http://schemas.openxmlformats.org/drawingml/2006/main" noGrp="1"/>
+          </p:cNvSpPr>
+          <p:nvPr/>
+        </p:nvSpPr>
+        <p:spPr>
+          <a:xfrm xmlns:a="http://schemas.openxmlformats.org/drawingml/2006/main">
+            <a:off x="9563100" y="2209800"/>
+            <a:ext cx="1581150" cy="2381250"/>
+          </a:xfrm>
+          <a:prstGeom xmlns:a="http://schemas.openxmlformats.org/drawingml/2006/main" prst="roundRect">
+            <a:avLst>
+              <a:gd name="adj" fmla="val 4819"/>
+            </a:avLst>
+          </a:prstGeom>
+          <a:solidFill xmlns:a="http://schemas.openxmlformats.org/drawingml/2006/main">
+            <a:srgbClr val="111827"/>
+          </a:solidFill>
+          <a:ln xmlns:a="http://schemas.openxmlformats.org/drawingml/2006/main" w="9525">
+            <a:solidFill>
+              <a:srgbClr val="2F3B55"/>
+            </a:solidFill>
+            <a:prstDash val="solid"/>
+          </a:ln>
+        </p:spPr>
+      </p:sp>
+      <p:sp>
+        <p:nvSpPr>
+          <p:cNvPr id="60" name="timeline-bar-6">
+            <a:extLst xmlns:a="http://schemas.openxmlformats.org/drawingml/2006/main">
+              <a:ext uri="{FF2B5EF4-FFF2-40B4-BE49-F238E27FC236}">
+                <a16:creationId xmlns:a16="http://schemas.microsoft.com/office/drawing/2014/main" id="{1140E738-A66E-408C-ADCE-4F6716445A32}"/>
+              </a:ext>
+            </a:extLst>
+          </p:cNvPr>
+          <p:cNvSpPr>
+            <a:spLocks xmlns:a="http://schemas.openxmlformats.org/drawingml/2006/main" noGrp="1"/>
+          </p:cNvSpPr>
+          <p:nvPr/>
+        </p:nvSpPr>
+        <p:spPr>
+          <a:xfrm xmlns:a="http://schemas.openxmlformats.org/drawingml/2006/main">
+            <a:off x="9563100" y="2209800"/>
+            <a:ext cx="1581150" cy="66675"/>
+          </a:xfrm>
+          <a:prstGeom xmlns:a="http://schemas.openxmlformats.org/drawingml/2006/main" prst="rect">
+            <a:avLst/>
+          </a:prstGeom>
+          <a:solidFill xmlns:a="http://schemas.openxmlformats.org/drawingml/2006/main">
+            <a:srgbClr val="7C3AED"/>
+          </a:solidFill>
+          <a:ln xmlns:a="http://schemas.openxmlformats.org/drawingml/2006/main" w="0">
+            <a:solidFill>
+              <a:srgbClr val="7C3AED"/>
+            </a:solidFill>
+            <a:prstDash val="solid"/>
+          </a:ln>
+        </p:spPr>
+      </p:sp>
+      <p:sp>
+        <p:nvSpPr>
+          <p:cNvPr id="61" name="timeline-month-6">
+            <a:extLst xmlns:a="http://schemas.openxmlformats.org/drawingml/2006/main">
+              <a:ext uri="{FF2B5EF4-FFF2-40B4-BE49-F238E27FC236}">
+                <a16:creationId xmlns:a16="http://schemas.microsoft.com/office/drawing/2014/main" id="{C4B5D2FF-AB84-458D-B9DC-63E6391C2689}"/>
+              </a:ext>
+            </a:extLst>
+          </p:cNvPr>
+          <p:cNvSpPr>
+            <a:spLocks xmlns:a="http://schemas.openxmlformats.org/drawingml/2006/main" noGrp="1"/>
+          </p:cNvSpPr>
+          <p:nvPr/>
+        </p:nvSpPr>
+        <p:spPr>
+          <a:xfrm xmlns:a="http://schemas.openxmlformats.org/drawingml/2006/main">
+            <a:off x="9715500" y="2438400"/>
+            <a:ext cx="666750" cy="228600"/>
+          </a:xfrm>
+          <a:prstGeom xmlns:a="http://schemas.openxmlformats.org/drawingml/2006/main" prst="rect">
+            <a:avLst/>
+          </a:prstGeom>
+          <a:noFill xmlns:a="http://schemas.openxmlformats.org/drawingml/2006/main"/>
+          <a:ln xmlns:a="http://schemas.openxmlformats.org/drawingml/2006/main" w="0">
+            <a:noFill/>
+            <a:prstDash val="solid"/>
+          </a:ln>
+        </p:spPr>
+        <p:txBody>
+          <a:bodyPr xmlns:a="http://schemas.openxmlformats.org/drawingml/2006/main"/>
+          <a:lstStyle xmlns:a="http://schemas.openxmlformats.org/drawingml/2006/main"/>
+          <a:p xmlns:a="http://schemas.openxmlformats.org/drawingml/2006/main">
+            <a:pPr>
+              <a:defRPr sz="1275" b="1">
+                <a:solidFill>
+                  <a:srgbClr val="7C3AED"/>
+                </a:solidFill>
+              </a:defRPr>
+            </a:pPr>
+            <a:r>
+              <a:rPr sz="1275" b="1">
+                <a:solidFill>
+                  <a:srgbClr val="7C3AED"/>
+                </a:solidFill>
+              </a:rPr>
+              <a:t>D-1M</a:t>
+            </a:r>
+          </a:p>
+        </p:txBody>
+      </p:sp>
+      <p:sp>
+        <p:nvSpPr>
+          <p:cNvPr id="62" name="timeline-title-6">
+            <a:extLst xmlns:a="http://schemas.openxmlformats.org/drawingml/2006/main">
+              <a:ext uri="{FF2B5EF4-FFF2-40B4-BE49-F238E27FC236}">
+                <a16:creationId xmlns:a16="http://schemas.microsoft.com/office/drawing/2014/main" id="{0375A532-2E38-46C0-8C10-C7A6043AF38C}"/>
+              </a:ext>
+            </a:extLst>
+          </p:cNvPr>
+          <p:cNvSpPr>
+            <a:spLocks xmlns:a="http://schemas.openxmlformats.org/drawingml/2006/main" noGrp="1"/>
+          </p:cNvSpPr>
+          <p:nvPr/>
+        </p:nvSpPr>
+        <p:spPr>
+          <a:xfrm xmlns:a="http://schemas.openxmlformats.org/drawingml/2006/main">
+            <a:off x="9715500" y="2762250"/>
+            <a:ext cx="1257300" cy="457200"/>
+          </a:xfrm>
+          <a:prstGeom xmlns:a="http://schemas.openxmlformats.org/drawingml/2006/main" prst="rect">
+            <a:avLst/>
+          </a:prstGeom>
+          <a:noFill xmlns:a="http://schemas.openxmlformats.org/drawingml/2006/main"/>
+          <a:ln xmlns:a="http://schemas.openxmlformats.org/drawingml/2006/main" w="0">
+            <a:noFill/>
+            <a:prstDash val="solid"/>
+          </a:ln>
+        </p:spPr>
+        <p:txBody>
+          <a:bodyPr xmlns:a="http://schemas.openxmlformats.org/drawingml/2006/main"/>
+          <a:lstStyle xmlns:a="http://schemas.openxmlformats.org/drawingml/2006/main"/>
+          <a:p xmlns:a="http://schemas.openxmlformats.org/drawingml/2006/main">
+            <a:pPr>
+              <a:defRPr sz="1350" b="1">
+                <a:solidFill>
+                  <a:srgbClr val="FFFFFF"/>
+                </a:solidFill>
+              </a:defRPr>
+            </a:pPr>
+            <a:r>
+              <a:rPr sz="1350" b="1">
+                <a:solidFill>
+                  <a:srgbClr val="FFFFFF"/>
+                </a:solidFill>
+              </a:rPr>
+              <a:t>리허설·배포</a:t>
+            </a:r>
+          </a:p>
+        </p:txBody>
+      </p:sp>
+      <p:sp>
+        <p:nvSpPr>
+          <p:cNvPr id="63" name="timeline-dot-6-1">
+            <a:extLst xmlns:a="http://schemas.openxmlformats.org/drawingml/2006/main">
+              <a:ext uri="{FF2B5EF4-FFF2-40B4-BE49-F238E27FC236}">
+                <a16:creationId xmlns:a16="http://schemas.microsoft.com/office/drawing/2014/main" id="{190106D9-6D00-41DA-BC71-EA376B99D2A5}"/>
+              </a:ext>
+            </a:extLst>
+          </p:cNvPr>
+          <p:cNvSpPr>
+            <a:spLocks xmlns:a="http://schemas.openxmlformats.org/drawingml/2006/main" noGrp="1"/>
+          </p:cNvSpPr>
+          <p:nvPr/>
+        </p:nvSpPr>
+        <p:spPr>
+          <a:xfrm xmlns:a="http://schemas.openxmlformats.org/drawingml/2006/main">
+            <a:off x="9715500" y="3371850"/>
+            <a:ext cx="114300" cy="209550"/>
+          </a:xfrm>
+          <a:prstGeom xmlns:a="http://schemas.openxmlformats.org/drawingml/2006/main" prst="rect">
+            <a:avLst/>
+          </a:prstGeom>
+          <a:noFill xmlns:a="http://schemas.openxmlformats.org/drawingml/2006/main"/>
+          <a:ln xmlns:a="http://schemas.openxmlformats.org/drawingml/2006/main" w="0">
+            <a:noFill/>
+            <a:prstDash val="solid"/>
+          </a:ln>
+        </p:spPr>
+        <p:txBody>
+          <a:bodyPr xmlns:a="http://schemas.openxmlformats.org/drawingml/2006/main"/>
+          <a:lstStyle xmlns:a="http://schemas.openxmlformats.org/drawingml/2006/main"/>
+          <a:p xmlns:a="http://schemas.openxmlformats.org/drawingml/2006/main">
+            <a:pPr>
+              <a:defRPr sz="1350" b="1">
+                <a:solidFill>
+                  <a:srgbClr val="7C3AED"/>
+                </a:solidFill>
+              </a:defRPr>
+            </a:pPr>
+            <a:r>
+              <a:rPr sz="1350" b="1">
+                <a:solidFill>
+                  <a:srgbClr val="7C3AED"/>
+                </a:solidFill>
+              </a:rPr>
+              <a:t>·</a:t>
+            </a:r>
+          </a:p>
+        </p:txBody>
+      </p:sp>
+      <p:sp>
+        <p:nvSpPr>
+          <p:cNvPr id="64" name="timeline-item-6-1">
+            <a:extLst xmlns:a="http://schemas.openxmlformats.org/drawingml/2006/main">
+              <a:ext uri="{FF2B5EF4-FFF2-40B4-BE49-F238E27FC236}">
+                <a16:creationId xmlns:a16="http://schemas.microsoft.com/office/drawing/2014/main" id="{2439D32B-D33C-41BA-9F00-74807B4A648D}"/>
+              </a:ext>
+            </a:extLst>
+          </p:cNvPr>
+          <p:cNvSpPr>
+            <a:spLocks xmlns:a="http://schemas.openxmlformats.org/drawingml/2006/main" noGrp="1"/>
+          </p:cNvSpPr>
+          <p:nvPr/>
+        </p:nvSpPr>
+        <p:spPr>
+          <a:xfrm xmlns:a="http://schemas.openxmlformats.org/drawingml/2006/main">
+            <a:off x="9848850" y="3400425"/>
+            <a:ext cx="1123950" cy="285750"/>
+          </a:xfrm>
+          <a:prstGeom xmlns:a="http://schemas.openxmlformats.org/drawingml/2006/main" prst="rect">
+            <a:avLst/>
+          </a:prstGeom>
+          <a:noFill xmlns:a="http://schemas.openxmlformats.org/drawingml/2006/main"/>
+          <a:ln xmlns:a="http://schemas.openxmlformats.org/drawingml/2006/main" w="0">
+            <a:noFill/>
+            <a:prstDash val="solid"/>
+          </a:ln>
+        </p:spPr>
+        <p:txBody>
+          <a:bodyPr xmlns:a="http://schemas.openxmlformats.org/drawingml/2006/main"/>
+          <a:lstStyle xmlns:a="http://schemas.openxmlformats.org/drawingml/2006/main"/>
+          <a:p xmlns:a="http://schemas.openxmlformats.org/drawingml/2006/main">
+            <a:pPr>
+              <a:defRPr sz="938">
+                <a:solidFill>
+                  <a:srgbClr val="CBD5E1"/>
+                </a:solidFill>
+              </a:defRPr>
+            </a:pPr>
+            <a:r>
+              <a:rPr sz="938">
+                <a:solidFill>
+                  <a:srgbClr val="CBD5E1"/>
+                </a:solidFill>
+              </a:rPr>
+              <a:t>배포 리허설</a:t>
+            </a:r>
+          </a:p>
+        </p:txBody>
+      </p:sp>
+      <p:sp>
+        <p:nvSpPr>
+          <p:cNvPr id="65" name="timeline-dot-6-2">
+            <a:extLst xmlns:a="http://schemas.openxmlformats.org/drawingml/2006/main">
+              <a:ext uri="{FF2B5EF4-FFF2-40B4-BE49-F238E27FC236}">
+                <a16:creationId xmlns:a16="http://schemas.microsoft.com/office/drawing/2014/main" id="{2748027A-A1E0-44FB-8956-79C4FDFAEEEC}"/>
+              </a:ext>
+            </a:extLst>
+          </p:cNvPr>
+          <p:cNvSpPr>
+            <a:spLocks xmlns:a="http://schemas.openxmlformats.org/drawingml/2006/main" noGrp="1"/>
+          </p:cNvSpPr>
+          <p:nvPr/>
+        </p:nvSpPr>
+        <p:spPr>
+          <a:xfrm xmlns:a="http://schemas.openxmlformats.org/drawingml/2006/main">
+            <a:off x="9715500" y="3695700"/>
+            <a:ext cx="114300" cy="209550"/>
+          </a:xfrm>
+          <a:prstGeom xmlns:a="http://schemas.openxmlformats.org/drawingml/2006/main" prst="rect">
+            <a:avLst/>
+          </a:prstGeom>
+          <a:noFill xmlns:a="http://schemas.openxmlformats.org/drawingml/2006/main"/>
+          <a:ln xmlns:a="http://schemas.openxmlformats.org/drawingml/2006/main" w="0">
+            <a:noFill/>
+            <a:prstDash val="solid"/>
+          </a:ln>
+        </p:spPr>
+        <p:txBody>
+          <a:bodyPr xmlns:a="http://schemas.openxmlformats.org/drawingml/2006/main"/>
+          <a:lstStyle xmlns:a="http://schemas.openxmlformats.org/drawingml/2006/main"/>
+          <a:p xmlns:a="http://schemas.openxmlformats.org/drawingml/2006/main">
+            <a:pPr>
+              <a:defRPr sz="1350" b="1">
+                <a:solidFill>
+                  <a:srgbClr val="7C3AED"/>
+                </a:solidFill>
+              </a:defRPr>
+            </a:pPr>
+            <a:r>
+              <a:rPr sz="1350" b="1">
+                <a:solidFill>
+                  <a:srgbClr val="7C3AED"/>
+                </a:solidFill>
+              </a:rPr>
+              <a:t>·</a:t>
+            </a:r>
+          </a:p>
+        </p:txBody>
+      </p:sp>
+      <p:sp>
+        <p:nvSpPr>
+          <p:cNvPr id="66" name="timeline-item-6-2">
+            <a:extLst xmlns:a="http://schemas.openxmlformats.org/drawingml/2006/main">
+              <a:ext uri="{FF2B5EF4-FFF2-40B4-BE49-F238E27FC236}">
+                <a16:creationId xmlns:a16="http://schemas.microsoft.com/office/drawing/2014/main" id="{31B4E298-D9E7-40C3-AA0B-6B93AA2CFA53}"/>
+              </a:ext>
+            </a:extLst>
+          </p:cNvPr>
+          <p:cNvSpPr>
+            <a:spLocks xmlns:a="http://schemas.openxmlformats.org/drawingml/2006/main" noGrp="1"/>
+          </p:cNvSpPr>
+          <p:nvPr/>
+        </p:nvSpPr>
+        <p:spPr>
+          <a:xfrm xmlns:a="http://schemas.openxmlformats.org/drawingml/2006/main">
+            <a:off x="9848850" y="3724275"/>
+            <a:ext cx="1123950" cy="285750"/>
+          </a:xfrm>
+          <a:prstGeom xmlns:a="http://schemas.openxmlformats.org/drawingml/2006/main" prst="rect">
+            <a:avLst/>
+          </a:prstGeom>
+          <a:noFill xmlns:a="http://schemas.openxmlformats.org/drawingml/2006/main"/>
+          <a:ln xmlns:a="http://schemas.openxmlformats.org/drawingml/2006/main" w="0">
+            <a:noFill/>
+            <a:prstDash val="solid"/>
+          </a:ln>
+        </p:spPr>
+        <p:txBody>
+          <a:bodyPr xmlns:a="http://schemas.openxmlformats.org/drawingml/2006/main"/>
+          <a:lstStyle xmlns:a="http://schemas.openxmlformats.org/drawingml/2006/main"/>
+          <a:p xmlns:a="http://schemas.openxmlformats.org/drawingml/2006/main">
+            <a:pPr>
+              <a:defRPr sz="938">
+                <a:solidFill>
+                  <a:srgbClr val="CBD5E1"/>
+                </a:solidFill>
+              </a:defRPr>
+            </a:pPr>
+            <a:r>
+              <a:rPr sz="938">
+                <a:solidFill>
+                  <a:srgbClr val="CBD5E1"/>
+                </a:solidFill>
+              </a:rPr>
+              <a:t>장애 대응 플랜</a:t>
+            </a:r>
+          </a:p>
+        </p:txBody>
+      </p:sp>
+      <p:sp>
+        <p:nvSpPr>
+          <p:cNvPr id="67" name="timeline-dot-6-3">
+            <a:extLst xmlns:a="http://schemas.openxmlformats.org/drawingml/2006/main">
+              <a:ext uri="{FF2B5EF4-FFF2-40B4-BE49-F238E27FC236}">
+                <a16:creationId xmlns:a16="http://schemas.microsoft.com/office/drawing/2014/main" id="{2A73B4AA-186E-4F3F-B741-F805FEEFE827}"/>
+              </a:ext>
+            </a:extLst>
+          </p:cNvPr>
+          <p:cNvSpPr>
+            <a:spLocks xmlns:a="http://schemas.openxmlformats.org/drawingml/2006/main" noGrp="1"/>
+          </p:cNvSpPr>
+          <p:nvPr/>
+        </p:nvSpPr>
+        <p:spPr>
+          <a:xfrm xmlns:a="http://schemas.openxmlformats.org/drawingml/2006/main">
+            <a:off x="9715500" y="4019550"/>
+            <a:ext cx="114300" cy="209550"/>
+          </a:xfrm>
+          <a:prstGeom xmlns:a="http://schemas.openxmlformats.org/drawingml/2006/main" prst="rect">
+            <a:avLst/>
+          </a:prstGeom>
+          <a:noFill xmlns:a="http://schemas.openxmlformats.org/drawingml/2006/main"/>
+          <a:ln xmlns:a="http://schemas.openxmlformats.org/drawingml/2006/main" w="0">
+            <a:noFill/>
+            <a:prstDash val="solid"/>
+          </a:ln>
+        </p:spPr>
+        <p:txBody>
+          <a:bodyPr xmlns:a="http://schemas.openxmlformats.org/drawingml/2006/main"/>
+          <a:lstStyle xmlns:a="http://schemas.openxmlformats.org/drawingml/2006/main"/>
+          <a:p xmlns:a="http://schemas.openxmlformats.org/drawingml/2006/main">
+            <a:pPr>
+              <a:defRPr sz="1350" b="1">
+                <a:solidFill>
+                  <a:srgbClr val="7C3AED"/>
+                </a:solidFill>
+              </a:defRPr>
+            </a:pPr>
+            <a:r>
+              <a:rPr sz="1350" b="1">
+                <a:solidFill>
+                  <a:srgbClr val="7C3AED"/>
+                </a:solidFill>
+              </a:rPr>
+              <a:t>·</a:t>
+            </a:r>
+          </a:p>
+        </p:txBody>
+      </p:sp>
+      <p:sp>
+        <p:nvSpPr>
+          <p:cNvPr id="68" name="timeline-item-6-3">
+            <a:extLst xmlns:a="http://schemas.openxmlformats.org/drawingml/2006/main">
+              <a:ext uri="{FF2B5EF4-FFF2-40B4-BE49-F238E27FC236}">
+                <a16:creationId xmlns:a16="http://schemas.microsoft.com/office/drawing/2014/main" id="{8A876E37-2E83-499E-BE87-22697CC10A46}"/>
+              </a:ext>
+            </a:extLst>
+          </p:cNvPr>
+          <p:cNvSpPr>
+            <a:spLocks xmlns:a="http://schemas.openxmlformats.org/drawingml/2006/main" noGrp="1"/>
+          </p:cNvSpPr>
+          <p:nvPr/>
+        </p:nvSpPr>
+        <p:spPr>
+          <a:xfrm xmlns:a="http://schemas.openxmlformats.org/drawingml/2006/main">
+            <a:off x="9848850" y="4048125"/>
+            <a:ext cx="1123950" cy="285750"/>
+          </a:xfrm>
+          <a:prstGeom xmlns:a="http://schemas.openxmlformats.org/drawingml/2006/main" prst="rect">
+            <a:avLst/>
+          </a:prstGeom>
+          <a:noFill xmlns:a="http://schemas.openxmlformats.org/drawingml/2006/main"/>
+          <a:ln xmlns:a="http://schemas.openxmlformats.org/drawingml/2006/main" w="0">
+            <a:noFill/>
+            <a:prstDash val="solid"/>
+          </a:ln>
+        </p:spPr>
+        <p:txBody>
+          <a:bodyPr xmlns:a="http://schemas.openxmlformats.org/drawingml/2006/main"/>
+          <a:lstStyle xmlns:a="http://schemas.openxmlformats.org/drawingml/2006/main"/>
+          <a:p xmlns:a="http://schemas.openxmlformats.org/drawingml/2006/main">
+            <a:pPr>
+              <a:defRPr sz="938">
+                <a:solidFill>
+                  <a:srgbClr val="CBD5E1"/>
+                </a:solidFill>
+              </a:defRPr>
+            </a:pPr>
+            <a:r>
+              <a:rPr sz="938">
+                <a:solidFill>
+                  <a:srgbClr val="CBD5E1"/>
+                </a:solidFill>
+              </a:rPr>
+              <a:t>런칭 당일 체계</a:t>
+            </a:r>
+          </a:p>
+        </p:txBody>
+      </p:sp>
+      <p:sp>
+        <p:nvSpPr>
+          <p:cNvPr id="69" name="management-title">
+            <a:extLst xmlns:a="http://schemas.openxmlformats.org/drawingml/2006/main">
+              <a:ext uri="{FF2B5EF4-FFF2-40B4-BE49-F238E27FC236}">
+                <a16:creationId xmlns:a16="http://schemas.microsoft.com/office/drawing/2014/main" id="{657A9D68-DA2F-4D05-8737-8459A3EAB631}"/>
+              </a:ext>
+            </a:extLst>
+          </p:cNvPr>
+          <p:cNvSpPr>
+            <a:spLocks xmlns:a="http://schemas.openxmlformats.org/drawingml/2006/main" noGrp="1"/>
+          </p:cNvSpPr>
+          <p:nvPr/>
+        </p:nvSpPr>
+        <p:spPr>
+          <a:xfrm xmlns:a="http://schemas.openxmlformats.org/drawingml/2006/main">
+            <a:off x="514350" y="4819650"/>
+            <a:ext cx="2286000" cy="266700"/>
+          </a:xfrm>
+          <a:prstGeom xmlns:a="http://schemas.openxmlformats.org/drawingml/2006/main" prst="rect">
+            <a:avLst/>
+          </a:prstGeom>
+          <a:noFill xmlns:a="http://schemas.openxmlformats.org/drawingml/2006/main"/>
+          <a:ln xmlns:a="http://schemas.openxmlformats.org/drawingml/2006/main" w="0">
+            <a:noFill/>
+            <a:prstDash val="solid"/>
+          </a:ln>
+        </p:spPr>
+        <p:txBody>
+          <a:bodyPr xmlns:a="http://schemas.openxmlformats.org/drawingml/2006/main"/>
+          <a:lstStyle xmlns:a="http://schemas.openxmlformats.org/drawingml/2006/main"/>
+          <a:p xmlns:a="http://schemas.openxmlformats.org/drawingml/2006/main">
+            <a:pPr>
+              <a:defRPr sz="1650" b="1">
+                <a:solidFill>
+                  <a:srgbClr val="FFFFFF"/>
+                </a:solidFill>
+              </a:defRPr>
+            </a:pPr>
+            <a:r>
+              <a:rPr sz="1650" b="1">
+                <a:solidFill>
+                  <a:srgbClr val="FFFFFF"/>
+                </a:solidFill>
+              </a:rPr>
+              <a:t>PM 관리 포인트</a:t>
+            </a:r>
+          </a:p>
+        </p:txBody>
+      </p:sp>
+      <p:sp>
+        <p:nvSpPr>
+          <p:cNvPr id="70" name="management-note">
+            <a:extLst xmlns:a="http://schemas.openxmlformats.org/drawingml/2006/main">
+              <a:ext uri="{FF2B5EF4-FFF2-40B4-BE49-F238E27FC236}">
+                <a16:creationId xmlns:a16="http://schemas.microsoft.com/office/drawing/2014/main" id="{2DB3FD3C-0397-4C22-A692-AA449B6C0B95}"/>
+              </a:ext>
+            </a:extLst>
+          </p:cNvPr>
+          <p:cNvSpPr>
+            <a:spLocks xmlns:a="http://schemas.openxmlformats.org/drawingml/2006/main" noGrp="1"/>
+          </p:cNvSpPr>
+          <p:nvPr/>
+        </p:nvSpPr>
+        <p:spPr>
+          <a:xfrm xmlns:a="http://schemas.openxmlformats.org/drawingml/2006/main">
+            <a:off x="2305050" y="4867275"/>
+            <a:ext cx="7239000" cy="209550"/>
+          </a:xfrm>
+          <a:prstGeom xmlns:a="http://schemas.openxmlformats.org/drawingml/2006/main" prst="rect">
+            <a:avLst/>
+          </a:prstGeom>
+          <a:noFill xmlns:a="http://schemas.openxmlformats.org/drawingml/2006/main"/>
+          <a:ln xmlns:a="http://schemas.openxmlformats.org/drawingml/2006/main" w="0">
+            <a:noFill/>
+            <a:prstDash val="solid"/>
+          </a:ln>
+        </p:spPr>
+        <p:txBody>
+          <a:bodyPr xmlns:a="http://schemas.openxmlformats.org/drawingml/2006/main"/>
+          <a:lstStyle xmlns:a="http://schemas.openxmlformats.org/drawingml/2006/main"/>
+          <a:p xmlns:a="http://schemas.openxmlformats.org/drawingml/2006/main">
+            <a:pPr>
+              <a:defRPr sz="1050">
+                <a:solidFill>
+                  <a:srgbClr val="94A3B8"/>
+                </a:solidFill>
+              </a:defRPr>
+            </a:pPr>
+            <a:r>
+              <a:rPr sz="1050">
+                <a:solidFill>
+                  <a:srgbClr val="94A3B8"/>
+                </a:solidFill>
+              </a:rPr>
+              <a:t>각 단계의 완료 기준을 명확히 두고, 빌드·QA·퍼블리셔 대응을 같은 리듬으로 관리합니다.</a:t>
+            </a:r>
+          </a:p>
+        </p:txBody>
+      </p:sp>
+      <p:sp>
+        <p:nvSpPr>
+          <p:cNvPr id="71" name="mgmt-card-1">
+            <a:extLst xmlns:a="http://schemas.openxmlformats.org/drawingml/2006/main">
+              <a:ext uri="{FF2B5EF4-FFF2-40B4-BE49-F238E27FC236}">
+                <a16:creationId xmlns:a16="http://schemas.microsoft.com/office/drawing/2014/main" id="{95874C78-B412-491A-8015-2E614E140F1A}"/>
+              </a:ext>
+            </a:extLst>
+          </p:cNvPr>
+          <p:cNvSpPr>
+            <a:spLocks xmlns:a="http://schemas.openxmlformats.org/drawingml/2006/main" noGrp="1"/>
+          </p:cNvSpPr>
+          <p:nvPr/>
+        </p:nvSpPr>
+        <p:spPr>
+          <a:xfrm xmlns:a="http://schemas.openxmlformats.org/drawingml/2006/main">
+            <a:off x="514350" y="5200650"/>
+            <a:ext cx="2476500" cy="781050"/>
+          </a:xfrm>
+          <a:prstGeom xmlns:a="http://schemas.openxmlformats.org/drawingml/2006/main" prst="roundRect">
+            <a:avLst>
+              <a:gd name="adj" fmla="val 9756"/>
+            </a:avLst>
+          </a:prstGeom>
+          <a:solidFill xmlns:a="http://schemas.openxmlformats.org/drawingml/2006/main">
+            <a:srgbClr val="151F34"/>
+          </a:solidFill>
+          <a:ln xmlns:a="http://schemas.openxmlformats.org/drawingml/2006/main" w="9525">
+            <a:solidFill>
+              <a:srgbClr val="2F3B55"/>
+            </a:solidFill>
+            <a:prstDash val="solid"/>
+          </a:ln>
+        </p:spPr>
+      </p:sp>
+      <p:sp>
+        <p:nvSpPr>
+          <p:cNvPr id="72" name="mgmt-bar-1">
+            <a:extLst xmlns:a="http://schemas.openxmlformats.org/drawingml/2006/main">
+              <a:ext uri="{FF2B5EF4-FFF2-40B4-BE49-F238E27FC236}">
+                <a16:creationId xmlns:a16="http://schemas.microsoft.com/office/drawing/2014/main" id="{387AF5D1-66A7-4E42-B8F3-225B9438CFBA}"/>
+              </a:ext>
+            </a:extLst>
+          </p:cNvPr>
+          <p:cNvSpPr>
+            <a:spLocks xmlns:a="http://schemas.openxmlformats.org/drawingml/2006/main" noGrp="1"/>
+          </p:cNvSpPr>
+          <p:nvPr/>
+        </p:nvSpPr>
+        <p:spPr>
+          <a:xfrm xmlns:a="http://schemas.openxmlformats.org/drawingml/2006/main">
+            <a:off x="514350" y="5200650"/>
+            <a:ext cx="2476500" cy="47625"/>
+          </a:xfrm>
+          <a:prstGeom xmlns:a="http://schemas.openxmlformats.org/drawingml/2006/main" prst="rect">
+            <a:avLst/>
+          </a:prstGeom>
+          <a:solidFill xmlns:a="http://schemas.openxmlformats.org/drawingml/2006/main">
+            <a:srgbClr val="00B8D9"/>
+          </a:solidFill>
+          <a:ln xmlns:a="http://schemas.openxmlformats.org/drawingml/2006/main" w="0">
+            <a:solidFill>
+              <a:srgbClr val="00B8D9"/>
+            </a:solidFill>
+            <a:prstDash val="solid"/>
+          </a:ln>
+        </p:spPr>
+      </p:sp>
+      <p:sp>
+        <p:nvSpPr>
+          <p:cNvPr id="73" name="mgmt-label-1">
+            <a:extLst xmlns:a="http://schemas.openxmlformats.org/drawingml/2006/main">
+              <a:ext uri="{FF2B5EF4-FFF2-40B4-BE49-F238E27FC236}">
+                <a16:creationId xmlns:a16="http://schemas.microsoft.com/office/drawing/2014/main" id="{29D969DC-8823-4FAD-8BB5-66225A29291B}"/>
+              </a:ext>
+            </a:extLst>
+          </p:cNvPr>
+          <p:cNvSpPr>
+            <a:spLocks xmlns:a="http://schemas.openxmlformats.org/drawingml/2006/main" noGrp="1"/>
+          </p:cNvSpPr>
+          <p:nvPr/>
+        </p:nvSpPr>
+        <p:spPr>
+          <a:xfrm xmlns:a="http://schemas.openxmlformats.org/drawingml/2006/main">
+            <a:off x="704850" y="5391150"/>
+            <a:ext cx="2000250" cy="228600"/>
+          </a:xfrm>
+          <a:prstGeom xmlns:a="http://schemas.openxmlformats.org/drawingml/2006/main" prst="rect">
+            <a:avLst/>
+          </a:prstGeom>
+          <a:noFill xmlns:a="http://schemas.openxmlformats.org/drawingml/2006/main"/>
+          <a:ln xmlns:a="http://schemas.openxmlformats.org/drawingml/2006/main" w="0">
+            <a:noFill/>
+            <a:prstDash val="solid"/>
+          </a:ln>
+        </p:spPr>
+        <p:txBody>
+          <a:bodyPr xmlns:a="http://schemas.openxmlformats.org/drawingml/2006/main"/>
+          <a:lstStyle xmlns:a="http://schemas.openxmlformats.org/drawingml/2006/main"/>
+          <a:p xmlns:a="http://schemas.openxmlformats.org/drawingml/2006/main">
+            <a:pPr>
+              <a:defRPr sz="1275" b="1">
+                <a:solidFill>
+                  <a:srgbClr val="FFFFFF"/>
+                </a:solidFill>
+              </a:defRPr>
+            </a:pPr>
+            <a:r>
+              <a:rPr sz="1275" b="1">
+                <a:solidFill>
+                  <a:srgbClr val="FFFFFF"/>
+                </a:solidFill>
+              </a:rPr>
+              <a:t>마일스톤</a:t>
+            </a:r>
+          </a:p>
+        </p:txBody>
+      </p:sp>
+      <p:sp>
+        <p:nvSpPr>
+          <p:cNvPr id="74" name="mgmt-body-1">
+            <a:extLst xmlns:a="http://schemas.openxmlformats.org/drawingml/2006/main">
+              <a:ext uri="{FF2B5EF4-FFF2-40B4-BE49-F238E27FC236}">
+                <a16:creationId xmlns:a16="http://schemas.microsoft.com/office/drawing/2014/main" id="{1B0F1B00-84EC-4081-86FE-A13B2C45563A}"/>
+              </a:ext>
+            </a:extLst>
+          </p:cNvPr>
+          <p:cNvSpPr>
+            <a:spLocks xmlns:a="http://schemas.openxmlformats.org/drawingml/2006/main" noGrp="1"/>
+          </p:cNvSpPr>
+          <p:nvPr/>
+        </p:nvSpPr>
+        <p:spPr>
+          <a:xfrm xmlns:a="http://schemas.openxmlformats.org/drawingml/2006/main">
+            <a:off x="704850" y="5657850"/>
+            <a:ext cx="2038350" cy="228600"/>
+          </a:xfrm>
+          <a:prstGeom xmlns:a="http://schemas.openxmlformats.org/drawingml/2006/main" prst="rect">
+            <a:avLst/>
+          </a:prstGeom>
+          <a:noFill xmlns:a="http://schemas.openxmlformats.org/drawingml/2006/main"/>
+          <a:ln xmlns:a="http://schemas.openxmlformats.org/drawingml/2006/main" w="0">
+            <a:noFill/>
+            <a:prstDash val="solid"/>
+          </a:ln>
+        </p:spPr>
+        <p:txBody>
+          <a:bodyPr xmlns:a="http://schemas.openxmlformats.org/drawingml/2006/main"/>
+          <a:lstStyle xmlns:a="http://schemas.openxmlformats.org/drawingml/2006/main"/>
+          <a:p xmlns:a="http://schemas.openxmlformats.org/drawingml/2006/main">
+            <a:pPr>
+              <a:defRPr sz="975">
+                <a:solidFill>
+                  <a:srgbClr val="CBD5E1"/>
+                </a:solidFill>
+              </a:defRPr>
+            </a:pPr>
+            <a:r>
+              <a:rPr sz="975">
+                <a:solidFill>
+                  <a:srgbClr val="CBD5E1"/>
+                </a:solidFill>
+              </a:rPr>
+              <a:t>단계별 게이트 기준 관리</a:t>
+            </a:r>
+          </a:p>
+        </p:txBody>
+      </p:sp>
+      <p:sp>
+        <p:nvSpPr>
+          <p:cNvPr id="75" name="mgmt-card-2">
+            <a:extLst xmlns:a="http://schemas.openxmlformats.org/drawingml/2006/main">
+              <a:ext uri="{FF2B5EF4-FFF2-40B4-BE49-F238E27FC236}">
+                <a16:creationId xmlns:a16="http://schemas.microsoft.com/office/drawing/2014/main" id="{75F9B55D-63EB-4E2F-8846-2237E2F6F73C}"/>
+              </a:ext>
+            </a:extLst>
+          </p:cNvPr>
+          <p:cNvSpPr>
+            <a:spLocks xmlns:a="http://schemas.openxmlformats.org/drawingml/2006/main" noGrp="1"/>
+          </p:cNvSpPr>
+          <p:nvPr/>
+        </p:nvSpPr>
+        <p:spPr>
+          <a:xfrm xmlns:a="http://schemas.openxmlformats.org/drawingml/2006/main">
+            <a:off x="3238500" y="5200650"/>
+            <a:ext cx="2476500" cy="781050"/>
+          </a:xfrm>
+          <a:prstGeom xmlns:a="http://schemas.openxmlformats.org/drawingml/2006/main" prst="roundRect">
+            <a:avLst>
+              <a:gd name="adj" fmla="val 9756"/>
+            </a:avLst>
+          </a:prstGeom>
+          <a:solidFill xmlns:a="http://schemas.openxmlformats.org/drawingml/2006/main">
+            <a:srgbClr val="151F34"/>
+          </a:solidFill>
+          <a:ln xmlns:a="http://schemas.openxmlformats.org/drawingml/2006/main" w="9525">
+            <a:solidFill>
+              <a:srgbClr val="2F3B55"/>
+            </a:solidFill>
+            <a:prstDash val="solid"/>
+          </a:ln>
+        </p:spPr>
+      </p:sp>
+      <p:sp>
+        <p:nvSpPr>
+          <p:cNvPr id="76" name="mgmt-bar-2">
+            <a:extLst xmlns:a="http://schemas.openxmlformats.org/drawingml/2006/main">
+              <a:ext uri="{FF2B5EF4-FFF2-40B4-BE49-F238E27FC236}">
+                <a16:creationId xmlns:a16="http://schemas.microsoft.com/office/drawing/2014/main" id="{CD430347-1047-4BA2-A3EC-AED3E9851618}"/>
+              </a:ext>
+            </a:extLst>
+          </p:cNvPr>
+          <p:cNvSpPr>
+            <a:spLocks xmlns:a="http://schemas.openxmlformats.org/drawingml/2006/main" noGrp="1"/>
+          </p:cNvSpPr>
+          <p:nvPr/>
+        </p:nvSpPr>
+        <p:spPr>
+          <a:xfrm xmlns:a="http://schemas.openxmlformats.org/drawingml/2006/main">
+            <a:off x="3238500" y="5200650"/>
+            <a:ext cx="2476500" cy="47625"/>
+          </a:xfrm>
+          <a:prstGeom xmlns:a="http://schemas.openxmlformats.org/drawingml/2006/main" prst="rect">
+            <a:avLst/>
+          </a:prstGeom>
+          <a:solidFill xmlns:a="http://schemas.openxmlformats.org/drawingml/2006/main">
+            <a:srgbClr val="FF6B35"/>
+          </a:solidFill>
+          <a:ln xmlns:a="http://schemas.openxmlformats.org/drawingml/2006/main" w="0">
+            <a:solidFill>
+              <a:srgbClr val="FF6B35"/>
+            </a:solidFill>
+            <a:prstDash val="solid"/>
+          </a:ln>
+        </p:spPr>
+      </p:sp>
+      <p:sp>
+        <p:nvSpPr>
+          <p:cNvPr id="77" name="mgmt-label-2">
+            <a:extLst xmlns:a="http://schemas.openxmlformats.org/drawingml/2006/main">
+              <a:ext uri="{FF2B5EF4-FFF2-40B4-BE49-F238E27FC236}">
+                <a16:creationId xmlns:a16="http://schemas.microsoft.com/office/drawing/2014/main" id="{16686872-EE19-4CCD-9BF5-90BB18013C6D}"/>
+              </a:ext>
+            </a:extLst>
+          </p:cNvPr>
+          <p:cNvSpPr>
+            <a:spLocks xmlns:a="http://schemas.openxmlformats.org/drawingml/2006/main" noGrp="1"/>
+          </p:cNvSpPr>
+          <p:nvPr/>
+        </p:nvSpPr>
+        <p:spPr>
+          <a:xfrm xmlns:a="http://schemas.openxmlformats.org/drawingml/2006/main">
+            <a:off x="3429000" y="5391150"/>
+            <a:ext cx="2000250" cy="228600"/>
+          </a:xfrm>
+          <a:prstGeom xmlns:a="http://schemas.openxmlformats.org/drawingml/2006/main" prst="rect">
+            <a:avLst/>
+          </a:prstGeom>
+          <a:noFill xmlns:a="http://schemas.openxmlformats.org/drawingml/2006/main"/>
+          <a:ln xmlns:a="http://schemas.openxmlformats.org/drawingml/2006/main" w="0">
+            <a:noFill/>
+            <a:prstDash val="solid"/>
+          </a:ln>
+        </p:spPr>
+        <p:txBody>
+          <a:bodyPr xmlns:a="http://schemas.openxmlformats.org/drawingml/2006/main"/>
+          <a:lstStyle xmlns:a="http://schemas.openxmlformats.org/drawingml/2006/main"/>
+          <a:p xmlns:a="http://schemas.openxmlformats.org/drawingml/2006/main">
+            <a:pPr>
+              <a:defRPr sz="1275" b="1">
+                <a:solidFill>
+                  <a:srgbClr val="FFFFFF"/>
+                </a:solidFill>
+              </a:defRPr>
+            </a:pPr>
+            <a:r>
+              <a:rPr sz="1275" b="1">
+                <a:solidFill>
+                  <a:srgbClr val="FFFFFF"/>
+                </a:solidFill>
+              </a:rPr>
+              <a:t>빌드·버전</a:t>
+            </a:r>
+          </a:p>
+        </p:txBody>
+      </p:sp>
+      <p:sp>
+        <p:nvSpPr>
+          <p:cNvPr id="78" name="mgmt-body-2">
+            <a:extLst xmlns:a="http://schemas.openxmlformats.org/drawingml/2006/main">
+              <a:ext uri="{FF2B5EF4-FFF2-40B4-BE49-F238E27FC236}">
+                <a16:creationId xmlns:a16="http://schemas.microsoft.com/office/drawing/2014/main" id="{266ADA6D-5169-4F74-B1F5-10F88A2D4354}"/>
+              </a:ext>
+            </a:extLst>
+          </p:cNvPr>
+          <p:cNvSpPr>
+            <a:spLocks xmlns:a="http://schemas.openxmlformats.org/drawingml/2006/main" noGrp="1"/>
+          </p:cNvSpPr>
+          <p:nvPr/>
+        </p:nvSpPr>
+        <p:spPr>
+          <a:xfrm xmlns:a="http://schemas.openxmlformats.org/drawingml/2006/main">
+            <a:off x="3429000" y="5657850"/>
+            <a:ext cx="2038350" cy="228600"/>
+          </a:xfrm>
+          <a:prstGeom xmlns:a="http://schemas.openxmlformats.org/drawingml/2006/main" prst="rect">
+            <a:avLst/>
+          </a:prstGeom>
+          <a:noFill xmlns:a="http://schemas.openxmlformats.org/drawingml/2006/main"/>
+          <a:ln xmlns:a="http://schemas.openxmlformats.org/drawingml/2006/main" w="0">
+            <a:noFill/>
+            <a:prstDash val="solid"/>
+          </a:ln>
+        </p:spPr>
+        <p:txBody>
+          <a:bodyPr xmlns:a="http://schemas.openxmlformats.org/drawingml/2006/main"/>
+          <a:lstStyle xmlns:a="http://schemas.openxmlformats.org/drawingml/2006/main"/>
+          <a:p xmlns:a="http://schemas.openxmlformats.org/drawingml/2006/main">
+            <a:pPr>
+              <a:defRPr sz="975">
+                <a:solidFill>
+                  <a:srgbClr val="CBD5E1"/>
+                </a:solidFill>
+              </a:defRPr>
+            </a:pPr>
+            <a:r>
+              <a:rPr sz="975">
+                <a:solidFill>
+                  <a:srgbClr val="CBD5E1"/>
+                </a:solidFill>
+              </a:rPr>
+              <a:t>Perforce 기반 후보 빌드 통제</a:t>
+            </a:r>
+          </a:p>
+        </p:txBody>
+      </p:sp>
+      <p:sp>
+        <p:nvSpPr>
+          <p:cNvPr id="79" name="mgmt-card-3">
+            <a:extLst xmlns:a="http://schemas.openxmlformats.org/drawingml/2006/main">
+              <a:ext uri="{FF2B5EF4-FFF2-40B4-BE49-F238E27FC236}">
+                <a16:creationId xmlns:a16="http://schemas.microsoft.com/office/drawing/2014/main" id="{76DA3954-FC8B-404C-9EFF-DE5A5FCD564F}"/>
+              </a:ext>
+            </a:extLst>
+          </p:cNvPr>
+          <p:cNvSpPr>
+            <a:spLocks xmlns:a="http://schemas.openxmlformats.org/drawingml/2006/main" noGrp="1"/>
+          </p:cNvSpPr>
+          <p:nvPr/>
+        </p:nvSpPr>
+        <p:spPr>
+          <a:xfrm xmlns:a="http://schemas.openxmlformats.org/drawingml/2006/main">
+            <a:off x="5962650" y="5200650"/>
+            <a:ext cx="2476500" cy="781050"/>
+          </a:xfrm>
+          <a:prstGeom xmlns:a="http://schemas.openxmlformats.org/drawingml/2006/main" prst="roundRect">
+            <a:avLst>
+              <a:gd name="adj" fmla="val 9756"/>
+            </a:avLst>
+          </a:prstGeom>
+          <a:solidFill xmlns:a="http://schemas.openxmlformats.org/drawingml/2006/main">
+            <a:srgbClr val="151F34"/>
+          </a:solidFill>
+          <a:ln xmlns:a="http://schemas.openxmlformats.org/drawingml/2006/main" w="9525">
+            <a:solidFill>
+              <a:srgbClr val="2F3B55"/>
+            </a:solidFill>
+            <a:prstDash val="solid"/>
+          </a:ln>
+        </p:spPr>
+      </p:sp>
+      <p:sp>
+        <p:nvSpPr>
+          <p:cNvPr id="80" name="mgmt-bar-3">
+            <a:extLst xmlns:a="http://schemas.openxmlformats.org/drawingml/2006/main">
+              <a:ext uri="{FF2B5EF4-FFF2-40B4-BE49-F238E27FC236}">
+                <a16:creationId xmlns:a16="http://schemas.microsoft.com/office/drawing/2014/main" id="{BD1C5FA8-DA5A-4385-8F85-DAE4548F551C}"/>
+              </a:ext>
+            </a:extLst>
+          </p:cNvPr>
+          <p:cNvSpPr>
+            <a:spLocks xmlns:a="http://schemas.openxmlformats.org/drawingml/2006/main" noGrp="1"/>
+          </p:cNvSpPr>
+          <p:nvPr/>
+        </p:nvSpPr>
+        <p:spPr>
+          <a:xfrm xmlns:a="http://schemas.openxmlformats.org/drawingml/2006/main">
+            <a:off x="5962650" y="5200650"/>
+            <a:ext cx="2476500" cy="47625"/>
+          </a:xfrm>
+          <a:prstGeom xmlns:a="http://schemas.openxmlformats.org/drawingml/2006/main" prst="rect">
+            <a:avLst/>
+          </a:prstGeom>
+          <a:solidFill xmlns:a="http://schemas.openxmlformats.org/drawingml/2006/main">
+            <a:srgbClr val="7C3AED"/>
+          </a:solidFill>
+          <a:ln xmlns:a="http://schemas.openxmlformats.org/drawingml/2006/main" w="0">
+            <a:solidFill>
+              <a:srgbClr val="7C3AED"/>
+            </a:solidFill>
+            <a:prstDash val="solid"/>
+          </a:ln>
+        </p:spPr>
+      </p:sp>
+      <p:sp>
+        <p:nvSpPr>
+          <p:cNvPr id="81" name="mgmt-label-3">
+            <a:extLst xmlns:a="http://schemas.openxmlformats.org/drawingml/2006/main">
+              <a:ext uri="{FF2B5EF4-FFF2-40B4-BE49-F238E27FC236}">
+                <a16:creationId xmlns:a16="http://schemas.microsoft.com/office/drawing/2014/main" id="{1A475A50-1440-4941-BE44-EB878926FADB}"/>
+              </a:ext>
+            </a:extLst>
+          </p:cNvPr>
+          <p:cNvSpPr>
+            <a:spLocks xmlns:a="http://schemas.openxmlformats.org/drawingml/2006/main" noGrp="1"/>
+          </p:cNvSpPr>
+          <p:nvPr/>
+        </p:nvSpPr>
+        <p:spPr>
+          <a:xfrm xmlns:a="http://schemas.openxmlformats.org/drawingml/2006/main">
+            <a:off x="6153150" y="5391150"/>
+            <a:ext cx="2000250" cy="228600"/>
+          </a:xfrm>
+          <a:prstGeom xmlns:a="http://schemas.openxmlformats.org/drawingml/2006/main" prst="rect">
+            <a:avLst/>
+          </a:prstGeom>
+          <a:noFill xmlns:a="http://schemas.openxmlformats.org/drawingml/2006/main"/>
+          <a:ln xmlns:a="http://schemas.openxmlformats.org/drawingml/2006/main" w="0">
+            <a:noFill/>
+            <a:prstDash val="solid"/>
+          </a:ln>
+        </p:spPr>
+        <p:txBody>
+          <a:bodyPr xmlns:a="http://schemas.openxmlformats.org/drawingml/2006/main"/>
+          <a:lstStyle xmlns:a="http://schemas.openxmlformats.org/drawingml/2006/main"/>
+          <a:p xmlns:a="http://schemas.openxmlformats.org/drawingml/2006/main">
+            <a:pPr>
+              <a:defRPr sz="1275" b="1">
+                <a:solidFill>
+                  <a:srgbClr val="FFFFFF"/>
+                </a:solidFill>
+              </a:defRPr>
+            </a:pPr>
+            <a:r>
+              <a:rPr sz="1275" b="1">
+                <a:solidFill>
+                  <a:srgbClr val="FFFFFF"/>
+                </a:solidFill>
+              </a:rPr>
+              <a:t>QA</a:t>
+            </a:r>
+          </a:p>
+        </p:txBody>
+      </p:sp>
+      <p:sp>
+        <p:nvSpPr>
+          <p:cNvPr id="82" name="mgmt-body-3">
+            <a:extLst xmlns:a="http://schemas.openxmlformats.org/drawingml/2006/main">
+              <a:ext uri="{FF2B5EF4-FFF2-40B4-BE49-F238E27FC236}">
+                <a16:creationId xmlns:a16="http://schemas.microsoft.com/office/drawing/2014/main" id="{CD5C234B-41EE-4783-A273-5CCA0840F2F9}"/>
+              </a:ext>
+            </a:extLst>
+          </p:cNvPr>
+          <p:cNvSpPr>
+            <a:spLocks xmlns:a="http://schemas.openxmlformats.org/drawingml/2006/main" noGrp="1"/>
+          </p:cNvSpPr>
+          <p:nvPr/>
+        </p:nvSpPr>
+        <p:spPr>
+          <a:xfrm xmlns:a="http://schemas.openxmlformats.org/drawingml/2006/main">
+            <a:off x="6153150" y="5657850"/>
+            <a:ext cx="2038350" cy="228600"/>
+          </a:xfrm>
+          <a:prstGeom xmlns:a="http://schemas.openxmlformats.org/drawingml/2006/main" prst="rect">
+            <a:avLst/>
+          </a:prstGeom>
+          <a:noFill xmlns:a="http://schemas.openxmlformats.org/drawingml/2006/main"/>
+          <a:ln xmlns:a="http://schemas.openxmlformats.org/drawingml/2006/main" w="0">
+            <a:noFill/>
+            <a:prstDash val="solid"/>
+          </a:ln>
+        </p:spPr>
+        <p:txBody>
+          <a:bodyPr xmlns:a="http://schemas.openxmlformats.org/drawingml/2006/main"/>
+          <a:lstStyle xmlns:a="http://schemas.openxmlformats.org/drawingml/2006/main"/>
+          <a:p xmlns:a="http://schemas.openxmlformats.org/drawingml/2006/main">
+            <a:pPr>
+              <a:defRPr sz="975">
+                <a:solidFill>
+                  <a:srgbClr val="CBD5E1"/>
+                </a:solidFill>
+              </a:defRPr>
+            </a:pPr>
+            <a:r>
+              <a:rPr sz="975">
+                <a:solidFill>
+                  <a:srgbClr val="CBD5E1"/>
+                </a:solidFill>
+              </a:rPr>
+              <a:t>결함 우선순위와 수정 반영 추적</a:t>
+            </a:r>
+          </a:p>
+        </p:txBody>
+      </p:sp>
+      <p:sp>
+        <p:nvSpPr>
+          <p:cNvPr id="83" name="mgmt-card-4">
+            <a:extLst xmlns:a="http://schemas.openxmlformats.org/drawingml/2006/main">
+              <a:ext uri="{FF2B5EF4-FFF2-40B4-BE49-F238E27FC236}">
+                <a16:creationId xmlns:a16="http://schemas.microsoft.com/office/drawing/2014/main" id="{97F788D7-0534-4D8A-9201-75B130289D68}"/>
+              </a:ext>
+            </a:extLst>
+          </p:cNvPr>
+          <p:cNvSpPr>
+            <a:spLocks xmlns:a="http://schemas.openxmlformats.org/drawingml/2006/main" noGrp="1"/>
+          </p:cNvSpPr>
+          <p:nvPr/>
+        </p:nvSpPr>
+        <p:spPr>
+          <a:xfrm xmlns:a="http://schemas.openxmlformats.org/drawingml/2006/main">
+            <a:off x="8686800" y="5200650"/>
+            <a:ext cx="2476500" cy="781050"/>
+          </a:xfrm>
+          <a:prstGeom xmlns:a="http://schemas.openxmlformats.org/drawingml/2006/main" prst="roundRect">
+            <a:avLst>
+              <a:gd name="adj" fmla="val 9756"/>
+            </a:avLst>
+          </a:prstGeom>
+          <a:solidFill xmlns:a="http://schemas.openxmlformats.org/drawingml/2006/main">
+            <a:srgbClr val="151F34"/>
+          </a:solidFill>
+          <a:ln xmlns:a="http://schemas.openxmlformats.org/drawingml/2006/main" w="9525">
+            <a:solidFill>
+              <a:srgbClr val="2F3B55"/>
+            </a:solidFill>
+            <a:prstDash val="solid"/>
+          </a:ln>
+        </p:spPr>
+      </p:sp>
+      <p:sp>
+        <p:nvSpPr>
+          <p:cNvPr id="84" name="mgmt-bar-4">
+            <a:extLst xmlns:a="http://schemas.openxmlformats.org/drawingml/2006/main">
+              <a:ext uri="{FF2B5EF4-FFF2-40B4-BE49-F238E27FC236}">
+                <a16:creationId xmlns:a16="http://schemas.microsoft.com/office/drawing/2014/main" id="{DF0CA658-C20E-4AF6-BBC5-D6A3B931803F}"/>
+              </a:ext>
+            </a:extLst>
+          </p:cNvPr>
+          <p:cNvSpPr>
+            <a:spLocks xmlns:a="http://schemas.openxmlformats.org/drawingml/2006/main" noGrp="1"/>
+          </p:cNvSpPr>
+          <p:nvPr/>
+        </p:nvSpPr>
+        <p:spPr>
+          <a:xfrm xmlns:a="http://schemas.openxmlformats.org/drawingml/2006/main">
+            <a:off x="8686800" y="5200650"/>
+            <a:ext cx="2476500" cy="47625"/>
+          </a:xfrm>
+          <a:prstGeom xmlns:a="http://schemas.openxmlformats.org/drawingml/2006/main" prst="rect">
+            <a:avLst/>
+          </a:prstGeom>
+          <a:solidFill xmlns:a="http://schemas.openxmlformats.org/drawingml/2006/main">
+            <a:srgbClr val="8BD9E8"/>
+          </a:solidFill>
+          <a:ln xmlns:a="http://schemas.openxmlformats.org/drawingml/2006/main" w="0">
+            <a:solidFill>
+              <a:srgbClr val="8BD9E8"/>
+            </a:solidFill>
+            <a:prstDash val="solid"/>
+          </a:ln>
+        </p:spPr>
+      </p:sp>
+      <p:sp>
+        <p:nvSpPr>
+          <p:cNvPr id="85" name="mgmt-label-4">
+            <a:extLst xmlns:a="http://schemas.openxmlformats.org/drawingml/2006/main">
+              <a:ext uri="{FF2B5EF4-FFF2-40B4-BE49-F238E27FC236}">
+                <a16:creationId xmlns:a16="http://schemas.microsoft.com/office/drawing/2014/main" id="{122A1E17-FE56-474C-B9CC-481F5BF8D235}"/>
+              </a:ext>
+            </a:extLst>
+          </p:cNvPr>
+          <p:cNvSpPr>
+            <a:spLocks xmlns:a="http://schemas.openxmlformats.org/drawingml/2006/main" noGrp="1"/>
+          </p:cNvSpPr>
+          <p:nvPr/>
+        </p:nvSpPr>
+        <p:spPr>
+          <a:xfrm xmlns:a="http://schemas.openxmlformats.org/drawingml/2006/main">
+            <a:off x="8877300" y="5391150"/>
+            <a:ext cx="2000250" cy="228600"/>
+          </a:xfrm>
+          <a:prstGeom xmlns:a="http://schemas.openxmlformats.org/drawingml/2006/main" prst="rect">
+            <a:avLst/>
+          </a:prstGeom>
+          <a:noFill xmlns:a="http://schemas.openxmlformats.org/drawingml/2006/main"/>
+          <a:ln xmlns:a="http://schemas.openxmlformats.org/drawingml/2006/main" w="0">
+            <a:noFill/>
+            <a:prstDash val="solid"/>
+          </a:ln>
+        </p:spPr>
+        <p:txBody>
+          <a:bodyPr xmlns:a="http://schemas.openxmlformats.org/drawingml/2006/main"/>
+          <a:lstStyle xmlns:a="http://schemas.openxmlformats.org/drawingml/2006/main"/>
+          <a:p xmlns:a="http://schemas.openxmlformats.org/drawingml/2006/main">
+            <a:pPr>
+              <a:defRPr sz="1275" b="1">
+                <a:solidFill>
+                  <a:srgbClr val="FFFFFF"/>
+                </a:solidFill>
+              </a:defRPr>
+            </a:pPr>
+            <a:r>
+              <a:rPr sz="1275" b="1">
+                <a:solidFill>
+                  <a:srgbClr val="FFFFFF"/>
+                </a:solidFill>
+              </a:rPr>
+              <a:t>커뮤니케이션</a:t>
+            </a:r>
+          </a:p>
+        </p:txBody>
+      </p:sp>
+      <p:sp>
+        <p:nvSpPr>
+          <p:cNvPr id="86" name="mgmt-body-4">
+            <a:extLst xmlns:a="http://schemas.openxmlformats.org/drawingml/2006/main">
+              <a:ext uri="{FF2B5EF4-FFF2-40B4-BE49-F238E27FC236}">
+                <a16:creationId xmlns:a16="http://schemas.microsoft.com/office/drawing/2014/main" id="{584C4ED0-EF63-438C-9188-D292E450F6D5}"/>
+              </a:ext>
+            </a:extLst>
+          </p:cNvPr>
+          <p:cNvSpPr>
+            <a:spLocks xmlns:a="http://schemas.openxmlformats.org/drawingml/2006/main" noGrp="1"/>
+          </p:cNvSpPr>
+          <p:nvPr/>
+        </p:nvSpPr>
+        <p:spPr>
+          <a:xfrm xmlns:a="http://schemas.openxmlformats.org/drawingml/2006/main">
+            <a:off x="8877300" y="5657850"/>
+            <a:ext cx="2038350" cy="228600"/>
+          </a:xfrm>
+          <a:prstGeom xmlns:a="http://schemas.openxmlformats.org/drawingml/2006/main" prst="rect">
+            <a:avLst/>
+          </a:prstGeom>
+          <a:noFill xmlns:a="http://schemas.openxmlformats.org/drawingml/2006/main"/>
+          <a:ln xmlns:a="http://schemas.openxmlformats.org/drawingml/2006/main" w="0">
+            <a:noFill/>
+            <a:prstDash val="solid"/>
+          </a:ln>
+        </p:spPr>
+        <p:txBody>
+          <a:bodyPr xmlns:a="http://schemas.openxmlformats.org/drawingml/2006/main"/>
+          <a:lstStyle xmlns:a="http://schemas.openxmlformats.org/drawingml/2006/main"/>
+          <a:p xmlns:a="http://schemas.openxmlformats.org/drawingml/2006/main">
+            <a:pPr>
+              <a:defRPr sz="975">
+                <a:solidFill>
+                  <a:srgbClr val="CBD5E1"/>
+                </a:solidFill>
+              </a:defRPr>
+            </a:pPr>
+            <a:r>
+              <a:rPr sz="975">
+                <a:solidFill>
+                  <a:srgbClr val="CBD5E1"/>
+                </a:solidFill>
+              </a:rPr>
+              <a:t>개발·QA·퍼블리셔 의사결정 정리</a:t>
+            </a:r>
+          </a:p>
+        </p:txBody>
+      </p:sp>
+    </p:spTree>
+    <p:extLst>
+      <p:ext uri="{BB962C8B-B14F-4D97-AF65-F5344CB8AC3E}">
+        <p14:creationId xmlns:p14="http://schemas.microsoft.com/office/powerpoint/2010/main" val="1483899283"/>
       </p:ext>
     </p:extLst>
   </p:cSld>

</xml_diff>

<commit_message>
Add launch gate criteria slide
</commit_message>
<xml_diff>
--- a/outputs/HIT2_일본_런칭_6개월전_로드맵_초안.pptx
+++ b/outputs/HIT2_일본_런칭_6개월전_로드맵_초안.pptx
@@ -2,14 +2,15 @@
 <file path=ppt/presentation.xml><?xml version="1.0" encoding="utf-8"?>
 <p:presentation xmlns:p="http://schemas.openxmlformats.org/presentationml/2006/main">
   <p:sldMasterIdLst>
-    <p:sldMasterId xmlns:r="http://schemas.openxmlformats.org/officeDocument/2006/relationships" id="2147483648" r:id="Ra73ca0284a5045bb"/>
+    <p:sldMasterId xmlns:r="http://schemas.openxmlformats.org/officeDocument/2006/relationships" id="2147483648" r:id="R7418ac167d254113"/>
   </p:sldMasterIdLst>
   <p:notesMasterIdLst>
-    <p:notesMasterId xmlns:r="http://schemas.openxmlformats.org/officeDocument/2006/relationships" r:id="Rd05d2d6db90245b2"/>
+    <p:notesMasterId xmlns:r="http://schemas.openxmlformats.org/officeDocument/2006/relationships" r:id="R914258d389384800"/>
   </p:notesMasterIdLst>
   <p:sldIdLst>
-    <p:sldId xmlns:r="http://schemas.openxmlformats.org/officeDocument/2006/relationships" id="256" r:id="Rcabe6be937b54c9b"/>
-    <p:sldId xmlns:r="http://schemas.openxmlformats.org/officeDocument/2006/relationships" id="257" r:id="Rafd15bd06e254ca0"/>
+    <p:sldId xmlns:r="http://schemas.openxmlformats.org/officeDocument/2006/relationships" id="256" r:id="Rbf84308bdb1b4a64"/>
+    <p:sldId xmlns:r="http://schemas.openxmlformats.org/officeDocument/2006/relationships" id="257" r:id="R62c02af46f574785"/>
+    <p:sldId xmlns:r="http://schemas.openxmlformats.org/officeDocument/2006/relationships" id="258" r:id="R1e1f5645a8ae41e2"/>
   </p:sldIdLst>
   <p:sldSz cx="12192000" cy="6858000"/>
   <p:notesSz cx="6858000" cy="9144000"/>
@@ -630,6 +631,72 @@
 </p:notes>
 </file>
 
+<file path=ppt/notesSlides/notesSlide3.xml><?xml version="1.0" encoding="utf-8"?>
+<p:notes xmlns:p="http://schemas.openxmlformats.org/presentationml/2006/main">
+  <p:cSld>
+    <p:spTree>
+      <p:nvGrpSpPr>
+        <p:cNvPr id="1" name=""/>
+        <p:cNvGrpSpPr/>
+        <p:nvPr/>
+      </p:nvGrpSpPr>
+      <p:grpSpPr>
+        <a:xfrm xmlns:a="http://schemas.openxmlformats.org/drawingml/2006/main"/>
+      </p:grpSpPr>
+      <p:sp>
+        <p:nvSpPr>
+          <p:cNvPr id="2" name="Slide Image Placeholder 1"/>
+          <p:cNvSpPr>
+            <a:spLocks xmlns:a="http://schemas.openxmlformats.org/drawingml/2006/main" noGrp="1"/>
+          </p:cNvSpPr>
+          <p:nvPr>
+            <p:ph type="sldImg" idx="0"/>
+          </p:nvPr>
+        </p:nvSpPr>
+        <p:spPr/>
+      </p:sp>
+      <p:sp>
+        <p:nvSpPr>
+          <p:cNvPr id="3" name="Notes Placeholder 2"/>
+          <p:cNvSpPr>
+            <a:spLocks xmlns:a="http://schemas.openxmlformats.org/drawingml/2006/main" noGrp="1"/>
+          </p:cNvSpPr>
+          <p:nvPr>
+            <p:ph type="body" idx="1"/>
+          </p:nvPr>
+        </p:nvSpPr>
+        <p:spPr/>
+        <p:txBody>
+          <a:bodyPr xmlns:a="http://schemas.openxmlformats.org/drawingml/2006/main"/>
+          <a:lstStyle xmlns:a="http://schemas.openxmlformats.org/drawingml/2006/main"/>
+          <a:p xmlns:a="http://schemas.openxmlformats.org/drawingml/2006/main"/>
+        </p:txBody>
+      </p:sp>
+      <p:sp>
+        <p:nvSpPr>
+          <p:cNvPr id="4" name="Slide Number Placeholder 3"/>
+          <p:cNvSpPr>
+            <a:spLocks xmlns:a="http://schemas.openxmlformats.org/drawingml/2006/main" noGrp="1"/>
+          </p:cNvSpPr>
+          <p:nvPr>
+            <p:ph type="sldNum" idx="5"/>
+          </p:nvPr>
+        </p:nvSpPr>
+        <p:spPr/>
+        <p:txBody>
+          <a:bodyPr xmlns:a="http://schemas.openxmlformats.org/drawingml/2006/main"/>
+          <a:lstStyle xmlns:a="http://schemas.openxmlformats.org/drawingml/2006/main"/>
+          <a:p xmlns:a="http://schemas.openxmlformats.org/drawingml/2006/main"/>
+        </p:txBody>
+      </p:sp>
+    </p:spTree>
+  </p:cSld>
+  <p:clrMapOvr>
+    <a:masterClrMapping xmlns:a="http://schemas.openxmlformats.org/drawingml/2006/main"/>
+  </p:clrMapOvr>
+</p:notes>
+</file>
+
 <file path=ppt/slideLayouts/slideLayout1.xml><?xml version="1.0" encoding="utf-8"?>
 <p:sldLayout xmlns:p="http://schemas.openxmlformats.org/presentationml/2006/main" type="title">
   <p:cSld name="Title Slide">
@@ -668,7 +735,7 @@
   </p:cSld>
   <p:clrMap bg1="lt1" tx1="dk1" bg2="lt2" tx2="dk2" accent1="accent1" accent2="accent2" accent3="accent3" accent4="accent4" accent5="accent5" accent6="accent6" hlink="hlink" folHlink="folHlink"/>
   <p:sldLayoutIdLst>
-    <p:sldLayoutId xmlns:r="http://schemas.openxmlformats.org/officeDocument/2006/relationships" id="2147483649" r:id="Reae83263f9e94357"/>
+    <p:sldLayoutId xmlns:r="http://schemas.openxmlformats.org/officeDocument/2006/relationships" id="2147483649" r:id="R520cccd694914c8d"/>
   </p:sldLayoutIdLst>
   <p:txStyles>
     <p:titleStyle>
@@ -1219,7 +1286,7 @@
           <p:cNvPr id="1" name="top-accent">
             <a:extLst xmlns:a="http://schemas.openxmlformats.org/drawingml/2006/main">
               <a:ext uri="{FF2B5EF4-FFF2-40B4-BE49-F238E27FC236}">
-                <a16:creationId xmlns:a16="http://schemas.microsoft.com/office/drawing/2014/main" id="{BA9FC31A-24E2-4404-8D73-0C0E94D66413}"/>
+                <a16:creationId xmlns:a16="http://schemas.microsoft.com/office/drawing/2014/main" id="{915478D6-C4E2-4B02-B978-E2F4ED0B4302}"/>
               </a:ext>
             </a:extLst>
           </p:cNvPr>
@@ -1252,7 +1319,7 @@
           <p:cNvPr id="2" name="left-accent">
             <a:extLst xmlns:a="http://schemas.openxmlformats.org/drawingml/2006/main">
               <a:ext uri="{FF2B5EF4-FFF2-40B4-BE49-F238E27FC236}">
-                <a16:creationId xmlns:a16="http://schemas.microsoft.com/office/drawing/2014/main" id="{318ECBE9-8C22-4F3C-A00A-0DBDAB7CC6BA}"/>
+                <a16:creationId xmlns:a16="http://schemas.microsoft.com/office/drawing/2014/main" id="{ED023C25-CB6D-456D-AE1F-3AB87497C6EE}"/>
               </a:ext>
             </a:extLst>
           </p:cNvPr>
@@ -1285,7 +1352,7 @@
           <p:cNvPr id="3" name="eyebrow">
             <a:extLst xmlns:a="http://schemas.openxmlformats.org/drawingml/2006/main">
               <a:ext uri="{FF2B5EF4-FFF2-40B4-BE49-F238E27FC236}">
-                <a16:creationId xmlns:a16="http://schemas.microsoft.com/office/drawing/2014/main" id="{A1088874-0181-4485-8D4B-6D337C2D4B34}"/>
+                <a16:creationId xmlns:a16="http://schemas.microsoft.com/office/drawing/2014/main" id="{7DB9DD6E-0B1E-409D-9F47-FAD1755D8796}"/>
               </a:ext>
             </a:extLst>
           </p:cNvPr>
@@ -1335,7 +1402,7 @@
           <p:cNvPr id="4" name="footer">
             <a:extLst xmlns:a="http://schemas.openxmlformats.org/drawingml/2006/main">
               <a:ext uri="{FF2B5EF4-FFF2-40B4-BE49-F238E27FC236}">
-                <a16:creationId xmlns:a16="http://schemas.microsoft.com/office/drawing/2014/main" id="{F27946D4-1325-49F4-A7C7-396F3A828558}"/>
+                <a16:creationId xmlns:a16="http://schemas.microsoft.com/office/drawing/2014/main" id="{589EBEF4-E64A-4757-B3AA-658A0BEB716C}"/>
               </a:ext>
             </a:extLst>
           </p:cNvPr>
@@ -1385,7 +1452,7 @@
           <p:cNvPr id="5" name="page-no">
             <a:extLst xmlns:a="http://schemas.openxmlformats.org/drawingml/2006/main">
               <a:ext uri="{FF2B5EF4-FFF2-40B4-BE49-F238E27FC236}">
-                <a16:creationId xmlns:a16="http://schemas.microsoft.com/office/drawing/2014/main" id="{03285238-2862-4D0E-AA45-748D870B772A}"/>
+                <a16:creationId xmlns:a16="http://schemas.microsoft.com/office/drawing/2014/main" id="{7C8D61A1-8182-427F-9A8C-3EEC5C7D58FD}"/>
               </a:ext>
             </a:extLst>
           </p:cNvPr>
@@ -1435,7 +1502,7 @@
           <p:cNvPr id="6" name="hero-panel">
             <a:extLst xmlns:a="http://schemas.openxmlformats.org/drawingml/2006/main">
               <a:ext uri="{FF2B5EF4-FFF2-40B4-BE49-F238E27FC236}">
-                <a16:creationId xmlns:a16="http://schemas.microsoft.com/office/drawing/2014/main" id="{FD609226-52E0-494C-8185-45B80C8E88E0}"/>
+                <a16:creationId xmlns:a16="http://schemas.microsoft.com/office/drawing/2014/main" id="{7F599A71-FE45-4C49-96E6-376333CFDEFC}"/>
               </a:ext>
             </a:extLst>
           </p:cNvPr>
@@ -1468,7 +1535,7 @@
           <p:cNvPr id="7" name="hero-kicker">
             <a:extLst xmlns:a="http://schemas.openxmlformats.org/drawingml/2006/main">
               <a:ext uri="{FF2B5EF4-FFF2-40B4-BE49-F238E27FC236}">
-                <a16:creationId xmlns:a16="http://schemas.microsoft.com/office/drawing/2014/main" id="{7D29E825-A250-42CC-93B2-2582FB102106}"/>
+                <a16:creationId xmlns:a16="http://schemas.microsoft.com/office/drawing/2014/main" id="{90BFCC91-B00C-485F-B5D4-0FEFE6A16920}"/>
               </a:ext>
             </a:extLst>
           </p:cNvPr>
@@ -1518,7 +1585,7 @@
           <p:cNvPr id="8" name="hero-title">
             <a:extLst xmlns:a="http://schemas.openxmlformats.org/drawingml/2006/main">
               <a:ext uri="{FF2B5EF4-FFF2-40B4-BE49-F238E27FC236}">
-                <a16:creationId xmlns:a16="http://schemas.microsoft.com/office/drawing/2014/main" id="{CEBCDEA0-AB34-49D3-B587-18E4B8685E76}"/>
+                <a16:creationId xmlns:a16="http://schemas.microsoft.com/office/drawing/2014/main" id="{1C1624C8-8DA4-42D9-B024-2AFD8DD768CA}"/>
               </a:ext>
             </a:extLst>
           </p:cNvPr>
@@ -1568,7 +1635,7 @@
           <p:cNvPr id="9" name="hero-subtitle">
             <a:extLst xmlns:a="http://schemas.openxmlformats.org/drawingml/2006/main">
               <a:ext uri="{FF2B5EF4-FFF2-40B4-BE49-F238E27FC236}">
-                <a16:creationId xmlns:a16="http://schemas.microsoft.com/office/drawing/2014/main" id="{F36DB0B3-40AF-4C87-80C1-DD45C1636414}"/>
+                <a16:creationId xmlns:a16="http://schemas.microsoft.com/office/drawing/2014/main" id="{BF1973F7-EDD0-4609-98B4-6074D36C725E}"/>
               </a:ext>
             </a:extLst>
           </p:cNvPr>
@@ -1618,7 +1685,7 @@
           <p:cNvPr id="10" name="tag-1">
             <a:extLst xmlns:a="http://schemas.openxmlformats.org/drawingml/2006/main">
               <a:ext uri="{FF2B5EF4-FFF2-40B4-BE49-F238E27FC236}">
-                <a16:creationId xmlns:a16="http://schemas.microsoft.com/office/drawing/2014/main" id="{3C230F18-95ED-4475-8E79-85CE2E583DA2}"/>
+                <a16:creationId xmlns:a16="http://schemas.microsoft.com/office/drawing/2014/main" id="{E7D25977-DB2E-4C56-BBDB-EBF5336941CB}"/>
               </a:ext>
             </a:extLst>
           </p:cNvPr>
@@ -1674,7 +1741,7 @@
           <p:cNvPr id="11" name="tag-2">
             <a:extLst xmlns:a="http://schemas.openxmlformats.org/drawingml/2006/main">
               <a:ext uri="{FF2B5EF4-FFF2-40B4-BE49-F238E27FC236}">
-                <a16:creationId xmlns:a16="http://schemas.microsoft.com/office/drawing/2014/main" id="{51E654B1-2B53-4070-8AAD-BC79C07BE457}"/>
+                <a16:creationId xmlns:a16="http://schemas.microsoft.com/office/drawing/2014/main" id="{25EAF25A-8F71-46E2-83E8-2341EE1CE9AA}"/>
               </a:ext>
             </a:extLst>
           </p:cNvPr>
@@ -1730,7 +1797,7 @@
           <p:cNvPr id="12" name="tag-3">
             <a:extLst xmlns:a="http://schemas.openxmlformats.org/drawingml/2006/main">
               <a:ext uri="{FF2B5EF4-FFF2-40B4-BE49-F238E27FC236}">
-                <a16:creationId xmlns:a16="http://schemas.microsoft.com/office/drawing/2014/main" id="{F9DEF68A-91EE-4212-AD10-F7BF4B3B98A2}"/>
+                <a16:creationId xmlns:a16="http://schemas.microsoft.com/office/drawing/2014/main" id="{A882FE4B-C872-4CCB-B7FD-CA0AE586B88B}"/>
               </a:ext>
             </a:extLst>
           </p:cNvPr>
@@ -1786,7 +1853,7 @@
           <p:cNvPr id="13" name="scope-title">
             <a:extLst xmlns:a="http://schemas.openxmlformats.org/drawingml/2006/main">
               <a:ext uri="{FF2B5EF4-FFF2-40B4-BE49-F238E27FC236}">
-                <a16:creationId xmlns:a16="http://schemas.microsoft.com/office/drawing/2014/main" id="{DE00ADF5-937B-4350-97C0-4F09F1B3A46A}"/>
+                <a16:creationId xmlns:a16="http://schemas.microsoft.com/office/drawing/2014/main" id="{DCC71DF3-4F72-4FC7-A341-27A46AF26988}"/>
               </a:ext>
             </a:extLst>
           </p:cNvPr>
@@ -1836,7 +1903,7 @@
           <p:cNvPr id="14" name="scope-note">
             <a:extLst xmlns:a="http://schemas.openxmlformats.org/drawingml/2006/main">
               <a:ext uri="{FF2B5EF4-FFF2-40B4-BE49-F238E27FC236}">
-                <a16:creationId xmlns:a16="http://schemas.microsoft.com/office/drawing/2014/main" id="{F4A25A1E-BD60-434D-949D-46F03D72D672}"/>
+                <a16:creationId xmlns:a16="http://schemas.microsoft.com/office/drawing/2014/main" id="{4E5FAB43-19AB-4831-BA4A-663D456C7B9A}"/>
               </a:ext>
             </a:extLst>
           </p:cNvPr>
@@ -1886,7 +1953,7 @@
           <p:cNvPr id="15" name="scope-row-1">
             <a:extLst xmlns:a="http://schemas.openxmlformats.org/drawingml/2006/main">
               <a:ext uri="{FF2B5EF4-FFF2-40B4-BE49-F238E27FC236}">
-                <a16:creationId xmlns:a16="http://schemas.microsoft.com/office/drawing/2014/main" id="{57A04C4A-D67B-4AE3-8A04-3D58CF5483ED}"/>
+                <a16:creationId xmlns:a16="http://schemas.microsoft.com/office/drawing/2014/main" id="{14595D21-8304-4EBB-BEA7-CE99EC4F026A}"/>
               </a:ext>
             </a:extLst>
           </p:cNvPr>
@@ -1919,7 +1986,7 @@
           <p:cNvPr id="16" name="scope-label-1">
             <a:extLst xmlns:a="http://schemas.openxmlformats.org/drawingml/2006/main">
               <a:ext uri="{FF2B5EF4-FFF2-40B4-BE49-F238E27FC236}">
-                <a16:creationId xmlns:a16="http://schemas.microsoft.com/office/drawing/2014/main" id="{658382CF-33F6-449F-A938-CE6049F75E7F}"/>
+                <a16:creationId xmlns:a16="http://schemas.microsoft.com/office/drawing/2014/main" id="{07E724B2-100F-4078-9CB9-ADFAC0406180}"/>
               </a:ext>
             </a:extLst>
           </p:cNvPr>
@@ -1969,7 +2036,7 @@
           <p:cNvPr id="17" name="scope-value-1">
             <a:extLst xmlns:a="http://schemas.openxmlformats.org/drawingml/2006/main">
               <a:ext uri="{FF2B5EF4-FFF2-40B4-BE49-F238E27FC236}">
-                <a16:creationId xmlns:a16="http://schemas.microsoft.com/office/drawing/2014/main" id="{958A698B-FB6D-408A-A016-79A50C0A600D}"/>
+                <a16:creationId xmlns:a16="http://schemas.microsoft.com/office/drawing/2014/main" id="{F513CBC5-C018-430F-A0C7-D02C876A99C2}"/>
               </a:ext>
             </a:extLst>
           </p:cNvPr>
@@ -2019,7 +2086,7 @@
           <p:cNvPr id="18" name="scope-row-2">
             <a:extLst xmlns:a="http://schemas.openxmlformats.org/drawingml/2006/main">
               <a:ext uri="{FF2B5EF4-FFF2-40B4-BE49-F238E27FC236}">
-                <a16:creationId xmlns:a16="http://schemas.microsoft.com/office/drawing/2014/main" id="{FAA8AA22-D23C-4662-BFC3-342F8D78C932}"/>
+                <a16:creationId xmlns:a16="http://schemas.microsoft.com/office/drawing/2014/main" id="{211FAC08-5FE6-461F-AEEA-C2DAA87D426C}"/>
               </a:ext>
             </a:extLst>
           </p:cNvPr>
@@ -2052,7 +2119,7 @@
           <p:cNvPr id="19" name="scope-label-2">
             <a:extLst xmlns:a="http://schemas.openxmlformats.org/drawingml/2006/main">
               <a:ext uri="{FF2B5EF4-FFF2-40B4-BE49-F238E27FC236}">
-                <a16:creationId xmlns:a16="http://schemas.microsoft.com/office/drawing/2014/main" id="{857210C4-0BD7-481A-B085-0C863E570C78}"/>
+                <a16:creationId xmlns:a16="http://schemas.microsoft.com/office/drawing/2014/main" id="{C1D609A1-251D-4C43-A8DF-60CE86A126CA}"/>
               </a:ext>
             </a:extLst>
           </p:cNvPr>
@@ -2102,7 +2169,7 @@
           <p:cNvPr id="20" name="scope-value-2">
             <a:extLst xmlns:a="http://schemas.openxmlformats.org/drawingml/2006/main">
               <a:ext uri="{FF2B5EF4-FFF2-40B4-BE49-F238E27FC236}">
-                <a16:creationId xmlns:a16="http://schemas.microsoft.com/office/drawing/2014/main" id="{1F4EC4FE-49C0-48C7-9317-6B5EE8F9D505}"/>
+                <a16:creationId xmlns:a16="http://schemas.microsoft.com/office/drawing/2014/main" id="{FE07C9B7-9251-4B43-9E01-4083708FBFF8}"/>
               </a:ext>
             </a:extLst>
           </p:cNvPr>
@@ -2152,7 +2219,7 @@
           <p:cNvPr id="21" name="scope-row-3">
             <a:extLst xmlns:a="http://schemas.openxmlformats.org/drawingml/2006/main">
               <a:ext uri="{FF2B5EF4-FFF2-40B4-BE49-F238E27FC236}">
-                <a16:creationId xmlns:a16="http://schemas.microsoft.com/office/drawing/2014/main" id="{DCEDB403-193A-4FDA-8B1C-C3528D274A9D}"/>
+                <a16:creationId xmlns:a16="http://schemas.microsoft.com/office/drawing/2014/main" id="{21C8AF00-CCD6-46F2-8DBE-D2845BB7CCFD}"/>
               </a:ext>
             </a:extLst>
           </p:cNvPr>
@@ -2185,7 +2252,7 @@
           <p:cNvPr id="22" name="scope-label-3">
             <a:extLst xmlns:a="http://schemas.openxmlformats.org/drawingml/2006/main">
               <a:ext uri="{FF2B5EF4-FFF2-40B4-BE49-F238E27FC236}">
-                <a16:creationId xmlns:a16="http://schemas.microsoft.com/office/drawing/2014/main" id="{EF8A8527-2333-4FE1-BDB5-85394A0F0672}"/>
+                <a16:creationId xmlns:a16="http://schemas.microsoft.com/office/drawing/2014/main" id="{C300E796-8E6E-43F6-A80F-C9670605ED63}"/>
               </a:ext>
             </a:extLst>
           </p:cNvPr>
@@ -2235,7 +2302,7 @@
           <p:cNvPr id="23" name="scope-value-3">
             <a:extLst xmlns:a="http://schemas.openxmlformats.org/drawingml/2006/main">
               <a:ext uri="{FF2B5EF4-FFF2-40B4-BE49-F238E27FC236}">
-                <a16:creationId xmlns:a16="http://schemas.microsoft.com/office/drawing/2014/main" id="{BD0BA77F-1F53-4CD9-8D29-03B1205F2629}"/>
+                <a16:creationId xmlns:a16="http://schemas.microsoft.com/office/drawing/2014/main" id="{56474A90-BFBB-4C1D-A98C-99EEF3BCAE81}"/>
               </a:ext>
             </a:extLst>
           </p:cNvPr>
@@ -2285,7 +2352,7 @@
           <p:cNvPr id="24" name="scope-row-4">
             <a:extLst xmlns:a="http://schemas.openxmlformats.org/drawingml/2006/main">
               <a:ext uri="{FF2B5EF4-FFF2-40B4-BE49-F238E27FC236}">
-                <a16:creationId xmlns:a16="http://schemas.microsoft.com/office/drawing/2014/main" id="{4E5E8517-434A-4200-98FF-3A61BF8C2793}"/>
+                <a16:creationId xmlns:a16="http://schemas.microsoft.com/office/drawing/2014/main" id="{73653595-F7BC-4DFD-83C4-2D0E57A7E781}"/>
               </a:ext>
             </a:extLst>
           </p:cNvPr>
@@ -2318,7 +2385,7 @@
           <p:cNvPr id="25" name="scope-label-4">
             <a:extLst xmlns:a="http://schemas.openxmlformats.org/drawingml/2006/main">
               <a:ext uri="{FF2B5EF4-FFF2-40B4-BE49-F238E27FC236}">
-                <a16:creationId xmlns:a16="http://schemas.microsoft.com/office/drawing/2014/main" id="{3FD7D3B8-F3D6-4D8C-BF9C-25E80BD4B53D}"/>
+                <a16:creationId xmlns:a16="http://schemas.microsoft.com/office/drawing/2014/main" id="{85390BD5-B89F-4BB8-BA98-689D64857A30}"/>
               </a:ext>
             </a:extLst>
           </p:cNvPr>
@@ -2368,7 +2435,7 @@
           <p:cNvPr id="26" name="scope-value-4">
             <a:extLst xmlns:a="http://schemas.openxmlformats.org/drawingml/2006/main">
               <a:ext uri="{FF2B5EF4-FFF2-40B4-BE49-F238E27FC236}">
-                <a16:creationId xmlns:a16="http://schemas.microsoft.com/office/drawing/2014/main" id="{2FE173D4-F179-413D-89B6-DEA695318E05}"/>
+                <a16:creationId xmlns:a16="http://schemas.microsoft.com/office/drawing/2014/main" id="{8EB7FB78-6B7A-460D-A1D4-35DE81FC8814}"/>
               </a:ext>
             </a:extLst>
           </p:cNvPr>
@@ -2418,7 +2485,7 @@
           <p:cNvPr id="27" name="evidence-title">
             <a:extLst xmlns:a="http://schemas.openxmlformats.org/drawingml/2006/main">
               <a:ext uri="{FF2B5EF4-FFF2-40B4-BE49-F238E27FC236}">
-                <a16:creationId xmlns:a16="http://schemas.microsoft.com/office/drawing/2014/main" id="{A69FE48F-F86B-42D3-AAEE-9148AE6AEE7D}"/>
+                <a16:creationId xmlns:a16="http://schemas.microsoft.com/office/drawing/2014/main" id="{E144894E-E9C3-4C11-A88C-B54C375B6B69}"/>
               </a:ext>
             </a:extLst>
           </p:cNvPr>
@@ -2468,7 +2535,7 @@
           <p:cNvPr id="28" name="evidence-card-1">
             <a:extLst xmlns:a="http://schemas.openxmlformats.org/drawingml/2006/main">
               <a:ext uri="{FF2B5EF4-FFF2-40B4-BE49-F238E27FC236}">
-                <a16:creationId xmlns:a16="http://schemas.microsoft.com/office/drawing/2014/main" id="{8F8751F5-E4BD-4F7C-9DBE-C1AD8DEAD100}"/>
+                <a16:creationId xmlns:a16="http://schemas.microsoft.com/office/drawing/2014/main" id="{9F0A17F9-2C37-4464-A861-B1F2A50E45D2}"/>
               </a:ext>
             </a:extLst>
           </p:cNvPr>
@@ -2503,7 +2570,7 @@
           <p:cNvPr id="29" name="evidence-bar-1">
             <a:extLst xmlns:a="http://schemas.openxmlformats.org/drawingml/2006/main">
               <a:ext uri="{FF2B5EF4-FFF2-40B4-BE49-F238E27FC236}">
-                <a16:creationId xmlns:a16="http://schemas.microsoft.com/office/drawing/2014/main" id="{D3946514-A71F-4A76-93AE-E9B8436F774F}"/>
+                <a16:creationId xmlns:a16="http://schemas.microsoft.com/office/drawing/2014/main" id="{E1D4CD3B-1413-4F23-89D8-7D6D932FB9A9}"/>
               </a:ext>
             </a:extLst>
           </p:cNvPr>
@@ -2536,7 +2603,7 @@
           <p:cNvPr id="30" name="evidence-title-1">
             <a:extLst xmlns:a="http://schemas.openxmlformats.org/drawingml/2006/main">
               <a:ext uri="{FF2B5EF4-FFF2-40B4-BE49-F238E27FC236}">
-                <a16:creationId xmlns:a16="http://schemas.microsoft.com/office/drawing/2014/main" id="{0ACB3B3B-5594-4D6D-A20C-2CDFDB9E3494}"/>
+                <a16:creationId xmlns:a16="http://schemas.microsoft.com/office/drawing/2014/main" id="{FECBBD11-8719-4334-AE99-8D7050E3EEA1}"/>
               </a:ext>
             </a:extLst>
           </p:cNvPr>
@@ -2586,7 +2653,7 @@
           <p:cNvPr id="31" name="evidence-body-1">
             <a:extLst xmlns:a="http://schemas.openxmlformats.org/drawingml/2006/main">
               <a:ext uri="{FF2B5EF4-FFF2-40B4-BE49-F238E27FC236}">
-                <a16:creationId xmlns:a16="http://schemas.microsoft.com/office/drawing/2014/main" id="{1864AB51-8B78-4549-A3C4-5DF3A917A8A9}"/>
+                <a16:creationId xmlns:a16="http://schemas.microsoft.com/office/drawing/2014/main" id="{7DA3C8AF-2BE6-4EAA-B12F-E6F86AD4FB73}"/>
               </a:ext>
             </a:extLst>
           </p:cNvPr>
@@ -2636,7 +2703,7 @@
           <p:cNvPr id="32" name="evidence-card-2">
             <a:extLst xmlns:a="http://schemas.openxmlformats.org/drawingml/2006/main">
               <a:ext uri="{FF2B5EF4-FFF2-40B4-BE49-F238E27FC236}">
-                <a16:creationId xmlns:a16="http://schemas.microsoft.com/office/drawing/2014/main" id="{7181B067-7D75-44B3-B434-7135E72E6C7D}"/>
+                <a16:creationId xmlns:a16="http://schemas.microsoft.com/office/drawing/2014/main" id="{0402305E-2FC3-4D57-9615-EC82D4528476}"/>
               </a:ext>
             </a:extLst>
           </p:cNvPr>
@@ -2671,7 +2738,7 @@
           <p:cNvPr id="33" name="evidence-bar-2">
             <a:extLst xmlns:a="http://schemas.openxmlformats.org/drawingml/2006/main">
               <a:ext uri="{FF2B5EF4-FFF2-40B4-BE49-F238E27FC236}">
-                <a16:creationId xmlns:a16="http://schemas.microsoft.com/office/drawing/2014/main" id="{0618AE7F-A349-4F0B-9F29-5A8D5E4E7064}"/>
+                <a16:creationId xmlns:a16="http://schemas.microsoft.com/office/drawing/2014/main" id="{7A0852F6-63E3-4D71-95B8-5D543F31E956}"/>
               </a:ext>
             </a:extLst>
           </p:cNvPr>
@@ -2704,7 +2771,7 @@
           <p:cNvPr id="34" name="evidence-title-2">
             <a:extLst xmlns:a="http://schemas.openxmlformats.org/drawingml/2006/main">
               <a:ext uri="{FF2B5EF4-FFF2-40B4-BE49-F238E27FC236}">
-                <a16:creationId xmlns:a16="http://schemas.microsoft.com/office/drawing/2014/main" id="{C84310C6-A1C5-4E24-8066-794B43ACA04E}"/>
+                <a16:creationId xmlns:a16="http://schemas.microsoft.com/office/drawing/2014/main" id="{00172DA9-9DA4-41F7-93F0-DA3C609E9A45}"/>
               </a:ext>
             </a:extLst>
           </p:cNvPr>
@@ -2754,7 +2821,7 @@
           <p:cNvPr id="35" name="evidence-body-2">
             <a:extLst xmlns:a="http://schemas.openxmlformats.org/drawingml/2006/main">
               <a:ext uri="{FF2B5EF4-FFF2-40B4-BE49-F238E27FC236}">
-                <a16:creationId xmlns:a16="http://schemas.microsoft.com/office/drawing/2014/main" id="{C510D274-6E8C-4EC0-BCBB-657D6A37ED45}"/>
+                <a16:creationId xmlns:a16="http://schemas.microsoft.com/office/drawing/2014/main" id="{0C1CEADD-B4AF-45C6-A413-BF9B600D5944}"/>
               </a:ext>
             </a:extLst>
           </p:cNvPr>
@@ -2804,7 +2871,7 @@
           <p:cNvPr id="36" name="evidence-card-3">
             <a:extLst xmlns:a="http://schemas.openxmlformats.org/drawingml/2006/main">
               <a:ext uri="{FF2B5EF4-FFF2-40B4-BE49-F238E27FC236}">
-                <a16:creationId xmlns:a16="http://schemas.microsoft.com/office/drawing/2014/main" id="{0879F31C-1545-4B71-8D1C-4E182904FE4B}"/>
+                <a16:creationId xmlns:a16="http://schemas.microsoft.com/office/drawing/2014/main" id="{2FD10DC0-7D6D-4493-B081-68F14DB5E5DD}"/>
               </a:ext>
             </a:extLst>
           </p:cNvPr>
@@ -2839,7 +2906,7 @@
           <p:cNvPr id="37" name="evidence-bar-3">
             <a:extLst xmlns:a="http://schemas.openxmlformats.org/drawingml/2006/main">
               <a:ext uri="{FF2B5EF4-FFF2-40B4-BE49-F238E27FC236}">
-                <a16:creationId xmlns:a16="http://schemas.microsoft.com/office/drawing/2014/main" id="{869906C6-9186-42F5-A2E2-B131D7AE65FF}"/>
+                <a16:creationId xmlns:a16="http://schemas.microsoft.com/office/drawing/2014/main" id="{71BBF68A-5F9D-46DA-8F79-B0F6D3F28786}"/>
               </a:ext>
             </a:extLst>
           </p:cNvPr>
@@ -2872,7 +2939,7 @@
           <p:cNvPr id="38" name="evidence-title-3">
             <a:extLst xmlns:a="http://schemas.openxmlformats.org/drawingml/2006/main">
               <a:ext uri="{FF2B5EF4-FFF2-40B4-BE49-F238E27FC236}">
-                <a16:creationId xmlns:a16="http://schemas.microsoft.com/office/drawing/2014/main" id="{A42996BC-EB0E-493F-857E-9582E1ADAE12}"/>
+                <a16:creationId xmlns:a16="http://schemas.microsoft.com/office/drawing/2014/main" id="{582CC6DC-17B6-4C56-B9C6-4C11AF3FFBBE}"/>
               </a:ext>
             </a:extLst>
           </p:cNvPr>
@@ -2922,7 +2989,7 @@
           <p:cNvPr id="39" name="evidence-body-3">
             <a:extLst xmlns:a="http://schemas.openxmlformats.org/drawingml/2006/main">
               <a:ext uri="{FF2B5EF4-FFF2-40B4-BE49-F238E27FC236}">
-                <a16:creationId xmlns:a16="http://schemas.microsoft.com/office/drawing/2014/main" id="{6112007E-216F-4F3F-B515-F92FA3BF0777}"/>
+                <a16:creationId xmlns:a16="http://schemas.microsoft.com/office/drawing/2014/main" id="{7060E1E2-4592-4FEC-84B8-08631965E3D6}"/>
               </a:ext>
             </a:extLst>
           </p:cNvPr>
@@ -2970,7 +3037,7 @@
     </p:spTree>
     <p:extLst>
       <p:ext uri="{BB962C8B-B14F-4D97-AF65-F5344CB8AC3E}">
-        <p14:creationId xmlns:p14="http://schemas.microsoft.com/office/powerpoint/2010/main" val="1814583000"/>
+        <p14:creationId xmlns:p14="http://schemas.microsoft.com/office/powerpoint/2010/main" val="1414832179"/>
       </p:ext>
     </p:extLst>
   </p:cSld>
@@ -3001,7 +3068,7 @@
           <p:cNvPr id="1" name="top-accent">
             <a:extLst xmlns:a="http://schemas.openxmlformats.org/drawingml/2006/main">
               <a:ext uri="{FF2B5EF4-FFF2-40B4-BE49-F238E27FC236}">
-                <a16:creationId xmlns:a16="http://schemas.microsoft.com/office/drawing/2014/main" id="{EBB80E51-0ED0-49EC-8FE2-B00791127130}"/>
+                <a16:creationId xmlns:a16="http://schemas.microsoft.com/office/drawing/2014/main" id="{C5B4065F-AF9C-472D-BEAC-01079763F569}"/>
               </a:ext>
             </a:extLst>
           </p:cNvPr>
@@ -3034,7 +3101,7 @@
           <p:cNvPr id="2" name="left-accent">
             <a:extLst xmlns:a="http://schemas.openxmlformats.org/drawingml/2006/main">
               <a:ext uri="{FF2B5EF4-FFF2-40B4-BE49-F238E27FC236}">
-                <a16:creationId xmlns:a16="http://schemas.microsoft.com/office/drawing/2014/main" id="{C24A0E22-DBDD-40F8-9CE4-B7DE98CA4311}"/>
+                <a16:creationId xmlns:a16="http://schemas.microsoft.com/office/drawing/2014/main" id="{108FB09B-C99E-40FA-B33C-CB151F014D58}"/>
               </a:ext>
             </a:extLst>
           </p:cNvPr>
@@ -3067,7 +3134,7 @@
           <p:cNvPr id="3" name="eyebrow">
             <a:extLst xmlns:a="http://schemas.openxmlformats.org/drawingml/2006/main">
               <a:ext uri="{FF2B5EF4-FFF2-40B4-BE49-F238E27FC236}">
-                <a16:creationId xmlns:a16="http://schemas.microsoft.com/office/drawing/2014/main" id="{ACE46DBE-529B-45B7-9DDB-08AB9C00C335}"/>
+                <a16:creationId xmlns:a16="http://schemas.microsoft.com/office/drawing/2014/main" id="{79F5C9BA-0339-4966-B12E-4B48029BD32C}"/>
               </a:ext>
             </a:extLst>
           </p:cNvPr>
@@ -3117,7 +3184,7 @@
           <p:cNvPr id="4" name="footer">
             <a:extLst xmlns:a="http://schemas.openxmlformats.org/drawingml/2006/main">
               <a:ext uri="{FF2B5EF4-FFF2-40B4-BE49-F238E27FC236}">
-                <a16:creationId xmlns:a16="http://schemas.microsoft.com/office/drawing/2014/main" id="{4912B251-6BBA-4BA2-A2DF-E4F5BC0CDB98}"/>
+                <a16:creationId xmlns:a16="http://schemas.microsoft.com/office/drawing/2014/main" id="{E5F9E4AD-7573-48A5-ACD7-C7697C81D5BD}"/>
               </a:ext>
             </a:extLst>
           </p:cNvPr>
@@ -3167,7 +3234,7 @@
           <p:cNvPr id="5" name="page-no">
             <a:extLst xmlns:a="http://schemas.openxmlformats.org/drawingml/2006/main">
               <a:ext uri="{FF2B5EF4-FFF2-40B4-BE49-F238E27FC236}">
-                <a16:creationId xmlns:a16="http://schemas.microsoft.com/office/drawing/2014/main" id="{2F44404A-D74F-4723-A909-5A7426041865}"/>
+                <a16:creationId xmlns:a16="http://schemas.microsoft.com/office/drawing/2014/main" id="{EA804ACF-259E-4576-BC80-30A91CFCC5C9}"/>
               </a:ext>
             </a:extLst>
           </p:cNvPr>
@@ -3217,7 +3284,7 @@
           <p:cNvPr id="6" name="title-02">
             <a:extLst xmlns:a="http://schemas.openxmlformats.org/drawingml/2006/main">
               <a:ext uri="{FF2B5EF4-FFF2-40B4-BE49-F238E27FC236}">
-                <a16:creationId xmlns:a16="http://schemas.microsoft.com/office/drawing/2014/main" id="{AD090A17-AB26-44C5-AE0A-9FF3F5451184}"/>
+                <a16:creationId xmlns:a16="http://schemas.microsoft.com/office/drawing/2014/main" id="{78331278-F27C-4F68-B39D-4C8FE45FE7EF}"/>
               </a:ext>
             </a:extLst>
           </p:cNvPr>
@@ -3267,7 +3334,7 @@
           <p:cNvPr id="7" name="subtitle-02">
             <a:extLst xmlns:a="http://schemas.openxmlformats.org/drawingml/2006/main">
               <a:ext uri="{FF2B5EF4-FFF2-40B4-BE49-F238E27FC236}">
-                <a16:creationId xmlns:a16="http://schemas.microsoft.com/office/drawing/2014/main" id="{3F87A94A-29D3-4C6A-AAD5-A2EB499DF463}"/>
+                <a16:creationId xmlns:a16="http://schemas.microsoft.com/office/drawing/2014/main" id="{06A6556A-7FB6-4A2A-894E-DF69689361A0}"/>
               </a:ext>
             </a:extLst>
           </p:cNvPr>
@@ -3317,7 +3384,7 @@
           <p:cNvPr id="8" name="timeline-line">
             <a:extLst xmlns:a="http://schemas.openxmlformats.org/drawingml/2006/main">
               <a:ext uri="{FF2B5EF4-FFF2-40B4-BE49-F238E27FC236}">
-                <a16:creationId xmlns:a16="http://schemas.microsoft.com/office/drawing/2014/main" id="{1AF8BC8D-223B-43A2-9E68-EF004A05E248}"/>
+                <a16:creationId xmlns:a16="http://schemas.microsoft.com/office/drawing/2014/main" id="{F91F3DFC-FD0B-49A9-B449-8A082B1A6CA5}"/>
               </a:ext>
             </a:extLst>
           </p:cNvPr>
@@ -3350,7 +3417,7 @@
           <p:cNvPr id="9" name="timeline-card-1">
             <a:extLst xmlns:a="http://schemas.openxmlformats.org/drawingml/2006/main">
               <a:ext uri="{FF2B5EF4-FFF2-40B4-BE49-F238E27FC236}">
-                <a16:creationId xmlns:a16="http://schemas.microsoft.com/office/drawing/2014/main" id="{EFBFFD49-DD52-4A22-8ADE-37BE131635FA}"/>
+                <a16:creationId xmlns:a16="http://schemas.microsoft.com/office/drawing/2014/main" id="{7C77F99E-032D-4082-A73D-ACFCA4610A4B}"/>
               </a:ext>
             </a:extLst>
           </p:cNvPr>
@@ -3385,7 +3452,7 @@
           <p:cNvPr id="10" name="timeline-bar-1">
             <a:extLst xmlns:a="http://schemas.openxmlformats.org/drawingml/2006/main">
               <a:ext uri="{FF2B5EF4-FFF2-40B4-BE49-F238E27FC236}">
-                <a16:creationId xmlns:a16="http://schemas.microsoft.com/office/drawing/2014/main" id="{5A3401E8-7500-4EB5-8E2C-BB27C1F4A13A}"/>
+                <a16:creationId xmlns:a16="http://schemas.microsoft.com/office/drawing/2014/main" id="{DC9B893B-A935-411F-BD8B-472C4675A11A}"/>
               </a:ext>
             </a:extLst>
           </p:cNvPr>
@@ -3418,7 +3485,7 @@
           <p:cNvPr id="11" name="timeline-month-1">
             <a:extLst xmlns:a="http://schemas.openxmlformats.org/drawingml/2006/main">
               <a:ext uri="{FF2B5EF4-FFF2-40B4-BE49-F238E27FC236}">
-                <a16:creationId xmlns:a16="http://schemas.microsoft.com/office/drawing/2014/main" id="{703AAC99-3161-44FF-9822-7B87989DDD58}"/>
+                <a16:creationId xmlns:a16="http://schemas.microsoft.com/office/drawing/2014/main" id="{D8D2538B-AEF6-42C5-83B2-FF5C5510FD29}"/>
               </a:ext>
             </a:extLst>
           </p:cNvPr>
@@ -3468,7 +3535,7 @@
           <p:cNvPr id="12" name="timeline-title-1">
             <a:extLst xmlns:a="http://schemas.openxmlformats.org/drawingml/2006/main">
               <a:ext uri="{FF2B5EF4-FFF2-40B4-BE49-F238E27FC236}">
-                <a16:creationId xmlns:a16="http://schemas.microsoft.com/office/drawing/2014/main" id="{310E51D9-78D8-41E2-BD52-A6D90BB6F05E}"/>
+                <a16:creationId xmlns:a16="http://schemas.microsoft.com/office/drawing/2014/main" id="{8F055F9B-1FD6-4BD3-A5E6-FFFB716924A6}"/>
               </a:ext>
             </a:extLst>
           </p:cNvPr>
@@ -3518,7 +3585,7 @@
           <p:cNvPr id="13" name="timeline-dot-1-1">
             <a:extLst xmlns:a="http://schemas.openxmlformats.org/drawingml/2006/main">
               <a:ext uri="{FF2B5EF4-FFF2-40B4-BE49-F238E27FC236}">
-                <a16:creationId xmlns:a16="http://schemas.microsoft.com/office/drawing/2014/main" id="{2545BA35-18C3-4855-B268-0F93E7310E76}"/>
+                <a16:creationId xmlns:a16="http://schemas.microsoft.com/office/drawing/2014/main" id="{80971BCC-3E95-401E-AC84-3D9D98071784}"/>
               </a:ext>
             </a:extLst>
           </p:cNvPr>
@@ -3568,7 +3635,7 @@
           <p:cNvPr id="14" name="timeline-item-1-1">
             <a:extLst xmlns:a="http://schemas.openxmlformats.org/drawingml/2006/main">
               <a:ext uri="{FF2B5EF4-FFF2-40B4-BE49-F238E27FC236}">
-                <a16:creationId xmlns:a16="http://schemas.microsoft.com/office/drawing/2014/main" id="{C3BF3712-6DCB-452E-9361-31439A5109C9}"/>
+                <a16:creationId xmlns:a16="http://schemas.microsoft.com/office/drawing/2014/main" id="{CD321824-E8AB-4817-8643-F9EFC76F8F08}"/>
               </a:ext>
             </a:extLst>
           </p:cNvPr>
@@ -3618,7 +3685,7 @@
           <p:cNvPr id="15" name="timeline-dot-1-2">
             <a:extLst xmlns:a="http://schemas.openxmlformats.org/drawingml/2006/main">
               <a:ext uri="{FF2B5EF4-FFF2-40B4-BE49-F238E27FC236}">
-                <a16:creationId xmlns:a16="http://schemas.microsoft.com/office/drawing/2014/main" id="{BAE03365-4177-4DBF-93B3-32C74B6B9703}"/>
+                <a16:creationId xmlns:a16="http://schemas.microsoft.com/office/drawing/2014/main" id="{6C80BE1F-3692-402D-A54D-A9AED1732DED}"/>
               </a:ext>
             </a:extLst>
           </p:cNvPr>
@@ -3668,7 +3735,7 @@
           <p:cNvPr id="16" name="timeline-item-1-2">
             <a:extLst xmlns:a="http://schemas.openxmlformats.org/drawingml/2006/main">
               <a:ext uri="{FF2B5EF4-FFF2-40B4-BE49-F238E27FC236}">
-                <a16:creationId xmlns:a16="http://schemas.microsoft.com/office/drawing/2014/main" id="{C72E1EAB-6587-4DFC-A7E0-5CA9317DFCF4}"/>
+                <a16:creationId xmlns:a16="http://schemas.microsoft.com/office/drawing/2014/main" id="{41ACFFF6-0F0E-491C-9FC3-2F490CF7E94E}"/>
               </a:ext>
             </a:extLst>
           </p:cNvPr>
@@ -3718,7 +3785,7 @@
           <p:cNvPr id="17" name="timeline-dot-1-3">
             <a:extLst xmlns:a="http://schemas.openxmlformats.org/drawingml/2006/main">
               <a:ext uri="{FF2B5EF4-FFF2-40B4-BE49-F238E27FC236}">
-                <a16:creationId xmlns:a16="http://schemas.microsoft.com/office/drawing/2014/main" id="{4EB239D0-99D9-478C-AB5A-4C3346BBCB5E}"/>
+                <a16:creationId xmlns:a16="http://schemas.microsoft.com/office/drawing/2014/main" id="{93FB5EA8-3AF8-40B6-A1A6-A1C03486FDAD}"/>
               </a:ext>
             </a:extLst>
           </p:cNvPr>
@@ -3768,7 +3835,7 @@
           <p:cNvPr id="18" name="timeline-item-1-3">
             <a:extLst xmlns:a="http://schemas.openxmlformats.org/drawingml/2006/main">
               <a:ext uri="{FF2B5EF4-FFF2-40B4-BE49-F238E27FC236}">
-                <a16:creationId xmlns:a16="http://schemas.microsoft.com/office/drawing/2014/main" id="{CD947CD6-1804-424A-A055-55F33C68C8E0}"/>
+                <a16:creationId xmlns:a16="http://schemas.microsoft.com/office/drawing/2014/main" id="{688CC708-B5E4-4124-9905-347F2F4DB545}"/>
               </a:ext>
             </a:extLst>
           </p:cNvPr>
@@ -3818,7 +3885,7 @@
           <p:cNvPr id="19" name="timeline-card-2">
             <a:extLst xmlns:a="http://schemas.openxmlformats.org/drawingml/2006/main">
               <a:ext uri="{FF2B5EF4-FFF2-40B4-BE49-F238E27FC236}">
-                <a16:creationId xmlns:a16="http://schemas.microsoft.com/office/drawing/2014/main" id="{A6A5FF29-6E45-4EAB-9E78-33592C55CDE7}"/>
+                <a16:creationId xmlns:a16="http://schemas.microsoft.com/office/drawing/2014/main" id="{FFDA65BA-3851-4630-AADC-C8C7C5E58341}"/>
               </a:ext>
             </a:extLst>
           </p:cNvPr>
@@ -3853,7 +3920,7 @@
           <p:cNvPr id="20" name="timeline-bar-2">
             <a:extLst xmlns:a="http://schemas.openxmlformats.org/drawingml/2006/main">
               <a:ext uri="{FF2B5EF4-FFF2-40B4-BE49-F238E27FC236}">
-                <a16:creationId xmlns:a16="http://schemas.microsoft.com/office/drawing/2014/main" id="{195578C6-DF0A-417B-8993-D858D5074EFE}"/>
+                <a16:creationId xmlns:a16="http://schemas.microsoft.com/office/drawing/2014/main" id="{DFB40DC3-62CB-46FF-9115-A62DE7525413}"/>
               </a:ext>
             </a:extLst>
           </p:cNvPr>
@@ -3886,7 +3953,7 @@
           <p:cNvPr id="21" name="timeline-month-2">
             <a:extLst xmlns:a="http://schemas.openxmlformats.org/drawingml/2006/main">
               <a:ext uri="{FF2B5EF4-FFF2-40B4-BE49-F238E27FC236}">
-                <a16:creationId xmlns:a16="http://schemas.microsoft.com/office/drawing/2014/main" id="{2F94A874-4DB0-4CA3-83CA-394EFD5BA16E}"/>
+                <a16:creationId xmlns:a16="http://schemas.microsoft.com/office/drawing/2014/main" id="{8E56C1FC-16A7-46D6-81CC-83BC6D5FBD1A}"/>
               </a:ext>
             </a:extLst>
           </p:cNvPr>
@@ -3936,7 +4003,7 @@
           <p:cNvPr id="22" name="timeline-title-2">
             <a:extLst xmlns:a="http://schemas.openxmlformats.org/drawingml/2006/main">
               <a:ext uri="{FF2B5EF4-FFF2-40B4-BE49-F238E27FC236}">
-                <a16:creationId xmlns:a16="http://schemas.microsoft.com/office/drawing/2014/main" id="{76C5231A-93DB-45B9-86B3-CEFBF886ACEB}"/>
+                <a16:creationId xmlns:a16="http://schemas.microsoft.com/office/drawing/2014/main" id="{F5A3600C-4C7E-4B5B-9E0A-4B5C35708D0B}"/>
               </a:ext>
             </a:extLst>
           </p:cNvPr>
@@ -3986,7 +4053,7 @@
           <p:cNvPr id="23" name="timeline-dot-2-1">
             <a:extLst xmlns:a="http://schemas.openxmlformats.org/drawingml/2006/main">
               <a:ext uri="{FF2B5EF4-FFF2-40B4-BE49-F238E27FC236}">
-                <a16:creationId xmlns:a16="http://schemas.microsoft.com/office/drawing/2014/main" id="{020463C6-BC47-48BF-8E26-D5597B163F5B}"/>
+                <a16:creationId xmlns:a16="http://schemas.microsoft.com/office/drawing/2014/main" id="{02A0192B-0F5C-496D-8AFA-9A9A22D38638}"/>
               </a:ext>
             </a:extLst>
           </p:cNvPr>
@@ -4036,7 +4103,7 @@
           <p:cNvPr id="24" name="timeline-item-2-1">
             <a:extLst xmlns:a="http://schemas.openxmlformats.org/drawingml/2006/main">
               <a:ext uri="{FF2B5EF4-FFF2-40B4-BE49-F238E27FC236}">
-                <a16:creationId xmlns:a16="http://schemas.microsoft.com/office/drawing/2014/main" id="{3601A83A-6A0D-4219-922A-88584211CE82}"/>
+                <a16:creationId xmlns:a16="http://schemas.microsoft.com/office/drawing/2014/main" id="{1B617751-0E19-44A9-885C-5248CD6F92B4}"/>
               </a:ext>
             </a:extLst>
           </p:cNvPr>
@@ -4086,7 +4153,7 @@
           <p:cNvPr id="25" name="timeline-dot-2-2">
             <a:extLst xmlns:a="http://schemas.openxmlformats.org/drawingml/2006/main">
               <a:ext uri="{FF2B5EF4-FFF2-40B4-BE49-F238E27FC236}">
-                <a16:creationId xmlns:a16="http://schemas.microsoft.com/office/drawing/2014/main" id="{DBCA3854-95EB-4A81-8013-74D58CFF98D3}"/>
+                <a16:creationId xmlns:a16="http://schemas.microsoft.com/office/drawing/2014/main" id="{DCF2427C-B0D1-4741-A7EC-6665F528DAEF}"/>
               </a:ext>
             </a:extLst>
           </p:cNvPr>
@@ -4136,7 +4203,7 @@
           <p:cNvPr id="26" name="timeline-item-2-2">
             <a:extLst xmlns:a="http://schemas.openxmlformats.org/drawingml/2006/main">
               <a:ext uri="{FF2B5EF4-FFF2-40B4-BE49-F238E27FC236}">
-                <a16:creationId xmlns:a16="http://schemas.microsoft.com/office/drawing/2014/main" id="{95A3EB83-2426-4D0C-9654-94ECA511AC99}"/>
+                <a16:creationId xmlns:a16="http://schemas.microsoft.com/office/drawing/2014/main" id="{C4114685-59AA-4F8D-A302-36C5E17610E6}"/>
               </a:ext>
             </a:extLst>
           </p:cNvPr>
@@ -4186,7 +4253,7 @@
           <p:cNvPr id="27" name="timeline-dot-2-3">
             <a:extLst xmlns:a="http://schemas.openxmlformats.org/drawingml/2006/main">
               <a:ext uri="{FF2B5EF4-FFF2-40B4-BE49-F238E27FC236}">
-                <a16:creationId xmlns:a16="http://schemas.microsoft.com/office/drawing/2014/main" id="{E89A61DA-D74F-4394-AA66-6EAC342B81E2}"/>
+                <a16:creationId xmlns:a16="http://schemas.microsoft.com/office/drawing/2014/main" id="{81570395-076B-4FED-A557-EC569F0B7504}"/>
               </a:ext>
             </a:extLst>
           </p:cNvPr>
@@ -4236,7 +4303,7 @@
           <p:cNvPr id="28" name="timeline-item-2-3">
             <a:extLst xmlns:a="http://schemas.openxmlformats.org/drawingml/2006/main">
               <a:ext uri="{FF2B5EF4-FFF2-40B4-BE49-F238E27FC236}">
-                <a16:creationId xmlns:a16="http://schemas.microsoft.com/office/drawing/2014/main" id="{5B3A70E0-2073-4398-AA10-6696199C42FE}"/>
+                <a16:creationId xmlns:a16="http://schemas.microsoft.com/office/drawing/2014/main" id="{23A0BD52-9FAE-4941-831F-A134F181F5EE}"/>
               </a:ext>
             </a:extLst>
           </p:cNvPr>
@@ -4286,7 +4353,7 @@
           <p:cNvPr id="29" name="timeline-card-3">
             <a:extLst xmlns:a="http://schemas.openxmlformats.org/drawingml/2006/main">
               <a:ext uri="{FF2B5EF4-FFF2-40B4-BE49-F238E27FC236}">
-                <a16:creationId xmlns:a16="http://schemas.microsoft.com/office/drawing/2014/main" id="{8136DCB9-7B16-4913-B210-019306A147DF}"/>
+                <a16:creationId xmlns:a16="http://schemas.microsoft.com/office/drawing/2014/main" id="{1B6A0DB0-0281-4B47-B3CE-008B196B1D06}"/>
               </a:ext>
             </a:extLst>
           </p:cNvPr>
@@ -4321,7 +4388,7 @@
           <p:cNvPr id="30" name="timeline-bar-3">
             <a:extLst xmlns:a="http://schemas.openxmlformats.org/drawingml/2006/main">
               <a:ext uri="{FF2B5EF4-FFF2-40B4-BE49-F238E27FC236}">
-                <a16:creationId xmlns:a16="http://schemas.microsoft.com/office/drawing/2014/main" id="{B2144D0E-8254-4CB6-B9A8-ABDA7373B5B3}"/>
+                <a16:creationId xmlns:a16="http://schemas.microsoft.com/office/drawing/2014/main" id="{D01BEA83-8DBD-48F2-B5F4-65C655709F87}"/>
               </a:ext>
             </a:extLst>
           </p:cNvPr>
@@ -4354,7 +4421,7 @@
           <p:cNvPr id="31" name="timeline-month-3">
             <a:extLst xmlns:a="http://schemas.openxmlformats.org/drawingml/2006/main">
               <a:ext uri="{FF2B5EF4-FFF2-40B4-BE49-F238E27FC236}">
-                <a16:creationId xmlns:a16="http://schemas.microsoft.com/office/drawing/2014/main" id="{77674FC3-5C2A-4F69-A853-0FED66BEE363}"/>
+                <a16:creationId xmlns:a16="http://schemas.microsoft.com/office/drawing/2014/main" id="{AB52A153-9088-4B9F-8969-835F9CE5864E}"/>
               </a:ext>
             </a:extLst>
           </p:cNvPr>
@@ -4404,7 +4471,7 @@
           <p:cNvPr id="32" name="timeline-title-3">
             <a:extLst xmlns:a="http://schemas.openxmlformats.org/drawingml/2006/main">
               <a:ext uri="{FF2B5EF4-FFF2-40B4-BE49-F238E27FC236}">
-                <a16:creationId xmlns:a16="http://schemas.microsoft.com/office/drawing/2014/main" id="{E5C1CD1D-8EE7-48FC-8C18-ED01B85A7784}"/>
+                <a16:creationId xmlns:a16="http://schemas.microsoft.com/office/drawing/2014/main" id="{DB557715-32F0-4615-A65D-51786465E29C}"/>
               </a:ext>
             </a:extLst>
           </p:cNvPr>
@@ -4454,7 +4521,7 @@
           <p:cNvPr id="33" name="timeline-dot-3-1">
             <a:extLst xmlns:a="http://schemas.openxmlformats.org/drawingml/2006/main">
               <a:ext uri="{FF2B5EF4-FFF2-40B4-BE49-F238E27FC236}">
-                <a16:creationId xmlns:a16="http://schemas.microsoft.com/office/drawing/2014/main" id="{E646D37B-A309-43BD-9623-BEB634A2106B}"/>
+                <a16:creationId xmlns:a16="http://schemas.microsoft.com/office/drawing/2014/main" id="{76A309AA-CA30-499F-BB0E-5856264DC388}"/>
               </a:ext>
             </a:extLst>
           </p:cNvPr>
@@ -4504,7 +4571,7 @@
           <p:cNvPr id="34" name="timeline-item-3-1">
             <a:extLst xmlns:a="http://schemas.openxmlformats.org/drawingml/2006/main">
               <a:ext uri="{FF2B5EF4-FFF2-40B4-BE49-F238E27FC236}">
-                <a16:creationId xmlns:a16="http://schemas.microsoft.com/office/drawing/2014/main" id="{F2439954-C73C-450D-B0BA-31CA66C854E3}"/>
+                <a16:creationId xmlns:a16="http://schemas.microsoft.com/office/drawing/2014/main" id="{DB4D1398-DD4C-46B8-9D91-52BCEF95632B}"/>
               </a:ext>
             </a:extLst>
           </p:cNvPr>
@@ -4554,7 +4621,7 @@
           <p:cNvPr id="35" name="timeline-dot-3-2">
             <a:extLst xmlns:a="http://schemas.openxmlformats.org/drawingml/2006/main">
               <a:ext uri="{FF2B5EF4-FFF2-40B4-BE49-F238E27FC236}">
-                <a16:creationId xmlns:a16="http://schemas.microsoft.com/office/drawing/2014/main" id="{819E8031-7889-44B8-A34D-0CC7BDAA3DF4}"/>
+                <a16:creationId xmlns:a16="http://schemas.microsoft.com/office/drawing/2014/main" id="{35BDA465-81F7-40F5-93A7-4A01701CF8C7}"/>
               </a:ext>
             </a:extLst>
           </p:cNvPr>
@@ -4604,7 +4671,7 @@
           <p:cNvPr id="36" name="timeline-item-3-2">
             <a:extLst xmlns:a="http://schemas.openxmlformats.org/drawingml/2006/main">
               <a:ext uri="{FF2B5EF4-FFF2-40B4-BE49-F238E27FC236}">
-                <a16:creationId xmlns:a16="http://schemas.microsoft.com/office/drawing/2014/main" id="{DB62570B-87A0-4119-A730-3E2AE8C291AE}"/>
+                <a16:creationId xmlns:a16="http://schemas.microsoft.com/office/drawing/2014/main" id="{646CBF00-3F2B-42E7-9FCD-39398F6DC1D1}"/>
               </a:ext>
             </a:extLst>
           </p:cNvPr>
@@ -4654,7 +4721,7 @@
           <p:cNvPr id="37" name="timeline-dot-3-3">
             <a:extLst xmlns:a="http://schemas.openxmlformats.org/drawingml/2006/main">
               <a:ext uri="{FF2B5EF4-FFF2-40B4-BE49-F238E27FC236}">
-                <a16:creationId xmlns:a16="http://schemas.microsoft.com/office/drawing/2014/main" id="{CA12C054-94C1-404C-9508-DE304EC1F921}"/>
+                <a16:creationId xmlns:a16="http://schemas.microsoft.com/office/drawing/2014/main" id="{3DF94618-5622-48C6-B2F7-701476A20C61}"/>
               </a:ext>
             </a:extLst>
           </p:cNvPr>
@@ -4704,7 +4771,7 @@
           <p:cNvPr id="38" name="timeline-item-3-3">
             <a:extLst xmlns:a="http://schemas.openxmlformats.org/drawingml/2006/main">
               <a:ext uri="{FF2B5EF4-FFF2-40B4-BE49-F238E27FC236}">
-                <a16:creationId xmlns:a16="http://schemas.microsoft.com/office/drawing/2014/main" id="{46D63C6A-6226-4AFA-ABC5-56C1A671A8B0}"/>
+                <a16:creationId xmlns:a16="http://schemas.microsoft.com/office/drawing/2014/main" id="{C375F0E8-5005-4417-A950-8E90F7519E6A}"/>
               </a:ext>
             </a:extLst>
           </p:cNvPr>
@@ -4754,7 +4821,7 @@
           <p:cNvPr id="39" name="timeline-card-4">
             <a:extLst xmlns:a="http://schemas.openxmlformats.org/drawingml/2006/main">
               <a:ext uri="{FF2B5EF4-FFF2-40B4-BE49-F238E27FC236}">
-                <a16:creationId xmlns:a16="http://schemas.microsoft.com/office/drawing/2014/main" id="{BBAFE33F-817D-45E3-BA76-8DFBDF1F5E32}"/>
+                <a16:creationId xmlns:a16="http://schemas.microsoft.com/office/drawing/2014/main" id="{AAC8974D-9BF0-4614-8443-8BB3A06390B4}"/>
               </a:ext>
             </a:extLst>
           </p:cNvPr>
@@ -4789,7 +4856,7 @@
           <p:cNvPr id="40" name="timeline-bar-4">
             <a:extLst xmlns:a="http://schemas.openxmlformats.org/drawingml/2006/main">
               <a:ext uri="{FF2B5EF4-FFF2-40B4-BE49-F238E27FC236}">
-                <a16:creationId xmlns:a16="http://schemas.microsoft.com/office/drawing/2014/main" id="{62CDFD11-7E16-4C63-974C-8DC49757E0B0}"/>
+                <a16:creationId xmlns:a16="http://schemas.microsoft.com/office/drawing/2014/main" id="{4D525D06-E5BD-473E-929B-ADC8810D2DB3}"/>
               </a:ext>
             </a:extLst>
           </p:cNvPr>
@@ -4822,7 +4889,7 @@
           <p:cNvPr id="41" name="timeline-month-4">
             <a:extLst xmlns:a="http://schemas.openxmlformats.org/drawingml/2006/main">
               <a:ext uri="{FF2B5EF4-FFF2-40B4-BE49-F238E27FC236}">
-                <a16:creationId xmlns:a16="http://schemas.microsoft.com/office/drawing/2014/main" id="{D3AEAB97-9726-4D3F-982F-7A6DB28ED4BB}"/>
+                <a16:creationId xmlns:a16="http://schemas.microsoft.com/office/drawing/2014/main" id="{39847B26-AE16-4ED8-B115-F124D0270868}"/>
               </a:ext>
             </a:extLst>
           </p:cNvPr>
@@ -4872,7 +4939,7 @@
           <p:cNvPr id="42" name="timeline-title-4">
             <a:extLst xmlns:a="http://schemas.openxmlformats.org/drawingml/2006/main">
               <a:ext uri="{FF2B5EF4-FFF2-40B4-BE49-F238E27FC236}">
-                <a16:creationId xmlns:a16="http://schemas.microsoft.com/office/drawing/2014/main" id="{E5B6B059-0906-4D60-8B2C-7B5FEF746CA5}"/>
+                <a16:creationId xmlns:a16="http://schemas.microsoft.com/office/drawing/2014/main" id="{7728BD85-7BAB-462B-B35D-DE20D3C255DB}"/>
               </a:ext>
             </a:extLst>
           </p:cNvPr>
@@ -4922,7 +4989,7 @@
           <p:cNvPr id="43" name="timeline-dot-4-1">
             <a:extLst xmlns:a="http://schemas.openxmlformats.org/drawingml/2006/main">
               <a:ext uri="{FF2B5EF4-FFF2-40B4-BE49-F238E27FC236}">
-                <a16:creationId xmlns:a16="http://schemas.microsoft.com/office/drawing/2014/main" id="{22471788-1676-4C04-A2C5-F8A8E0230848}"/>
+                <a16:creationId xmlns:a16="http://schemas.microsoft.com/office/drawing/2014/main" id="{1EF3C154-8231-4A08-8B53-2F8B1AE830A4}"/>
               </a:ext>
             </a:extLst>
           </p:cNvPr>
@@ -4972,7 +5039,7 @@
           <p:cNvPr id="44" name="timeline-item-4-1">
             <a:extLst xmlns:a="http://schemas.openxmlformats.org/drawingml/2006/main">
               <a:ext uri="{FF2B5EF4-FFF2-40B4-BE49-F238E27FC236}">
-                <a16:creationId xmlns:a16="http://schemas.microsoft.com/office/drawing/2014/main" id="{CC168F41-406A-4B99-904D-2DE9BA834DE5}"/>
+                <a16:creationId xmlns:a16="http://schemas.microsoft.com/office/drawing/2014/main" id="{D446BC95-5D78-4F17-8EB5-182E2876B308}"/>
               </a:ext>
             </a:extLst>
           </p:cNvPr>
@@ -5022,7 +5089,7 @@
           <p:cNvPr id="45" name="timeline-dot-4-2">
             <a:extLst xmlns:a="http://schemas.openxmlformats.org/drawingml/2006/main">
               <a:ext uri="{FF2B5EF4-FFF2-40B4-BE49-F238E27FC236}">
-                <a16:creationId xmlns:a16="http://schemas.microsoft.com/office/drawing/2014/main" id="{8C1DB313-AEAD-4331-A234-19185727C628}"/>
+                <a16:creationId xmlns:a16="http://schemas.microsoft.com/office/drawing/2014/main" id="{94AE69AA-75D2-4D23-AEFA-97A6B9C7DDCC}"/>
               </a:ext>
             </a:extLst>
           </p:cNvPr>
@@ -5072,7 +5139,7 @@
           <p:cNvPr id="46" name="timeline-item-4-2">
             <a:extLst xmlns:a="http://schemas.openxmlformats.org/drawingml/2006/main">
               <a:ext uri="{FF2B5EF4-FFF2-40B4-BE49-F238E27FC236}">
-                <a16:creationId xmlns:a16="http://schemas.microsoft.com/office/drawing/2014/main" id="{41F72C9B-9C28-4CE7-9B7C-BFDD8458A1D5}"/>
+                <a16:creationId xmlns:a16="http://schemas.microsoft.com/office/drawing/2014/main" id="{E95DE8D2-DE78-456D-8B95-1F56149BB8B7}"/>
               </a:ext>
             </a:extLst>
           </p:cNvPr>
@@ -5122,7 +5189,7 @@
           <p:cNvPr id="47" name="timeline-dot-4-3">
             <a:extLst xmlns:a="http://schemas.openxmlformats.org/drawingml/2006/main">
               <a:ext uri="{FF2B5EF4-FFF2-40B4-BE49-F238E27FC236}">
-                <a16:creationId xmlns:a16="http://schemas.microsoft.com/office/drawing/2014/main" id="{5DFA0259-D8C2-4D21-990D-3E7344EA1C19}"/>
+                <a16:creationId xmlns:a16="http://schemas.microsoft.com/office/drawing/2014/main" id="{0D0409BB-B352-4AD4-B4CE-8FFDF30CD2F0}"/>
               </a:ext>
             </a:extLst>
           </p:cNvPr>
@@ -5172,7 +5239,7 @@
           <p:cNvPr id="48" name="timeline-item-4-3">
             <a:extLst xmlns:a="http://schemas.openxmlformats.org/drawingml/2006/main">
               <a:ext uri="{FF2B5EF4-FFF2-40B4-BE49-F238E27FC236}">
-                <a16:creationId xmlns:a16="http://schemas.microsoft.com/office/drawing/2014/main" id="{96EE19D7-C07E-402A-9C45-DF64809023B2}"/>
+                <a16:creationId xmlns:a16="http://schemas.microsoft.com/office/drawing/2014/main" id="{FF8795DD-3BF8-474F-B441-D2528F5499A0}"/>
               </a:ext>
             </a:extLst>
           </p:cNvPr>
@@ -5222,7 +5289,7 @@
           <p:cNvPr id="49" name="timeline-card-5">
             <a:extLst xmlns:a="http://schemas.openxmlformats.org/drawingml/2006/main">
               <a:ext uri="{FF2B5EF4-FFF2-40B4-BE49-F238E27FC236}">
-                <a16:creationId xmlns:a16="http://schemas.microsoft.com/office/drawing/2014/main" id="{178273AE-828F-483A-864D-368840254D40}"/>
+                <a16:creationId xmlns:a16="http://schemas.microsoft.com/office/drawing/2014/main" id="{D1E9EE8D-5ACD-4A39-A481-07953AADB0D6}"/>
               </a:ext>
             </a:extLst>
           </p:cNvPr>
@@ -5257,7 +5324,7 @@
           <p:cNvPr id="50" name="timeline-bar-5">
             <a:extLst xmlns:a="http://schemas.openxmlformats.org/drawingml/2006/main">
               <a:ext uri="{FF2B5EF4-FFF2-40B4-BE49-F238E27FC236}">
-                <a16:creationId xmlns:a16="http://schemas.microsoft.com/office/drawing/2014/main" id="{44E61251-C9A2-4BC4-987B-821C6687A3C4}"/>
+                <a16:creationId xmlns:a16="http://schemas.microsoft.com/office/drawing/2014/main" id="{378D48FE-331B-4CCA-A695-197E2D129F2D}"/>
               </a:ext>
             </a:extLst>
           </p:cNvPr>
@@ -5290,7 +5357,7 @@
           <p:cNvPr id="51" name="timeline-month-5">
             <a:extLst xmlns:a="http://schemas.openxmlformats.org/drawingml/2006/main">
               <a:ext uri="{FF2B5EF4-FFF2-40B4-BE49-F238E27FC236}">
-                <a16:creationId xmlns:a16="http://schemas.microsoft.com/office/drawing/2014/main" id="{C1C4B18B-32B9-42FF-8FB7-9F02F4077960}"/>
+                <a16:creationId xmlns:a16="http://schemas.microsoft.com/office/drawing/2014/main" id="{0272FC7C-3E2D-474C-8746-792FADE9D55F}"/>
               </a:ext>
             </a:extLst>
           </p:cNvPr>
@@ -5340,7 +5407,7 @@
           <p:cNvPr id="52" name="timeline-title-5">
             <a:extLst xmlns:a="http://schemas.openxmlformats.org/drawingml/2006/main">
               <a:ext uri="{FF2B5EF4-FFF2-40B4-BE49-F238E27FC236}">
-                <a16:creationId xmlns:a16="http://schemas.microsoft.com/office/drawing/2014/main" id="{0784565D-925E-4DE6-8186-6715B52BB3D6}"/>
+                <a16:creationId xmlns:a16="http://schemas.microsoft.com/office/drawing/2014/main" id="{6782BFB3-41BC-4B05-9E89-7E21A0679A7C}"/>
               </a:ext>
             </a:extLst>
           </p:cNvPr>
@@ -5390,7 +5457,7 @@
           <p:cNvPr id="53" name="timeline-dot-5-1">
             <a:extLst xmlns:a="http://schemas.openxmlformats.org/drawingml/2006/main">
               <a:ext uri="{FF2B5EF4-FFF2-40B4-BE49-F238E27FC236}">
-                <a16:creationId xmlns:a16="http://schemas.microsoft.com/office/drawing/2014/main" id="{368FE6CF-3F55-49D3-AC08-67F2EF7DAA97}"/>
+                <a16:creationId xmlns:a16="http://schemas.microsoft.com/office/drawing/2014/main" id="{EE670B59-AB95-42D3-B87D-55EA92B06E20}"/>
               </a:ext>
             </a:extLst>
           </p:cNvPr>
@@ -5440,7 +5507,7 @@
           <p:cNvPr id="54" name="timeline-item-5-1">
             <a:extLst xmlns:a="http://schemas.openxmlformats.org/drawingml/2006/main">
               <a:ext uri="{FF2B5EF4-FFF2-40B4-BE49-F238E27FC236}">
-                <a16:creationId xmlns:a16="http://schemas.microsoft.com/office/drawing/2014/main" id="{E16AC7F9-5689-42BF-8F30-C51E557F3836}"/>
+                <a16:creationId xmlns:a16="http://schemas.microsoft.com/office/drawing/2014/main" id="{267724D5-D8B1-452F-BDA4-33110D16DF3D}"/>
               </a:ext>
             </a:extLst>
           </p:cNvPr>
@@ -5490,7 +5557,7 @@
           <p:cNvPr id="55" name="timeline-dot-5-2">
             <a:extLst xmlns:a="http://schemas.openxmlformats.org/drawingml/2006/main">
               <a:ext uri="{FF2B5EF4-FFF2-40B4-BE49-F238E27FC236}">
-                <a16:creationId xmlns:a16="http://schemas.microsoft.com/office/drawing/2014/main" id="{19D62180-B89D-4575-BD80-AEB35A81D074}"/>
+                <a16:creationId xmlns:a16="http://schemas.microsoft.com/office/drawing/2014/main" id="{98B057A9-B951-4945-AD07-4B2D35652285}"/>
               </a:ext>
             </a:extLst>
           </p:cNvPr>
@@ -5540,7 +5607,7 @@
           <p:cNvPr id="56" name="timeline-item-5-2">
             <a:extLst xmlns:a="http://schemas.openxmlformats.org/drawingml/2006/main">
               <a:ext uri="{FF2B5EF4-FFF2-40B4-BE49-F238E27FC236}">
-                <a16:creationId xmlns:a16="http://schemas.microsoft.com/office/drawing/2014/main" id="{8A040A55-7FF4-49E4-BB19-E9D24DEF3BAF}"/>
+                <a16:creationId xmlns:a16="http://schemas.microsoft.com/office/drawing/2014/main" id="{E7AA0977-2113-4DD8-9B8D-096E8146D6EB}"/>
               </a:ext>
             </a:extLst>
           </p:cNvPr>
@@ -5590,7 +5657,7 @@
           <p:cNvPr id="57" name="timeline-dot-5-3">
             <a:extLst xmlns:a="http://schemas.openxmlformats.org/drawingml/2006/main">
               <a:ext uri="{FF2B5EF4-FFF2-40B4-BE49-F238E27FC236}">
-                <a16:creationId xmlns:a16="http://schemas.microsoft.com/office/drawing/2014/main" id="{FAD2EAFF-1EBD-475C-A77D-00797D2C45AE}"/>
+                <a16:creationId xmlns:a16="http://schemas.microsoft.com/office/drawing/2014/main" id="{C608EACA-F1A6-4050-8E59-71BE5578F226}"/>
               </a:ext>
             </a:extLst>
           </p:cNvPr>
@@ -5640,7 +5707,7 @@
           <p:cNvPr id="58" name="timeline-item-5-3">
             <a:extLst xmlns:a="http://schemas.openxmlformats.org/drawingml/2006/main">
               <a:ext uri="{FF2B5EF4-FFF2-40B4-BE49-F238E27FC236}">
-                <a16:creationId xmlns:a16="http://schemas.microsoft.com/office/drawing/2014/main" id="{5D39F1B2-7C29-4BE1-87B3-1D69E437FABC}"/>
+                <a16:creationId xmlns:a16="http://schemas.microsoft.com/office/drawing/2014/main" id="{52C54133-7A2A-4A91-A196-5BC77FF16E8D}"/>
               </a:ext>
             </a:extLst>
           </p:cNvPr>
@@ -5690,7 +5757,7 @@
           <p:cNvPr id="59" name="timeline-card-6">
             <a:extLst xmlns:a="http://schemas.openxmlformats.org/drawingml/2006/main">
               <a:ext uri="{FF2B5EF4-FFF2-40B4-BE49-F238E27FC236}">
-                <a16:creationId xmlns:a16="http://schemas.microsoft.com/office/drawing/2014/main" id="{D8A66099-8B7F-4D6E-8D39-2BE63B1D141D}"/>
+                <a16:creationId xmlns:a16="http://schemas.microsoft.com/office/drawing/2014/main" id="{F6CEE417-E5C5-42A1-836D-640A400B90DA}"/>
               </a:ext>
             </a:extLst>
           </p:cNvPr>
@@ -5725,7 +5792,7 @@
           <p:cNvPr id="60" name="timeline-bar-6">
             <a:extLst xmlns:a="http://schemas.openxmlformats.org/drawingml/2006/main">
               <a:ext uri="{FF2B5EF4-FFF2-40B4-BE49-F238E27FC236}">
-                <a16:creationId xmlns:a16="http://schemas.microsoft.com/office/drawing/2014/main" id="{1140E738-A66E-408C-ADCE-4F6716445A32}"/>
+                <a16:creationId xmlns:a16="http://schemas.microsoft.com/office/drawing/2014/main" id="{DBB628AA-ACB9-47D9-B43E-0EAAF85CAC36}"/>
               </a:ext>
             </a:extLst>
           </p:cNvPr>
@@ -5758,7 +5825,7 @@
           <p:cNvPr id="61" name="timeline-month-6">
             <a:extLst xmlns:a="http://schemas.openxmlformats.org/drawingml/2006/main">
               <a:ext uri="{FF2B5EF4-FFF2-40B4-BE49-F238E27FC236}">
-                <a16:creationId xmlns:a16="http://schemas.microsoft.com/office/drawing/2014/main" id="{C4B5D2FF-AB84-458D-B9DC-63E6391C2689}"/>
+                <a16:creationId xmlns:a16="http://schemas.microsoft.com/office/drawing/2014/main" id="{6483C664-D17D-4AA2-945B-C16AD65457B5}"/>
               </a:ext>
             </a:extLst>
           </p:cNvPr>
@@ -5808,7 +5875,7 @@
           <p:cNvPr id="62" name="timeline-title-6">
             <a:extLst xmlns:a="http://schemas.openxmlformats.org/drawingml/2006/main">
               <a:ext uri="{FF2B5EF4-FFF2-40B4-BE49-F238E27FC236}">
-                <a16:creationId xmlns:a16="http://schemas.microsoft.com/office/drawing/2014/main" id="{0375A532-2E38-46C0-8C10-C7A6043AF38C}"/>
+                <a16:creationId xmlns:a16="http://schemas.microsoft.com/office/drawing/2014/main" id="{5F526A02-A929-4699-99B9-A02F8013D499}"/>
               </a:ext>
             </a:extLst>
           </p:cNvPr>
@@ -5858,7 +5925,7 @@
           <p:cNvPr id="63" name="timeline-dot-6-1">
             <a:extLst xmlns:a="http://schemas.openxmlformats.org/drawingml/2006/main">
               <a:ext uri="{FF2B5EF4-FFF2-40B4-BE49-F238E27FC236}">
-                <a16:creationId xmlns:a16="http://schemas.microsoft.com/office/drawing/2014/main" id="{190106D9-6D00-41DA-BC71-EA376B99D2A5}"/>
+                <a16:creationId xmlns:a16="http://schemas.microsoft.com/office/drawing/2014/main" id="{7AE6970A-196D-4CF4-B9E6-31169E4613C4}"/>
               </a:ext>
             </a:extLst>
           </p:cNvPr>
@@ -5908,7 +5975,7 @@
           <p:cNvPr id="64" name="timeline-item-6-1">
             <a:extLst xmlns:a="http://schemas.openxmlformats.org/drawingml/2006/main">
               <a:ext uri="{FF2B5EF4-FFF2-40B4-BE49-F238E27FC236}">
-                <a16:creationId xmlns:a16="http://schemas.microsoft.com/office/drawing/2014/main" id="{2439D32B-D33C-41BA-9F00-74807B4A648D}"/>
+                <a16:creationId xmlns:a16="http://schemas.microsoft.com/office/drawing/2014/main" id="{62C06B8D-D1A2-4F2E-89FA-6D7B9EFF47D1}"/>
               </a:ext>
             </a:extLst>
           </p:cNvPr>
@@ -5958,7 +6025,7 @@
           <p:cNvPr id="65" name="timeline-dot-6-2">
             <a:extLst xmlns:a="http://schemas.openxmlformats.org/drawingml/2006/main">
               <a:ext uri="{FF2B5EF4-FFF2-40B4-BE49-F238E27FC236}">
-                <a16:creationId xmlns:a16="http://schemas.microsoft.com/office/drawing/2014/main" id="{2748027A-A1E0-44FB-8956-79C4FDFAEEEC}"/>
+                <a16:creationId xmlns:a16="http://schemas.microsoft.com/office/drawing/2014/main" id="{47B44FB4-7CC4-4C6B-BB08-397515522B32}"/>
               </a:ext>
             </a:extLst>
           </p:cNvPr>
@@ -6008,7 +6075,7 @@
           <p:cNvPr id="66" name="timeline-item-6-2">
             <a:extLst xmlns:a="http://schemas.openxmlformats.org/drawingml/2006/main">
               <a:ext uri="{FF2B5EF4-FFF2-40B4-BE49-F238E27FC236}">
-                <a16:creationId xmlns:a16="http://schemas.microsoft.com/office/drawing/2014/main" id="{31B4E298-D9E7-40C3-AA0B-6B93AA2CFA53}"/>
+                <a16:creationId xmlns:a16="http://schemas.microsoft.com/office/drawing/2014/main" id="{77E639F7-CD89-47FA-B263-EB47EC35C521}"/>
               </a:ext>
             </a:extLst>
           </p:cNvPr>
@@ -6058,7 +6125,7 @@
           <p:cNvPr id="67" name="timeline-dot-6-3">
             <a:extLst xmlns:a="http://schemas.openxmlformats.org/drawingml/2006/main">
               <a:ext uri="{FF2B5EF4-FFF2-40B4-BE49-F238E27FC236}">
-                <a16:creationId xmlns:a16="http://schemas.microsoft.com/office/drawing/2014/main" id="{2A73B4AA-186E-4F3F-B741-F805FEEFE827}"/>
+                <a16:creationId xmlns:a16="http://schemas.microsoft.com/office/drawing/2014/main" id="{F05B7C0A-7E65-4954-9F76-228225B24F65}"/>
               </a:ext>
             </a:extLst>
           </p:cNvPr>
@@ -6108,7 +6175,7 @@
           <p:cNvPr id="68" name="timeline-item-6-3">
             <a:extLst xmlns:a="http://schemas.openxmlformats.org/drawingml/2006/main">
               <a:ext uri="{FF2B5EF4-FFF2-40B4-BE49-F238E27FC236}">
-                <a16:creationId xmlns:a16="http://schemas.microsoft.com/office/drawing/2014/main" id="{8A876E37-2E83-499E-BE87-22697CC10A46}"/>
+                <a16:creationId xmlns:a16="http://schemas.microsoft.com/office/drawing/2014/main" id="{D2CE6211-C823-44E1-9986-66E6ABC6BEDF}"/>
               </a:ext>
             </a:extLst>
           </p:cNvPr>
@@ -6158,7 +6225,7 @@
           <p:cNvPr id="69" name="management-title">
             <a:extLst xmlns:a="http://schemas.openxmlformats.org/drawingml/2006/main">
               <a:ext uri="{FF2B5EF4-FFF2-40B4-BE49-F238E27FC236}">
-                <a16:creationId xmlns:a16="http://schemas.microsoft.com/office/drawing/2014/main" id="{657A9D68-DA2F-4D05-8737-8459A3EAB631}"/>
+                <a16:creationId xmlns:a16="http://schemas.microsoft.com/office/drawing/2014/main" id="{23E6D33D-7CA3-4039-80DB-3AC3DBD23DA0}"/>
               </a:ext>
             </a:extLst>
           </p:cNvPr>
@@ -6208,7 +6275,7 @@
           <p:cNvPr id="70" name="management-note">
             <a:extLst xmlns:a="http://schemas.openxmlformats.org/drawingml/2006/main">
               <a:ext uri="{FF2B5EF4-FFF2-40B4-BE49-F238E27FC236}">
-                <a16:creationId xmlns:a16="http://schemas.microsoft.com/office/drawing/2014/main" id="{2DB3FD3C-0397-4C22-A692-AA449B6C0B95}"/>
+                <a16:creationId xmlns:a16="http://schemas.microsoft.com/office/drawing/2014/main" id="{46A80453-4025-4817-992D-70C82E4CBB7E}"/>
               </a:ext>
             </a:extLst>
           </p:cNvPr>
@@ -6258,7 +6325,7 @@
           <p:cNvPr id="71" name="mgmt-card-1">
             <a:extLst xmlns:a="http://schemas.openxmlformats.org/drawingml/2006/main">
               <a:ext uri="{FF2B5EF4-FFF2-40B4-BE49-F238E27FC236}">
-                <a16:creationId xmlns:a16="http://schemas.microsoft.com/office/drawing/2014/main" id="{95874C78-B412-491A-8015-2E614E140F1A}"/>
+                <a16:creationId xmlns:a16="http://schemas.microsoft.com/office/drawing/2014/main" id="{84824C05-2EE7-46D7-9137-44C25129EB91}"/>
               </a:ext>
             </a:extLst>
           </p:cNvPr>
@@ -6293,7 +6360,7 @@
           <p:cNvPr id="72" name="mgmt-bar-1">
             <a:extLst xmlns:a="http://schemas.openxmlformats.org/drawingml/2006/main">
               <a:ext uri="{FF2B5EF4-FFF2-40B4-BE49-F238E27FC236}">
-                <a16:creationId xmlns:a16="http://schemas.microsoft.com/office/drawing/2014/main" id="{387AF5D1-66A7-4E42-B8F3-225B9438CFBA}"/>
+                <a16:creationId xmlns:a16="http://schemas.microsoft.com/office/drawing/2014/main" id="{B1B1AEC8-CD5E-4E2E-8972-EE2EA14974F1}"/>
               </a:ext>
             </a:extLst>
           </p:cNvPr>
@@ -6326,7 +6393,7 @@
           <p:cNvPr id="73" name="mgmt-label-1">
             <a:extLst xmlns:a="http://schemas.openxmlformats.org/drawingml/2006/main">
               <a:ext uri="{FF2B5EF4-FFF2-40B4-BE49-F238E27FC236}">
-                <a16:creationId xmlns:a16="http://schemas.microsoft.com/office/drawing/2014/main" id="{29D969DC-8823-4FAD-8BB5-66225A29291B}"/>
+                <a16:creationId xmlns:a16="http://schemas.microsoft.com/office/drawing/2014/main" id="{A8347DE2-982C-49F1-9EFD-0862056DB028}"/>
               </a:ext>
             </a:extLst>
           </p:cNvPr>
@@ -6376,7 +6443,7 @@
           <p:cNvPr id="74" name="mgmt-body-1">
             <a:extLst xmlns:a="http://schemas.openxmlformats.org/drawingml/2006/main">
               <a:ext uri="{FF2B5EF4-FFF2-40B4-BE49-F238E27FC236}">
-                <a16:creationId xmlns:a16="http://schemas.microsoft.com/office/drawing/2014/main" id="{1B0F1B00-84EC-4081-86FE-A13B2C45563A}"/>
+                <a16:creationId xmlns:a16="http://schemas.microsoft.com/office/drawing/2014/main" id="{8507851C-FCCA-49B7-AC28-D1F10D4C3D8F}"/>
               </a:ext>
             </a:extLst>
           </p:cNvPr>
@@ -6426,7 +6493,7 @@
           <p:cNvPr id="75" name="mgmt-card-2">
             <a:extLst xmlns:a="http://schemas.openxmlformats.org/drawingml/2006/main">
               <a:ext uri="{FF2B5EF4-FFF2-40B4-BE49-F238E27FC236}">
-                <a16:creationId xmlns:a16="http://schemas.microsoft.com/office/drawing/2014/main" id="{75F9B55D-63EB-4E2F-8846-2237E2F6F73C}"/>
+                <a16:creationId xmlns:a16="http://schemas.microsoft.com/office/drawing/2014/main" id="{B35691A3-ECBA-4042-9A05-3C7EAB11FD7A}"/>
               </a:ext>
             </a:extLst>
           </p:cNvPr>
@@ -6461,7 +6528,7 @@
           <p:cNvPr id="76" name="mgmt-bar-2">
             <a:extLst xmlns:a="http://schemas.openxmlformats.org/drawingml/2006/main">
               <a:ext uri="{FF2B5EF4-FFF2-40B4-BE49-F238E27FC236}">
-                <a16:creationId xmlns:a16="http://schemas.microsoft.com/office/drawing/2014/main" id="{CD430347-1047-4BA2-A3EC-AED3E9851618}"/>
+                <a16:creationId xmlns:a16="http://schemas.microsoft.com/office/drawing/2014/main" id="{80969DE9-6307-4C60-83C5-F10AD4B853E0}"/>
               </a:ext>
             </a:extLst>
           </p:cNvPr>
@@ -6494,7 +6561,7 @@
           <p:cNvPr id="77" name="mgmt-label-2">
             <a:extLst xmlns:a="http://schemas.openxmlformats.org/drawingml/2006/main">
               <a:ext uri="{FF2B5EF4-FFF2-40B4-BE49-F238E27FC236}">
-                <a16:creationId xmlns:a16="http://schemas.microsoft.com/office/drawing/2014/main" id="{16686872-EE19-4CCD-9BF5-90BB18013C6D}"/>
+                <a16:creationId xmlns:a16="http://schemas.microsoft.com/office/drawing/2014/main" id="{D82233D0-1F10-4EAB-ACD5-B4F4A51F20F5}"/>
               </a:ext>
             </a:extLst>
           </p:cNvPr>
@@ -6544,7 +6611,7 @@
           <p:cNvPr id="78" name="mgmt-body-2">
             <a:extLst xmlns:a="http://schemas.openxmlformats.org/drawingml/2006/main">
               <a:ext uri="{FF2B5EF4-FFF2-40B4-BE49-F238E27FC236}">
-                <a16:creationId xmlns:a16="http://schemas.microsoft.com/office/drawing/2014/main" id="{266ADA6D-5169-4F74-B1F5-10F88A2D4354}"/>
+                <a16:creationId xmlns:a16="http://schemas.microsoft.com/office/drawing/2014/main" id="{0062A4BE-8F01-4ACE-BC76-65A0C92AACEF}"/>
               </a:ext>
             </a:extLst>
           </p:cNvPr>
@@ -6594,7 +6661,7 @@
           <p:cNvPr id="79" name="mgmt-card-3">
             <a:extLst xmlns:a="http://schemas.openxmlformats.org/drawingml/2006/main">
               <a:ext uri="{FF2B5EF4-FFF2-40B4-BE49-F238E27FC236}">
-                <a16:creationId xmlns:a16="http://schemas.microsoft.com/office/drawing/2014/main" id="{76DA3954-FC8B-404C-9EFF-DE5A5FCD564F}"/>
+                <a16:creationId xmlns:a16="http://schemas.microsoft.com/office/drawing/2014/main" id="{66013F89-EF7E-4898-8DBE-5992D6B0C742}"/>
               </a:ext>
             </a:extLst>
           </p:cNvPr>
@@ -6629,7 +6696,7 @@
           <p:cNvPr id="80" name="mgmt-bar-3">
             <a:extLst xmlns:a="http://schemas.openxmlformats.org/drawingml/2006/main">
               <a:ext uri="{FF2B5EF4-FFF2-40B4-BE49-F238E27FC236}">
-                <a16:creationId xmlns:a16="http://schemas.microsoft.com/office/drawing/2014/main" id="{BD1C5FA8-DA5A-4385-8F85-DAE4548F551C}"/>
+                <a16:creationId xmlns:a16="http://schemas.microsoft.com/office/drawing/2014/main" id="{04C6820E-BA70-453F-B7ED-F7D9F728EF4F}"/>
               </a:ext>
             </a:extLst>
           </p:cNvPr>
@@ -6662,7 +6729,7 @@
           <p:cNvPr id="81" name="mgmt-label-3">
             <a:extLst xmlns:a="http://schemas.openxmlformats.org/drawingml/2006/main">
               <a:ext uri="{FF2B5EF4-FFF2-40B4-BE49-F238E27FC236}">
-                <a16:creationId xmlns:a16="http://schemas.microsoft.com/office/drawing/2014/main" id="{1A475A50-1440-4941-BE44-EB878926FADB}"/>
+                <a16:creationId xmlns:a16="http://schemas.microsoft.com/office/drawing/2014/main" id="{F44A9C6C-7453-49CF-A2B5-93D31C32F8B6}"/>
               </a:ext>
             </a:extLst>
           </p:cNvPr>
@@ -6712,7 +6779,7 @@
           <p:cNvPr id="82" name="mgmt-body-3">
             <a:extLst xmlns:a="http://schemas.openxmlformats.org/drawingml/2006/main">
               <a:ext uri="{FF2B5EF4-FFF2-40B4-BE49-F238E27FC236}">
-                <a16:creationId xmlns:a16="http://schemas.microsoft.com/office/drawing/2014/main" id="{CD5C234B-41EE-4783-A273-5CCA0840F2F9}"/>
+                <a16:creationId xmlns:a16="http://schemas.microsoft.com/office/drawing/2014/main" id="{0670FCB6-76ED-45BD-8F37-08C8F5AEFDC1}"/>
               </a:ext>
             </a:extLst>
           </p:cNvPr>
@@ -6762,7 +6829,7 @@
           <p:cNvPr id="83" name="mgmt-card-4">
             <a:extLst xmlns:a="http://schemas.openxmlformats.org/drawingml/2006/main">
               <a:ext uri="{FF2B5EF4-FFF2-40B4-BE49-F238E27FC236}">
-                <a16:creationId xmlns:a16="http://schemas.microsoft.com/office/drawing/2014/main" id="{97F788D7-0534-4D8A-9201-75B130289D68}"/>
+                <a16:creationId xmlns:a16="http://schemas.microsoft.com/office/drawing/2014/main" id="{AC32FC36-E2E9-465C-B4E9-E56D3B3CE28C}"/>
               </a:ext>
             </a:extLst>
           </p:cNvPr>
@@ -6797,7 +6864,7 @@
           <p:cNvPr id="84" name="mgmt-bar-4">
             <a:extLst xmlns:a="http://schemas.openxmlformats.org/drawingml/2006/main">
               <a:ext uri="{FF2B5EF4-FFF2-40B4-BE49-F238E27FC236}">
-                <a16:creationId xmlns:a16="http://schemas.microsoft.com/office/drawing/2014/main" id="{DF0CA658-C20E-4AF6-BBC5-D6A3B931803F}"/>
+                <a16:creationId xmlns:a16="http://schemas.microsoft.com/office/drawing/2014/main" id="{A0A98AAA-F63F-4B49-8517-8F1EF20D850D}"/>
               </a:ext>
             </a:extLst>
           </p:cNvPr>
@@ -6830,7 +6897,7 @@
           <p:cNvPr id="85" name="mgmt-label-4">
             <a:extLst xmlns:a="http://schemas.openxmlformats.org/drawingml/2006/main">
               <a:ext uri="{FF2B5EF4-FFF2-40B4-BE49-F238E27FC236}">
-                <a16:creationId xmlns:a16="http://schemas.microsoft.com/office/drawing/2014/main" id="{122A1E17-FE56-474C-B9CC-481F5BF8D235}"/>
+                <a16:creationId xmlns:a16="http://schemas.microsoft.com/office/drawing/2014/main" id="{DAD6C970-B201-402B-9545-3B5D986ACEE1}"/>
               </a:ext>
             </a:extLst>
           </p:cNvPr>
@@ -6880,7 +6947,7 @@
           <p:cNvPr id="86" name="mgmt-body-4">
             <a:extLst xmlns:a="http://schemas.openxmlformats.org/drawingml/2006/main">
               <a:ext uri="{FF2B5EF4-FFF2-40B4-BE49-F238E27FC236}">
-                <a16:creationId xmlns:a16="http://schemas.microsoft.com/office/drawing/2014/main" id="{584C4ED0-EF63-438C-9188-D292E450F6D5}"/>
+                <a16:creationId xmlns:a16="http://schemas.microsoft.com/office/drawing/2014/main" id="{A08A694A-A422-4068-896D-4D2B709EF470}"/>
               </a:ext>
             </a:extLst>
           </p:cNvPr>
@@ -6928,7 +6995,2389 @@
     </p:spTree>
     <p:extLst>
       <p:ext uri="{BB962C8B-B14F-4D97-AF65-F5344CB8AC3E}">
-        <p14:creationId xmlns:p14="http://schemas.microsoft.com/office/powerpoint/2010/main" val="1483899283"/>
+        <p14:creationId xmlns:p14="http://schemas.microsoft.com/office/powerpoint/2010/main" val="58456663"/>
+      </p:ext>
+    </p:extLst>
+  </p:cSld>
+</p:sld>
+</file>
+
+<file path=ppt/slides/slide3.xml><?xml version="1.0" encoding="utf-8"?>
+<p:sld xmlns:p="http://schemas.openxmlformats.org/presentationml/2006/main">
+  <p:cSld>
+    <p:bg>
+      <p:bgPr>
+        <a:solidFill xmlns:a="http://schemas.openxmlformats.org/drawingml/2006/main">
+          <a:srgbClr val="0B1020"/>
+        </a:solidFill>
+      </p:bgPr>
+    </p:bg>
+    <p:spTree>
+      <p:nvGrpSpPr>
+        <p:cNvPr id="1" name=""/>
+        <p:cNvGrpSpPr/>
+        <p:nvPr/>
+      </p:nvGrpSpPr>
+      <p:grpSpPr>
+        <a:xfrm xmlns:a="http://schemas.openxmlformats.org/drawingml/2006/main"/>
+      </p:grpSpPr>
+      <p:sp>
+        <p:nvSpPr>
+          <p:cNvPr id="1" name="top-accent">
+            <a:extLst xmlns:a="http://schemas.openxmlformats.org/drawingml/2006/main">
+              <a:ext uri="{FF2B5EF4-FFF2-40B4-BE49-F238E27FC236}">
+                <a16:creationId xmlns:a16="http://schemas.microsoft.com/office/drawing/2014/main" id="{F2C4A980-4570-4BB2-A38C-0D91B067527C}"/>
+              </a:ext>
+            </a:extLst>
+          </p:cNvPr>
+          <p:cNvSpPr>
+            <a:spLocks xmlns:a="http://schemas.openxmlformats.org/drawingml/2006/main" noGrp="1"/>
+          </p:cNvSpPr>
+          <p:nvPr/>
+        </p:nvSpPr>
+        <p:spPr>
+          <a:xfrm xmlns:a="http://schemas.openxmlformats.org/drawingml/2006/main">
+            <a:off x="0" y="0"/>
+            <a:ext cx="12192000" cy="95250"/>
+          </a:xfrm>
+          <a:prstGeom xmlns:a="http://schemas.openxmlformats.org/drawingml/2006/main" prst="rect">
+            <a:avLst/>
+          </a:prstGeom>
+          <a:solidFill xmlns:a="http://schemas.openxmlformats.org/drawingml/2006/main">
+            <a:srgbClr val="00B8D9"/>
+          </a:solidFill>
+          <a:ln xmlns:a="http://schemas.openxmlformats.org/drawingml/2006/main" w="0">
+            <a:solidFill>
+              <a:srgbClr val="00B8D9"/>
+            </a:solidFill>
+            <a:prstDash val="solid"/>
+          </a:ln>
+        </p:spPr>
+      </p:sp>
+      <p:sp>
+        <p:nvSpPr>
+          <p:cNvPr id="2" name="left-accent">
+            <a:extLst xmlns:a="http://schemas.openxmlformats.org/drawingml/2006/main">
+              <a:ext uri="{FF2B5EF4-FFF2-40B4-BE49-F238E27FC236}">
+                <a16:creationId xmlns:a16="http://schemas.microsoft.com/office/drawing/2014/main" id="{EA1F300C-3F46-41A4-9832-75643A9E0554}"/>
+              </a:ext>
+            </a:extLst>
+          </p:cNvPr>
+          <p:cNvSpPr>
+            <a:spLocks xmlns:a="http://schemas.openxmlformats.org/drawingml/2006/main" noGrp="1"/>
+          </p:cNvSpPr>
+          <p:nvPr/>
+        </p:nvSpPr>
+        <p:spPr>
+          <a:xfrm xmlns:a="http://schemas.openxmlformats.org/drawingml/2006/main">
+            <a:off x="0" y="0"/>
+            <a:ext cx="152400" cy="6858000"/>
+          </a:xfrm>
+          <a:prstGeom xmlns:a="http://schemas.openxmlformats.org/drawingml/2006/main" prst="rect">
+            <a:avLst/>
+          </a:prstGeom>
+          <a:solidFill xmlns:a="http://schemas.openxmlformats.org/drawingml/2006/main">
+            <a:srgbClr val="FF6B35"/>
+          </a:solidFill>
+          <a:ln xmlns:a="http://schemas.openxmlformats.org/drawingml/2006/main" w="0">
+            <a:solidFill>
+              <a:srgbClr val="FF6B35"/>
+            </a:solidFill>
+            <a:prstDash val="solid"/>
+          </a:ln>
+        </p:spPr>
+      </p:sp>
+      <p:sp>
+        <p:nvSpPr>
+          <p:cNvPr id="3" name="eyebrow">
+            <a:extLst xmlns:a="http://schemas.openxmlformats.org/drawingml/2006/main">
+              <a:ext uri="{FF2B5EF4-FFF2-40B4-BE49-F238E27FC236}">
+                <a16:creationId xmlns:a16="http://schemas.microsoft.com/office/drawing/2014/main" id="{7D982622-6C19-49FE-A7AF-7BB7007F7CC7}"/>
+              </a:ext>
+            </a:extLst>
+          </p:cNvPr>
+          <p:cNvSpPr>
+            <a:spLocks xmlns:a="http://schemas.openxmlformats.org/drawingml/2006/main" noGrp="1"/>
+          </p:cNvSpPr>
+          <p:nvPr/>
+        </p:nvSpPr>
+        <p:spPr>
+          <a:xfrm xmlns:a="http://schemas.openxmlformats.org/drawingml/2006/main">
+            <a:off x="514350" y="361950"/>
+            <a:ext cx="5905500" cy="285750"/>
+          </a:xfrm>
+          <a:prstGeom xmlns:a="http://schemas.openxmlformats.org/drawingml/2006/main" prst="rect">
+            <a:avLst/>
+          </a:prstGeom>
+          <a:noFill xmlns:a="http://schemas.openxmlformats.org/drawingml/2006/main"/>
+          <a:ln xmlns:a="http://schemas.openxmlformats.org/drawingml/2006/main" w="0">
+            <a:noFill/>
+            <a:prstDash val="solid"/>
+          </a:ln>
+        </p:spPr>
+        <p:txBody>
+          <a:bodyPr xmlns:a="http://schemas.openxmlformats.org/drawingml/2006/main"/>
+          <a:lstStyle xmlns:a="http://schemas.openxmlformats.org/drawingml/2006/main"/>
+          <a:p xmlns:a="http://schemas.openxmlformats.org/drawingml/2006/main">
+            <a:pPr>
+              <a:defRPr sz="1125" b="1">
+                <a:solidFill>
+                  <a:srgbClr val="8BD9E8"/>
+                </a:solidFill>
+              </a:defRPr>
+            </a:pPr>
+            <a:r>
+              <a:rPr sz="1125" b="1">
+                <a:solidFill>
+                  <a:srgbClr val="8BD9E8"/>
+                </a:solidFill>
+              </a:rPr>
+              <a:t>LAUNCH GATE CRITERIA | PAGE 03</a:t>
+            </a:r>
+          </a:p>
+        </p:txBody>
+      </p:sp>
+      <p:sp>
+        <p:nvSpPr>
+          <p:cNvPr id="4" name="footer">
+            <a:extLst xmlns:a="http://schemas.openxmlformats.org/drawingml/2006/main">
+              <a:ext uri="{FF2B5EF4-FFF2-40B4-BE49-F238E27FC236}">
+                <a16:creationId xmlns:a16="http://schemas.microsoft.com/office/drawing/2014/main" id="{B3B15104-419C-4A4E-B3B5-7AAB760ADB9E}"/>
+              </a:ext>
+            </a:extLst>
+          </p:cNvPr>
+          <p:cNvSpPr>
+            <a:spLocks xmlns:a="http://schemas.openxmlformats.org/drawingml/2006/main" noGrp="1"/>
+          </p:cNvSpPr>
+          <p:nvPr/>
+        </p:nvSpPr>
+        <p:spPr>
+          <a:xfrm xmlns:a="http://schemas.openxmlformats.org/drawingml/2006/main">
+            <a:off x="514350" y="6457950"/>
+            <a:ext cx="4953000" cy="266700"/>
+          </a:xfrm>
+          <a:prstGeom xmlns:a="http://schemas.openxmlformats.org/drawingml/2006/main" prst="rect">
+            <a:avLst/>
+          </a:prstGeom>
+          <a:noFill xmlns:a="http://schemas.openxmlformats.org/drawingml/2006/main"/>
+          <a:ln xmlns:a="http://schemas.openxmlformats.org/drawingml/2006/main" w="0">
+            <a:noFill/>
+            <a:prstDash val="solid"/>
+          </a:ln>
+        </p:spPr>
+        <p:txBody>
+          <a:bodyPr xmlns:a="http://schemas.openxmlformats.org/drawingml/2006/main"/>
+          <a:lstStyle xmlns:a="http://schemas.openxmlformats.org/drawingml/2006/main"/>
+          <a:p xmlns:a="http://schemas.openxmlformats.org/drawingml/2006/main">
+            <a:pPr>
+              <a:defRPr sz="1125">
+                <a:solidFill>
+                  <a:srgbClr val="94A3B8"/>
+                </a:solidFill>
+              </a:defRPr>
+            </a:pPr>
+            <a:r>
+              <a:rPr sz="1125">
+                <a:solidFill>
+                  <a:srgbClr val="94A3B8"/>
+                </a:solidFill>
+              </a:rPr>
+              <a:t>HIT2 일본 서비스 런칭 6개월 전 로드맵</a:t>
+            </a:r>
+          </a:p>
+        </p:txBody>
+      </p:sp>
+      <p:sp>
+        <p:nvSpPr>
+          <p:cNvPr id="5" name="page-no">
+            <a:extLst xmlns:a="http://schemas.openxmlformats.org/drawingml/2006/main">
+              <a:ext uri="{FF2B5EF4-FFF2-40B4-BE49-F238E27FC236}">
+                <a16:creationId xmlns:a16="http://schemas.microsoft.com/office/drawing/2014/main" id="{D32EA220-CEB8-4865-93D5-4B1A5DAEE738}"/>
+              </a:ext>
+            </a:extLst>
+          </p:cNvPr>
+          <p:cNvSpPr>
+            <a:spLocks xmlns:a="http://schemas.openxmlformats.org/drawingml/2006/main" noGrp="1"/>
+          </p:cNvSpPr>
+          <p:nvPr/>
+        </p:nvSpPr>
+        <p:spPr>
+          <a:xfrm xmlns:a="http://schemas.openxmlformats.org/drawingml/2006/main">
+            <a:off x="10953750" y="6457950"/>
+            <a:ext cx="419100" cy="266700"/>
+          </a:xfrm>
+          <a:prstGeom xmlns:a="http://schemas.openxmlformats.org/drawingml/2006/main" prst="rect">
+            <a:avLst/>
+          </a:prstGeom>
+          <a:noFill xmlns:a="http://schemas.openxmlformats.org/drawingml/2006/main"/>
+          <a:ln xmlns:a="http://schemas.openxmlformats.org/drawingml/2006/main" w="0">
+            <a:noFill/>
+            <a:prstDash val="solid"/>
+          </a:ln>
+        </p:spPr>
+        <p:txBody>
+          <a:bodyPr xmlns:a="http://schemas.openxmlformats.org/drawingml/2006/main"/>
+          <a:lstStyle xmlns:a="http://schemas.openxmlformats.org/drawingml/2006/main"/>
+          <a:p xmlns:a="http://schemas.openxmlformats.org/drawingml/2006/main">
+            <a:pPr algn="r">
+              <a:defRPr sz="1200" b="1">
+                <a:solidFill>
+                  <a:srgbClr val="94A3B8"/>
+                </a:solidFill>
+              </a:defRPr>
+            </a:pPr>
+            <a:r>
+              <a:rPr sz="1200" b="1">
+                <a:solidFill>
+                  <a:srgbClr val="94A3B8"/>
+                </a:solidFill>
+              </a:rPr>
+              <a:t>03</a:t>
+            </a:r>
+          </a:p>
+        </p:txBody>
+      </p:sp>
+      <p:sp>
+        <p:nvSpPr>
+          <p:cNvPr id="6" name="title-03">
+            <a:extLst xmlns:a="http://schemas.openxmlformats.org/drawingml/2006/main">
+              <a:ext uri="{FF2B5EF4-FFF2-40B4-BE49-F238E27FC236}">
+                <a16:creationId xmlns:a16="http://schemas.microsoft.com/office/drawing/2014/main" id="{77BFF889-8ACA-4062-8395-E09342248453}"/>
+              </a:ext>
+            </a:extLst>
+          </p:cNvPr>
+          <p:cNvSpPr>
+            <a:spLocks xmlns:a="http://schemas.openxmlformats.org/drawingml/2006/main" noGrp="1"/>
+          </p:cNvSpPr>
+          <p:nvPr/>
+        </p:nvSpPr>
+        <p:spPr>
+          <a:xfrm xmlns:a="http://schemas.openxmlformats.org/drawingml/2006/main">
+            <a:off x="514350" y="781050"/>
+            <a:ext cx="10572750" cy="533400"/>
+          </a:xfrm>
+          <a:prstGeom xmlns:a="http://schemas.openxmlformats.org/drawingml/2006/main" prst="rect">
+            <a:avLst/>
+          </a:prstGeom>
+          <a:noFill xmlns:a="http://schemas.openxmlformats.org/drawingml/2006/main"/>
+          <a:ln xmlns:a="http://schemas.openxmlformats.org/drawingml/2006/main" w="0">
+            <a:noFill/>
+            <a:prstDash val="solid"/>
+          </a:ln>
+        </p:spPr>
+        <p:txBody>
+          <a:bodyPr xmlns:a="http://schemas.openxmlformats.org/drawingml/2006/main"/>
+          <a:lstStyle xmlns:a="http://schemas.openxmlformats.org/drawingml/2006/main"/>
+          <a:p xmlns:a="http://schemas.openxmlformats.org/drawingml/2006/main">
+            <a:pPr>
+              <a:defRPr sz="2550" b="1">
+                <a:solidFill>
+                  <a:srgbClr val="FFFFFF"/>
+                </a:solidFill>
+              </a:defRPr>
+            </a:pPr>
+            <a:r>
+              <a:rPr sz="2550" b="1">
+                <a:solidFill>
+                  <a:srgbClr val="FFFFFF"/>
+                </a:solidFill>
+              </a:rPr>
+              <a:t>런칭 게이트는 일정이 아니라 통과 기준으로 관리합니다</a:t>
+            </a:r>
+          </a:p>
+        </p:txBody>
+      </p:sp>
+      <p:sp>
+        <p:nvSpPr>
+          <p:cNvPr id="7" name="subtitle-03">
+            <a:extLst xmlns:a="http://schemas.openxmlformats.org/drawingml/2006/main">
+              <a:ext uri="{FF2B5EF4-FFF2-40B4-BE49-F238E27FC236}">
+                <a16:creationId xmlns:a16="http://schemas.microsoft.com/office/drawing/2014/main" id="{C1665073-6F92-4F61-B6CD-36448A6CFFD7}"/>
+              </a:ext>
+            </a:extLst>
+          </p:cNvPr>
+          <p:cNvSpPr>
+            <a:spLocks xmlns:a="http://schemas.openxmlformats.org/drawingml/2006/main" noGrp="1"/>
+          </p:cNvSpPr>
+          <p:nvPr/>
+        </p:nvSpPr>
+        <p:spPr>
+          <a:xfrm xmlns:a="http://schemas.openxmlformats.org/drawingml/2006/main">
+            <a:off x="533400" y="1371600"/>
+            <a:ext cx="10287000" cy="323850"/>
+          </a:xfrm>
+          <a:prstGeom xmlns:a="http://schemas.openxmlformats.org/drawingml/2006/main" prst="rect">
+            <a:avLst/>
+          </a:prstGeom>
+          <a:noFill xmlns:a="http://schemas.openxmlformats.org/drawingml/2006/main"/>
+          <a:ln xmlns:a="http://schemas.openxmlformats.org/drawingml/2006/main" w="0">
+            <a:noFill/>
+            <a:prstDash val="solid"/>
+          </a:ln>
+        </p:spPr>
+        <p:txBody>
+          <a:bodyPr xmlns:a="http://schemas.openxmlformats.org/drawingml/2006/main"/>
+          <a:lstStyle xmlns:a="http://schemas.openxmlformats.org/drawingml/2006/main"/>
+          <a:p xmlns:a="http://schemas.openxmlformats.org/drawingml/2006/main">
+            <a:pPr>
+              <a:defRPr sz="1275">
+                <a:solidFill>
+                  <a:srgbClr val="CBD5E1"/>
+                </a:solidFill>
+              </a:defRPr>
+            </a:pPr>
+            <a:r>
+              <a:rPr sz="1275">
+                <a:solidFill>
+                  <a:srgbClr val="CBD5E1"/>
+                </a:solidFill>
+              </a:rPr>
+              <a:t>월별 일정표만으로는 리스크가 숨기 쉽기 때문에, 범위·빌드·QA·검수 기준을 게이트로 묶어 판정합니다.</a:t>
+            </a:r>
+          </a:p>
+        </p:txBody>
+      </p:sp>
+      <p:sp>
+        <p:nvSpPr>
+          <p:cNvPr id="8" name="gate-section-title">
+            <a:extLst xmlns:a="http://schemas.openxmlformats.org/drawingml/2006/main">
+              <a:ext uri="{FF2B5EF4-FFF2-40B4-BE49-F238E27FC236}">
+                <a16:creationId xmlns:a16="http://schemas.microsoft.com/office/drawing/2014/main" id="{0FE4A4AF-373E-4940-BB4C-7F4C74238DA1}"/>
+              </a:ext>
+            </a:extLst>
+          </p:cNvPr>
+          <p:cNvSpPr>
+            <a:spLocks xmlns:a="http://schemas.openxmlformats.org/drawingml/2006/main" noGrp="1"/>
+          </p:cNvSpPr>
+          <p:nvPr/>
+        </p:nvSpPr>
+        <p:spPr>
+          <a:xfrm xmlns:a="http://schemas.openxmlformats.org/drawingml/2006/main">
+            <a:off x="514350" y="1752600"/>
+            <a:ext cx="2095500" cy="285750"/>
+          </a:xfrm>
+          <a:prstGeom xmlns:a="http://schemas.openxmlformats.org/drawingml/2006/main" prst="rect">
+            <a:avLst/>
+          </a:prstGeom>
+          <a:noFill xmlns:a="http://schemas.openxmlformats.org/drawingml/2006/main"/>
+          <a:ln xmlns:a="http://schemas.openxmlformats.org/drawingml/2006/main" w="0">
+            <a:noFill/>
+            <a:prstDash val="solid"/>
+          </a:ln>
+        </p:spPr>
+        <p:txBody>
+          <a:bodyPr xmlns:a="http://schemas.openxmlformats.org/drawingml/2006/main"/>
+          <a:lstStyle xmlns:a="http://schemas.openxmlformats.org/drawingml/2006/main"/>
+          <a:p xmlns:a="http://schemas.openxmlformats.org/drawingml/2006/main">
+            <a:pPr>
+              <a:defRPr sz="1650" b="1">
+                <a:solidFill>
+                  <a:srgbClr val="FFFFFF"/>
+                </a:solidFill>
+              </a:defRPr>
+            </a:pPr>
+            <a:r>
+              <a:rPr sz="1650" b="1">
+                <a:solidFill>
+                  <a:srgbClr val="FFFFFF"/>
+                </a:solidFill>
+              </a:rPr>
+              <a:t>핵심 게이트</a:t>
+            </a:r>
+          </a:p>
+        </p:txBody>
+      </p:sp>
+      <p:sp>
+        <p:nvSpPr>
+          <p:cNvPr id="9" name="gate-card-1">
+            <a:extLst xmlns:a="http://schemas.openxmlformats.org/drawingml/2006/main">
+              <a:ext uri="{FF2B5EF4-FFF2-40B4-BE49-F238E27FC236}">
+                <a16:creationId xmlns:a16="http://schemas.microsoft.com/office/drawing/2014/main" id="{B3111E65-678B-433B-AF3A-81F7AA7B5A4B}"/>
+              </a:ext>
+            </a:extLst>
+          </p:cNvPr>
+          <p:cNvSpPr>
+            <a:spLocks xmlns:a="http://schemas.openxmlformats.org/drawingml/2006/main" noGrp="1"/>
+          </p:cNvSpPr>
+          <p:nvPr/>
+        </p:nvSpPr>
+        <p:spPr>
+          <a:xfrm xmlns:a="http://schemas.openxmlformats.org/drawingml/2006/main">
+            <a:off x="514350" y="2095500"/>
+            <a:ext cx="3714750" cy="933450"/>
+          </a:xfrm>
+          <a:prstGeom xmlns:a="http://schemas.openxmlformats.org/drawingml/2006/main" prst="roundRect">
+            <a:avLst>
+              <a:gd name="adj" fmla="val 8163"/>
+            </a:avLst>
+          </a:prstGeom>
+          <a:solidFill xmlns:a="http://schemas.openxmlformats.org/drawingml/2006/main">
+            <a:srgbClr val="111827"/>
+          </a:solidFill>
+          <a:ln xmlns:a="http://schemas.openxmlformats.org/drawingml/2006/main" w="9525">
+            <a:solidFill>
+              <a:srgbClr val="2F3B55"/>
+            </a:solidFill>
+            <a:prstDash val="solid"/>
+          </a:ln>
+        </p:spPr>
+      </p:sp>
+      <p:sp>
+        <p:nvSpPr>
+          <p:cNvPr id="10" name="gate-bar-1">
+            <a:extLst xmlns:a="http://schemas.openxmlformats.org/drawingml/2006/main">
+              <a:ext uri="{FF2B5EF4-FFF2-40B4-BE49-F238E27FC236}">
+                <a16:creationId xmlns:a16="http://schemas.microsoft.com/office/drawing/2014/main" id="{8A8850C3-9CB2-4977-AB96-79633811AB4D}"/>
+              </a:ext>
+            </a:extLst>
+          </p:cNvPr>
+          <p:cNvSpPr>
+            <a:spLocks xmlns:a="http://schemas.openxmlformats.org/drawingml/2006/main" noGrp="1"/>
+          </p:cNvSpPr>
+          <p:nvPr/>
+        </p:nvSpPr>
+        <p:spPr>
+          <a:xfrm xmlns:a="http://schemas.openxmlformats.org/drawingml/2006/main">
+            <a:off x="514350" y="2095500"/>
+            <a:ext cx="66675" cy="933450"/>
+          </a:xfrm>
+          <a:prstGeom xmlns:a="http://schemas.openxmlformats.org/drawingml/2006/main" prst="rect">
+            <a:avLst/>
+          </a:prstGeom>
+          <a:solidFill xmlns:a="http://schemas.openxmlformats.org/drawingml/2006/main">
+            <a:srgbClr val="00B8D9"/>
+          </a:solidFill>
+          <a:ln xmlns:a="http://schemas.openxmlformats.org/drawingml/2006/main" w="0">
+            <a:solidFill>
+              <a:srgbClr val="00B8D9"/>
+            </a:solidFill>
+            <a:prstDash val="solid"/>
+          </a:ln>
+        </p:spPr>
+      </p:sp>
+      <p:sp>
+        <p:nvSpPr>
+          <p:cNvPr id="11" name="gate-phase-1">
+            <a:extLst xmlns:a="http://schemas.openxmlformats.org/drawingml/2006/main">
+              <a:ext uri="{FF2B5EF4-FFF2-40B4-BE49-F238E27FC236}">
+                <a16:creationId xmlns:a16="http://schemas.microsoft.com/office/drawing/2014/main" id="{84DD06CD-8B5F-4273-A5B5-179DED53871A}"/>
+              </a:ext>
+            </a:extLst>
+          </p:cNvPr>
+          <p:cNvSpPr>
+            <a:spLocks xmlns:a="http://schemas.openxmlformats.org/drawingml/2006/main" noGrp="1"/>
+          </p:cNvSpPr>
+          <p:nvPr/>
+        </p:nvSpPr>
+        <p:spPr>
+          <a:xfrm xmlns:a="http://schemas.openxmlformats.org/drawingml/2006/main">
+            <a:off x="781050" y="2247900"/>
+            <a:ext cx="800100" cy="228600"/>
+          </a:xfrm>
+          <a:prstGeom xmlns:a="http://schemas.openxmlformats.org/drawingml/2006/main" prst="rect">
+            <a:avLst/>
+          </a:prstGeom>
+          <a:noFill xmlns:a="http://schemas.openxmlformats.org/drawingml/2006/main"/>
+          <a:ln xmlns:a="http://schemas.openxmlformats.org/drawingml/2006/main" w="0">
+            <a:noFill/>
+            <a:prstDash val="solid"/>
+          </a:ln>
+        </p:spPr>
+        <p:txBody>
+          <a:bodyPr xmlns:a="http://schemas.openxmlformats.org/drawingml/2006/main"/>
+          <a:lstStyle xmlns:a="http://schemas.openxmlformats.org/drawingml/2006/main"/>
+          <a:p xmlns:a="http://schemas.openxmlformats.org/drawingml/2006/main">
+            <a:pPr>
+              <a:defRPr sz="1200" b="1">
+                <a:solidFill>
+                  <a:srgbClr val="00B8D9"/>
+                </a:solidFill>
+              </a:defRPr>
+            </a:pPr>
+            <a:r>
+              <a:rPr sz="1200" b="1">
+                <a:solidFill>
+                  <a:srgbClr val="00B8D9"/>
+                </a:solidFill>
+              </a:rPr>
+              <a:t>Gate 1</a:t>
+            </a:r>
+          </a:p>
+        </p:txBody>
+      </p:sp>
+      <p:sp>
+        <p:nvSpPr>
+          <p:cNvPr id="12" name="gate-title-1">
+            <a:extLst xmlns:a="http://schemas.openxmlformats.org/drawingml/2006/main">
+              <a:ext uri="{FF2B5EF4-FFF2-40B4-BE49-F238E27FC236}">
+                <a16:creationId xmlns:a16="http://schemas.microsoft.com/office/drawing/2014/main" id="{766CF535-C27B-4F6D-8F4A-D7D4A956B04B}"/>
+              </a:ext>
+            </a:extLst>
+          </p:cNvPr>
+          <p:cNvSpPr>
+            <a:spLocks xmlns:a="http://schemas.openxmlformats.org/drawingml/2006/main" noGrp="1"/>
+          </p:cNvSpPr>
+          <p:nvPr/>
+        </p:nvSpPr>
+        <p:spPr>
+          <a:xfrm xmlns:a="http://schemas.openxmlformats.org/drawingml/2006/main">
+            <a:off x="1619250" y="2238375"/>
+            <a:ext cx="2190750" cy="247650"/>
+          </a:xfrm>
+          <a:prstGeom xmlns:a="http://schemas.openxmlformats.org/drawingml/2006/main" prst="rect">
+            <a:avLst/>
+          </a:prstGeom>
+          <a:noFill xmlns:a="http://schemas.openxmlformats.org/drawingml/2006/main"/>
+          <a:ln xmlns:a="http://schemas.openxmlformats.org/drawingml/2006/main" w="0">
+            <a:noFill/>
+            <a:prstDash val="solid"/>
+          </a:ln>
+        </p:spPr>
+        <p:txBody>
+          <a:bodyPr xmlns:a="http://schemas.openxmlformats.org/drawingml/2006/main"/>
+          <a:lstStyle xmlns:a="http://schemas.openxmlformats.org/drawingml/2006/main"/>
+          <a:p xmlns:a="http://schemas.openxmlformats.org/drawingml/2006/main">
+            <a:pPr>
+              <a:defRPr sz="1425" b="1">
+                <a:solidFill>
+                  <a:srgbClr val="FFFFFF"/>
+                </a:solidFill>
+              </a:defRPr>
+            </a:pPr>
+            <a:r>
+              <a:rPr sz="1425" b="1">
+                <a:solidFill>
+                  <a:srgbClr val="FFFFFF"/>
+                </a:solidFill>
+              </a:rPr>
+              <a:t>범위 고정</a:t>
+            </a:r>
+          </a:p>
+        </p:txBody>
+      </p:sp>
+      <p:sp>
+        <p:nvSpPr>
+          <p:cNvPr id="13" name="gate-body-1">
+            <a:extLst xmlns:a="http://schemas.openxmlformats.org/drawingml/2006/main">
+              <a:ext uri="{FF2B5EF4-FFF2-40B4-BE49-F238E27FC236}">
+                <a16:creationId xmlns:a16="http://schemas.microsoft.com/office/drawing/2014/main" id="{EF0C9AD2-35DA-4C63-AE64-E7ADD496D969}"/>
+              </a:ext>
+            </a:extLst>
+          </p:cNvPr>
+          <p:cNvSpPr>
+            <a:spLocks xmlns:a="http://schemas.openxmlformats.org/drawingml/2006/main" noGrp="1"/>
+          </p:cNvSpPr>
+          <p:nvPr/>
+        </p:nvSpPr>
+        <p:spPr>
+          <a:xfrm xmlns:a="http://schemas.openxmlformats.org/drawingml/2006/main">
+            <a:off x="781050" y="2590800"/>
+            <a:ext cx="3028950" cy="304800"/>
+          </a:xfrm>
+          <a:prstGeom xmlns:a="http://schemas.openxmlformats.org/drawingml/2006/main" prst="rect">
+            <a:avLst/>
+          </a:prstGeom>
+          <a:noFill xmlns:a="http://schemas.openxmlformats.org/drawingml/2006/main"/>
+          <a:ln xmlns:a="http://schemas.openxmlformats.org/drawingml/2006/main" w="0">
+            <a:noFill/>
+            <a:prstDash val="solid"/>
+          </a:ln>
+        </p:spPr>
+        <p:txBody>
+          <a:bodyPr xmlns:a="http://schemas.openxmlformats.org/drawingml/2006/main"/>
+          <a:lstStyle xmlns:a="http://schemas.openxmlformats.org/drawingml/2006/main"/>
+          <a:p xmlns:a="http://schemas.openxmlformats.org/drawingml/2006/main">
+            <a:pPr>
+              <a:defRPr sz="1050">
+                <a:solidFill>
+                  <a:srgbClr val="CBD5E1"/>
+                </a:solidFill>
+              </a:defRPr>
+            </a:pPr>
+            <a:r>
+              <a:rPr sz="1050">
+                <a:solidFill>
+                  <a:srgbClr val="CBD5E1"/>
+                </a:solidFill>
+              </a:rPr>
+              <a:t>일본 서비스 범위와 콘텐츠 기준을 확정하고, 변경 요청은 영향도 검토 후 반영합니다.</a:t>
+            </a:r>
+          </a:p>
+        </p:txBody>
+      </p:sp>
+      <p:sp>
+        <p:nvSpPr>
+          <p:cNvPr id="14" name="gate-card-2">
+            <a:extLst xmlns:a="http://schemas.openxmlformats.org/drawingml/2006/main">
+              <a:ext uri="{FF2B5EF4-FFF2-40B4-BE49-F238E27FC236}">
+                <a16:creationId xmlns:a16="http://schemas.microsoft.com/office/drawing/2014/main" id="{3DE61C86-46EA-49A1-BE79-8C6EC96BDC57}"/>
+              </a:ext>
+            </a:extLst>
+          </p:cNvPr>
+          <p:cNvSpPr>
+            <a:spLocks xmlns:a="http://schemas.openxmlformats.org/drawingml/2006/main" noGrp="1"/>
+          </p:cNvSpPr>
+          <p:nvPr/>
+        </p:nvSpPr>
+        <p:spPr>
+          <a:xfrm xmlns:a="http://schemas.openxmlformats.org/drawingml/2006/main">
+            <a:off x="514350" y="3295650"/>
+            <a:ext cx="3714750" cy="933450"/>
+          </a:xfrm>
+          <a:prstGeom xmlns:a="http://schemas.openxmlformats.org/drawingml/2006/main" prst="roundRect">
+            <a:avLst>
+              <a:gd name="adj" fmla="val 8163"/>
+            </a:avLst>
+          </a:prstGeom>
+          <a:solidFill xmlns:a="http://schemas.openxmlformats.org/drawingml/2006/main">
+            <a:srgbClr val="111827"/>
+          </a:solidFill>
+          <a:ln xmlns:a="http://schemas.openxmlformats.org/drawingml/2006/main" w="9525">
+            <a:solidFill>
+              <a:srgbClr val="2F3B55"/>
+            </a:solidFill>
+            <a:prstDash val="solid"/>
+          </a:ln>
+        </p:spPr>
+      </p:sp>
+      <p:sp>
+        <p:nvSpPr>
+          <p:cNvPr id="15" name="gate-bar-2">
+            <a:extLst xmlns:a="http://schemas.openxmlformats.org/drawingml/2006/main">
+              <a:ext uri="{FF2B5EF4-FFF2-40B4-BE49-F238E27FC236}">
+                <a16:creationId xmlns:a16="http://schemas.microsoft.com/office/drawing/2014/main" id="{308BA253-CF53-40C9-B876-518D53FF1B0A}"/>
+              </a:ext>
+            </a:extLst>
+          </p:cNvPr>
+          <p:cNvSpPr>
+            <a:spLocks xmlns:a="http://schemas.openxmlformats.org/drawingml/2006/main" noGrp="1"/>
+          </p:cNvSpPr>
+          <p:nvPr/>
+        </p:nvSpPr>
+        <p:spPr>
+          <a:xfrm xmlns:a="http://schemas.openxmlformats.org/drawingml/2006/main">
+            <a:off x="514350" y="3295650"/>
+            <a:ext cx="66675" cy="933450"/>
+          </a:xfrm>
+          <a:prstGeom xmlns:a="http://schemas.openxmlformats.org/drawingml/2006/main" prst="rect">
+            <a:avLst/>
+          </a:prstGeom>
+          <a:solidFill xmlns:a="http://schemas.openxmlformats.org/drawingml/2006/main">
+            <a:srgbClr val="FF6B35"/>
+          </a:solidFill>
+          <a:ln xmlns:a="http://schemas.openxmlformats.org/drawingml/2006/main" w="0">
+            <a:solidFill>
+              <a:srgbClr val="FF6B35"/>
+            </a:solidFill>
+            <a:prstDash val="solid"/>
+          </a:ln>
+        </p:spPr>
+      </p:sp>
+      <p:sp>
+        <p:nvSpPr>
+          <p:cNvPr id="16" name="gate-phase-2">
+            <a:extLst xmlns:a="http://schemas.openxmlformats.org/drawingml/2006/main">
+              <a:ext uri="{FF2B5EF4-FFF2-40B4-BE49-F238E27FC236}">
+                <a16:creationId xmlns:a16="http://schemas.microsoft.com/office/drawing/2014/main" id="{CADFB0A6-10B6-4B08-9175-22D85E22B330}"/>
+              </a:ext>
+            </a:extLst>
+          </p:cNvPr>
+          <p:cNvSpPr>
+            <a:spLocks xmlns:a="http://schemas.openxmlformats.org/drawingml/2006/main" noGrp="1"/>
+          </p:cNvSpPr>
+          <p:nvPr/>
+        </p:nvSpPr>
+        <p:spPr>
+          <a:xfrm xmlns:a="http://schemas.openxmlformats.org/drawingml/2006/main">
+            <a:off x="781050" y="3448050"/>
+            <a:ext cx="800100" cy="228600"/>
+          </a:xfrm>
+          <a:prstGeom xmlns:a="http://schemas.openxmlformats.org/drawingml/2006/main" prst="rect">
+            <a:avLst/>
+          </a:prstGeom>
+          <a:noFill xmlns:a="http://schemas.openxmlformats.org/drawingml/2006/main"/>
+          <a:ln xmlns:a="http://schemas.openxmlformats.org/drawingml/2006/main" w="0">
+            <a:noFill/>
+            <a:prstDash val="solid"/>
+          </a:ln>
+        </p:spPr>
+        <p:txBody>
+          <a:bodyPr xmlns:a="http://schemas.openxmlformats.org/drawingml/2006/main"/>
+          <a:lstStyle xmlns:a="http://schemas.openxmlformats.org/drawingml/2006/main"/>
+          <a:p xmlns:a="http://schemas.openxmlformats.org/drawingml/2006/main">
+            <a:pPr>
+              <a:defRPr sz="1200" b="1">
+                <a:solidFill>
+                  <a:srgbClr val="FF6B35"/>
+                </a:solidFill>
+              </a:defRPr>
+            </a:pPr>
+            <a:r>
+              <a:rPr sz="1200" b="1">
+                <a:solidFill>
+                  <a:srgbClr val="FF6B35"/>
+                </a:solidFill>
+              </a:rPr>
+              <a:t>Gate 2</a:t>
+            </a:r>
+          </a:p>
+        </p:txBody>
+      </p:sp>
+      <p:sp>
+        <p:nvSpPr>
+          <p:cNvPr id="17" name="gate-title-2">
+            <a:extLst xmlns:a="http://schemas.openxmlformats.org/drawingml/2006/main">
+              <a:ext uri="{FF2B5EF4-FFF2-40B4-BE49-F238E27FC236}">
+                <a16:creationId xmlns:a16="http://schemas.microsoft.com/office/drawing/2014/main" id="{7227540E-5488-441E-8B8D-D2D4E3BD7DF6}"/>
+              </a:ext>
+            </a:extLst>
+          </p:cNvPr>
+          <p:cNvSpPr>
+            <a:spLocks xmlns:a="http://schemas.openxmlformats.org/drawingml/2006/main" noGrp="1"/>
+          </p:cNvSpPr>
+          <p:nvPr/>
+        </p:nvSpPr>
+        <p:spPr>
+          <a:xfrm xmlns:a="http://schemas.openxmlformats.org/drawingml/2006/main">
+            <a:off x="1619250" y="3438525"/>
+            <a:ext cx="2190750" cy="247650"/>
+          </a:xfrm>
+          <a:prstGeom xmlns:a="http://schemas.openxmlformats.org/drawingml/2006/main" prst="rect">
+            <a:avLst/>
+          </a:prstGeom>
+          <a:noFill xmlns:a="http://schemas.openxmlformats.org/drawingml/2006/main"/>
+          <a:ln xmlns:a="http://schemas.openxmlformats.org/drawingml/2006/main" w="0">
+            <a:noFill/>
+            <a:prstDash val="solid"/>
+          </a:ln>
+        </p:spPr>
+        <p:txBody>
+          <a:bodyPr xmlns:a="http://schemas.openxmlformats.org/drawingml/2006/main"/>
+          <a:lstStyle xmlns:a="http://schemas.openxmlformats.org/drawingml/2006/main"/>
+          <a:p xmlns:a="http://schemas.openxmlformats.org/drawingml/2006/main">
+            <a:pPr>
+              <a:defRPr sz="1425" b="1">
+                <a:solidFill>
+                  <a:srgbClr val="FFFFFF"/>
+                </a:solidFill>
+              </a:defRPr>
+            </a:pPr>
+            <a:r>
+              <a:rPr sz="1425" b="1">
+                <a:solidFill>
+                  <a:srgbClr val="FFFFFF"/>
+                </a:solidFill>
+              </a:rPr>
+              <a:t>검수 진입</a:t>
+            </a:r>
+          </a:p>
+        </p:txBody>
+      </p:sp>
+      <p:sp>
+        <p:nvSpPr>
+          <p:cNvPr id="18" name="gate-body-2">
+            <a:extLst xmlns:a="http://schemas.openxmlformats.org/drawingml/2006/main">
+              <a:ext uri="{FF2B5EF4-FFF2-40B4-BE49-F238E27FC236}">
+                <a16:creationId xmlns:a16="http://schemas.microsoft.com/office/drawing/2014/main" id="{4F9E845A-59D7-49F2-BEDB-FE5B7E20BF67}"/>
+              </a:ext>
+            </a:extLst>
+          </p:cNvPr>
+          <p:cNvSpPr>
+            <a:spLocks xmlns:a="http://schemas.openxmlformats.org/drawingml/2006/main" noGrp="1"/>
+          </p:cNvSpPr>
+          <p:nvPr/>
+        </p:nvSpPr>
+        <p:spPr>
+          <a:xfrm xmlns:a="http://schemas.openxmlformats.org/drawingml/2006/main">
+            <a:off x="781050" y="3790950"/>
+            <a:ext cx="3028950" cy="304800"/>
+          </a:xfrm>
+          <a:prstGeom xmlns:a="http://schemas.openxmlformats.org/drawingml/2006/main" prst="rect">
+            <a:avLst/>
+          </a:prstGeom>
+          <a:noFill xmlns:a="http://schemas.openxmlformats.org/drawingml/2006/main"/>
+          <a:ln xmlns:a="http://schemas.openxmlformats.org/drawingml/2006/main" w="0">
+            <a:noFill/>
+            <a:prstDash val="solid"/>
+          </a:ln>
+        </p:spPr>
+        <p:txBody>
+          <a:bodyPr xmlns:a="http://schemas.openxmlformats.org/drawingml/2006/main"/>
+          <a:lstStyle xmlns:a="http://schemas.openxmlformats.org/drawingml/2006/main"/>
+          <a:p xmlns:a="http://schemas.openxmlformats.org/drawingml/2006/main">
+            <a:pPr>
+              <a:defRPr sz="1050">
+                <a:solidFill>
+                  <a:srgbClr val="CBD5E1"/>
+                </a:solidFill>
+              </a:defRPr>
+            </a:pPr>
+            <a:r>
+              <a:rPr sz="1050">
+                <a:solidFill>
+                  <a:srgbClr val="CBD5E1"/>
+                </a:solidFill>
+              </a:rPr>
+              <a:t>현지화 리소스와 주요 기능 반영 상태를 확인한 뒤 내부 QA와 퍼블리셔 검수에 진입합니다.</a:t>
+            </a:r>
+          </a:p>
+        </p:txBody>
+      </p:sp>
+      <p:sp>
+        <p:nvSpPr>
+          <p:cNvPr id="19" name="gate-card-3">
+            <a:extLst xmlns:a="http://schemas.openxmlformats.org/drawingml/2006/main">
+              <a:ext uri="{FF2B5EF4-FFF2-40B4-BE49-F238E27FC236}">
+                <a16:creationId xmlns:a16="http://schemas.microsoft.com/office/drawing/2014/main" id="{A5A89A7E-5FCA-41DC-9187-1D00D84EEB4D}"/>
+              </a:ext>
+            </a:extLst>
+          </p:cNvPr>
+          <p:cNvSpPr>
+            <a:spLocks xmlns:a="http://schemas.openxmlformats.org/drawingml/2006/main" noGrp="1"/>
+          </p:cNvSpPr>
+          <p:nvPr/>
+        </p:nvSpPr>
+        <p:spPr>
+          <a:xfrm xmlns:a="http://schemas.openxmlformats.org/drawingml/2006/main">
+            <a:off x="514350" y="4495800"/>
+            <a:ext cx="3714750" cy="933450"/>
+          </a:xfrm>
+          <a:prstGeom xmlns:a="http://schemas.openxmlformats.org/drawingml/2006/main" prst="roundRect">
+            <a:avLst>
+              <a:gd name="adj" fmla="val 8163"/>
+            </a:avLst>
+          </a:prstGeom>
+          <a:solidFill xmlns:a="http://schemas.openxmlformats.org/drawingml/2006/main">
+            <a:srgbClr val="111827"/>
+          </a:solidFill>
+          <a:ln xmlns:a="http://schemas.openxmlformats.org/drawingml/2006/main" w="9525">
+            <a:solidFill>
+              <a:srgbClr val="2F3B55"/>
+            </a:solidFill>
+            <a:prstDash val="solid"/>
+          </a:ln>
+        </p:spPr>
+      </p:sp>
+      <p:sp>
+        <p:nvSpPr>
+          <p:cNvPr id="20" name="gate-bar-3">
+            <a:extLst xmlns:a="http://schemas.openxmlformats.org/drawingml/2006/main">
+              <a:ext uri="{FF2B5EF4-FFF2-40B4-BE49-F238E27FC236}">
+                <a16:creationId xmlns:a16="http://schemas.microsoft.com/office/drawing/2014/main" id="{E1475169-C584-4153-9783-4EB14A53593B}"/>
+              </a:ext>
+            </a:extLst>
+          </p:cNvPr>
+          <p:cNvSpPr>
+            <a:spLocks xmlns:a="http://schemas.openxmlformats.org/drawingml/2006/main" noGrp="1"/>
+          </p:cNvSpPr>
+          <p:nvPr/>
+        </p:nvSpPr>
+        <p:spPr>
+          <a:xfrm xmlns:a="http://schemas.openxmlformats.org/drawingml/2006/main">
+            <a:off x="514350" y="4495800"/>
+            <a:ext cx="66675" cy="933450"/>
+          </a:xfrm>
+          <a:prstGeom xmlns:a="http://schemas.openxmlformats.org/drawingml/2006/main" prst="rect">
+            <a:avLst/>
+          </a:prstGeom>
+          <a:solidFill xmlns:a="http://schemas.openxmlformats.org/drawingml/2006/main">
+            <a:srgbClr val="7C3AED"/>
+          </a:solidFill>
+          <a:ln xmlns:a="http://schemas.openxmlformats.org/drawingml/2006/main" w="0">
+            <a:solidFill>
+              <a:srgbClr val="7C3AED"/>
+            </a:solidFill>
+            <a:prstDash val="solid"/>
+          </a:ln>
+        </p:spPr>
+      </p:sp>
+      <p:sp>
+        <p:nvSpPr>
+          <p:cNvPr id="21" name="gate-phase-3">
+            <a:extLst xmlns:a="http://schemas.openxmlformats.org/drawingml/2006/main">
+              <a:ext uri="{FF2B5EF4-FFF2-40B4-BE49-F238E27FC236}">
+                <a16:creationId xmlns:a16="http://schemas.microsoft.com/office/drawing/2014/main" id="{BBFD7033-5848-4B76-B68F-AB55B36F5916}"/>
+              </a:ext>
+            </a:extLst>
+          </p:cNvPr>
+          <p:cNvSpPr>
+            <a:spLocks xmlns:a="http://schemas.openxmlformats.org/drawingml/2006/main" noGrp="1"/>
+          </p:cNvSpPr>
+          <p:nvPr/>
+        </p:nvSpPr>
+        <p:spPr>
+          <a:xfrm xmlns:a="http://schemas.openxmlformats.org/drawingml/2006/main">
+            <a:off x="781050" y="4648200"/>
+            <a:ext cx="800100" cy="228600"/>
+          </a:xfrm>
+          <a:prstGeom xmlns:a="http://schemas.openxmlformats.org/drawingml/2006/main" prst="rect">
+            <a:avLst/>
+          </a:prstGeom>
+          <a:noFill xmlns:a="http://schemas.openxmlformats.org/drawingml/2006/main"/>
+          <a:ln xmlns:a="http://schemas.openxmlformats.org/drawingml/2006/main" w="0">
+            <a:noFill/>
+            <a:prstDash val="solid"/>
+          </a:ln>
+        </p:spPr>
+        <p:txBody>
+          <a:bodyPr xmlns:a="http://schemas.openxmlformats.org/drawingml/2006/main"/>
+          <a:lstStyle xmlns:a="http://schemas.openxmlformats.org/drawingml/2006/main"/>
+          <a:p xmlns:a="http://schemas.openxmlformats.org/drawingml/2006/main">
+            <a:pPr>
+              <a:defRPr sz="1200" b="1">
+                <a:solidFill>
+                  <a:srgbClr val="7C3AED"/>
+                </a:solidFill>
+              </a:defRPr>
+            </a:pPr>
+            <a:r>
+              <a:rPr sz="1200" b="1">
+                <a:solidFill>
+                  <a:srgbClr val="7C3AED"/>
+                </a:solidFill>
+              </a:rPr>
+              <a:t>Gate 3</a:t>
+            </a:r>
+          </a:p>
+        </p:txBody>
+      </p:sp>
+      <p:sp>
+        <p:nvSpPr>
+          <p:cNvPr id="22" name="gate-title-3">
+            <a:extLst xmlns:a="http://schemas.openxmlformats.org/drawingml/2006/main">
+              <a:ext uri="{FF2B5EF4-FFF2-40B4-BE49-F238E27FC236}">
+                <a16:creationId xmlns:a16="http://schemas.microsoft.com/office/drawing/2014/main" id="{F6027F08-AAD3-4A8F-9909-9F83CA3EF5D2}"/>
+              </a:ext>
+            </a:extLst>
+          </p:cNvPr>
+          <p:cNvSpPr>
+            <a:spLocks xmlns:a="http://schemas.openxmlformats.org/drawingml/2006/main" noGrp="1"/>
+          </p:cNvSpPr>
+          <p:nvPr/>
+        </p:nvSpPr>
+        <p:spPr>
+          <a:xfrm xmlns:a="http://schemas.openxmlformats.org/drawingml/2006/main">
+            <a:off x="1619250" y="4638675"/>
+            <a:ext cx="2190750" cy="247650"/>
+          </a:xfrm>
+          <a:prstGeom xmlns:a="http://schemas.openxmlformats.org/drawingml/2006/main" prst="rect">
+            <a:avLst/>
+          </a:prstGeom>
+          <a:noFill xmlns:a="http://schemas.openxmlformats.org/drawingml/2006/main"/>
+          <a:ln xmlns:a="http://schemas.openxmlformats.org/drawingml/2006/main" w="0">
+            <a:noFill/>
+            <a:prstDash val="solid"/>
+          </a:ln>
+        </p:spPr>
+        <p:txBody>
+          <a:bodyPr xmlns:a="http://schemas.openxmlformats.org/drawingml/2006/main"/>
+          <a:lstStyle xmlns:a="http://schemas.openxmlformats.org/drawingml/2006/main"/>
+          <a:p xmlns:a="http://schemas.openxmlformats.org/drawingml/2006/main">
+            <a:pPr>
+              <a:defRPr sz="1425" b="1">
+                <a:solidFill>
+                  <a:srgbClr val="FFFFFF"/>
+                </a:solidFill>
+              </a:defRPr>
+            </a:pPr>
+            <a:r>
+              <a:rPr sz="1425" b="1">
+                <a:solidFill>
+                  <a:srgbClr val="FFFFFF"/>
+                </a:solidFill>
+              </a:rPr>
+              <a:t>런칭 후보</a:t>
+            </a:r>
+          </a:p>
+        </p:txBody>
+      </p:sp>
+      <p:sp>
+        <p:nvSpPr>
+          <p:cNvPr id="23" name="gate-body-3">
+            <a:extLst xmlns:a="http://schemas.openxmlformats.org/drawingml/2006/main">
+              <a:ext uri="{FF2B5EF4-FFF2-40B4-BE49-F238E27FC236}">
+                <a16:creationId xmlns:a16="http://schemas.microsoft.com/office/drawing/2014/main" id="{A7C0D76F-0114-47D7-8A81-9F83B6DE3C4B}"/>
+              </a:ext>
+            </a:extLst>
+          </p:cNvPr>
+          <p:cNvSpPr>
+            <a:spLocks xmlns:a="http://schemas.openxmlformats.org/drawingml/2006/main" noGrp="1"/>
+          </p:cNvSpPr>
+          <p:nvPr/>
+        </p:nvSpPr>
+        <p:spPr>
+          <a:xfrm xmlns:a="http://schemas.openxmlformats.org/drawingml/2006/main">
+            <a:off x="781050" y="4991100"/>
+            <a:ext cx="3028950" cy="304800"/>
+          </a:xfrm>
+          <a:prstGeom xmlns:a="http://schemas.openxmlformats.org/drawingml/2006/main" prst="rect">
+            <a:avLst/>
+          </a:prstGeom>
+          <a:noFill xmlns:a="http://schemas.openxmlformats.org/drawingml/2006/main"/>
+          <a:ln xmlns:a="http://schemas.openxmlformats.org/drawingml/2006/main" w="0">
+            <a:noFill/>
+            <a:prstDash val="solid"/>
+          </a:ln>
+        </p:spPr>
+        <p:txBody>
+          <a:bodyPr xmlns:a="http://schemas.openxmlformats.org/drawingml/2006/main"/>
+          <a:lstStyle xmlns:a="http://schemas.openxmlformats.org/drawingml/2006/main"/>
+          <a:p xmlns:a="http://schemas.openxmlformats.org/drawingml/2006/main">
+            <a:pPr>
+              <a:defRPr sz="1050">
+                <a:solidFill>
+                  <a:srgbClr val="CBD5E1"/>
+                </a:solidFill>
+              </a:defRPr>
+            </a:pPr>
+            <a:r>
+              <a:rPr sz="1050">
+                <a:solidFill>
+                  <a:srgbClr val="CBD5E1"/>
+                </a:solidFill>
+              </a:rPr>
+              <a:t>치명 이슈와 잔여 리스크를 분리하고, 배포 가능한 후보 빌드 기준을 고정합니다.</a:t>
+            </a:r>
+          </a:p>
+        </p:txBody>
+      </p:sp>
+      <p:sp>
+        <p:nvSpPr>
+          <p:cNvPr id="24" name="decision-title">
+            <a:extLst xmlns:a="http://schemas.openxmlformats.org/drawingml/2006/main">
+              <a:ext uri="{FF2B5EF4-FFF2-40B4-BE49-F238E27FC236}">
+                <a16:creationId xmlns:a16="http://schemas.microsoft.com/office/drawing/2014/main" id="{6D530ED2-89A2-475C-8FDB-9DB6A9222A9A}"/>
+              </a:ext>
+            </a:extLst>
+          </p:cNvPr>
+          <p:cNvSpPr>
+            <a:spLocks xmlns:a="http://schemas.openxmlformats.org/drawingml/2006/main" noGrp="1"/>
+          </p:cNvSpPr>
+          <p:nvPr/>
+        </p:nvSpPr>
+        <p:spPr>
+          <a:xfrm xmlns:a="http://schemas.openxmlformats.org/drawingml/2006/main">
+            <a:off x="4686300" y="1752600"/>
+            <a:ext cx="2286000" cy="285750"/>
+          </a:xfrm>
+          <a:prstGeom xmlns:a="http://schemas.openxmlformats.org/drawingml/2006/main" prst="rect">
+            <a:avLst/>
+          </a:prstGeom>
+          <a:noFill xmlns:a="http://schemas.openxmlformats.org/drawingml/2006/main"/>
+          <a:ln xmlns:a="http://schemas.openxmlformats.org/drawingml/2006/main" w="0">
+            <a:noFill/>
+            <a:prstDash val="solid"/>
+          </a:ln>
+        </p:spPr>
+        <p:txBody>
+          <a:bodyPr xmlns:a="http://schemas.openxmlformats.org/drawingml/2006/main"/>
+          <a:lstStyle xmlns:a="http://schemas.openxmlformats.org/drawingml/2006/main"/>
+          <a:p xmlns:a="http://schemas.openxmlformats.org/drawingml/2006/main">
+            <a:pPr>
+              <a:defRPr sz="1650" b="1">
+                <a:solidFill>
+                  <a:srgbClr val="FFFFFF"/>
+                </a:solidFill>
+              </a:defRPr>
+            </a:pPr>
+            <a:r>
+              <a:rPr sz="1650" b="1">
+                <a:solidFill>
+                  <a:srgbClr val="FFFFFF"/>
+                </a:solidFill>
+              </a:rPr>
+              <a:t>판정 체크리스트</a:t>
+            </a:r>
+          </a:p>
+        </p:txBody>
+      </p:sp>
+      <p:sp>
+        <p:nvSpPr>
+          <p:cNvPr id="25" name="decision-note">
+            <a:extLst xmlns:a="http://schemas.openxmlformats.org/drawingml/2006/main">
+              <a:ext uri="{FF2B5EF4-FFF2-40B4-BE49-F238E27FC236}">
+                <a16:creationId xmlns:a16="http://schemas.microsoft.com/office/drawing/2014/main" id="{39536B98-6D8E-4AE8-B165-087F2FB13BC8}"/>
+              </a:ext>
+            </a:extLst>
+          </p:cNvPr>
+          <p:cNvSpPr>
+            <a:spLocks xmlns:a="http://schemas.openxmlformats.org/drawingml/2006/main" noGrp="1"/>
+          </p:cNvSpPr>
+          <p:nvPr/>
+        </p:nvSpPr>
+        <p:spPr>
+          <a:xfrm xmlns:a="http://schemas.openxmlformats.org/drawingml/2006/main">
+            <a:off x="6896100" y="1809750"/>
+            <a:ext cx="4095750" cy="209550"/>
+          </a:xfrm>
+          <a:prstGeom xmlns:a="http://schemas.openxmlformats.org/drawingml/2006/main" prst="rect">
+            <a:avLst/>
+          </a:prstGeom>
+          <a:noFill xmlns:a="http://schemas.openxmlformats.org/drawingml/2006/main"/>
+          <a:ln xmlns:a="http://schemas.openxmlformats.org/drawingml/2006/main" w="0">
+            <a:noFill/>
+            <a:prstDash val="solid"/>
+          </a:ln>
+        </p:spPr>
+        <p:txBody>
+          <a:bodyPr xmlns:a="http://schemas.openxmlformats.org/drawingml/2006/main"/>
+          <a:lstStyle xmlns:a="http://schemas.openxmlformats.org/drawingml/2006/main"/>
+          <a:p xmlns:a="http://schemas.openxmlformats.org/drawingml/2006/main">
+            <a:pPr>
+              <a:defRPr sz="1050">
+                <a:solidFill>
+                  <a:srgbClr val="94A3B8"/>
+                </a:solidFill>
+              </a:defRPr>
+            </a:pPr>
+            <a:r>
+              <a:rPr sz="1050">
+                <a:solidFill>
+                  <a:srgbClr val="94A3B8"/>
+                </a:solidFill>
+              </a:rPr>
+              <a:t>각 항목은 완료 여부보다 다음 단계 진입 가능성을 기준으로 판단합니다.</a:t>
+            </a:r>
+          </a:p>
+        </p:txBody>
+      </p:sp>
+      <p:sp>
+        <p:nvSpPr>
+          <p:cNvPr id="26" name="decision-header">
+            <a:extLst xmlns:a="http://schemas.openxmlformats.org/drawingml/2006/main">
+              <a:ext uri="{FF2B5EF4-FFF2-40B4-BE49-F238E27FC236}">
+                <a16:creationId xmlns:a16="http://schemas.microsoft.com/office/drawing/2014/main" id="{41D2B7DA-1D40-4D79-8371-8EAD20001EFB}"/>
+              </a:ext>
+            </a:extLst>
+          </p:cNvPr>
+          <p:cNvSpPr>
+            <a:spLocks xmlns:a="http://schemas.openxmlformats.org/drawingml/2006/main" noGrp="1"/>
+          </p:cNvSpPr>
+          <p:nvPr/>
+        </p:nvSpPr>
+        <p:spPr>
+          <a:xfrm xmlns:a="http://schemas.openxmlformats.org/drawingml/2006/main">
+            <a:off x="4686300" y="2133600"/>
+            <a:ext cx="6705600" cy="323850"/>
+          </a:xfrm>
+          <a:prstGeom xmlns:a="http://schemas.openxmlformats.org/drawingml/2006/main" prst="rect">
+            <a:avLst/>
+          </a:prstGeom>
+          <a:solidFill xmlns:a="http://schemas.openxmlformats.org/drawingml/2006/main">
+            <a:srgbClr val="00B8D9"/>
+          </a:solidFill>
+          <a:ln xmlns:a="http://schemas.openxmlformats.org/drawingml/2006/main" w="0">
+            <a:solidFill>
+              <a:srgbClr val="00B8D9"/>
+            </a:solidFill>
+            <a:prstDash val="solid"/>
+          </a:ln>
+        </p:spPr>
+      </p:sp>
+      <p:sp>
+        <p:nvSpPr>
+          <p:cNvPr id="27" name="decision-th-1">
+            <a:extLst xmlns:a="http://schemas.openxmlformats.org/drawingml/2006/main">
+              <a:ext uri="{FF2B5EF4-FFF2-40B4-BE49-F238E27FC236}">
+                <a16:creationId xmlns:a16="http://schemas.microsoft.com/office/drawing/2014/main" id="{5CE88542-8D22-4C90-B2B6-4E7E14F4B53E}"/>
+              </a:ext>
+            </a:extLst>
+          </p:cNvPr>
+          <p:cNvSpPr>
+            <a:spLocks xmlns:a="http://schemas.openxmlformats.org/drawingml/2006/main" noGrp="1"/>
+          </p:cNvSpPr>
+          <p:nvPr/>
+        </p:nvSpPr>
+        <p:spPr>
+          <a:xfrm xmlns:a="http://schemas.openxmlformats.org/drawingml/2006/main">
+            <a:off x="4933950" y="2209800"/>
+            <a:ext cx="1143000" cy="190500"/>
+          </a:xfrm>
+          <a:prstGeom xmlns:a="http://schemas.openxmlformats.org/drawingml/2006/main" prst="rect">
+            <a:avLst/>
+          </a:prstGeom>
+          <a:noFill xmlns:a="http://schemas.openxmlformats.org/drawingml/2006/main"/>
+          <a:ln xmlns:a="http://schemas.openxmlformats.org/drawingml/2006/main" w="0">
+            <a:noFill/>
+            <a:prstDash val="solid"/>
+          </a:ln>
+        </p:spPr>
+        <p:txBody>
+          <a:bodyPr xmlns:a="http://schemas.openxmlformats.org/drawingml/2006/main"/>
+          <a:lstStyle xmlns:a="http://schemas.openxmlformats.org/drawingml/2006/main"/>
+          <a:p xmlns:a="http://schemas.openxmlformats.org/drawingml/2006/main">
+            <a:pPr>
+              <a:defRPr sz="1050" b="1">
+                <a:solidFill>
+                  <a:srgbClr val="06111F"/>
+                </a:solidFill>
+              </a:defRPr>
+            </a:pPr>
+            <a:r>
+              <a:rPr sz="1050" b="1">
+                <a:solidFill>
+                  <a:srgbClr val="06111F"/>
+                </a:solidFill>
+              </a:rPr>
+              <a:t>항목</a:t>
+            </a:r>
+          </a:p>
+        </p:txBody>
+      </p:sp>
+      <p:sp>
+        <p:nvSpPr>
+          <p:cNvPr id="28" name="decision-th-2">
+            <a:extLst xmlns:a="http://schemas.openxmlformats.org/drawingml/2006/main">
+              <a:ext uri="{FF2B5EF4-FFF2-40B4-BE49-F238E27FC236}">
+                <a16:creationId xmlns:a16="http://schemas.microsoft.com/office/drawing/2014/main" id="{76B20F2D-CE05-4AFA-B6CD-C63C544C76A1}"/>
+              </a:ext>
+            </a:extLst>
+          </p:cNvPr>
+          <p:cNvSpPr>
+            <a:spLocks xmlns:a="http://schemas.openxmlformats.org/drawingml/2006/main" noGrp="1"/>
+          </p:cNvSpPr>
+          <p:nvPr/>
+        </p:nvSpPr>
+        <p:spPr>
+          <a:xfrm xmlns:a="http://schemas.openxmlformats.org/drawingml/2006/main">
+            <a:off x="6934200" y="2209800"/>
+            <a:ext cx="1714500" cy="190500"/>
+          </a:xfrm>
+          <a:prstGeom xmlns:a="http://schemas.openxmlformats.org/drawingml/2006/main" prst="rect">
+            <a:avLst/>
+          </a:prstGeom>
+          <a:noFill xmlns:a="http://schemas.openxmlformats.org/drawingml/2006/main"/>
+          <a:ln xmlns:a="http://schemas.openxmlformats.org/drawingml/2006/main" w="0">
+            <a:noFill/>
+            <a:prstDash val="solid"/>
+          </a:ln>
+        </p:spPr>
+        <p:txBody>
+          <a:bodyPr xmlns:a="http://schemas.openxmlformats.org/drawingml/2006/main"/>
+          <a:lstStyle xmlns:a="http://schemas.openxmlformats.org/drawingml/2006/main"/>
+          <a:p xmlns:a="http://schemas.openxmlformats.org/drawingml/2006/main">
+            <a:pPr>
+              <a:defRPr sz="1050" b="1">
+                <a:solidFill>
+                  <a:srgbClr val="06111F"/>
+                </a:solidFill>
+              </a:defRPr>
+            </a:pPr>
+            <a:r>
+              <a:rPr sz="1050" b="1">
+                <a:solidFill>
+                  <a:srgbClr val="06111F"/>
+                </a:solidFill>
+              </a:rPr>
+              <a:t>통과 기준</a:t>
+            </a:r>
+          </a:p>
+        </p:txBody>
+      </p:sp>
+      <p:sp>
+        <p:nvSpPr>
+          <p:cNvPr id="29" name="decision-th-3">
+            <a:extLst xmlns:a="http://schemas.openxmlformats.org/drawingml/2006/main">
+              <a:ext uri="{FF2B5EF4-FFF2-40B4-BE49-F238E27FC236}">
+                <a16:creationId xmlns:a16="http://schemas.microsoft.com/office/drawing/2014/main" id="{C86BD559-5D48-4873-A243-398D5833D104}"/>
+              </a:ext>
+            </a:extLst>
+          </p:cNvPr>
+          <p:cNvSpPr>
+            <a:spLocks xmlns:a="http://schemas.openxmlformats.org/drawingml/2006/main" noGrp="1"/>
+          </p:cNvSpPr>
+          <p:nvPr/>
+        </p:nvSpPr>
+        <p:spPr>
+          <a:xfrm xmlns:a="http://schemas.openxmlformats.org/drawingml/2006/main">
+            <a:off x="10096500" y="2209800"/>
+            <a:ext cx="762000" cy="190500"/>
+          </a:xfrm>
+          <a:prstGeom xmlns:a="http://schemas.openxmlformats.org/drawingml/2006/main" prst="rect">
+            <a:avLst/>
+          </a:prstGeom>
+          <a:noFill xmlns:a="http://schemas.openxmlformats.org/drawingml/2006/main"/>
+          <a:ln xmlns:a="http://schemas.openxmlformats.org/drawingml/2006/main" w="0">
+            <a:noFill/>
+            <a:prstDash val="solid"/>
+          </a:ln>
+        </p:spPr>
+        <p:txBody>
+          <a:bodyPr xmlns:a="http://schemas.openxmlformats.org/drawingml/2006/main"/>
+          <a:lstStyle xmlns:a="http://schemas.openxmlformats.org/drawingml/2006/main"/>
+          <a:p xmlns:a="http://schemas.openxmlformats.org/drawingml/2006/main">
+            <a:pPr algn="ctr">
+              <a:defRPr sz="1050" b="1">
+                <a:solidFill>
+                  <a:srgbClr val="06111F"/>
+                </a:solidFill>
+              </a:defRPr>
+            </a:pPr>
+            <a:r>
+              <a:rPr sz="1050" b="1">
+                <a:solidFill>
+                  <a:srgbClr val="06111F"/>
+                </a:solidFill>
+              </a:rPr>
+              <a:t>주관</a:t>
+            </a:r>
+          </a:p>
+        </p:txBody>
+      </p:sp>
+      <p:sp>
+        <p:nvSpPr>
+          <p:cNvPr id="30" name="decision-row-1">
+            <a:extLst xmlns:a="http://schemas.openxmlformats.org/drawingml/2006/main">
+              <a:ext uri="{FF2B5EF4-FFF2-40B4-BE49-F238E27FC236}">
+                <a16:creationId xmlns:a16="http://schemas.microsoft.com/office/drawing/2014/main" id="{F8AE3080-F1FF-4475-9C7D-CC5961266049}"/>
+              </a:ext>
+            </a:extLst>
+          </p:cNvPr>
+          <p:cNvSpPr>
+            <a:spLocks xmlns:a="http://schemas.openxmlformats.org/drawingml/2006/main" noGrp="1"/>
+          </p:cNvSpPr>
+          <p:nvPr/>
+        </p:nvSpPr>
+        <p:spPr>
+          <a:xfrm xmlns:a="http://schemas.openxmlformats.org/drawingml/2006/main">
+            <a:off x="4686300" y="2457450"/>
+            <a:ext cx="6705600" cy="552450"/>
+          </a:xfrm>
+          <a:prstGeom xmlns:a="http://schemas.openxmlformats.org/drawingml/2006/main" prst="rect">
+            <a:avLst/>
+          </a:prstGeom>
+          <a:solidFill xmlns:a="http://schemas.openxmlformats.org/drawingml/2006/main">
+            <a:srgbClr val="151F34"/>
+          </a:solidFill>
+          <a:ln xmlns:a="http://schemas.openxmlformats.org/drawingml/2006/main" w="9525">
+            <a:solidFill>
+              <a:srgbClr val="2F3B55"/>
+            </a:solidFill>
+            <a:prstDash val="solid"/>
+          </a:ln>
+        </p:spPr>
+      </p:sp>
+      <p:sp>
+        <p:nvSpPr>
+          <p:cNvPr id="31" name="decision-item-1">
+            <a:extLst xmlns:a="http://schemas.openxmlformats.org/drawingml/2006/main">
+              <a:ext uri="{FF2B5EF4-FFF2-40B4-BE49-F238E27FC236}">
+                <a16:creationId xmlns:a16="http://schemas.microsoft.com/office/drawing/2014/main" id="{93AF291A-E5D6-4568-B24F-32EE68EDC51D}"/>
+              </a:ext>
+            </a:extLst>
+          </p:cNvPr>
+          <p:cNvSpPr>
+            <a:spLocks xmlns:a="http://schemas.openxmlformats.org/drawingml/2006/main" noGrp="1"/>
+          </p:cNvSpPr>
+          <p:nvPr/>
+        </p:nvSpPr>
+        <p:spPr>
+          <a:xfrm xmlns:a="http://schemas.openxmlformats.org/drawingml/2006/main">
+            <a:off x="4933950" y="2619375"/>
+            <a:ext cx="1809750" cy="228600"/>
+          </a:xfrm>
+          <a:prstGeom xmlns:a="http://schemas.openxmlformats.org/drawingml/2006/main" prst="rect">
+            <a:avLst/>
+          </a:prstGeom>
+          <a:noFill xmlns:a="http://schemas.openxmlformats.org/drawingml/2006/main"/>
+          <a:ln xmlns:a="http://schemas.openxmlformats.org/drawingml/2006/main" w="0">
+            <a:noFill/>
+            <a:prstDash val="solid"/>
+          </a:ln>
+        </p:spPr>
+        <p:txBody>
+          <a:bodyPr xmlns:a="http://schemas.openxmlformats.org/drawingml/2006/main"/>
+          <a:lstStyle xmlns:a="http://schemas.openxmlformats.org/drawingml/2006/main"/>
+          <a:p xmlns:a="http://schemas.openxmlformats.org/drawingml/2006/main">
+            <a:pPr>
+              <a:defRPr sz="1125" b="1">
+                <a:solidFill>
+                  <a:srgbClr val="00B8D9"/>
+                </a:solidFill>
+              </a:defRPr>
+            </a:pPr>
+            <a:r>
+              <a:rPr sz="1125" b="1">
+                <a:solidFill>
+                  <a:srgbClr val="00B8D9"/>
+                </a:solidFill>
+              </a:rPr>
+              <a:t>서비스 범위</a:t>
+            </a:r>
+          </a:p>
+        </p:txBody>
+      </p:sp>
+      <p:sp>
+        <p:nvSpPr>
+          <p:cNvPr id="32" name="decision-gate-1">
+            <a:extLst xmlns:a="http://schemas.openxmlformats.org/drawingml/2006/main">
+              <a:ext uri="{FF2B5EF4-FFF2-40B4-BE49-F238E27FC236}">
+                <a16:creationId xmlns:a16="http://schemas.microsoft.com/office/drawing/2014/main" id="{F0A265BB-77A5-4636-AE83-9CC6FF767A5F}"/>
+              </a:ext>
+            </a:extLst>
+          </p:cNvPr>
+          <p:cNvSpPr>
+            <a:spLocks xmlns:a="http://schemas.openxmlformats.org/drawingml/2006/main" noGrp="1"/>
+          </p:cNvSpPr>
+          <p:nvPr/>
+        </p:nvSpPr>
+        <p:spPr>
+          <a:xfrm xmlns:a="http://schemas.openxmlformats.org/drawingml/2006/main">
+            <a:off x="6934200" y="2581275"/>
+            <a:ext cx="2857500" cy="285750"/>
+          </a:xfrm>
+          <a:prstGeom xmlns:a="http://schemas.openxmlformats.org/drawingml/2006/main" prst="rect">
+            <a:avLst/>
+          </a:prstGeom>
+          <a:noFill xmlns:a="http://schemas.openxmlformats.org/drawingml/2006/main"/>
+          <a:ln xmlns:a="http://schemas.openxmlformats.org/drawingml/2006/main" w="0">
+            <a:noFill/>
+            <a:prstDash val="solid"/>
+          </a:ln>
+        </p:spPr>
+        <p:txBody>
+          <a:bodyPr xmlns:a="http://schemas.openxmlformats.org/drawingml/2006/main"/>
+          <a:lstStyle xmlns:a="http://schemas.openxmlformats.org/drawingml/2006/main"/>
+          <a:p xmlns:a="http://schemas.openxmlformats.org/drawingml/2006/main">
+            <a:pPr>
+              <a:defRPr sz="1050">
+                <a:solidFill>
+                  <a:srgbClr val="FFFFFF"/>
+                </a:solidFill>
+              </a:defRPr>
+            </a:pPr>
+            <a:r>
+              <a:rPr sz="1050">
+                <a:solidFill>
+                  <a:srgbClr val="FFFFFF"/>
+                </a:solidFill>
+              </a:rPr>
+              <a:t>런칭 포함·제외 콘텐츠와 변경 승인 기준 확정</a:t>
+            </a:r>
+          </a:p>
+        </p:txBody>
+      </p:sp>
+      <p:sp>
+        <p:nvSpPr>
+          <p:cNvPr id="33" name="decision-owner-1">
+            <a:extLst xmlns:a="http://schemas.openxmlformats.org/drawingml/2006/main">
+              <a:ext uri="{FF2B5EF4-FFF2-40B4-BE49-F238E27FC236}">
+                <a16:creationId xmlns:a16="http://schemas.microsoft.com/office/drawing/2014/main" id="{DB90D8E3-911E-42ED-B905-1D757A23A4AA}"/>
+              </a:ext>
+            </a:extLst>
+          </p:cNvPr>
+          <p:cNvSpPr>
+            <a:spLocks xmlns:a="http://schemas.openxmlformats.org/drawingml/2006/main" noGrp="1"/>
+          </p:cNvSpPr>
+          <p:nvPr/>
+        </p:nvSpPr>
+        <p:spPr>
+          <a:xfrm xmlns:a="http://schemas.openxmlformats.org/drawingml/2006/main">
+            <a:off x="10058400" y="2619375"/>
+            <a:ext cx="933450" cy="228600"/>
+          </a:xfrm>
+          <a:prstGeom xmlns:a="http://schemas.openxmlformats.org/drawingml/2006/main" prst="rect">
+            <a:avLst/>
+          </a:prstGeom>
+          <a:noFill xmlns:a="http://schemas.openxmlformats.org/drawingml/2006/main"/>
+          <a:ln xmlns:a="http://schemas.openxmlformats.org/drawingml/2006/main" w="0">
+            <a:noFill/>
+            <a:prstDash val="solid"/>
+          </a:ln>
+        </p:spPr>
+        <p:txBody>
+          <a:bodyPr xmlns:a="http://schemas.openxmlformats.org/drawingml/2006/main"/>
+          <a:lstStyle xmlns:a="http://schemas.openxmlformats.org/drawingml/2006/main"/>
+          <a:p xmlns:a="http://schemas.openxmlformats.org/drawingml/2006/main">
+            <a:pPr algn="ctr">
+              <a:defRPr sz="1050" b="1">
+                <a:solidFill>
+                  <a:srgbClr val="CBD5E1"/>
+                </a:solidFill>
+              </a:defRPr>
+            </a:pPr>
+            <a:r>
+              <a:rPr sz="1050" b="1">
+                <a:solidFill>
+                  <a:srgbClr val="CBD5E1"/>
+                </a:solidFill>
+              </a:rPr>
+              <a:t>PM</a:t>
+            </a:r>
+          </a:p>
+        </p:txBody>
+      </p:sp>
+      <p:sp>
+        <p:nvSpPr>
+          <p:cNvPr id="34" name="decision-row-2">
+            <a:extLst xmlns:a="http://schemas.openxmlformats.org/drawingml/2006/main">
+              <a:ext uri="{FF2B5EF4-FFF2-40B4-BE49-F238E27FC236}">
+                <a16:creationId xmlns:a16="http://schemas.microsoft.com/office/drawing/2014/main" id="{DA00C44D-5B34-446A-B3AE-29F6B3F684D2}"/>
+              </a:ext>
+            </a:extLst>
+          </p:cNvPr>
+          <p:cNvSpPr>
+            <a:spLocks xmlns:a="http://schemas.openxmlformats.org/drawingml/2006/main" noGrp="1"/>
+          </p:cNvSpPr>
+          <p:nvPr/>
+        </p:nvSpPr>
+        <p:spPr>
+          <a:xfrm xmlns:a="http://schemas.openxmlformats.org/drawingml/2006/main">
+            <a:off x="4686300" y="3009900"/>
+            <a:ext cx="6705600" cy="552450"/>
+          </a:xfrm>
+          <a:prstGeom xmlns:a="http://schemas.openxmlformats.org/drawingml/2006/main" prst="rect">
+            <a:avLst/>
+          </a:prstGeom>
+          <a:solidFill xmlns:a="http://schemas.openxmlformats.org/drawingml/2006/main">
+            <a:srgbClr val="111827"/>
+          </a:solidFill>
+          <a:ln xmlns:a="http://schemas.openxmlformats.org/drawingml/2006/main" w="9525">
+            <a:solidFill>
+              <a:srgbClr val="2F3B55"/>
+            </a:solidFill>
+            <a:prstDash val="solid"/>
+          </a:ln>
+        </p:spPr>
+      </p:sp>
+      <p:sp>
+        <p:nvSpPr>
+          <p:cNvPr id="35" name="decision-item-2">
+            <a:extLst xmlns:a="http://schemas.openxmlformats.org/drawingml/2006/main">
+              <a:ext uri="{FF2B5EF4-FFF2-40B4-BE49-F238E27FC236}">
+                <a16:creationId xmlns:a16="http://schemas.microsoft.com/office/drawing/2014/main" id="{E3760915-D434-4E8B-AEAE-A1E1D56F976E}"/>
+              </a:ext>
+            </a:extLst>
+          </p:cNvPr>
+          <p:cNvSpPr>
+            <a:spLocks xmlns:a="http://schemas.openxmlformats.org/drawingml/2006/main" noGrp="1"/>
+          </p:cNvSpPr>
+          <p:nvPr/>
+        </p:nvSpPr>
+        <p:spPr>
+          <a:xfrm xmlns:a="http://schemas.openxmlformats.org/drawingml/2006/main">
+            <a:off x="4933950" y="3171825"/>
+            <a:ext cx="1809750" cy="228600"/>
+          </a:xfrm>
+          <a:prstGeom xmlns:a="http://schemas.openxmlformats.org/drawingml/2006/main" prst="rect">
+            <a:avLst/>
+          </a:prstGeom>
+          <a:noFill xmlns:a="http://schemas.openxmlformats.org/drawingml/2006/main"/>
+          <a:ln xmlns:a="http://schemas.openxmlformats.org/drawingml/2006/main" w="0">
+            <a:noFill/>
+            <a:prstDash val="solid"/>
+          </a:ln>
+        </p:spPr>
+        <p:txBody>
+          <a:bodyPr xmlns:a="http://schemas.openxmlformats.org/drawingml/2006/main"/>
+          <a:lstStyle xmlns:a="http://schemas.openxmlformats.org/drawingml/2006/main"/>
+          <a:p xmlns:a="http://schemas.openxmlformats.org/drawingml/2006/main">
+            <a:pPr>
+              <a:defRPr sz="1125" b="1">
+                <a:solidFill>
+                  <a:srgbClr val="FF6B35"/>
+                </a:solidFill>
+              </a:defRPr>
+            </a:pPr>
+            <a:r>
+              <a:rPr sz="1125" b="1">
+                <a:solidFill>
+                  <a:srgbClr val="FF6B35"/>
+                </a:solidFill>
+              </a:rPr>
+              <a:t>빌드 기준</a:t>
+            </a:r>
+          </a:p>
+        </p:txBody>
+      </p:sp>
+      <p:sp>
+        <p:nvSpPr>
+          <p:cNvPr id="36" name="decision-gate-2">
+            <a:extLst xmlns:a="http://schemas.openxmlformats.org/drawingml/2006/main">
+              <a:ext uri="{FF2B5EF4-FFF2-40B4-BE49-F238E27FC236}">
+                <a16:creationId xmlns:a16="http://schemas.microsoft.com/office/drawing/2014/main" id="{81E81F00-9AF0-43DB-9D93-F1215693AD5A}"/>
+              </a:ext>
+            </a:extLst>
+          </p:cNvPr>
+          <p:cNvSpPr>
+            <a:spLocks xmlns:a="http://schemas.openxmlformats.org/drawingml/2006/main" noGrp="1"/>
+          </p:cNvSpPr>
+          <p:nvPr/>
+        </p:nvSpPr>
+        <p:spPr>
+          <a:xfrm xmlns:a="http://schemas.openxmlformats.org/drawingml/2006/main">
+            <a:off x="6934200" y="3133725"/>
+            <a:ext cx="2857500" cy="285750"/>
+          </a:xfrm>
+          <a:prstGeom xmlns:a="http://schemas.openxmlformats.org/drawingml/2006/main" prst="rect">
+            <a:avLst/>
+          </a:prstGeom>
+          <a:noFill xmlns:a="http://schemas.openxmlformats.org/drawingml/2006/main"/>
+          <a:ln xmlns:a="http://schemas.openxmlformats.org/drawingml/2006/main" w="0">
+            <a:noFill/>
+            <a:prstDash val="solid"/>
+          </a:ln>
+        </p:spPr>
+        <p:txBody>
+          <a:bodyPr xmlns:a="http://schemas.openxmlformats.org/drawingml/2006/main"/>
+          <a:lstStyle xmlns:a="http://schemas.openxmlformats.org/drawingml/2006/main"/>
+          <a:p xmlns:a="http://schemas.openxmlformats.org/drawingml/2006/main">
+            <a:pPr>
+              <a:defRPr sz="1050">
+                <a:solidFill>
+                  <a:srgbClr val="FFFFFF"/>
+                </a:solidFill>
+              </a:defRPr>
+            </a:pPr>
+            <a:r>
+              <a:rPr sz="1050">
+                <a:solidFill>
+                  <a:srgbClr val="FFFFFF"/>
+                </a:solidFill>
+              </a:rPr>
+              <a:t>Perforce 브랜치와 후보 빌드 태그 운영 기준 합의</a:t>
+            </a:r>
+          </a:p>
+        </p:txBody>
+      </p:sp>
+      <p:sp>
+        <p:nvSpPr>
+          <p:cNvPr id="37" name="decision-owner-2">
+            <a:extLst xmlns:a="http://schemas.openxmlformats.org/drawingml/2006/main">
+              <a:ext uri="{FF2B5EF4-FFF2-40B4-BE49-F238E27FC236}">
+                <a16:creationId xmlns:a16="http://schemas.microsoft.com/office/drawing/2014/main" id="{DA9AC35A-733C-4589-8D2E-A846E6E651D9}"/>
+              </a:ext>
+            </a:extLst>
+          </p:cNvPr>
+          <p:cNvSpPr>
+            <a:spLocks xmlns:a="http://schemas.openxmlformats.org/drawingml/2006/main" noGrp="1"/>
+          </p:cNvSpPr>
+          <p:nvPr/>
+        </p:nvSpPr>
+        <p:spPr>
+          <a:xfrm xmlns:a="http://schemas.openxmlformats.org/drawingml/2006/main">
+            <a:off x="10058400" y="3171825"/>
+            <a:ext cx="933450" cy="228600"/>
+          </a:xfrm>
+          <a:prstGeom xmlns:a="http://schemas.openxmlformats.org/drawingml/2006/main" prst="rect">
+            <a:avLst/>
+          </a:prstGeom>
+          <a:noFill xmlns:a="http://schemas.openxmlformats.org/drawingml/2006/main"/>
+          <a:ln xmlns:a="http://schemas.openxmlformats.org/drawingml/2006/main" w="0">
+            <a:noFill/>
+            <a:prstDash val="solid"/>
+          </a:ln>
+        </p:spPr>
+        <p:txBody>
+          <a:bodyPr xmlns:a="http://schemas.openxmlformats.org/drawingml/2006/main"/>
+          <a:lstStyle xmlns:a="http://schemas.openxmlformats.org/drawingml/2006/main"/>
+          <a:p xmlns:a="http://schemas.openxmlformats.org/drawingml/2006/main">
+            <a:pPr algn="ctr">
+              <a:defRPr sz="1050" b="1">
+                <a:solidFill>
+                  <a:srgbClr val="CBD5E1"/>
+                </a:solidFill>
+              </a:defRPr>
+            </a:pPr>
+            <a:r>
+              <a:rPr sz="1050" b="1">
+                <a:solidFill>
+                  <a:srgbClr val="CBD5E1"/>
+                </a:solidFill>
+              </a:rPr>
+              <a:t>개발</a:t>
+            </a:r>
+          </a:p>
+        </p:txBody>
+      </p:sp>
+      <p:sp>
+        <p:nvSpPr>
+          <p:cNvPr id="38" name="decision-row-3">
+            <a:extLst xmlns:a="http://schemas.openxmlformats.org/drawingml/2006/main">
+              <a:ext uri="{FF2B5EF4-FFF2-40B4-BE49-F238E27FC236}">
+                <a16:creationId xmlns:a16="http://schemas.microsoft.com/office/drawing/2014/main" id="{5487862A-C0BE-4868-B70E-AFBCFC8549E3}"/>
+              </a:ext>
+            </a:extLst>
+          </p:cNvPr>
+          <p:cNvSpPr>
+            <a:spLocks xmlns:a="http://schemas.openxmlformats.org/drawingml/2006/main" noGrp="1"/>
+          </p:cNvSpPr>
+          <p:nvPr/>
+        </p:nvSpPr>
+        <p:spPr>
+          <a:xfrm xmlns:a="http://schemas.openxmlformats.org/drawingml/2006/main">
+            <a:off x="4686300" y="3562350"/>
+            <a:ext cx="6705600" cy="552450"/>
+          </a:xfrm>
+          <a:prstGeom xmlns:a="http://schemas.openxmlformats.org/drawingml/2006/main" prst="rect">
+            <a:avLst/>
+          </a:prstGeom>
+          <a:solidFill xmlns:a="http://schemas.openxmlformats.org/drawingml/2006/main">
+            <a:srgbClr val="151F34"/>
+          </a:solidFill>
+          <a:ln xmlns:a="http://schemas.openxmlformats.org/drawingml/2006/main" w="9525">
+            <a:solidFill>
+              <a:srgbClr val="2F3B55"/>
+            </a:solidFill>
+            <a:prstDash val="solid"/>
+          </a:ln>
+        </p:spPr>
+      </p:sp>
+      <p:sp>
+        <p:nvSpPr>
+          <p:cNvPr id="39" name="decision-item-3">
+            <a:extLst xmlns:a="http://schemas.openxmlformats.org/drawingml/2006/main">
+              <a:ext uri="{FF2B5EF4-FFF2-40B4-BE49-F238E27FC236}">
+                <a16:creationId xmlns:a16="http://schemas.microsoft.com/office/drawing/2014/main" id="{FDFE9D2A-B567-4244-BC99-56FB30F512A5}"/>
+              </a:ext>
+            </a:extLst>
+          </p:cNvPr>
+          <p:cNvSpPr>
+            <a:spLocks xmlns:a="http://schemas.openxmlformats.org/drawingml/2006/main" noGrp="1"/>
+          </p:cNvSpPr>
+          <p:nvPr/>
+        </p:nvSpPr>
+        <p:spPr>
+          <a:xfrm xmlns:a="http://schemas.openxmlformats.org/drawingml/2006/main">
+            <a:off x="4933950" y="3724275"/>
+            <a:ext cx="1809750" cy="228600"/>
+          </a:xfrm>
+          <a:prstGeom xmlns:a="http://schemas.openxmlformats.org/drawingml/2006/main" prst="rect">
+            <a:avLst/>
+          </a:prstGeom>
+          <a:noFill xmlns:a="http://schemas.openxmlformats.org/drawingml/2006/main"/>
+          <a:ln xmlns:a="http://schemas.openxmlformats.org/drawingml/2006/main" w="0">
+            <a:noFill/>
+            <a:prstDash val="solid"/>
+          </a:ln>
+        </p:spPr>
+        <p:txBody>
+          <a:bodyPr xmlns:a="http://schemas.openxmlformats.org/drawingml/2006/main"/>
+          <a:lstStyle xmlns:a="http://schemas.openxmlformats.org/drawingml/2006/main"/>
+          <a:p xmlns:a="http://schemas.openxmlformats.org/drawingml/2006/main">
+            <a:pPr>
+              <a:defRPr sz="1125" b="1">
+                <a:solidFill>
+                  <a:srgbClr val="7C3AED"/>
+                </a:solidFill>
+              </a:defRPr>
+            </a:pPr>
+            <a:r>
+              <a:rPr sz="1125" b="1">
+                <a:solidFill>
+                  <a:srgbClr val="7C3AED"/>
+                </a:solidFill>
+              </a:rPr>
+              <a:t>QA 안정성</a:t>
+            </a:r>
+          </a:p>
+        </p:txBody>
+      </p:sp>
+      <p:sp>
+        <p:nvSpPr>
+          <p:cNvPr id="40" name="decision-gate-3">
+            <a:extLst xmlns:a="http://schemas.openxmlformats.org/drawingml/2006/main">
+              <a:ext uri="{FF2B5EF4-FFF2-40B4-BE49-F238E27FC236}">
+                <a16:creationId xmlns:a16="http://schemas.microsoft.com/office/drawing/2014/main" id="{C30CBF68-52F3-422D-8E49-F3D8A1CD4407}"/>
+              </a:ext>
+            </a:extLst>
+          </p:cNvPr>
+          <p:cNvSpPr>
+            <a:spLocks xmlns:a="http://schemas.openxmlformats.org/drawingml/2006/main" noGrp="1"/>
+          </p:cNvSpPr>
+          <p:nvPr/>
+        </p:nvSpPr>
+        <p:spPr>
+          <a:xfrm xmlns:a="http://schemas.openxmlformats.org/drawingml/2006/main">
+            <a:off x="6934200" y="3686175"/>
+            <a:ext cx="2857500" cy="285750"/>
+          </a:xfrm>
+          <a:prstGeom xmlns:a="http://schemas.openxmlformats.org/drawingml/2006/main" prst="rect">
+            <a:avLst/>
+          </a:prstGeom>
+          <a:noFill xmlns:a="http://schemas.openxmlformats.org/drawingml/2006/main"/>
+          <a:ln xmlns:a="http://schemas.openxmlformats.org/drawingml/2006/main" w="0">
+            <a:noFill/>
+            <a:prstDash val="solid"/>
+          </a:ln>
+        </p:spPr>
+        <p:txBody>
+          <a:bodyPr xmlns:a="http://schemas.openxmlformats.org/drawingml/2006/main"/>
+          <a:lstStyle xmlns:a="http://schemas.openxmlformats.org/drawingml/2006/main"/>
+          <a:p xmlns:a="http://schemas.openxmlformats.org/drawingml/2006/main">
+            <a:pPr>
+              <a:defRPr sz="1050">
+                <a:solidFill>
+                  <a:srgbClr val="FFFFFF"/>
+                </a:solidFill>
+              </a:defRPr>
+            </a:pPr>
+            <a:r>
+              <a:rPr sz="1050">
+                <a:solidFill>
+                  <a:srgbClr val="FFFFFF"/>
+                </a:solidFill>
+              </a:rPr>
+              <a:t>치명 이슈 0건, 주요 이슈 수정 계획과 잔여 리스크 공유</a:t>
+            </a:r>
+          </a:p>
+        </p:txBody>
+      </p:sp>
+      <p:sp>
+        <p:nvSpPr>
+          <p:cNvPr id="41" name="decision-owner-3">
+            <a:extLst xmlns:a="http://schemas.openxmlformats.org/drawingml/2006/main">
+              <a:ext uri="{FF2B5EF4-FFF2-40B4-BE49-F238E27FC236}">
+                <a16:creationId xmlns:a16="http://schemas.microsoft.com/office/drawing/2014/main" id="{CC23460F-80F8-4D1A-B797-3E178C412CFC}"/>
+              </a:ext>
+            </a:extLst>
+          </p:cNvPr>
+          <p:cNvSpPr>
+            <a:spLocks xmlns:a="http://schemas.openxmlformats.org/drawingml/2006/main" noGrp="1"/>
+          </p:cNvSpPr>
+          <p:nvPr/>
+        </p:nvSpPr>
+        <p:spPr>
+          <a:xfrm xmlns:a="http://schemas.openxmlformats.org/drawingml/2006/main">
+            <a:off x="10058400" y="3724275"/>
+            <a:ext cx="933450" cy="228600"/>
+          </a:xfrm>
+          <a:prstGeom xmlns:a="http://schemas.openxmlformats.org/drawingml/2006/main" prst="rect">
+            <a:avLst/>
+          </a:prstGeom>
+          <a:noFill xmlns:a="http://schemas.openxmlformats.org/drawingml/2006/main"/>
+          <a:ln xmlns:a="http://schemas.openxmlformats.org/drawingml/2006/main" w="0">
+            <a:noFill/>
+            <a:prstDash val="solid"/>
+          </a:ln>
+        </p:spPr>
+        <p:txBody>
+          <a:bodyPr xmlns:a="http://schemas.openxmlformats.org/drawingml/2006/main"/>
+          <a:lstStyle xmlns:a="http://schemas.openxmlformats.org/drawingml/2006/main"/>
+          <a:p xmlns:a="http://schemas.openxmlformats.org/drawingml/2006/main">
+            <a:pPr algn="ctr">
+              <a:defRPr sz="1050" b="1">
+                <a:solidFill>
+                  <a:srgbClr val="CBD5E1"/>
+                </a:solidFill>
+              </a:defRPr>
+            </a:pPr>
+            <a:r>
+              <a:rPr sz="1050" b="1">
+                <a:solidFill>
+                  <a:srgbClr val="CBD5E1"/>
+                </a:solidFill>
+              </a:rPr>
+              <a:t>QA</a:t>
+            </a:r>
+          </a:p>
+        </p:txBody>
+      </p:sp>
+      <p:sp>
+        <p:nvSpPr>
+          <p:cNvPr id="42" name="decision-row-4">
+            <a:extLst xmlns:a="http://schemas.openxmlformats.org/drawingml/2006/main">
+              <a:ext uri="{FF2B5EF4-FFF2-40B4-BE49-F238E27FC236}">
+                <a16:creationId xmlns:a16="http://schemas.microsoft.com/office/drawing/2014/main" id="{8511F758-BA17-42B9-94C8-1A04FCC2E5EE}"/>
+              </a:ext>
+            </a:extLst>
+          </p:cNvPr>
+          <p:cNvSpPr>
+            <a:spLocks xmlns:a="http://schemas.openxmlformats.org/drawingml/2006/main" noGrp="1"/>
+          </p:cNvSpPr>
+          <p:nvPr/>
+        </p:nvSpPr>
+        <p:spPr>
+          <a:xfrm xmlns:a="http://schemas.openxmlformats.org/drawingml/2006/main">
+            <a:off x="4686300" y="4114800"/>
+            <a:ext cx="6705600" cy="552450"/>
+          </a:xfrm>
+          <a:prstGeom xmlns:a="http://schemas.openxmlformats.org/drawingml/2006/main" prst="rect">
+            <a:avLst/>
+          </a:prstGeom>
+          <a:solidFill xmlns:a="http://schemas.openxmlformats.org/drawingml/2006/main">
+            <a:srgbClr val="111827"/>
+          </a:solidFill>
+          <a:ln xmlns:a="http://schemas.openxmlformats.org/drawingml/2006/main" w="9525">
+            <a:solidFill>
+              <a:srgbClr val="2F3B55"/>
+            </a:solidFill>
+            <a:prstDash val="solid"/>
+          </a:ln>
+        </p:spPr>
+      </p:sp>
+      <p:sp>
+        <p:nvSpPr>
+          <p:cNvPr id="43" name="decision-item-4">
+            <a:extLst xmlns:a="http://schemas.openxmlformats.org/drawingml/2006/main">
+              <a:ext uri="{FF2B5EF4-FFF2-40B4-BE49-F238E27FC236}">
+                <a16:creationId xmlns:a16="http://schemas.microsoft.com/office/drawing/2014/main" id="{F14DECFC-7F8D-45E6-B5EC-7ED25711BC91}"/>
+              </a:ext>
+            </a:extLst>
+          </p:cNvPr>
+          <p:cNvSpPr>
+            <a:spLocks xmlns:a="http://schemas.openxmlformats.org/drawingml/2006/main" noGrp="1"/>
+          </p:cNvSpPr>
+          <p:nvPr/>
+        </p:nvSpPr>
+        <p:spPr>
+          <a:xfrm xmlns:a="http://schemas.openxmlformats.org/drawingml/2006/main">
+            <a:off x="4933950" y="4276725"/>
+            <a:ext cx="1809750" cy="228600"/>
+          </a:xfrm>
+          <a:prstGeom xmlns:a="http://schemas.openxmlformats.org/drawingml/2006/main" prst="rect">
+            <a:avLst/>
+          </a:prstGeom>
+          <a:noFill xmlns:a="http://schemas.openxmlformats.org/drawingml/2006/main"/>
+          <a:ln xmlns:a="http://schemas.openxmlformats.org/drawingml/2006/main" w="0">
+            <a:noFill/>
+            <a:prstDash val="solid"/>
+          </a:ln>
+        </p:spPr>
+        <p:txBody>
+          <a:bodyPr xmlns:a="http://schemas.openxmlformats.org/drawingml/2006/main"/>
+          <a:lstStyle xmlns:a="http://schemas.openxmlformats.org/drawingml/2006/main"/>
+          <a:p xmlns:a="http://schemas.openxmlformats.org/drawingml/2006/main">
+            <a:pPr>
+              <a:defRPr sz="1125" b="1">
+                <a:solidFill>
+                  <a:srgbClr val="8BD9E8"/>
+                </a:solidFill>
+              </a:defRPr>
+            </a:pPr>
+            <a:r>
+              <a:rPr sz="1125" b="1">
+                <a:solidFill>
+                  <a:srgbClr val="8BD9E8"/>
+                </a:solidFill>
+              </a:rPr>
+              <a:t>퍼블리셔 검수</a:t>
+            </a:r>
+          </a:p>
+        </p:txBody>
+      </p:sp>
+      <p:sp>
+        <p:nvSpPr>
+          <p:cNvPr id="44" name="decision-gate-4">
+            <a:extLst xmlns:a="http://schemas.openxmlformats.org/drawingml/2006/main">
+              <a:ext uri="{FF2B5EF4-FFF2-40B4-BE49-F238E27FC236}">
+                <a16:creationId xmlns:a16="http://schemas.microsoft.com/office/drawing/2014/main" id="{D1E17F3F-64A1-4AA5-B441-DFCF0531A7F7}"/>
+              </a:ext>
+            </a:extLst>
+          </p:cNvPr>
+          <p:cNvSpPr>
+            <a:spLocks xmlns:a="http://schemas.openxmlformats.org/drawingml/2006/main" noGrp="1"/>
+          </p:cNvSpPr>
+          <p:nvPr/>
+        </p:nvSpPr>
+        <p:spPr>
+          <a:xfrm xmlns:a="http://schemas.openxmlformats.org/drawingml/2006/main">
+            <a:off x="6934200" y="4238625"/>
+            <a:ext cx="2857500" cy="285750"/>
+          </a:xfrm>
+          <a:prstGeom xmlns:a="http://schemas.openxmlformats.org/drawingml/2006/main" prst="rect">
+            <a:avLst/>
+          </a:prstGeom>
+          <a:noFill xmlns:a="http://schemas.openxmlformats.org/drawingml/2006/main"/>
+          <a:ln xmlns:a="http://schemas.openxmlformats.org/drawingml/2006/main" w="0">
+            <a:noFill/>
+            <a:prstDash val="solid"/>
+          </a:ln>
+        </p:spPr>
+        <p:txBody>
+          <a:bodyPr xmlns:a="http://schemas.openxmlformats.org/drawingml/2006/main"/>
+          <a:lstStyle xmlns:a="http://schemas.openxmlformats.org/drawingml/2006/main"/>
+          <a:p xmlns:a="http://schemas.openxmlformats.org/drawingml/2006/main">
+            <a:pPr>
+              <a:defRPr sz="1050">
+                <a:solidFill>
+                  <a:srgbClr val="FFFFFF"/>
+                </a:solidFill>
+              </a:defRPr>
+            </a:pPr>
+            <a:r>
+              <a:rPr sz="1050">
+                <a:solidFill>
+                  <a:srgbClr val="FFFFFF"/>
+                </a:solidFill>
+              </a:rPr>
+              <a:t>검수 요청, 피드백, 재전달 일정이 추적 가능한 상태</a:t>
+            </a:r>
+          </a:p>
+        </p:txBody>
+      </p:sp>
+      <p:sp>
+        <p:nvSpPr>
+          <p:cNvPr id="45" name="decision-owner-4">
+            <a:extLst xmlns:a="http://schemas.openxmlformats.org/drawingml/2006/main">
+              <a:ext uri="{FF2B5EF4-FFF2-40B4-BE49-F238E27FC236}">
+                <a16:creationId xmlns:a16="http://schemas.microsoft.com/office/drawing/2014/main" id="{BB4C2B74-D2E3-47A1-8209-696E666A33A1}"/>
+              </a:ext>
+            </a:extLst>
+          </p:cNvPr>
+          <p:cNvSpPr>
+            <a:spLocks xmlns:a="http://schemas.openxmlformats.org/drawingml/2006/main" noGrp="1"/>
+          </p:cNvSpPr>
+          <p:nvPr/>
+        </p:nvSpPr>
+        <p:spPr>
+          <a:xfrm xmlns:a="http://schemas.openxmlformats.org/drawingml/2006/main">
+            <a:off x="10058400" y="4276725"/>
+            <a:ext cx="933450" cy="228600"/>
+          </a:xfrm>
+          <a:prstGeom xmlns:a="http://schemas.openxmlformats.org/drawingml/2006/main" prst="rect">
+            <a:avLst/>
+          </a:prstGeom>
+          <a:noFill xmlns:a="http://schemas.openxmlformats.org/drawingml/2006/main"/>
+          <a:ln xmlns:a="http://schemas.openxmlformats.org/drawingml/2006/main" w="0">
+            <a:noFill/>
+            <a:prstDash val="solid"/>
+          </a:ln>
+        </p:spPr>
+        <p:txBody>
+          <a:bodyPr xmlns:a="http://schemas.openxmlformats.org/drawingml/2006/main"/>
+          <a:lstStyle xmlns:a="http://schemas.openxmlformats.org/drawingml/2006/main"/>
+          <a:p xmlns:a="http://schemas.openxmlformats.org/drawingml/2006/main">
+            <a:pPr algn="ctr">
+              <a:defRPr sz="1050" b="1">
+                <a:solidFill>
+                  <a:srgbClr val="CBD5E1"/>
+                </a:solidFill>
+              </a:defRPr>
+            </a:pPr>
+            <a:r>
+              <a:rPr sz="1050" b="1">
+                <a:solidFill>
+                  <a:srgbClr val="CBD5E1"/>
+                </a:solidFill>
+              </a:rPr>
+              <a:t>PM</a:t>
+            </a:r>
+          </a:p>
+        </p:txBody>
+      </p:sp>
+      <p:sp>
+        <p:nvSpPr>
+          <p:cNvPr id="46" name="decision-row-5">
+            <a:extLst xmlns:a="http://schemas.openxmlformats.org/drawingml/2006/main">
+              <a:ext uri="{FF2B5EF4-FFF2-40B4-BE49-F238E27FC236}">
+                <a16:creationId xmlns:a16="http://schemas.microsoft.com/office/drawing/2014/main" id="{1C8981E7-03FE-4E62-9343-8D1E3A17B4B6}"/>
+              </a:ext>
+            </a:extLst>
+          </p:cNvPr>
+          <p:cNvSpPr>
+            <a:spLocks xmlns:a="http://schemas.openxmlformats.org/drawingml/2006/main" noGrp="1"/>
+          </p:cNvSpPr>
+          <p:nvPr/>
+        </p:nvSpPr>
+        <p:spPr>
+          <a:xfrm xmlns:a="http://schemas.openxmlformats.org/drawingml/2006/main">
+            <a:off x="4686300" y="4667250"/>
+            <a:ext cx="6705600" cy="552450"/>
+          </a:xfrm>
+          <a:prstGeom xmlns:a="http://schemas.openxmlformats.org/drawingml/2006/main" prst="rect">
+            <a:avLst/>
+          </a:prstGeom>
+          <a:solidFill xmlns:a="http://schemas.openxmlformats.org/drawingml/2006/main">
+            <a:srgbClr val="151F34"/>
+          </a:solidFill>
+          <a:ln xmlns:a="http://schemas.openxmlformats.org/drawingml/2006/main" w="9525">
+            <a:solidFill>
+              <a:srgbClr val="2F3B55"/>
+            </a:solidFill>
+            <a:prstDash val="solid"/>
+          </a:ln>
+        </p:spPr>
+      </p:sp>
+      <p:sp>
+        <p:nvSpPr>
+          <p:cNvPr id="47" name="decision-item-5">
+            <a:extLst xmlns:a="http://schemas.openxmlformats.org/drawingml/2006/main">
+              <a:ext uri="{FF2B5EF4-FFF2-40B4-BE49-F238E27FC236}">
+                <a16:creationId xmlns:a16="http://schemas.microsoft.com/office/drawing/2014/main" id="{0AD55C7B-21E5-4802-A2AC-BE70FC586B63}"/>
+              </a:ext>
+            </a:extLst>
+          </p:cNvPr>
+          <p:cNvSpPr>
+            <a:spLocks xmlns:a="http://schemas.openxmlformats.org/drawingml/2006/main" noGrp="1"/>
+          </p:cNvSpPr>
+          <p:nvPr/>
+        </p:nvSpPr>
+        <p:spPr>
+          <a:xfrm xmlns:a="http://schemas.openxmlformats.org/drawingml/2006/main">
+            <a:off x="4933950" y="4829175"/>
+            <a:ext cx="1809750" cy="228600"/>
+          </a:xfrm>
+          <a:prstGeom xmlns:a="http://schemas.openxmlformats.org/drawingml/2006/main" prst="rect">
+            <a:avLst/>
+          </a:prstGeom>
+          <a:noFill xmlns:a="http://schemas.openxmlformats.org/drawingml/2006/main"/>
+          <a:ln xmlns:a="http://schemas.openxmlformats.org/drawingml/2006/main" w="0">
+            <a:noFill/>
+            <a:prstDash val="solid"/>
+          </a:ln>
+        </p:spPr>
+        <p:txBody>
+          <a:bodyPr xmlns:a="http://schemas.openxmlformats.org/drawingml/2006/main"/>
+          <a:lstStyle xmlns:a="http://schemas.openxmlformats.org/drawingml/2006/main"/>
+          <a:p xmlns:a="http://schemas.openxmlformats.org/drawingml/2006/main">
+            <a:pPr>
+              <a:defRPr sz="1125" b="1">
+                <a:solidFill>
+                  <a:srgbClr val="FF6B35"/>
+                </a:solidFill>
+              </a:defRPr>
+            </a:pPr>
+            <a:r>
+              <a:rPr sz="1125" b="1">
+                <a:solidFill>
+                  <a:srgbClr val="FF6B35"/>
+                </a:solidFill>
+              </a:rPr>
+              <a:t>배포 준비</a:t>
+            </a:r>
+          </a:p>
+        </p:txBody>
+      </p:sp>
+      <p:sp>
+        <p:nvSpPr>
+          <p:cNvPr id="48" name="decision-gate-5">
+            <a:extLst xmlns:a="http://schemas.openxmlformats.org/drawingml/2006/main">
+              <a:ext uri="{FF2B5EF4-FFF2-40B4-BE49-F238E27FC236}">
+                <a16:creationId xmlns:a16="http://schemas.microsoft.com/office/drawing/2014/main" id="{B280930C-024D-4D89-8184-525E6467912E}"/>
+              </a:ext>
+            </a:extLst>
+          </p:cNvPr>
+          <p:cNvSpPr>
+            <a:spLocks xmlns:a="http://schemas.openxmlformats.org/drawingml/2006/main" noGrp="1"/>
+          </p:cNvSpPr>
+          <p:nvPr/>
+        </p:nvSpPr>
+        <p:spPr>
+          <a:xfrm xmlns:a="http://schemas.openxmlformats.org/drawingml/2006/main">
+            <a:off x="6934200" y="4791075"/>
+            <a:ext cx="2857500" cy="285750"/>
+          </a:xfrm>
+          <a:prstGeom xmlns:a="http://schemas.openxmlformats.org/drawingml/2006/main" prst="rect">
+            <a:avLst/>
+          </a:prstGeom>
+          <a:noFill xmlns:a="http://schemas.openxmlformats.org/drawingml/2006/main"/>
+          <a:ln xmlns:a="http://schemas.openxmlformats.org/drawingml/2006/main" w="0">
+            <a:noFill/>
+            <a:prstDash val="solid"/>
+          </a:ln>
+        </p:spPr>
+        <p:txBody>
+          <a:bodyPr xmlns:a="http://schemas.openxmlformats.org/drawingml/2006/main"/>
+          <a:lstStyle xmlns:a="http://schemas.openxmlformats.org/drawingml/2006/main"/>
+          <a:p xmlns:a="http://schemas.openxmlformats.org/drawingml/2006/main">
+            <a:pPr>
+              <a:defRPr sz="1050">
+                <a:solidFill>
+                  <a:srgbClr val="FFFFFF"/>
+                </a:solidFill>
+              </a:defRPr>
+            </a:pPr>
+            <a:r>
+              <a:rPr sz="1050">
+                <a:solidFill>
+                  <a:srgbClr val="FFFFFF"/>
+                </a:solidFill>
+              </a:rPr>
+              <a:t>스토어·공지·장애 대응 플랜의 최종 담당자 확인</a:t>
+            </a:r>
+          </a:p>
+        </p:txBody>
+      </p:sp>
+      <p:sp>
+        <p:nvSpPr>
+          <p:cNvPr id="49" name="decision-owner-5">
+            <a:extLst xmlns:a="http://schemas.openxmlformats.org/drawingml/2006/main">
+              <a:ext uri="{FF2B5EF4-FFF2-40B4-BE49-F238E27FC236}">
+                <a16:creationId xmlns:a16="http://schemas.microsoft.com/office/drawing/2014/main" id="{C25E2986-0D1C-4E0E-B4A7-419E8D084F7D}"/>
+              </a:ext>
+            </a:extLst>
+          </p:cNvPr>
+          <p:cNvSpPr>
+            <a:spLocks xmlns:a="http://schemas.openxmlformats.org/drawingml/2006/main" noGrp="1"/>
+          </p:cNvSpPr>
+          <p:nvPr/>
+        </p:nvSpPr>
+        <p:spPr>
+          <a:xfrm xmlns:a="http://schemas.openxmlformats.org/drawingml/2006/main">
+            <a:off x="10058400" y="4829175"/>
+            <a:ext cx="933450" cy="228600"/>
+          </a:xfrm>
+          <a:prstGeom xmlns:a="http://schemas.openxmlformats.org/drawingml/2006/main" prst="rect">
+            <a:avLst/>
+          </a:prstGeom>
+          <a:noFill xmlns:a="http://schemas.openxmlformats.org/drawingml/2006/main"/>
+          <a:ln xmlns:a="http://schemas.openxmlformats.org/drawingml/2006/main" w="0">
+            <a:noFill/>
+            <a:prstDash val="solid"/>
+          </a:ln>
+        </p:spPr>
+        <p:txBody>
+          <a:bodyPr xmlns:a="http://schemas.openxmlformats.org/drawingml/2006/main"/>
+          <a:lstStyle xmlns:a="http://schemas.openxmlformats.org/drawingml/2006/main"/>
+          <a:p xmlns:a="http://schemas.openxmlformats.org/drawingml/2006/main">
+            <a:pPr algn="ctr">
+              <a:defRPr sz="1050" b="1">
+                <a:solidFill>
+                  <a:srgbClr val="CBD5E1"/>
+                </a:solidFill>
+              </a:defRPr>
+            </a:pPr>
+            <a:r>
+              <a:rPr sz="1050" b="1">
+                <a:solidFill>
+                  <a:srgbClr val="CBD5E1"/>
+                </a:solidFill>
+              </a:rPr>
+              <a:t>운영</a:t>
+            </a:r>
+          </a:p>
+        </p:txBody>
+      </p:sp>
+      <p:sp>
+        <p:nvSpPr>
+          <p:cNvPr id="50" name="principle-panel">
+            <a:extLst xmlns:a="http://schemas.openxmlformats.org/drawingml/2006/main">
+              <a:ext uri="{FF2B5EF4-FFF2-40B4-BE49-F238E27FC236}">
+                <a16:creationId xmlns:a16="http://schemas.microsoft.com/office/drawing/2014/main" id="{21D4491B-93B1-4BE6-90D8-AFAC6F5BA384}"/>
+              </a:ext>
+            </a:extLst>
+          </p:cNvPr>
+          <p:cNvSpPr>
+            <a:spLocks xmlns:a="http://schemas.openxmlformats.org/drawingml/2006/main" noGrp="1"/>
+          </p:cNvSpPr>
+          <p:nvPr/>
+        </p:nvSpPr>
+        <p:spPr>
+          <a:xfrm xmlns:a="http://schemas.openxmlformats.org/drawingml/2006/main">
+            <a:off x="514350" y="5791200"/>
+            <a:ext cx="10877550" cy="419100"/>
+          </a:xfrm>
+          <a:prstGeom xmlns:a="http://schemas.openxmlformats.org/drawingml/2006/main" prst="roundRect">
+            <a:avLst>
+              <a:gd name="adj" fmla="val 18182"/>
+            </a:avLst>
+          </a:prstGeom>
+          <a:solidFill xmlns:a="http://schemas.openxmlformats.org/drawingml/2006/main">
+            <a:srgbClr val="10192E"/>
+          </a:solidFill>
+          <a:ln xmlns:a="http://schemas.openxmlformats.org/drawingml/2006/main" w="9525">
+            <a:solidFill>
+              <a:srgbClr val="22304E"/>
+            </a:solidFill>
+            <a:prstDash val="solid"/>
+          </a:ln>
+        </p:spPr>
+      </p:sp>
+      <p:sp>
+        <p:nvSpPr>
+          <p:cNvPr id="51" name="principle-label">
+            <a:extLst xmlns:a="http://schemas.openxmlformats.org/drawingml/2006/main">
+              <a:ext uri="{FF2B5EF4-FFF2-40B4-BE49-F238E27FC236}">
+                <a16:creationId xmlns:a16="http://schemas.microsoft.com/office/drawing/2014/main" id="{9B217DDC-3F38-4CEF-A73A-AEEABAA14758}"/>
+              </a:ext>
+            </a:extLst>
+          </p:cNvPr>
+          <p:cNvSpPr>
+            <a:spLocks xmlns:a="http://schemas.openxmlformats.org/drawingml/2006/main" noGrp="1"/>
+          </p:cNvSpPr>
+          <p:nvPr/>
+        </p:nvSpPr>
+        <p:spPr>
+          <a:xfrm xmlns:a="http://schemas.openxmlformats.org/drawingml/2006/main">
+            <a:off x="781050" y="5905500"/>
+            <a:ext cx="1143000" cy="209550"/>
+          </a:xfrm>
+          <a:prstGeom xmlns:a="http://schemas.openxmlformats.org/drawingml/2006/main" prst="rect">
+            <a:avLst/>
+          </a:prstGeom>
+          <a:noFill xmlns:a="http://schemas.openxmlformats.org/drawingml/2006/main"/>
+          <a:ln xmlns:a="http://schemas.openxmlformats.org/drawingml/2006/main" w="0">
+            <a:noFill/>
+            <a:prstDash val="solid"/>
+          </a:ln>
+        </p:spPr>
+        <p:txBody>
+          <a:bodyPr xmlns:a="http://schemas.openxmlformats.org/drawingml/2006/main"/>
+          <a:lstStyle xmlns:a="http://schemas.openxmlformats.org/drawingml/2006/main"/>
+          <a:p xmlns:a="http://schemas.openxmlformats.org/drawingml/2006/main">
+            <a:pPr>
+              <a:defRPr sz="1200" b="1">
+                <a:solidFill>
+                  <a:srgbClr val="8BD9E8"/>
+                </a:solidFill>
+              </a:defRPr>
+            </a:pPr>
+            <a:r>
+              <a:rPr sz="1200" b="1">
+                <a:solidFill>
+                  <a:srgbClr val="8BD9E8"/>
+                </a:solidFill>
+              </a:rPr>
+              <a:t>운영 원칙</a:t>
+            </a:r>
+          </a:p>
+        </p:txBody>
+      </p:sp>
+      <p:sp>
+        <p:nvSpPr>
+          <p:cNvPr id="52" name="principle-body">
+            <a:extLst xmlns:a="http://schemas.openxmlformats.org/drawingml/2006/main">
+              <a:ext uri="{FF2B5EF4-FFF2-40B4-BE49-F238E27FC236}">
+                <a16:creationId xmlns:a16="http://schemas.microsoft.com/office/drawing/2014/main" id="{9F9B4364-8B18-44B3-A579-B65AC8A5C124}"/>
+              </a:ext>
+            </a:extLst>
+          </p:cNvPr>
+          <p:cNvSpPr>
+            <a:spLocks xmlns:a="http://schemas.openxmlformats.org/drawingml/2006/main" noGrp="1"/>
+          </p:cNvSpPr>
+          <p:nvPr/>
+        </p:nvSpPr>
+        <p:spPr>
+          <a:xfrm xmlns:a="http://schemas.openxmlformats.org/drawingml/2006/main">
+            <a:off x="1962150" y="5905500"/>
+            <a:ext cx="8096250" cy="209550"/>
+          </a:xfrm>
+          <a:prstGeom xmlns:a="http://schemas.openxmlformats.org/drawingml/2006/main" prst="rect">
+            <a:avLst/>
+          </a:prstGeom>
+          <a:noFill xmlns:a="http://schemas.openxmlformats.org/drawingml/2006/main"/>
+          <a:ln xmlns:a="http://schemas.openxmlformats.org/drawingml/2006/main" w="0">
+            <a:noFill/>
+            <a:prstDash val="solid"/>
+          </a:ln>
+        </p:spPr>
+        <p:txBody>
+          <a:bodyPr xmlns:a="http://schemas.openxmlformats.org/drawingml/2006/main"/>
+          <a:lstStyle xmlns:a="http://schemas.openxmlformats.org/drawingml/2006/main"/>
+          <a:p xmlns:a="http://schemas.openxmlformats.org/drawingml/2006/main">
+            <a:pPr>
+              <a:defRPr sz="1125">
+                <a:solidFill>
+                  <a:srgbClr val="FFFFFF"/>
+                </a:solidFill>
+              </a:defRPr>
+            </a:pPr>
+            <a:r>
+              <a:rPr sz="1125">
+                <a:solidFill>
+                  <a:srgbClr val="FFFFFF"/>
+                </a:solidFill>
+              </a:rPr>
+              <a:t>게이트 미통과 항목은 일정 지연이 아니라 의사결정 이슈로 분리해, 영향도와 대안을 함께 보고합니다.</a:t>
+            </a:r>
+          </a:p>
+        </p:txBody>
+      </p:sp>
+    </p:spTree>
+    <p:extLst>
+      <p:ext uri="{BB962C8B-B14F-4D97-AF65-F5344CB8AC3E}">
+        <p14:creationId xmlns:p14="http://schemas.microsoft.com/office/powerpoint/2010/main" val="535118993"/>
       </p:ext>
     </p:extLst>
   </p:cSld>

</xml_diff>

<commit_message>
Add risk response slide and align PM wording
</commit_message>
<xml_diff>
--- a/outputs/HIT2_일본_런칭_6개월전_로드맵_초안.pptx
+++ b/outputs/HIT2_일본_런칭_6개월전_로드맵_초안.pptx
@@ -2,15 +2,16 @@
 <file path=ppt/presentation.xml><?xml version="1.0" encoding="utf-8"?>
 <p:presentation xmlns:p="http://schemas.openxmlformats.org/presentationml/2006/main">
   <p:sldMasterIdLst>
-    <p:sldMasterId xmlns:r="http://schemas.openxmlformats.org/officeDocument/2006/relationships" id="2147483648" r:id="R7418ac167d254113"/>
+    <p:sldMasterId xmlns:r="http://schemas.openxmlformats.org/officeDocument/2006/relationships" id="2147483648" r:id="Re2abd73a81de496d"/>
   </p:sldMasterIdLst>
   <p:notesMasterIdLst>
-    <p:notesMasterId xmlns:r="http://schemas.openxmlformats.org/officeDocument/2006/relationships" r:id="R914258d389384800"/>
+    <p:notesMasterId xmlns:r="http://schemas.openxmlformats.org/officeDocument/2006/relationships" r:id="Rbbabfd3ada2b443a"/>
   </p:notesMasterIdLst>
   <p:sldIdLst>
-    <p:sldId xmlns:r="http://schemas.openxmlformats.org/officeDocument/2006/relationships" id="256" r:id="Rbf84308bdb1b4a64"/>
-    <p:sldId xmlns:r="http://schemas.openxmlformats.org/officeDocument/2006/relationships" id="257" r:id="R62c02af46f574785"/>
-    <p:sldId xmlns:r="http://schemas.openxmlformats.org/officeDocument/2006/relationships" id="258" r:id="R1e1f5645a8ae41e2"/>
+    <p:sldId xmlns:r="http://schemas.openxmlformats.org/officeDocument/2006/relationships" id="256" r:id="R024cdb1efd834df7"/>
+    <p:sldId xmlns:r="http://schemas.openxmlformats.org/officeDocument/2006/relationships" id="257" r:id="R2dc7314c8eb643cc"/>
+    <p:sldId xmlns:r="http://schemas.openxmlformats.org/officeDocument/2006/relationships" id="258" r:id="Rcc906091a5b44633"/>
+    <p:sldId xmlns:r="http://schemas.openxmlformats.org/officeDocument/2006/relationships" id="259" r:id="R02074470234f403d"/>
   </p:sldIdLst>
   <p:sldSz cx="12192000" cy="6858000"/>
   <p:notesSz cx="6858000" cy="9144000"/>
@@ -697,6 +698,72 @@
 </p:notes>
 </file>
 
+<file path=ppt/notesSlides/notesSlide4.xml><?xml version="1.0" encoding="utf-8"?>
+<p:notes xmlns:p="http://schemas.openxmlformats.org/presentationml/2006/main">
+  <p:cSld>
+    <p:spTree>
+      <p:nvGrpSpPr>
+        <p:cNvPr id="1" name=""/>
+        <p:cNvGrpSpPr/>
+        <p:nvPr/>
+      </p:nvGrpSpPr>
+      <p:grpSpPr>
+        <a:xfrm xmlns:a="http://schemas.openxmlformats.org/drawingml/2006/main"/>
+      </p:grpSpPr>
+      <p:sp>
+        <p:nvSpPr>
+          <p:cNvPr id="2" name="Slide Image Placeholder 1"/>
+          <p:cNvSpPr>
+            <a:spLocks xmlns:a="http://schemas.openxmlformats.org/drawingml/2006/main" noGrp="1"/>
+          </p:cNvSpPr>
+          <p:nvPr>
+            <p:ph type="sldImg" idx="0"/>
+          </p:nvPr>
+        </p:nvSpPr>
+        <p:spPr/>
+      </p:sp>
+      <p:sp>
+        <p:nvSpPr>
+          <p:cNvPr id="3" name="Notes Placeholder 2"/>
+          <p:cNvSpPr>
+            <a:spLocks xmlns:a="http://schemas.openxmlformats.org/drawingml/2006/main" noGrp="1"/>
+          </p:cNvSpPr>
+          <p:nvPr>
+            <p:ph type="body" idx="1"/>
+          </p:nvPr>
+        </p:nvSpPr>
+        <p:spPr/>
+        <p:txBody>
+          <a:bodyPr xmlns:a="http://schemas.openxmlformats.org/drawingml/2006/main"/>
+          <a:lstStyle xmlns:a="http://schemas.openxmlformats.org/drawingml/2006/main"/>
+          <a:p xmlns:a="http://schemas.openxmlformats.org/drawingml/2006/main"/>
+        </p:txBody>
+      </p:sp>
+      <p:sp>
+        <p:nvSpPr>
+          <p:cNvPr id="4" name="Slide Number Placeholder 3"/>
+          <p:cNvSpPr>
+            <a:spLocks xmlns:a="http://schemas.openxmlformats.org/drawingml/2006/main" noGrp="1"/>
+          </p:cNvSpPr>
+          <p:nvPr>
+            <p:ph type="sldNum" idx="5"/>
+          </p:nvPr>
+        </p:nvSpPr>
+        <p:spPr/>
+        <p:txBody>
+          <a:bodyPr xmlns:a="http://schemas.openxmlformats.org/drawingml/2006/main"/>
+          <a:lstStyle xmlns:a="http://schemas.openxmlformats.org/drawingml/2006/main"/>
+          <a:p xmlns:a="http://schemas.openxmlformats.org/drawingml/2006/main"/>
+        </p:txBody>
+      </p:sp>
+    </p:spTree>
+  </p:cSld>
+  <p:clrMapOvr>
+    <a:masterClrMapping xmlns:a="http://schemas.openxmlformats.org/drawingml/2006/main"/>
+  </p:clrMapOvr>
+</p:notes>
+</file>
+
 <file path=ppt/slideLayouts/slideLayout1.xml><?xml version="1.0" encoding="utf-8"?>
 <p:sldLayout xmlns:p="http://schemas.openxmlformats.org/presentationml/2006/main" type="title">
   <p:cSld name="Title Slide">
@@ -735,7 +802,7 @@
   </p:cSld>
   <p:clrMap bg1="lt1" tx1="dk1" bg2="lt2" tx2="dk2" accent1="accent1" accent2="accent2" accent3="accent3" accent4="accent4" accent5="accent5" accent6="accent6" hlink="hlink" folHlink="folHlink"/>
   <p:sldLayoutIdLst>
-    <p:sldLayoutId xmlns:r="http://schemas.openxmlformats.org/officeDocument/2006/relationships" id="2147483649" r:id="R520cccd694914c8d"/>
+    <p:sldLayoutId xmlns:r="http://schemas.openxmlformats.org/officeDocument/2006/relationships" id="2147483649" r:id="Re05a8c3bde804376"/>
   </p:sldLayoutIdLst>
   <p:txStyles>
     <p:titleStyle>
@@ -1286,7 +1353,7 @@
           <p:cNvPr id="1" name="top-accent">
             <a:extLst xmlns:a="http://schemas.openxmlformats.org/drawingml/2006/main">
               <a:ext uri="{FF2B5EF4-FFF2-40B4-BE49-F238E27FC236}">
-                <a16:creationId xmlns:a16="http://schemas.microsoft.com/office/drawing/2014/main" id="{915478D6-C4E2-4B02-B978-E2F4ED0B4302}"/>
+                <a16:creationId xmlns:a16="http://schemas.microsoft.com/office/drawing/2014/main" id="{EF6E871E-54F0-46E6-8632-C6221EA04BE9}"/>
               </a:ext>
             </a:extLst>
           </p:cNvPr>
@@ -1319,7 +1386,7 @@
           <p:cNvPr id="2" name="left-accent">
             <a:extLst xmlns:a="http://schemas.openxmlformats.org/drawingml/2006/main">
               <a:ext uri="{FF2B5EF4-FFF2-40B4-BE49-F238E27FC236}">
-                <a16:creationId xmlns:a16="http://schemas.microsoft.com/office/drawing/2014/main" id="{ED023C25-CB6D-456D-AE1F-3AB87497C6EE}"/>
+                <a16:creationId xmlns:a16="http://schemas.microsoft.com/office/drawing/2014/main" id="{3A14BE7F-9051-4111-8876-2915016BCA97}"/>
               </a:ext>
             </a:extLst>
           </p:cNvPr>
@@ -1352,7 +1419,7 @@
           <p:cNvPr id="3" name="eyebrow">
             <a:extLst xmlns:a="http://schemas.openxmlformats.org/drawingml/2006/main">
               <a:ext uri="{FF2B5EF4-FFF2-40B4-BE49-F238E27FC236}">
-                <a16:creationId xmlns:a16="http://schemas.microsoft.com/office/drawing/2014/main" id="{7DB9DD6E-0B1E-409D-9F47-FAD1755D8796}"/>
+                <a16:creationId xmlns:a16="http://schemas.microsoft.com/office/drawing/2014/main" id="{C32C1A1C-5FFC-41B9-A302-1295D55D94DB}"/>
               </a:ext>
             </a:extLst>
           </p:cNvPr>
@@ -1402,7 +1469,7 @@
           <p:cNvPr id="4" name="footer">
             <a:extLst xmlns:a="http://schemas.openxmlformats.org/drawingml/2006/main">
               <a:ext uri="{FF2B5EF4-FFF2-40B4-BE49-F238E27FC236}">
-                <a16:creationId xmlns:a16="http://schemas.microsoft.com/office/drawing/2014/main" id="{589EBEF4-E64A-4757-B3AA-658A0BEB716C}"/>
+                <a16:creationId xmlns:a16="http://schemas.microsoft.com/office/drawing/2014/main" id="{FD5DD82E-E3DB-4FEB-9FCB-F5EA6BE73D10}"/>
               </a:ext>
             </a:extLst>
           </p:cNvPr>
@@ -1452,7 +1519,7 @@
           <p:cNvPr id="5" name="page-no">
             <a:extLst xmlns:a="http://schemas.openxmlformats.org/drawingml/2006/main">
               <a:ext uri="{FF2B5EF4-FFF2-40B4-BE49-F238E27FC236}">
-                <a16:creationId xmlns:a16="http://schemas.microsoft.com/office/drawing/2014/main" id="{7C8D61A1-8182-427F-9A8C-3EEC5C7D58FD}"/>
+                <a16:creationId xmlns:a16="http://schemas.microsoft.com/office/drawing/2014/main" id="{CA3927E2-ED2A-4F33-A815-A4799442B53B}"/>
               </a:ext>
             </a:extLst>
           </p:cNvPr>
@@ -1502,7 +1569,7 @@
           <p:cNvPr id="6" name="hero-panel">
             <a:extLst xmlns:a="http://schemas.openxmlformats.org/drawingml/2006/main">
               <a:ext uri="{FF2B5EF4-FFF2-40B4-BE49-F238E27FC236}">
-                <a16:creationId xmlns:a16="http://schemas.microsoft.com/office/drawing/2014/main" id="{7F599A71-FE45-4C49-96E6-376333CFDEFC}"/>
+                <a16:creationId xmlns:a16="http://schemas.microsoft.com/office/drawing/2014/main" id="{B5FF9048-4163-4B0B-93C6-B38C81DB7D1D}"/>
               </a:ext>
             </a:extLst>
           </p:cNvPr>
@@ -1535,7 +1602,7 @@
           <p:cNvPr id="7" name="hero-kicker">
             <a:extLst xmlns:a="http://schemas.openxmlformats.org/drawingml/2006/main">
               <a:ext uri="{FF2B5EF4-FFF2-40B4-BE49-F238E27FC236}">
-                <a16:creationId xmlns:a16="http://schemas.microsoft.com/office/drawing/2014/main" id="{90BFCC91-B00C-485F-B5D4-0FEFE6A16920}"/>
+                <a16:creationId xmlns:a16="http://schemas.microsoft.com/office/drawing/2014/main" id="{4B3D6365-598D-4C53-A782-0DDE18628968}"/>
               </a:ext>
             </a:extLst>
           </p:cNvPr>
@@ -1585,7 +1652,7 @@
           <p:cNvPr id="8" name="hero-title">
             <a:extLst xmlns:a="http://schemas.openxmlformats.org/drawingml/2006/main">
               <a:ext uri="{FF2B5EF4-FFF2-40B4-BE49-F238E27FC236}">
-                <a16:creationId xmlns:a16="http://schemas.microsoft.com/office/drawing/2014/main" id="{1C1624C8-8DA4-42D9-B024-2AFD8DD768CA}"/>
+                <a16:creationId xmlns:a16="http://schemas.microsoft.com/office/drawing/2014/main" id="{ADDCD46F-298C-4890-A394-6DEB66135A7D}"/>
               </a:ext>
             </a:extLst>
           </p:cNvPr>
@@ -1635,7 +1702,7 @@
           <p:cNvPr id="9" name="hero-subtitle">
             <a:extLst xmlns:a="http://schemas.openxmlformats.org/drawingml/2006/main">
               <a:ext uri="{FF2B5EF4-FFF2-40B4-BE49-F238E27FC236}">
-                <a16:creationId xmlns:a16="http://schemas.microsoft.com/office/drawing/2014/main" id="{BF1973F7-EDD0-4609-98B4-6074D36C725E}"/>
+                <a16:creationId xmlns:a16="http://schemas.microsoft.com/office/drawing/2014/main" id="{B2035ACF-A406-4B83-8FC5-790E60FECC20}"/>
               </a:ext>
             </a:extLst>
           </p:cNvPr>
@@ -1685,7 +1752,7 @@
           <p:cNvPr id="10" name="tag-1">
             <a:extLst xmlns:a="http://schemas.openxmlformats.org/drawingml/2006/main">
               <a:ext uri="{FF2B5EF4-FFF2-40B4-BE49-F238E27FC236}">
-                <a16:creationId xmlns:a16="http://schemas.microsoft.com/office/drawing/2014/main" id="{E7D25977-DB2E-4C56-BBDB-EBF5336941CB}"/>
+                <a16:creationId xmlns:a16="http://schemas.microsoft.com/office/drawing/2014/main" id="{CF57E612-CB17-4AD0-8089-6E513D93C944}"/>
               </a:ext>
             </a:extLst>
           </p:cNvPr>
@@ -1741,7 +1808,7 @@
           <p:cNvPr id="11" name="tag-2">
             <a:extLst xmlns:a="http://schemas.openxmlformats.org/drawingml/2006/main">
               <a:ext uri="{FF2B5EF4-FFF2-40B4-BE49-F238E27FC236}">
-                <a16:creationId xmlns:a16="http://schemas.microsoft.com/office/drawing/2014/main" id="{25EAF25A-8F71-46E2-83E8-2341EE1CE9AA}"/>
+                <a16:creationId xmlns:a16="http://schemas.microsoft.com/office/drawing/2014/main" id="{24F0C8BB-A82A-4004-849C-D4BF74FA91B4}"/>
               </a:ext>
             </a:extLst>
           </p:cNvPr>
@@ -1797,7 +1864,7 @@
           <p:cNvPr id="12" name="tag-3">
             <a:extLst xmlns:a="http://schemas.openxmlformats.org/drawingml/2006/main">
               <a:ext uri="{FF2B5EF4-FFF2-40B4-BE49-F238E27FC236}">
-                <a16:creationId xmlns:a16="http://schemas.microsoft.com/office/drawing/2014/main" id="{A882FE4B-C872-4CCB-B7FD-CA0AE586B88B}"/>
+                <a16:creationId xmlns:a16="http://schemas.microsoft.com/office/drawing/2014/main" id="{54D690C4-BCBD-4C88-A91C-A0CF61AFFA22}"/>
               </a:ext>
             </a:extLst>
           </p:cNvPr>
@@ -1853,7 +1920,7 @@
           <p:cNvPr id="13" name="scope-title">
             <a:extLst xmlns:a="http://schemas.openxmlformats.org/drawingml/2006/main">
               <a:ext uri="{FF2B5EF4-FFF2-40B4-BE49-F238E27FC236}">
-                <a16:creationId xmlns:a16="http://schemas.microsoft.com/office/drawing/2014/main" id="{DCC71DF3-4F72-4FC7-A341-27A46AF26988}"/>
+                <a16:creationId xmlns:a16="http://schemas.microsoft.com/office/drawing/2014/main" id="{E2FD3ADC-F90D-4E4B-A9F3-78846F15D4D1}"/>
               </a:ext>
             </a:extLst>
           </p:cNvPr>
@@ -1903,7 +1970,7 @@
           <p:cNvPr id="14" name="scope-note">
             <a:extLst xmlns:a="http://schemas.openxmlformats.org/drawingml/2006/main">
               <a:ext uri="{FF2B5EF4-FFF2-40B4-BE49-F238E27FC236}">
-                <a16:creationId xmlns:a16="http://schemas.microsoft.com/office/drawing/2014/main" id="{4E5FAB43-19AB-4831-BA4A-663D456C7B9A}"/>
+                <a16:creationId xmlns:a16="http://schemas.microsoft.com/office/drawing/2014/main" id="{67DB9ADC-84EC-4214-8A32-A95E83F163AD}"/>
               </a:ext>
             </a:extLst>
           </p:cNvPr>
@@ -1953,7 +2020,7 @@
           <p:cNvPr id="15" name="scope-row-1">
             <a:extLst xmlns:a="http://schemas.openxmlformats.org/drawingml/2006/main">
               <a:ext uri="{FF2B5EF4-FFF2-40B4-BE49-F238E27FC236}">
-                <a16:creationId xmlns:a16="http://schemas.microsoft.com/office/drawing/2014/main" id="{14595D21-8304-4EBB-BEA7-CE99EC4F026A}"/>
+                <a16:creationId xmlns:a16="http://schemas.microsoft.com/office/drawing/2014/main" id="{4C12610D-4C0A-4214-A87F-4CE4CFCC5388}"/>
               </a:ext>
             </a:extLst>
           </p:cNvPr>
@@ -1986,7 +2053,7 @@
           <p:cNvPr id="16" name="scope-label-1">
             <a:extLst xmlns:a="http://schemas.openxmlformats.org/drawingml/2006/main">
               <a:ext uri="{FF2B5EF4-FFF2-40B4-BE49-F238E27FC236}">
-                <a16:creationId xmlns:a16="http://schemas.microsoft.com/office/drawing/2014/main" id="{07E724B2-100F-4078-9CB9-ADFAC0406180}"/>
+                <a16:creationId xmlns:a16="http://schemas.microsoft.com/office/drawing/2014/main" id="{335F205F-678E-4644-BF6F-DFF2B1A0CB01}"/>
               </a:ext>
             </a:extLst>
           </p:cNvPr>
@@ -2036,7 +2103,7 @@
           <p:cNvPr id="17" name="scope-value-1">
             <a:extLst xmlns:a="http://schemas.openxmlformats.org/drawingml/2006/main">
               <a:ext uri="{FF2B5EF4-FFF2-40B4-BE49-F238E27FC236}">
-                <a16:creationId xmlns:a16="http://schemas.microsoft.com/office/drawing/2014/main" id="{F513CBC5-C018-430F-A0C7-D02C876A99C2}"/>
+                <a16:creationId xmlns:a16="http://schemas.microsoft.com/office/drawing/2014/main" id="{00DBFD1A-EB29-4725-B716-FAFE3197E388}"/>
               </a:ext>
             </a:extLst>
           </p:cNvPr>
@@ -2086,7 +2153,7 @@
           <p:cNvPr id="18" name="scope-row-2">
             <a:extLst xmlns:a="http://schemas.openxmlformats.org/drawingml/2006/main">
               <a:ext uri="{FF2B5EF4-FFF2-40B4-BE49-F238E27FC236}">
-                <a16:creationId xmlns:a16="http://schemas.microsoft.com/office/drawing/2014/main" id="{211FAC08-5FE6-461F-AEEA-C2DAA87D426C}"/>
+                <a16:creationId xmlns:a16="http://schemas.microsoft.com/office/drawing/2014/main" id="{E2C42690-E149-4D87-BB53-D4C433F83DEF}"/>
               </a:ext>
             </a:extLst>
           </p:cNvPr>
@@ -2119,7 +2186,7 @@
           <p:cNvPr id="19" name="scope-label-2">
             <a:extLst xmlns:a="http://schemas.openxmlformats.org/drawingml/2006/main">
               <a:ext uri="{FF2B5EF4-FFF2-40B4-BE49-F238E27FC236}">
-                <a16:creationId xmlns:a16="http://schemas.microsoft.com/office/drawing/2014/main" id="{C1D609A1-251D-4C43-A8DF-60CE86A126CA}"/>
+                <a16:creationId xmlns:a16="http://schemas.microsoft.com/office/drawing/2014/main" id="{7564D172-F2AA-47A5-B310-FB14808851A8}"/>
               </a:ext>
             </a:extLst>
           </p:cNvPr>
@@ -2169,7 +2236,7 @@
           <p:cNvPr id="20" name="scope-value-2">
             <a:extLst xmlns:a="http://schemas.openxmlformats.org/drawingml/2006/main">
               <a:ext uri="{FF2B5EF4-FFF2-40B4-BE49-F238E27FC236}">
-                <a16:creationId xmlns:a16="http://schemas.microsoft.com/office/drawing/2014/main" id="{FE07C9B7-9251-4B43-9E01-4083708FBFF8}"/>
+                <a16:creationId xmlns:a16="http://schemas.microsoft.com/office/drawing/2014/main" id="{72CE553D-A5A4-460B-A0A0-645FA4F87452}"/>
               </a:ext>
             </a:extLst>
           </p:cNvPr>
@@ -2219,7 +2286,7 @@
           <p:cNvPr id="21" name="scope-row-3">
             <a:extLst xmlns:a="http://schemas.openxmlformats.org/drawingml/2006/main">
               <a:ext uri="{FF2B5EF4-FFF2-40B4-BE49-F238E27FC236}">
-                <a16:creationId xmlns:a16="http://schemas.microsoft.com/office/drawing/2014/main" id="{21C8AF00-CCD6-46F2-8DBE-D2845BB7CCFD}"/>
+                <a16:creationId xmlns:a16="http://schemas.microsoft.com/office/drawing/2014/main" id="{B667751D-BD09-406F-99F1-722EEC65EB80}"/>
               </a:ext>
             </a:extLst>
           </p:cNvPr>
@@ -2252,7 +2319,7 @@
           <p:cNvPr id="22" name="scope-label-3">
             <a:extLst xmlns:a="http://schemas.openxmlformats.org/drawingml/2006/main">
               <a:ext uri="{FF2B5EF4-FFF2-40B4-BE49-F238E27FC236}">
-                <a16:creationId xmlns:a16="http://schemas.microsoft.com/office/drawing/2014/main" id="{C300E796-8E6E-43F6-A80F-C9670605ED63}"/>
+                <a16:creationId xmlns:a16="http://schemas.microsoft.com/office/drawing/2014/main" id="{2F87E506-3350-4812-A89B-23CE9E6A589D}"/>
               </a:ext>
             </a:extLst>
           </p:cNvPr>
@@ -2302,7 +2369,7 @@
           <p:cNvPr id="23" name="scope-value-3">
             <a:extLst xmlns:a="http://schemas.openxmlformats.org/drawingml/2006/main">
               <a:ext uri="{FF2B5EF4-FFF2-40B4-BE49-F238E27FC236}">
-                <a16:creationId xmlns:a16="http://schemas.microsoft.com/office/drawing/2014/main" id="{56474A90-BFBB-4C1D-A98C-99EEF3BCAE81}"/>
+                <a16:creationId xmlns:a16="http://schemas.microsoft.com/office/drawing/2014/main" id="{536D4063-A103-4223-ABBD-5BE69D1DAD6B}"/>
               </a:ext>
             </a:extLst>
           </p:cNvPr>
@@ -2352,7 +2419,7 @@
           <p:cNvPr id="24" name="scope-row-4">
             <a:extLst xmlns:a="http://schemas.openxmlformats.org/drawingml/2006/main">
               <a:ext uri="{FF2B5EF4-FFF2-40B4-BE49-F238E27FC236}">
-                <a16:creationId xmlns:a16="http://schemas.microsoft.com/office/drawing/2014/main" id="{73653595-F7BC-4DFD-83C4-2D0E57A7E781}"/>
+                <a16:creationId xmlns:a16="http://schemas.microsoft.com/office/drawing/2014/main" id="{833BE1D9-9783-4146-A0CC-C52E2D831BD0}"/>
               </a:ext>
             </a:extLst>
           </p:cNvPr>
@@ -2385,7 +2452,7 @@
           <p:cNvPr id="25" name="scope-label-4">
             <a:extLst xmlns:a="http://schemas.openxmlformats.org/drawingml/2006/main">
               <a:ext uri="{FF2B5EF4-FFF2-40B4-BE49-F238E27FC236}">
-                <a16:creationId xmlns:a16="http://schemas.microsoft.com/office/drawing/2014/main" id="{85390BD5-B89F-4BB8-BA98-689D64857A30}"/>
+                <a16:creationId xmlns:a16="http://schemas.microsoft.com/office/drawing/2014/main" id="{48716E3A-78B4-4F01-B41F-738A48415E0E}"/>
               </a:ext>
             </a:extLst>
           </p:cNvPr>
@@ -2435,7 +2502,7 @@
           <p:cNvPr id="26" name="scope-value-4">
             <a:extLst xmlns:a="http://schemas.openxmlformats.org/drawingml/2006/main">
               <a:ext uri="{FF2B5EF4-FFF2-40B4-BE49-F238E27FC236}">
-                <a16:creationId xmlns:a16="http://schemas.microsoft.com/office/drawing/2014/main" id="{8EB7FB78-6B7A-460D-A1D4-35DE81FC8814}"/>
+                <a16:creationId xmlns:a16="http://schemas.microsoft.com/office/drawing/2014/main" id="{20287506-F50E-4BEC-9DDD-AE98ACFE6920}"/>
               </a:ext>
             </a:extLst>
           </p:cNvPr>
@@ -2485,7 +2552,7 @@
           <p:cNvPr id="27" name="evidence-title">
             <a:extLst xmlns:a="http://schemas.openxmlformats.org/drawingml/2006/main">
               <a:ext uri="{FF2B5EF4-FFF2-40B4-BE49-F238E27FC236}">
-                <a16:creationId xmlns:a16="http://schemas.microsoft.com/office/drawing/2014/main" id="{E144894E-E9C3-4C11-A88C-B54C375B6B69}"/>
+                <a16:creationId xmlns:a16="http://schemas.microsoft.com/office/drawing/2014/main" id="{5FC098D1-8FE2-4FA9-B3BA-39F847ED071A}"/>
               </a:ext>
             </a:extLst>
           </p:cNvPr>
@@ -2535,7 +2602,7 @@
           <p:cNvPr id="28" name="evidence-card-1">
             <a:extLst xmlns:a="http://schemas.openxmlformats.org/drawingml/2006/main">
               <a:ext uri="{FF2B5EF4-FFF2-40B4-BE49-F238E27FC236}">
-                <a16:creationId xmlns:a16="http://schemas.microsoft.com/office/drawing/2014/main" id="{9F0A17F9-2C37-4464-A861-B1F2A50E45D2}"/>
+                <a16:creationId xmlns:a16="http://schemas.microsoft.com/office/drawing/2014/main" id="{0557C158-E4DA-4C69-9F38-744AF0D0AC43}"/>
               </a:ext>
             </a:extLst>
           </p:cNvPr>
@@ -2570,7 +2637,7 @@
           <p:cNvPr id="29" name="evidence-bar-1">
             <a:extLst xmlns:a="http://schemas.openxmlformats.org/drawingml/2006/main">
               <a:ext uri="{FF2B5EF4-FFF2-40B4-BE49-F238E27FC236}">
-                <a16:creationId xmlns:a16="http://schemas.microsoft.com/office/drawing/2014/main" id="{E1D4CD3B-1413-4F23-89D8-7D6D932FB9A9}"/>
+                <a16:creationId xmlns:a16="http://schemas.microsoft.com/office/drawing/2014/main" id="{92050C45-487E-4773-8D46-6A7589DFF300}"/>
               </a:ext>
             </a:extLst>
           </p:cNvPr>
@@ -2603,7 +2670,7 @@
           <p:cNvPr id="30" name="evidence-title-1">
             <a:extLst xmlns:a="http://schemas.openxmlformats.org/drawingml/2006/main">
               <a:ext uri="{FF2B5EF4-FFF2-40B4-BE49-F238E27FC236}">
-                <a16:creationId xmlns:a16="http://schemas.microsoft.com/office/drawing/2014/main" id="{FECBBD11-8719-4334-AE99-8D7050E3EEA1}"/>
+                <a16:creationId xmlns:a16="http://schemas.microsoft.com/office/drawing/2014/main" id="{AE069EFC-1F3B-4928-BF0D-C78EC46CFD86}"/>
               </a:ext>
             </a:extLst>
           </p:cNvPr>
@@ -2653,7 +2720,7 @@
           <p:cNvPr id="31" name="evidence-body-1">
             <a:extLst xmlns:a="http://schemas.openxmlformats.org/drawingml/2006/main">
               <a:ext uri="{FF2B5EF4-FFF2-40B4-BE49-F238E27FC236}">
-                <a16:creationId xmlns:a16="http://schemas.microsoft.com/office/drawing/2014/main" id="{7DA3C8AF-2BE6-4EAA-B12F-E6F86AD4FB73}"/>
+                <a16:creationId xmlns:a16="http://schemas.microsoft.com/office/drawing/2014/main" id="{C4244FE5-551D-4AB6-ABD1-D257415A3E8F}"/>
               </a:ext>
             </a:extLst>
           </p:cNvPr>
@@ -2703,7 +2770,7 @@
           <p:cNvPr id="32" name="evidence-card-2">
             <a:extLst xmlns:a="http://schemas.openxmlformats.org/drawingml/2006/main">
               <a:ext uri="{FF2B5EF4-FFF2-40B4-BE49-F238E27FC236}">
-                <a16:creationId xmlns:a16="http://schemas.microsoft.com/office/drawing/2014/main" id="{0402305E-2FC3-4D57-9615-EC82D4528476}"/>
+                <a16:creationId xmlns:a16="http://schemas.microsoft.com/office/drawing/2014/main" id="{D3999706-A676-46CC-8871-8E62BB80E267}"/>
               </a:ext>
             </a:extLst>
           </p:cNvPr>
@@ -2738,7 +2805,7 @@
           <p:cNvPr id="33" name="evidence-bar-2">
             <a:extLst xmlns:a="http://schemas.openxmlformats.org/drawingml/2006/main">
               <a:ext uri="{FF2B5EF4-FFF2-40B4-BE49-F238E27FC236}">
-                <a16:creationId xmlns:a16="http://schemas.microsoft.com/office/drawing/2014/main" id="{7A0852F6-63E3-4D71-95B8-5D543F31E956}"/>
+                <a16:creationId xmlns:a16="http://schemas.microsoft.com/office/drawing/2014/main" id="{FA6292D2-1300-4D2B-9756-15FA1FF1D6F6}"/>
               </a:ext>
             </a:extLst>
           </p:cNvPr>
@@ -2771,7 +2838,7 @@
           <p:cNvPr id="34" name="evidence-title-2">
             <a:extLst xmlns:a="http://schemas.openxmlformats.org/drawingml/2006/main">
               <a:ext uri="{FF2B5EF4-FFF2-40B4-BE49-F238E27FC236}">
-                <a16:creationId xmlns:a16="http://schemas.microsoft.com/office/drawing/2014/main" id="{00172DA9-9DA4-41F7-93F0-DA3C609E9A45}"/>
+                <a16:creationId xmlns:a16="http://schemas.microsoft.com/office/drawing/2014/main" id="{57D91E72-C2FC-4020-B2FA-F15D015352D7}"/>
               </a:ext>
             </a:extLst>
           </p:cNvPr>
@@ -2821,7 +2888,7 @@
           <p:cNvPr id="35" name="evidence-body-2">
             <a:extLst xmlns:a="http://schemas.openxmlformats.org/drawingml/2006/main">
               <a:ext uri="{FF2B5EF4-FFF2-40B4-BE49-F238E27FC236}">
-                <a16:creationId xmlns:a16="http://schemas.microsoft.com/office/drawing/2014/main" id="{0C1CEADD-B4AF-45C6-A413-BF9B600D5944}"/>
+                <a16:creationId xmlns:a16="http://schemas.microsoft.com/office/drawing/2014/main" id="{8250533F-B925-4437-A9BA-2B30FFAD37FB}"/>
               </a:ext>
             </a:extLst>
           </p:cNvPr>
@@ -2871,7 +2938,7 @@
           <p:cNvPr id="36" name="evidence-card-3">
             <a:extLst xmlns:a="http://schemas.openxmlformats.org/drawingml/2006/main">
               <a:ext uri="{FF2B5EF4-FFF2-40B4-BE49-F238E27FC236}">
-                <a16:creationId xmlns:a16="http://schemas.microsoft.com/office/drawing/2014/main" id="{2FD10DC0-7D6D-4493-B081-68F14DB5E5DD}"/>
+                <a16:creationId xmlns:a16="http://schemas.microsoft.com/office/drawing/2014/main" id="{2440D61D-BA59-44FB-93E0-527A33186F04}"/>
               </a:ext>
             </a:extLst>
           </p:cNvPr>
@@ -2906,7 +2973,7 @@
           <p:cNvPr id="37" name="evidence-bar-3">
             <a:extLst xmlns:a="http://schemas.openxmlformats.org/drawingml/2006/main">
               <a:ext uri="{FF2B5EF4-FFF2-40B4-BE49-F238E27FC236}">
-                <a16:creationId xmlns:a16="http://schemas.microsoft.com/office/drawing/2014/main" id="{71BBF68A-5F9D-46DA-8F79-B0F6D3F28786}"/>
+                <a16:creationId xmlns:a16="http://schemas.microsoft.com/office/drawing/2014/main" id="{90EDC4F0-6B5D-46B9-B858-E72664433829}"/>
               </a:ext>
             </a:extLst>
           </p:cNvPr>
@@ -2939,7 +3006,7 @@
           <p:cNvPr id="38" name="evidence-title-3">
             <a:extLst xmlns:a="http://schemas.openxmlformats.org/drawingml/2006/main">
               <a:ext uri="{FF2B5EF4-FFF2-40B4-BE49-F238E27FC236}">
-                <a16:creationId xmlns:a16="http://schemas.microsoft.com/office/drawing/2014/main" id="{582CC6DC-17B6-4C56-B9C6-4C11AF3FFBBE}"/>
+                <a16:creationId xmlns:a16="http://schemas.microsoft.com/office/drawing/2014/main" id="{2F4E645D-5998-4334-9F21-5DD1A9E2E011}"/>
               </a:ext>
             </a:extLst>
           </p:cNvPr>
@@ -2989,7 +3056,7 @@
           <p:cNvPr id="39" name="evidence-body-3">
             <a:extLst xmlns:a="http://schemas.openxmlformats.org/drawingml/2006/main">
               <a:ext uri="{FF2B5EF4-FFF2-40B4-BE49-F238E27FC236}">
-                <a16:creationId xmlns:a16="http://schemas.microsoft.com/office/drawing/2014/main" id="{7060E1E2-4592-4FEC-84B8-08631965E3D6}"/>
+                <a16:creationId xmlns:a16="http://schemas.microsoft.com/office/drawing/2014/main" id="{92AC30B7-B8D2-489D-A6C4-3AA6BAB60631}"/>
               </a:ext>
             </a:extLst>
           </p:cNvPr>
@@ -3037,7 +3104,7 @@
     </p:spTree>
     <p:extLst>
       <p:ext uri="{BB962C8B-B14F-4D97-AF65-F5344CB8AC3E}">
-        <p14:creationId xmlns:p14="http://schemas.microsoft.com/office/powerpoint/2010/main" val="1414832179"/>
+        <p14:creationId xmlns:p14="http://schemas.microsoft.com/office/powerpoint/2010/main" val="1190684672"/>
       </p:ext>
     </p:extLst>
   </p:cSld>
@@ -3068,7 +3135,7 @@
           <p:cNvPr id="1" name="top-accent">
             <a:extLst xmlns:a="http://schemas.openxmlformats.org/drawingml/2006/main">
               <a:ext uri="{FF2B5EF4-FFF2-40B4-BE49-F238E27FC236}">
-                <a16:creationId xmlns:a16="http://schemas.microsoft.com/office/drawing/2014/main" id="{C5B4065F-AF9C-472D-BEAC-01079763F569}"/>
+                <a16:creationId xmlns:a16="http://schemas.microsoft.com/office/drawing/2014/main" id="{3A43E086-8A89-47E3-B486-42AA2E637266}"/>
               </a:ext>
             </a:extLst>
           </p:cNvPr>
@@ -3101,7 +3168,7 @@
           <p:cNvPr id="2" name="left-accent">
             <a:extLst xmlns:a="http://schemas.openxmlformats.org/drawingml/2006/main">
               <a:ext uri="{FF2B5EF4-FFF2-40B4-BE49-F238E27FC236}">
-                <a16:creationId xmlns:a16="http://schemas.microsoft.com/office/drawing/2014/main" id="{108FB09B-C99E-40FA-B33C-CB151F014D58}"/>
+                <a16:creationId xmlns:a16="http://schemas.microsoft.com/office/drawing/2014/main" id="{8CAB8563-9111-4E26-A49E-089BE172A324}"/>
               </a:ext>
             </a:extLst>
           </p:cNvPr>
@@ -3134,7 +3201,7 @@
           <p:cNvPr id="3" name="eyebrow">
             <a:extLst xmlns:a="http://schemas.openxmlformats.org/drawingml/2006/main">
               <a:ext uri="{FF2B5EF4-FFF2-40B4-BE49-F238E27FC236}">
-                <a16:creationId xmlns:a16="http://schemas.microsoft.com/office/drawing/2014/main" id="{79F5C9BA-0339-4966-B12E-4B48029BD32C}"/>
+                <a16:creationId xmlns:a16="http://schemas.microsoft.com/office/drawing/2014/main" id="{1BEA5706-5583-417F-82EE-3B8A6F18699C}"/>
               </a:ext>
             </a:extLst>
           </p:cNvPr>
@@ -3184,7 +3251,7 @@
           <p:cNvPr id="4" name="footer">
             <a:extLst xmlns:a="http://schemas.openxmlformats.org/drawingml/2006/main">
               <a:ext uri="{FF2B5EF4-FFF2-40B4-BE49-F238E27FC236}">
-                <a16:creationId xmlns:a16="http://schemas.microsoft.com/office/drawing/2014/main" id="{E5F9E4AD-7573-48A5-ACD7-C7697C81D5BD}"/>
+                <a16:creationId xmlns:a16="http://schemas.microsoft.com/office/drawing/2014/main" id="{4A206D99-822B-4291-8893-61B826891897}"/>
               </a:ext>
             </a:extLst>
           </p:cNvPr>
@@ -3234,7 +3301,7 @@
           <p:cNvPr id="5" name="page-no">
             <a:extLst xmlns:a="http://schemas.openxmlformats.org/drawingml/2006/main">
               <a:ext uri="{FF2B5EF4-FFF2-40B4-BE49-F238E27FC236}">
-                <a16:creationId xmlns:a16="http://schemas.microsoft.com/office/drawing/2014/main" id="{EA804ACF-259E-4576-BC80-30A91CFCC5C9}"/>
+                <a16:creationId xmlns:a16="http://schemas.microsoft.com/office/drawing/2014/main" id="{4510B05D-BD79-4AAD-B7CD-91CD538072E5}"/>
               </a:ext>
             </a:extLst>
           </p:cNvPr>
@@ -3284,7 +3351,7 @@
           <p:cNvPr id="6" name="title-02">
             <a:extLst xmlns:a="http://schemas.openxmlformats.org/drawingml/2006/main">
               <a:ext uri="{FF2B5EF4-FFF2-40B4-BE49-F238E27FC236}">
-                <a16:creationId xmlns:a16="http://schemas.microsoft.com/office/drawing/2014/main" id="{78331278-F27C-4F68-B39D-4C8FE45FE7EF}"/>
+                <a16:creationId xmlns:a16="http://schemas.microsoft.com/office/drawing/2014/main" id="{93DA5A2B-44BD-47A5-A31C-4FB7EBBFF8B8}"/>
               </a:ext>
             </a:extLst>
           </p:cNvPr>
@@ -3324,7 +3391,7 @@
                   <a:srgbClr val="FFFFFF"/>
                 </a:solidFill>
               </a:rPr>
-              <a:t>6개월 런칭 준비는 네 축이 병렬로 움직입니다</a:t>
+              <a:t>6개월 런칭 준비는 마일스톤과 릴리즈 기준을 함께 맞춥니다</a:t>
             </a:r>
           </a:p>
         </p:txBody>
@@ -3334,7 +3401,7 @@
           <p:cNvPr id="7" name="subtitle-02">
             <a:extLst xmlns:a="http://schemas.openxmlformats.org/drawingml/2006/main">
               <a:ext uri="{FF2B5EF4-FFF2-40B4-BE49-F238E27FC236}">
-                <a16:creationId xmlns:a16="http://schemas.microsoft.com/office/drawing/2014/main" id="{06A6556A-7FB6-4A2A-894E-DF69689361A0}"/>
+                <a16:creationId xmlns:a16="http://schemas.microsoft.com/office/drawing/2014/main" id="{25E878C4-34F9-4EDE-8FE9-8D979D71A44D}"/>
               </a:ext>
             </a:extLst>
           </p:cNvPr>
@@ -3374,7 +3441,7 @@
                   <a:srgbClr val="CBD5E1"/>
                 </a:solidFill>
               </a:rPr>
-              <a:t>월별 단계는 순차 진행처럼 보이지만, PM 관점에서는 범위·버전·검수 기준을 동시에 맞춰야 합니다.</a:t>
+              <a:t>PM 관점에서는 일정·범위 통제, 빌드·버전 관리, QA, 퍼블리셔 대응을 같은 흐름으로 관리해야 합니다.</a:t>
             </a:r>
           </a:p>
         </p:txBody>
@@ -3384,7 +3451,7 @@
           <p:cNvPr id="8" name="timeline-line">
             <a:extLst xmlns:a="http://schemas.openxmlformats.org/drawingml/2006/main">
               <a:ext uri="{FF2B5EF4-FFF2-40B4-BE49-F238E27FC236}">
-                <a16:creationId xmlns:a16="http://schemas.microsoft.com/office/drawing/2014/main" id="{F91F3DFC-FD0B-49A9-B449-8A082B1A6CA5}"/>
+                <a16:creationId xmlns:a16="http://schemas.microsoft.com/office/drawing/2014/main" id="{DA61E38C-309C-4557-B424-8156157CAC2E}"/>
               </a:ext>
             </a:extLst>
           </p:cNvPr>
@@ -3417,7 +3484,7 @@
           <p:cNvPr id="9" name="timeline-card-1">
             <a:extLst xmlns:a="http://schemas.openxmlformats.org/drawingml/2006/main">
               <a:ext uri="{FF2B5EF4-FFF2-40B4-BE49-F238E27FC236}">
-                <a16:creationId xmlns:a16="http://schemas.microsoft.com/office/drawing/2014/main" id="{7C77F99E-032D-4082-A73D-ACFCA4610A4B}"/>
+                <a16:creationId xmlns:a16="http://schemas.microsoft.com/office/drawing/2014/main" id="{71F326DD-56CB-4AFF-A765-E1FAAC97618F}"/>
               </a:ext>
             </a:extLst>
           </p:cNvPr>
@@ -3452,7 +3519,7 @@
           <p:cNvPr id="10" name="timeline-bar-1">
             <a:extLst xmlns:a="http://schemas.openxmlformats.org/drawingml/2006/main">
               <a:ext uri="{FF2B5EF4-FFF2-40B4-BE49-F238E27FC236}">
-                <a16:creationId xmlns:a16="http://schemas.microsoft.com/office/drawing/2014/main" id="{DC9B893B-A935-411F-BD8B-472C4675A11A}"/>
+                <a16:creationId xmlns:a16="http://schemas.microsoft.com/office/drawing/2014/main" id="{B652463F-AFCF-44F4-94C3-596167665129}"/>
               </a:ext>
             </a:extLst>
           </p:cNvPr>
@@ -3485,7 +3552,7 @@
           <p:cNvPr id="11" name="timeline-month-1">
             <a:extLst xmlns:a="http://schemas.openxmlformats.org/drawingml/2006/main">
               <a:ext uri="{FF2B5EF4-FFF2-40B4-BE49-F238E27FC236}">
-                <a16:creationId xmlns:a16="http://schemas.microsoft.com/office/drawing/2014/main" id="{D8D2538B-AEF6-42C5-83B2-FF5C5510FD29}"/>
+                <a16:creationId xmlns:a16="http://schemas.microsoft.com/office/drawing/2014/main" id="{DCE0EA11-1AAE-4717-95F8-26061B505C24}"/>
               </a:ext>
             </a:extLst>
           </p:cNvPr>
@@ -3535,7 +3602,7 @@
           <p:cNvPr id="12" name="timeline-title-1">
             <a:extLst xmlns:a="http://schemas.openxmlformats.org/drawingml/2006/main">
               <a:ext uri="{FF2B5EF4-FFF2-40B4-BE49-F238E27FC236}">
-                <a16:creationId xmlns:a16="http://schemas.microsoft.com/office/drawing/2014/main" id="{8F055F9B-1FD6-4BD3-A5E6-FFFB716924A6}"/>
+                <a16:creationId xmlns:a16="http://schemas.microsoft.com/office/drawing/2014/main" id="{F9079AF9-10DB-480B-945A-9E18BDF9DA8A}"/>
               </a:ext>
             </a:extLst>
           </p:cNvPr>
@@ -3575,7 +3642,7 @@
                   <a:srgbClr val="FFFFFF"/>
                 </a:solidFill>
               </a:rPr>
-              <a:t>런칭 범위 확정</a:t>
+              <a:t>범위·일정 확정</a:t>
             </a:r>
           </a:p>
         </p:txBody>
@@ -3585,7 +3652,7 @@
           <p:cNvPr id="13" name="timeline-dot-1-1">
             <a:extLst xmlns:a="http://schemas.openxmlformats.org/drawingml/2006/main">
               <a:ext uri="{FF2B5EF4-FFF2-40B4-BE49-F238E27FC236}">
-                <a16:creationId xmlns:a16="http://schemas.microsoft.com/office/drawing/2014/main" id="{80971BCC-3E95-401E-AC84-3D9D98071784}"/>
+                <a16:creationId xmlns:a16="http://schemas.microsoft.com/office/drawing/2014/main" id="{2C5E123D-D31B-4307-9FC4-AF7593AA2603}"/>
               </a:ext>
             </a:extLst>
           </p:cNvPr>
@@ -3635,7 +3702,7 @@
           <p:cNvPr id="14" name="timeline-item-1-1">
             <a:extLst xmlns:a="http://schemas.openxmlformats.org/drawingml/2006/main">
               <a:ext uri="{FF2B5EF4-FFF2-40B4-BE49-F238E27FC236}">
-                <a16:creationId xmlns:a16="http://schemas.microsoft.com/office/drawing/2014/main" id="{CD321824-E8AB-4817-8643-F9EFC76F8F08}"/>
+                <a16:creationId xmlns:a16="http://schemas.microsoft.com/office/drawing/2014/main" id="{901EB455-DC34-4374-9350-63185609CA8E}"/>
               </a:ext>
             </a:extLst>
           </p:cNvPr>
@@ -3685,7 +3752,7 @@
           <p:cNvPr id="15" name="timeline-dot-1-2">
             <a:extLst xmlns:a="http://schemas.openxmlformats.org/drawingml/2006/main">
               <a:ext uri="{FF2B5EF4-FFF2-40B4-BE49-F238E27FC236}">
-                <a16:creationId xmlns:a16="http://schemas.microsoft.com/office/drawing/2014/main" id="{6C80BE1F-3692-402D-A54D-A9AED1732DED}"/>
+                <a16:creationId xmlns:a16="http://schemas.microsoft.com/office/drawing/2014/main" id="{5F4D47F7-3FD2-45BD-9B60-681FE8C9834A}"/>
               </a:ext>
             </a:extLst>
           </p:cNvPr>
@@ -3735,7 +3802,7 @@
           <p:cNvPr id="16" name="timeline-item-1-2">
             <a:extLst xmlns:a="http://schemas.openxmlformats.org/drawingml/2006/main">
               <a:ext uri="{FF2B5EF4-FFF2-40B4-BE49-F238E27FC236}">
-                <a16:creationId xmlns:a16="http://schemas.microsoft.com/office/drawing/2014/main" id="{41ACFFF6-0F0E-491C-9FC3-2F490CF7E94E}"/>
+                <a16:creationId xmlns:a16="http://schemas.microsoft.com/office/drawing/2014/main" id="{7673024C-A4B5-4A58-8D71-2885E6E62120}"/>
               </a:ext>
             </a:extLst>
           </p:cNvPr>
@@ -3775,7 +3842,7 @@
                   <a:srgbClr val="CBD5E1"/>
                 </a:solidFill>
               </a:rPr>
-              <a:t>주요 콘텐츠 기준</a:t>
+              <a:t>마일스톤 기준</a:t>
             </a:r>
           </a:p>
         </p:txBody>
@@ -3785,7 +3852,7 @@
           <p:cNvPr id="17" name="timeline-dot-1-3">
             <a:extLst xmlns:a="http://schemas.openxmlformats.org/drawingml/2006/main">
               <a:ext uri="{FF2B5EF4-FFF2-40B4-BE49-F238E27FC236}">
-                <a16:creationId xmlns:a16="http://schemas.microsoft.com/office/drawing/2014/main" id="{93FB5EA8-3AF8-40B6-A1A6-A1C03486FDAD}"/>
+                <a16:creationId xmlns:a16="http://schemas.microsoft.com/office/drawing/2014/main" id="{2EDB2DB6-7193-4B99-97A0-D09C0D634D40}"/>
               </a:ext>
             </a:extLst>
           </p:cNvPr>
@@ -3835,7 +3902,7 @@
           <p:cNvPr id="18" name="timeline-item-1-3">
             <a:extLst xmlns:a="http://schemas.openxmlformats.org/drawingml/2006/main">
               <a:ext uri="{FF2B5EF4-FFF2-40B4-BE49-F238E27FC236}">
-                <a16:creationId xmlns:a16="http://schemas.microsoft.com/office/drawing/2014/main" id="{688CC708-B5E4-4124-9905-347F2F4DB545}"/>
+                <a16:creationId xmlns:a16="http://schemas.microsoft.com/office/drawing/2014/main" id="{5C633E05-D953-488C-B990-93673E5E7FCF}"/>
               </a:ext>
             </a:extLst>
           </p:cNvPr>
@@ -3885,7 +3952,7 @@
           <p:cNvPr id="19" name="timeline-card-2">
             <a:extLst xmlns:a="http://schemas.openxmlformats.org/drawingml/2006/main">
               <a:ext uri="{FF2B5EF4-FFF2-40B4-BE49-F238E27FC236}">
-                <a16:creationId xmlns:a16="http://schemas.microsoft.com/office/drawing/2014/main" id="{FFDA65BA-3851-4630-AADC-C8C7C5E58341}"/>
+                <a16:creationId xmlns:a16="http://schemas.microsoft.com/office/drawing/2014/main" id="{22F9E5B4-F844-423C-B4DD-6CFFD20B2379}"/>
               </a:ext>
             </a:extLst>
           </p:cNvPr>
@@ -3920,7 +3987,7 @@
           <p:cNvPr id="20" name="timeline-bar-2">
             <a:extLst xmlns:a="http://schemas.openxmlformats.org/drawingml/2006/main">
               <a:ext uri="{FF2B5EF4-FFF2-40B4-BE49-F238E27FC236}">
-                <a16:creationId xmlns:a16="http://schemas.microsoft.com/office/drawing/2014/main" id="{DFB40DC3-62CB-46FF-9115-A62DE7525413}"/>
+                <a16:creationId xmlns:a16="http://schemas.microsoft.com/office/drawing/2014/main" id="{C969E6A5-9E57-43B9-BD01-0773E50338B8}"/>
               </a:ext>
             </a:extLst>
           </p:cNvPr>
@@ -3953,7 +4020,7 @@
           <p:cNvPr id="21" name="timeline-month-2">
             <a:extLst xmlns:a="http://schemas.openxmlformats.org/drawingml/2006/main">
               <a:ext uri="{FF2B5EF4-FFF2-40B4-BE49-F238E27FC236}">
-                <a16:creationId xmlns:a16="http://schemas.microsoft.com/office/drawing/2014/main" id="{8E56C1FC-16A7-46D6-81CC-83BC6D5FBD1A}"/>
+                <a16:creationId xmlns:a16="http://schemas.microsoft.com/office/drawing/2014/main" id="{8BBA170C-B22B-43CE-89F2-DF96FD87787E}"/>
               </a:ext>
             </a:extLst>
           </p:cNvPr>
@@ -4003,7 +4070,7 @@
           <p:cNvPr id="22" name="timeline-title-2">
             <a:extLst xmlns:a="http://schemas.openxmlformats.org/drawingml/2006/main">
               <a:ext uri="{FF2B5EF4-FFF2-40B4-BE49-F238E27FC236}">
-                <a16:creationId xmlns:a16="http://schemas.microsoft.com/office/drawing/2014/main" id="{F5A3600C-4C7E-4B5B-9E0A-4B5C35708D0B}"/>
+                <a16:creationId xmlns:a16="http://schemas.microsoft.com/office/drawing/2014/main" id="{A2DF04A3-5377-45F3-BF16-DC407016C95A}"/>
               </a:ext>
             </a:extLst>
           </p:cNvPr>
@@ -4043,7 +4110,7 @@
                   <a:srgbClr val="FFFFFF"/>
                 </a:solidFill>
               </a:rPr>
-              <a:t>개발·현지화 동기화</a:t>
+              <a:t>개발·현지화 반영</a:t>
             </a:r>
           </a:p>
         </p:txBody>
@@ -4053,7 +4120,7 @@
           <p:cNvPr id="23" name="timeline-dot-2-1">
             <a:extLst xmlns:a="http://schemas.openxmlformats.org/drawingml/2006/main">
               <a:ext uri="{FF2B5EF4-FFF2-40B4-BE49-F238E27FC236}">
-                <a16:creationId xmlns:a16="http://schemas.microsoft.com/office/drawing/2014/main" id="{02A0192B-0F5C-496D-8AFA-9A9A22D38638}"/>
+                <a16:creationId xmlns:a16="http://schemas.microsoft.com/office/drawing/2014/main" id="{E423776E-62F2-4829-897F-1A36521CDF04}"/>
               </a:ext>
             </a:extLst>
           </p:cNvPr>
@@ -4103,7 +4170,7 @@
           <p:cNvPr id="24" name="timeline-item-2-1">
             <a:extLst xmlns:a="http://schemas.openxmlformats.org/drawingml/2006/main">
               <a:ext uri="{FF2B5EF4-FFF2-40B4-BE49-F238E27FC236}">
-                <a16:creationId xmlns:a16="http://schemas.microsoft.com/office/drawing/2014/main" id="{1B617751-0E19-44A9-885C-5248CD6F92B4}"/>
+                <a16:creationId xmlns:a16="http://schemas.microsoft.com/office/drawing/2014/main" id="{C19D0E56-E0B8-419F-84ED-329D7AF56DF5}"/>
               </a:ext>
             </a:extLst>
           </p:cNvPr>
@@ -4143,7 +4210,7 @@
                   <a:srgbClr val="CBD5E1"/>
                 </a:solidFill>
               </a:rPr>
-              <a:t>번역·리소스 반영</a:t>
+              <a:t>번역 리소스 반영</a:t>
             </a:r>
           </a:p>
         </p:txBody>
@@ -4153,7 +4220,7 @@
           <p:cNvPr id="25" name="timeline-dot-2-2">
             <a:extLst xmlns:a="http://schemas.openxmlformats.org/drawingml/2006/main">
               <a:ext uri="{FF2B5EF4-FFF2-40B4-BE49-F238E27FC236}">
-                <a16:creationId xmlns:a16="http://schemas.microsoft.com/office/drawing/2014/main" id="{DCF2427C-B0D1-4741-A7EC-6665F528DAEF}"/>
+                <a16:creationId xmlns:a16="http://schemas.microsoft.com/office/drawing/2014/main" id="{FC1AAA73-D307-4699-80C6-C174401D3800}"/>
               </a:ext>
             </a:extLst>
           </p:cNvPr>
@@ -4203,7 +4270,7 @@
           <p:cNvPr id="26" name="timeline-item-2-2">
             <a:extLst xmlns:a="http://schemas.openxmlformats.org/drawingml/2006/main">
               <a:ext uri="{FF2B5EF4-FFF2-40B4-BE49-F238E27FC236}">
-                <a16:creationId xmlns:a16="http://schemas.microsoft.com/office/drawing/2014/main" id="{C4114685-59AA-4F8D-A302-36C5E17610E6}"/>
+                <a16:creationId xmlns:a16="http://schemas.microsoft.com/office/drawing/2014/main" id="{18C39682-6242-4D80-85E6-860A8FF522BA}"/>
               </a:ext>
             </a:extLst>
           </p:cNvPr>
@@ -4253,7 +4320,7 @@
           <p:cNvPr id="27" name="timeline-dot-2-3">
             <a:extLst xmlns:a="http://schemas.openxmlformats.org/drawingml/2006/main">
               <a:ext uri="{FF2B5EF4-FFF2-40B4-BE49-F238E27FC236}">
-                <a16:creationId xmlns:a16="http://schemas.microsoft.com/office/drawing/2014/main" id="{81570395-076B-4FED-A557-EC569F0B7504}"/>
+                <a16:creationId xmlns:a16="http://schemas.microsoft.com/office/drawing/2014/main" id="{9E21BD62-2784-4B02-AD59-02F013B548A1}"/>
               </a:ext>
             </a:extLst>
           </p:cNvPr>
@@ -4303,7 +4370,7 @@
           <p:cNvPr id="28" name="timeline-item-2-3">
             <a:extLst xmlns:a="http://schemas.openxmlformats.org/drawingml/2006/main">
               <a:ext uri="{FF2B5EF4-FFF2-40B4-BE49-F238E27FC236}">
-                <a16:creationId xmlns:a16="http://schemas.microsoft.com/office/drawing/2014/main" id="{23A0BD52-9FAE-4941-831F-A134F181F5EE}"/>
+                <a16:creationId xmlns:a16="http://schemas.microsoft.com/office/drawing/2014/main" id="{33B048E2-1BBB-487C-BD6F-067CCB2EB70A}"/>
               </a:ext>
             </a:extLst>
           </p:cNvPr>
@@ -4343,7 +4410,7 @@
                   <a:srgbClr val="CBD5E1"/>
                 </a:solidFill>
               </a:rPr>
-              <a:t>기능 마감 기준</a:t>
+              <a:t>개발 마감 기준</a:t>
             </a:r>
           </a:p>
         </p:txBody>
@@ -4353,7 +4420,7 @@
           <p:cNvPr id="29" name="timeline-card-3">
             <a:extLst xmlns:a="http://schemas.openxmlformats.org/drawingml/2006/main">
               <a:ext uri="{FF2B5EF4-FFF2-40B4-BE49-F238E27FC236}">
-                <a16:creationId xmlns:a16="http://schemas.microsoft.com/office/drawing/2014/main" id="{1B6A0DB0-0281-4B47-B3CE-008B196B1D06}"/>
+                <a16:creationId xmlns:a16="http://schemas.microsoft.com/office/drawing/2014/main" id="{DBB47F54-3E3F-45D4-AFB2-C4266C736F28}"/>
               </a:ext>
             </a:extLst>
           </p:cNvPr>
@@ -4388,7 +4455,7 @@
           <p:cNvPr id="30" name="timeline-bar-3">
             <a:extLst xmlns:a="http://schemas.openxmlformats.org/drawingml/2006/main">
               <a:ext uri="{FF2B5EF4-FFF2-40B4-BE49-F238E27FC236}">
-                <a16:creationId xmlns:a16="http://schemas.microsoft.com/office/drawing/2014/main" id="{D01BEA83-8DBD-48F2-B5F4-65C655709F87}"/>
+                <a16:creationId xmlns:a16="http://schemas.microsoft.com/office/drawing/2014/main" id="{E7A7958E-B5C7-45E8-8521-919A33181D1F}"/>
               </a:ext>
             </a:extLst>
           </p:cNvPr>
@@ -4421,7 +4488,7 @@
           <p:cNvPr id="31" name="timeline-month-3">
             <a:extLst xmlns:a="http://schemas.openxmlformats.org/drawingml/2006/main">
               <a:ext uri="{FF2B5EF4-FFF2-40B4-BE49-F238E27FC236}">
-                <a16:creationId xmlns:a16="http://schemas.microsoft.com/office/drawing/2014/main" id="{AB52A153-9088-4B9F-8969-835F9CE5864E}"/>
+                <a16:creationId xmlns:a16="http://schemas.microsoft.com/office/drawing/2014/main" id="{1E316BF3-5FF9-4197-BF12-665826D63B52}"/>
               </a:ext>
             </a:extLst>
           </p:cNvPr>
@@ -4471,7 +4538,7 @@
           <p:cNvPr id="32" name="timeline-title-3">
             <a:extLst xmlns:a="http://schemas.openxmlformats.org/drawingml/2006/main">
               <a:ext uri="{FF2B5EF4-FFF2-40B4-BE49-F238E27FC236}">
-                <a16:creationId xmlns:a16="http://schemas.microsoft.com/office/drawing/2014/main" id="{DB557715-32F0-4615-A65D-51786465E29C}"/>
+                <a16:creationId xmlns:a16="http://schemas.microsoft.com/office/drawing/2014/main" id="{D04C2607-4A9A-4600-BAB4-A72FF6BB59FA}"/>
               </a:ext>
             </a:extLst>
           </p:cNvPr>
@@ -4511,7 +4578,7 @@
                   <a:srgbClr val="FFFFFF"/>
                 </a:solidFill>
               </a:rPr>
-              <a:t>내부 QA 진입</a:t>
+              <a:t>QA 진입</a:t>
             </a:r>
           </a:p>
         </p:txBody>
@@ -4521,7 +4588,7 @@
           <p:cNvPr id="33" name="timeline-dot-3-1">
             <a:extLst xmlns:a="http://schemas.openxmlformats.org/drawingml/2006/main">
               <a:ext uri="{FF2B5EF4-FFF2-40B4-BE49-F238E27FC236}">
-                <a16:creationId xmlns:a16="http://schemas.microsoft.com/office/drawing/2014/main" id="{76A309AA-CA30-499F-BB0E-5856264DC388}"/>
+                <a16:creationId xmlns:a16="http://schemas.microsoft.com/office/drawing/2014/main" id="{4804ACF8-4EA2-4910-8C6D-C38A08045C38}"/>
               </a:ext>
             </a:extLst>
           </p:cNvPr>
@@ -4571,7 +4638,7 @@
           <p:cNvPr id="34" name="timeline-item-3-1">
             <a:extLst xmlns:a="http://schemas.openxmlformats.org/drawingml/2006/main">
               <a:ext uri="{FF2B5EF4-FFF2-40B4-BE49-F238E27FC236}">
-                <a16:creationId xmlns:a16="http://schemas.microsoft.com/office/drawing/2014/main" id="{DB4D1398-DD4C-46B8-9D91-52BCEF95632B}"/>
+                <a16:creationId xmlns:a16="http://schemas.microsoft.com/office/drawing/2014/main" id="{E68D4359-A05F-476C-8FC5-05026FF736DB}"/>
               </a:ext>
             </a:extLst>
           </p:cNvPr>
@@ -4621,7 +4688,7 @@
           <p:cNvPr id="35" name="timeline-dot-3-2">
             <a:extLst xmlns:a="http://schemas.openxmlformats.org/drawingml/2006/main">
               <a:ext uri="{FF2B5EF4-FFF2-40B4-BE49-F238E27FC236}">
-                <a16:creationId xmlns:a16="http://schemas.microsoft.com/office/drawing/2014/main" id="{35BDA465-81F7-40F5-93A7-4A01701CF8C7}"/>
+                <a16:creationId xmlns:a16="http://schemas.microsoft.com/office/drawing/2014/main" id="{1E24820B-82D6-42C0-B322-DE5D7A7102B9}"/>
               </a:ext>
             </a:extLst>
           </p:cNvPr>
@@ -4671,7 +4738,7 @@
           <p:cNvPr id="36" name="timeline-item-3-2">
             <a:extLst xmlns:a="http://schemas.openxmlformats.org/drawingml/2006/main">
               <a:ext uri="{FF2B5EF4-FFF2-40B4-BE49-F238E27FC236}">
-                <a16:creationId xmlns:a16="http://schemas.microsoft.com/office/drawing/2014/main" id="{646CBF00-3F2B-42E7-9FCD-39398F6DC1D1}"/>
+                <a16:creationId xmlns:a16="http://schemas.microsoft.com/office/drawing/2014/main" id="{CF19FC2F-1EA1-47B5-8716-D2D2C1FE4FD0}"/>
               </a:ext>
             </a:extLst>
           </p:cNvPr>
@@ -4711,7 +4778,7 @@
                   <a:srgbClr val="CBD5E1"/>
                 </a:solidFill>
               </a:rPr>
-              <a:t>결함 등급 분류</a:t>
+              <a:t>이슈 등급 분류</a:t>
             </a:r>
           </a:p>
         </p:txBody>
@@ -4721,7 +4788,7 @@
           <p:cNvPr id="37" name="timeline-dot-3-3">
             <a:extLst xmlns:a="http://schemas.openxmlformats.org/drawingml/2006/main">
               <a:ext uri="{FF2B5EF4-FFF2-40B4-BE49-F238E27FC236}">
-                <a16:creationId xmlns:a16="http://schemas.microsoft.com/office/drawing/2014/main" id="{3DF94618-5622-48C6-B2F7-701476A20C61}"/>
+                <a16:creationId xmlns:a16="http://schemas.microsoft.com/office/drawing/2014/main" id="{D210B9CC-E680-4DA6-BB24-614588AFDC0A}"/>
               </a:ext>
             </a:extLst>
           </p:cNvPr>
@@ -4771,7 +4838,7 @@
           <p:cNvPr id="38" name="timeline-item-3-3">
             <a:extLst xmlns:a="http://schemas.openxmlformats.org/drawingml/2006/main">
               <a:ext uri="{FF2B5EF4-FFF2-40B4-BE49-F238E27FC236}">
-                <a16:creationId xmlns:a16="http://schemas.microsoft.com/office/drawing/2014/main" id="{C375F0E8-5005-4417-A950-8E90F7519E6A}"/>
+                <a16:creationId xmlns:a16="http://schemas.microsoft.com/office/drawing/2014/main" id="{92AA4F92-1DAB-41AF-80CF-660871505E6D}"/>
               </a:ext>
             </a:extLst>
           </p:cNvPr>
@@ -4821,7 +4888,7 @@
           <p:cNvPr id="39" name="timeline-card-4">
             <a:extLst xmlns:a="http://schemas.openxmlformats.org/drawingml/2006/main">
               <a:ext uri="{FF2B5EF4-FFF2-40B4-BE49-F238E27FC236}">
-                <a16:creationId xmlns:a16="http://schemas.microsoft.com/office/drawing/2014/main" id="{AAC8974D-9BF0-4614-8443-8BB3A06390B4}"/>
+                <a16:creationId xmlns:a16="http://schemas.microsoft.com/office/drawing/2014/main" id="{0FFA0A42-43DC-4762-A511-B4B1ECDC1645}"/>
               </a:ext>
             </a:extLst>
           </p:cNvPr>
@@ -4856,7 +4923,7 @@
           <p:cNvPr id="40" name="timeline-bar-4">
             <a:extLst xmlns:a="http://schemas.openxmlformats.org/drawingml/2006/main">
               <a:ext uri="{FF2B5EF4-FFF2-40B4-BE49-F238E27FC236}">
-                <a16:creationId xmlns:a16="http://schemas.microsoft.com/office/drawing/2014/main" id="{4D525D06-E5BD-473E-929B-ADC8810D2DB3}"/>
+                <a16:creationId xmlns:a16="http://schemas.microsoft.com/office/drawing/2014/main" id="{12486716-92B3-42AC-A178-9F518C1F7C53}"/>
               </a:ext>
             </a:extLst>
           </p:cNvPr>
@@ -4889,7 +4956,7 @@
           <p:cNvPr id="41" name="timeline-month-4">
             <a:extLst xmlns:a="http://schemas.openxmlformats.org/drawingml/2006/main">
               <a:ext uri="{FF2B5EF4-FFF2-40B4-BE49-F238E27FC236}">
-                <a16:creationId xmlns:a16="http://schemas.microsoft.com/office/drawing/2014/main" id="{39847B26-AE16-4ED8-B115-F124D0270868}"/>
+                <a16:creationId xmlns:a16="http://schemas.microsoft.com/office/drawing/2014/main" id="{2E330539-8CC1-40C6-B096-C1C76C8D6EAB}"/>
               </a:ext>
             </a:extLst>
           </p:cNvPr>
@@ -4939,7 +5006,7 @@
           <p:cNvPr id="42" name="timeline-title-4">
             <a:extLst xmlns:a="http://schemas.openxmlformats.org/drawingml/2006/main">
               <a:ext uri="{FF2B5EF4-FFF2-40B4-BE49-F238E27FC236}">
-                <a16:creationId xmlns:a16="http://schemas.microsoft.com/office/drawing/2014/main" id="{7728BD85-7BAB-462B-B35D-DE20D3C255DB}"/>
+                <a16:creationId xmlns:a16="http://schemas.microsoft.com/office/drawing/2014/main" id="{A9FC81E3-6E02-4707-8FEB-885B1EBFC64A}"/>
               </a:ext>
             </a:extLst>
           </p:cNvPr>
@@ -4989,7 +5056,7 @@
           <p:cNvPr id="43" name="timeline-dot-4-1">
             <a:extLst xmlns:a="http://schemas.openxmlformats.org/drawingml/2006/main">
               <a:ext uri="{FF2B5EF4-FFF2-40B4-BE49-F238E27FC236}">
-                <a16:creationId xmlns:a16="http://schemas.microsoft.com/office/drawing/2014/main" id="{1EF3C154-8231-4A08-8B53-2F8B1AE830A4}"/>
+                <a16:creationId xmlns:a16="http://schemas.microsoft.com/office/drawing/2014/main" id="{1376D649-D37E-495B-BE9D-43E198FDC1DB}"/>
               </a:ext>
             </a:extLst>
           </p:cNvPr>
@@ -5039,7 +5106,7 @@
           <p:cNvPr id="44" name="timeline-item-4-1">
             <a:extLst xmlns:a="http://schemas.openxmlformats.org/drawingml/2006/main">
               <a:ext uri="{FF2B5EF4-FFF2-40B4-BE49-F238E27FC236}">
-                <a16:creationId xmlns:a16="http://schemas.microsoft.com/office/drawing/2014/main" id="{D446BC95-5D78-4F17-8EB5-182E2876B308}"/>
+                <a16:creationId xmlns:a16="http://schemas.microsoft.com/office/drawing/2014/main" id="{512A8B08-988C-462F-8B78-D97B8F7B78D4}"/>
               </a:ext>
             </a:extLst>
           </p:cNvPr>
@@ -5089,7 +5156,7 @@
           <p:cNvPr id="45" name="timeline-dot-4-2">
             <a:extLst xmlns:a="http://schemas.openxmlformats.org/drawingml/2006/main">
               <a:ext uri="{FF2B5EF4-FFF2-40B4-BE49-F238E27FC236}">
-                <a16:creationId xmlns:a16="http://schemas.microsoft.com/office/drawing/2014/main" id="{94AE69AA-75D2-4D23-AEFA-97A6B9C7DDCC}"/>
+                <a16:creationId xmlns:a16="http://schemas.microsoft.com/office/drawing/2014/main" id="{FD4E6DE5-31C1-4FAC-9315-6638BF0E7147}"/>
               </a:ext>
             </a:extLst>
           </p:cNvPr>
@@ -5139,7 +5206,7 @@
           <p:cNvPr id="46" name="timeline-item-4-2">
             <a:extLst xmlns:a="http://schemas.openxmlformats.org/drawingml/2006/main">
               <a:ext uri="{FF2B5EF4-FFF2-40B4-BE49-F238E27FC236}">
-                <a16:creationId xmlns:a16="http://schemas.microsoft.com/office/drawing/2014/main" id="{E95DE8D2-DE78-456D-8B95-1F56149BB8B7}"/>
+                <a16:creationId xmlns:a16="http://schemas.microsoft.com/office/drawing/2014/main" id="{786D1630-04A3-4B3B-8D42-65EEEEBE19CE}"/>
               </a:ext>
             </a:extLst>
           </p:cNvPr>
@@ -5189,7 +5256,7 @@
           <p:cNvPr id="47" name="timeline-dot-4-3">
             <a:extLst xmlns:a="http://schemas.openxmlformats.org/drawingml/2006/main">
               <a:ext uri="{FF2B5EF4-FFF2-40B4-BE49-F238E27FC236}">
-                <a16:creationId xmlns:a16="http://schemas.microsoft.com/office/drawing/2014/main" id="{0D0409BB-B352-4AD4-B4CE-8FFDF30CD2F0}"/>
+                <a16:creationId xmlns:a16="http://schemas.microsoft.com/office/drawing/2014/main" id="{4C7A9791-7C4E-4273-BD47-40D2D5BC6A71}"/>
               </a:ext>
             </a:extLst>
           </p:cNvPr>
@@ -5239,7 +5306,7 @@
           <p:cNvPr id="48" name="timeline-item-4-3">
             <a:extLst xmlns:a="http://schemas.openxmlformats.org/drawingml/2006/main">
               <a:ext uri="{FF2B5EF4-FFF2-40B4-BE49-F238E27FC236}">
-                <a16:creationId xmlns:a16="http://schemas.microsoft.com/office/drawing/2014/main" id="{FF8795DD-3BF8-474F-B441-D2528F5499A0}"/>
+                <a16:creationId xmlns:a16="http://schemas.microsoft.com/office/drawing/2014/main" id="{74047F89-03F6-496D-8425-321CAFDCDD66}"/>
               </a:ext>
             </a:extLst>
           </p:cNvPr>
@@ -5289,7 +5356,7 @@
           <p:cNvPr id="49" name="timeline-card-5">
             <a:extLst xmlns:a="http://schemas.openxmlformats.org/drawingml/2006/main">
               <a:ext uri="{FF2B5EF4-FFF2-40B4-BE49-F238E27FC236}">
-                <a16:creationId xmlns:a16="http://schemas.microsoft.com/office/drawing/2014/main" id="{D1E9EE8D-5ACD-4A39-A481-07953AADB0D6}"/>
+                <a16:creationId xmlns:a16="http://schemas.microsoft.com/office/drawing/2014/main" id="{EC399B6E-744A-467D-9EFC-97702A008EEB}"/>
               </a:ext>
             </a:extLst>
           </p:cNvPr>
@@ -5324,7 +5391,7 @@
           <p:cNvPr id="50" name="timeline-bar-5">
             <a:extLst xmlns:a="http://schemas.openxmlformats.org/drawingml/2006/main">
               <a:ext uri="{FF2B5EF4-FFF2-40B4-BE49-F238E27FC236}">
-                <a16:creationId xmlns:a16="http://schemas.microsoft.com/office/drawing/2014/main" id="{378D48FE-331B-4CCA-A695-197E2D129F2D}"/>
+                <a16:creationId xmlns:a16="http://schemas.microsoft.com/office/drawing/2014/main" id="{61220510-B666-444C-8B7A-8FA61CAB0D8B}"/>
               </a:ext>
             </a:extLst>
           </p:cNvPr>
@@ -5357,7 +5424,7 @@
           <p:cNvPr id="51" name="timeline-month-5">
             <a:extLst xmlns:a="http://schemas.openxmlformats.org/drawingml/2006/main">
               <a:ext uri="{FF2B5EF4-FFF2-40B4-BE49-F238E27FC236}">
-                <a16:creationId xmlns:a16="http://schemas.microsoft.com/office/drawing/2014/main" id="{0272FC7C-3E2D-474C-8746-792FADE9D55F}"/>
+                <a16:creationId xmlns:a16="http://schemas.microsoft.com/office/drawing/2014/main" id="{84921866-73AF-45EA-B166-BD0C644BEABD}"/>
               </a:ext>
             </a:extLst>
           </p:cNvPr>
@@ -5407,7 +5474,7 @@
           <p:cNvPr id="52" name="timeline-title-5">
             <a:extLst xmlns:a="http://schemas.openxmlformats.org/drawingml/2006/main">
               <a:ext uri="{FF2B5EF4-FFF2-40B4-BE49-F238E27FC236}">
-                <a16:creationId xmlns:a16="http://schemas.microsoft.com/office/drawing/2014/main" id="{6782BFB3-41BC-4B05-9E89-7E21A0679A7C}"/>
+                <a16:creationId xmlns:a16="http://schemas.microsoft.com/office/drawing/2014/main" id="{4EF3FDC2-493D-42C0-9377-D9CB6EE760F2}"/>
               </a:ext>
             </a:extLst>
           </p:cNvPr>
@@ -5457,7 +5524,7 @@
           <p:cNvPr id="53" name="timeline-dot-5-1">
             <a:extLst xmlns:a="http://schemas.openxmlformats.org/drawingml/2006/main">
               <a:ext uri="{FF2B5EF4-FFF2-40B4-BE49-F238E27FC236}">
-                <a16:creationId xmlns:a16="http://schemas.microsoft.com/office/drawing/2014/main" id="{EE670B59-AB95-42D3-B87D-55EA92B06E20}"/>
+                <a16:creationId xmlns:a16="http://schemas.microsoft.com/office/drawing/2014/main" id="{CB195D7A-59BA-404C-ABF0-908E1CDCF27D}"/>
               </a:ext>
             </a:extLst>
           </p:cNvPr>
@@ -5507,7 +5574,7 @@
           <p:cNvPr id="54" name="timeline-item-5-1">
             <a:extLst xmlns:a="http://schemas.openxmlformats.org/drawingml/2006/main">
               <a:ext uri="{FF2B5EF4-FFF2-40B4-BE49-F238E27FC236}">
-                <a16:creationId xmlns:a16="http://schemas.microsoft.com/office/drawing/2014/main" id="{267724D5-D8B1-452F-BDA4-33110D16DF3D}"/>
+                <a16:creationId xmlns:a16="http://schemas.microsoft.com/office/drawing/2014/main" id="{EBCAA5AD-FECC-4CA6-A900-014A01291AA4}"/>
               </a:ext>
             </a:extLst>
           </p:cNvPr>
@@ -5557,7 +5624,7 @@
           <p:cNvPr id="55" name="timeline-dot-5-2">
             <a:extLst xmlns:a="http://schemas.openxmlformats.org/drawingml/2006/main">
               <a:ext uri="{FF2B5EF4-FFF2-40B4-BE49-F238E27FC236}">
-                <a16:creationId xmlns:a16="http://schemas.microsoft.com/office/drawing/2014/main" id="{98B057A9-B951-4945-AD07-4B2D35652285}"/>
+                <a16:creationId xmlns:a16="http://schemas.microsoft.com/office/drawing/2014/main" id="{08A31B75-D30E-40AF-BA1F-1EF8F4FE456F}"/>
               </a:ext>
             </a:extLst>
           </p:cNvPr>
@@ -5607,7 +5674,7 @@
           <p:cNvPr id="56" name="timeline-item-5-2">
             <a:extLst xmlns:a="http://schemas.openxmlformats.org/drawingml/2006/main">
               <a:ext uri="{FF2B5EF4-FFF2-40B4-BE49-F238E27FC236}">
-                <a16:creationId xmlns:a16="http://schemas.microsoft.com/office/drawing/2014/main" id="{E7AA0977-2113-4DD8-9B8D-096E8146D6EB}"/>
+                <a16:creationId xmlns:a16="http://schemas.microsoft.com/office/drawing/2014/main" id="{AAC6BC4E-41D7-440D-B91D-9B038415DD1B}"/>
               </a:ext>
             </a:extLst>
           </p:cNvPr>
@@ -5657,7 +5724,7 @@
           <p:cNvPr id="57" name="timeline-dot-5-3">
             <a:extLst xmlns:a="http://schemas.openxmlformats.org/drawingml/2006/main">
               <a:ext uri="{FF2B5EF4-FFF2-40B4-BE49-F238E27FC236}">
-                <a16:creationId xmlns:a16="http://schemas.microsoft.com/office/drawing/2014/main" id="{C608EACA-F1A6-4050-8E59-71BE5578F226}"/>
+                <a16:creationId xmlns:a16="http://schemas.microsoft.com/office/drawing/2014/main" id="{8709111A-CB14-4DC2-B8CD-6EF97408F8E7}"/>
               </a:ext>
             </a:extLst>
           </p:cNvPr>
@@ -5707,7 +5774,7 @@
           <p:cNvPr id="58" name="timeline-item-5-3">
             <a:extLst xmlns:a="http://schemas.openxmlformats.org/drawingml/2006/main">
               <a:ext uri="{FF2B5EF4-FFF2-40B4-BE49-F238E27FC236}">
-                <a16:creationId xmlns:a16="http://schemas.microsoft.com/office/drawing/2014/main" id="{52C54133-7A2A-4A91-A196-5BC77FF16E8D}"/>
+                <a16:creationId xmlns:a16="http://schemas.microsoft.com/office/drawing/2014/main" id="{A04420B3-6574-49A0-A54D-3C0337E9EC35}"/>
               </a:ext>
             </a:extLst>
           </p:cNvPr>
@@ -5747,7 +5814,7 @@
                   <a:srgbClr val="CBD5E1"/>
                 </a:solidFill>
               </a:rPr>
-              <a:t>스토어·심의 체크</a:t>
+              <a:t>심의·스토어 체크</a:t>
             </a:r>
           </a:p>
         </p:txBody>
@@ -5757,7 +5824,7 @@
           <p:cNvPr id="59" name="timeline-card-6">
             <a:extLst xmlns:a="http://schemas.openxmlformats.org/drawingml/2006/main">
               <a:ext uri="{FF2B5EF4-FFF2-40B4-BE49-F238E27FC236}">
-                <a16:creationId xmlns:a16="http://schemas.microsoft.com/office/drawing/2014/main" id="{F6CEE417-E5C5-42A1-836D-640A400B90DA}"/>
+                <a16:creationId xmlns:a16="http://schemas.microsoft.com/office/drawing/2014/main" id="{2BD4F686-2A66-4025-B862-54E59C2EC4CB}"/>
               </a:ext>
             </a:extLst>
           </p:cNvPr>
@@ -5792,7 +5859,7 @@
           <p:cNvPr id="60" name="timeline-bar-6">
             <a:extLst xmlns:a="http://schemas.openxmlformats.org/drawingml/2006/main">
               <a:ext uri="{FF2B5EF4-FFF2-40B4-BE49-F238E27FC236}">
-                <a16:creationId xmlns:a16="http://schemas.microsoft.com/office/drawing/2014/main" id="{DBB628AA-ACB9-47D9-B43E-0EAAF85CAC36}"/>
+                <a16:creationId xmlns:a16="http://schemas.microsoft.com/office/drawing/2014/main" id="{708B108C-1324-411B-9BA7-4A2BFB86C235}"/>
               </a:ext>
             </a:extLst>
           </p:cNvPr>
@@ -5825,7 +5892,7 @@
           <p:cNvPr id="61" name="timeline-month-6">
             <a:extLst xmlns:a="http://schemas.openxmlformats.org/drawingml/2006/main">
               <a:ext uri="{FF2B5EF4-FFF2-40B4-BE49-F238E27FC236}">
-                <a16:creationId xmlns:a16="http://schemas.microsoft.com/office/drawing/2014/main" id="{6483C664-D17D-4AA2-945B-C16AD65457B5}"/>
+                <a16:creationId xmlns:a16="http://schemas.microsoft.com/office/drawing/2014/main" id="{5A956DAE-A19D-46B6-8FD9-A1909D90CF1D}"/>
               </a:ext>
             </a:extLst>
           </p:cNvPr>
@@ -5875,7 +5942,7 @@
           <p:cNvPr id="62" name="timeline-title-6">
             <a:extLst xmlns:a="http://schemas.openxmlformats.org/drawingml/2006/main">
               <a:ext uri="{FF2B5EF4-FFF2-40B4-BE49-F238E27FC236}">
-                <a16:creationId xmlns:a16="http://schemas.microsoft.com/office/drawing/2014/main" id="{5F526A02-A929-4699-99B9-A02F8013D499}"/>
+                <a16:creationId xmlns:a16="http://schemas.microsoft.com/office/drawing/2014/main" id="{6B3E2FED-BFEA-4575-AD32-628E7A71ECB7}"/>
               </a:ext>
             </a:extLst>
           </p:cNvPr>
@@ -5915,7 +5982,7 @@
                   <a:srgbClr val="FFFFFF"/>
                 </a:solidFill>
               </a:rPr>
-              <a:t>리허설·배포</a:t>
+              <a:t>Live 릴리즈 준비</a:t>
             </a:r>
           </a:p>
         </p:txBody>
@@ -5925,7 +5992,7 @@
           <p:cNvPr id="63" name="timeline-dot-6-1">
             <a:extLst xmlns:a="http://schemas.openxmlformats.org/drawingml/2006/main">
               <a:ext uri="{FF2B5EF4-FFF2-40B4-BE49-F238E27FC236}">
-                <a16:creationId xmlns:a16="http://schemas.microsoft.com/office/drawing/2014/main" id="{7AE6970A-196D-4CF4-B9E6-31169E4613C4}"/>
+                <a16:creationId xmlns:a16="http://schemas.microsoft.com/office/drawing/2014/main" id="{23CE8EB4-54C2-4298-BBAC-A48DE6BD8CDD}"/>
               </a:ext>
             </a:extLst>
           </p:cNvPr>
@@ -5975,7 +6042,7 @@
           <p:cNvPr id="64" name="timeline-item-6-1">
             <a:extLst xmlns:a="http://schemas.openxmlformats.org/drawingml/2006/main">
               <a:ext uri="{FF2B5EF4-FFF2-40B4-BE49-F238E27FC236}">
-                <a16:creationId xmlns:a16="http://schemas.microsoft.com/office/drawing/2014/main" id="{62C06B8D-D1A2-4F2E-89FA-6D7B9EFF47D1}"/>
+                <a16:creationId xmlns:a16="http://schemas.microsoft.com/office/drawing/2014/main" id="{43FC7D4C-4B80-4BF1-ABF6-3A3B57D1C162}"/>
               </a:ext>
             </a:extLst>
           </p:cNvPr>
@@ -6025,7 +6092,7 @@
           <p:cNvPr id="65" name="timeline-dot-6-2">
             <a:extLst xmlns:a="http://schemas.openxmlformats.org/drawingml/2006/main">
               <a:ext uri="{FF2B5EF4-FFF2-40B4-BE49-F238E27FC236}">
-                <a16:creationId xmlns:a16="http://schemas.microsoft.com/office/drawing/2014/main" id="{47B44FB4-7CC4-4C6B-BB08-397515522B32}"/>
+                <a16:creationId xmlns:a16="http://schemas.microsoft.com/office/drawing/2014/main" id="{00F3C90B-9B09-4E02-96E6-2EC70BB24F67}"/>
               </a:ext>
             </a:extLst>
           </p:cNvPr>
@@ -6075,7 +6142,7 @@
           <p:cNvPr id="66" name="timeline-item-6-2">
             <a:extLst xmlns:a="http://schemas.openxmlformats.org/drawingml/2006/main">
               <a:ext uri="{FF2B5EF4-FFF2-40B4-BE49-F238E27FC236}">
-                <a16:creationId xmlns:a16="http://schemas.microsoft.com/office/drawing/2014/main" id="{77E639F7-CD89-47FA-B263-EB47EC35C521}"/>
+                <a16:creationId xmlns:a16="http://schemas.microsoft.com/office/drawing/2014/main" id="{F6D35562-8500-46E4-BDD1-E2B11DF4E942}"/>
               </a:ext>
             </a:extLst>
           </p:cNvPr>
@@ -6125,7 +6192,7 @@
           <p:cNvPr id="67" name="timeline-dot-6-3">
             <a:extLst xmlns:a="http://schemas.openxmlformats.org/drawingml/2006/main">
               <a:ext uri="{FF2B5EF4-FFF2-40B4-BE49-F238E27FC236}">
-                <a16:creationId xmlns:a16="http://schemas.microsoft.com/office/drawing/2014/main" id="{F05B7C0A-7E65-4954-9F76-228225B24F65}"/>
+                <a16:creationId xmlns:a16="http://schemas.microsoft.com/office/drawing/2014/main" id="{3C7B0809-D291-486E-8D05-B106B403C6D0}"/>
               </a:ext>
             </a:extLst>
           </p:cNvPr>
@@ -6175,7 +6242,7 @@
           <p:cNvPr id="68" name="timeline-item-6-3">
             <a:extLst xmlns:a="http://schemas.openxmlformats.org/drawingml/2006/main">
               <a:ext uri="{FF2B5EF4-FFF2-40B4-BE49-F238E27FC236}">
-                <a16:creationId xmlns:a16="http://schemas.microsoft.com/office/drawing/2014/main" id="{D2CE6211-C823-44E1-9986-66E6ABC6BEDF}"/>
+                <a16:creationId xmlns:a16="http://schemas.microsoft.com/office/drawing/2014/main" id="{3DB2143D-1795-4F0A-A6B3-2E7CBBFF69FC}"/>
               </a:ext>
             </a:extLst>
           </p:cNvPr>
@@ -6225,7 +6292,7 @@
           <p:cNvPr id="69" name="management-title">
             <a:extLst xmlns:a="http://schemas.openxmlformats.org/drawingml/2006/main">
               <a:ext uri="{FF2B5EF4-FFF2-40B4-BE49-F238E27FC236}">
-                <a16:creationId xmlns:a16="http://schemas.microsoft.com/office/drawing/2014/main" id="{23E6D33D-7CA3-4039-80DB-3AC3DBD23DA0}"/>
+                <a16:creationId xmlns:a16="http://schemas.microsoft.com/office/drawing/2014/main" id="{8B4EED73-B94C-4426-9A47-C3E1523503CD}"/>
               </a:ext>
             </a:extLst>
           </p:cNvPr>
@@ -6275,7 +6342,7 @@
           <p:cNvPr id="70" name="management-note">
             <a:extLst xmlns:a="http://schemas.openxmlformats.org/drawingml/2006/main">
               <a:ext uri="{FF2B5EF4-FFF2-40B4-BE49-F238E27FC236}">
-                <a16:creationId xmlns:a16="http://schemas.microsoft.com/office/drawing/2014/main" id="{46A80453-4025-4817-992D-70C82E4CBB7E}"/>
+                <a16:creationId xmlns:a16="http://schemas.microsoft.com/office/drawing/2014/main" id="{07FBB63D-C0D7-4535-9B80-559FAF62DE84}"/>
               </a:ext>
             </a:extLst>
           </p:cNvPr>
@@ -6315,7 +6382,7 @@
                   <a:srgbClr val="94A3B8"/>
                 </a:solidFill>
               </a:rPr>
-              <a:t>각 단계의 완료 기준을 명확히 두고, 빌드·QA·퍼블리셔 대응을 같은 리듬으로 관리합니다.</a:t>
+              <a:t>마일스톤별 완료 기준을 두고, 빌드·버전·QA·퍼블리셔 대응을 함께 추적합니다.</a:t>
             </a:r>
           </a:p>
         </p:txBody>
@@ -6325,7 +6392,7 @@
           <p:cNvPr id="71" name="mgmt-card-1">
             <a:extLst xmlns:a="http://schemas.openxmlformats.org/drawingml/2006/main">
               <a:ext uri="{FF2B5EF4-FFF2-40B4-BE49-F238E27FC236}">
-                <a16:creationId xmlns:a16="http://schemas.microsoft.com/office/drawing/2014/main" id="{84824C05-2EE7-46D7-9137-44C25129EB91}"/>
+                <a16:creationId xmlns:a16="http://schemas.microsoft.com/office/drawing/2014/main" id="{E15F8F58-41E2-4145-9110-900F0A06D938}"/>
               </a:ext>
             </a:extLst>
           </p:cNvPr>
@@ -6360,7 +6427,7 @@
           <p:cNvPr id="72" name="mgmt-bar-1">
             <a:extLst xmlns:a="http://schemas.openxmlformats.org/drawingml/2006/main">
               <a:ext uri="{FF2B5EF4-FFF2-40B4-BE49-F238E27FC236}">
-                <a16:creationId xmlns:a16="http://schemas.microsoft.com/office/drawing/2014/main" id="{B1B1AEC8-CD5E-4E2E-8972-EE2EA14974F1}"/>
+                <a16:creationId xmlns:a16="http://schemas.microsoft.com/office/drawing/2014/main" id="{5B3F837C-7109-4855-9123-481E74B0D5EB}"/>
               </a:ext>
             </a:extLst>
           </p:cNvPr>
@@ -6393,7 +6460,7 @@
           <p:cNvPr id="73" name="mgmt-label-1">
             <a:extLst xmlns:a="http://schemas.openxmlformats.org/drawingml/2006/main">
               <a:ext uri="{FF2B5EF4-FFF2-40B4-BE49-F238E27FC236}">
-                <a16:creationId xmlns:a16="http://schemas.microsoft.com/office/drawing/2014/main" id="{A8347DE2-982C-49F1-9EFD-0862056DB028}"/>
+                <a16:creationId xmlns:a16="http://schemas.microsoft.com/office/drawing/2014/main" id="{237F3CC8-6D45-4360-AA3C-588249C2306D}"/>
               </a:ext>
             </a:extLst>
           </p:cNvPr>
@@ -6443,7 +6510,7 @@
           <p:cNvPr id="74" name="mgmt-body-1">
             <a:extLst xmlns:a="http://schemas.openxmlformats.org/drawingml/2006/main">
               <a:ext uri="{FF2B5EF4-FFF2-40B4-BE49-F238E27FC236}">
-                <a16:creationId xmlns:a16="http://schemas.microsoft.com/office/drawing/2014/main" id="{8507851C-FCCA-49B7-AC28-D1F10D4C3D8F}"/>
+                <a16:creationId xmlns:a16="http://schemas.microsoft.com/office/drawing/2014/main" id="{A46A886F-0781-4E68-AC80-40EC536D198E}"/>
               </a:ext>
             </a:extLst>
           </p:cNvPr>
@@ -6483,7 +6550,7 @@
                   <a:srgbClr val="CBD5E1"/>
                 </a:solidFill>
               </a:rPr>
-              <a:t>단계별 게이트 기준 관리</a:t>
+              <a:t>일정·범위 통제 기준 관리</a:t>
             </a:r>
           </a:p>
         </p:txBody>
@@ -6493,7 +6560,7 @@
           <p:cNvPr id="75" name="mgmt-card-2">
             <a:extLst xmlns:a="http://schemas.openxmlformats.org/drawingml/2006/main">
               <a:ext uri="{FF2B5EF4-FFF2-40B4-BE49-F238E27FC236}">
-                <a16:creationId xmlns:a16="http://schemas.microsoft.com/office/drawing/2014/main" id="{B35691A3-ECBA-4042-9A05-3C7EAB11FD7A}"/>
+                <a16:creationId xmlns:a16="http://schemas.microsoft.com/office/drawing/2014/main" id="{386A610C-DB9A-401D-9367-B6E589338185}"/>
               </a:ext>
             </a:extLst>
           </p:cNvPr>
@@ -6528,7 +6595,7 @@
           <p:cNvPr id="76" name="mgmt-bar-2">
             <a:extLst xmlns:a="http://schemas.openxmlformats.org/drawingml/2006/main">
               <a:ext uri="{FF2B5EF4-FFF2-40B4-BE49-F238E27FC236}">
-                <a16:creationId xmlns:a16="http://schemas.microsoft.com/office/drawing/2014/main" id="{80969DE9-6307-4C60-83C5-F10AD4B853E0}"/>
+                <a16:creationId xmlns:a16="http://schemas.microsoft.com/office/drawing/2014/main" id="{63907001-3C41-4709-80BB-702F1971E41B}"/>
               </a:ext>
             </a:extLst>
           </p:cNvPr>
@@ -6561,7 +6628,7 @@
           <p:cNvPr id="77" name="mgmt-label-2">
             <a:extLst xmlns:a="http://schemas.openxmlformats.org/drawingml/2006/main">
               <a:ext uri="{FF2B5EF4-FFF2-40B4-BE49-F238E27FC236}">
-                <a16:creationId xmlns:a16="http://schemas.microsoft.com/office/drawing/2014/main" id="{D82233D0-1F10-4EAB-ACD5-B4F4A51F20F5}"/>
+                <a16:creationId xmlns:a16="http://schemas.microsoft.com/office/drawing/2014/main" id="{E31B5C6D-D93C-4418-BA2F-F4ED3A07B9E0}"/>
               </a:ext>
             </a:extLst>
           </p:cNvPr>
@@ -6611,7 +6678,7 @@
           <p:cNvPr id="78" name="mgmt-body-2">
             <a:extLst xmlns:a="http://schemas.openxmlformats.org/drawingml/2006/main">
               <a:ext uri="{FF2B5EF4-FFF2-40B4-BE49-F238E27FC236}">
-                <a16:creationId xmlns:a16="http://schemas.microsoft.com/office/drawing/2014/main" id="{0062A4BE-8F01-4ACE-BC76-65A0C92AACEF}"/>
+                <a16:creationId xmlns:a16="http://schemas.microsoft.com/office/drawing/2014/main" id="{C3AFEF9B-7CB3-407B-BA92-AB46521011C5}"/>
               </a:ext>
             </a:extLst>
           </p:cNvPr>
@@ -6651,7 +6718,7 @@
                   <a:srgbClr val="CBD5E1"/>
                 </a:solidFill>
               </a:rPr>
-              <a:t>Perforce 기반 후보 빌드 통제</a:t>
+              <a:t>Perforce 기반 릴리즈 관리</a:t>
             </a:r>
           </a:p>
         </p:txBody>
@@ -6661,7 +6728,7 @@
           <p:cNvPr id="79" name="mgmt-card-3">
             <a:extLst xmlns:a="http://schemas.openxmlformats.org/drawingml/2006/main">
               <a:ext uri="{FF2B5EF4-FFF2-40B4-BE49-F238E27FC236}">
-                <a16:creationId xmlns:a16="http://schemas.microsoft.com/office/drawing/2014/main" id="{66013F89-EF7E-4898-8DBE-5992D6B0C742}"/>
+                <a16:creationId xmlns:a16="http://schemas.microsoft.com/office/drawing/2014/main" id="{C28F5A7E-C39A-4623-ACD1-2CEB3B2151F9}"/>
               </a:ext>
             </a:extLst>
           </p:cNvPr>
@@ -6696,7 +6763,7 @@
           <p:cNvPr id="80" name="mgmt-bar-3">
             <a:extLst xmlns:a="http://schemas.openxmlformats.org/drawingml/2006/main">
               <a:ext uri="{FF2B5EF4-FFF2-40B4-BE49-F238E27FC236}">
-                <a16:creationId xmlns:a16="http://schemas.microsoft.com/office/drawing/2014/main" id="{04C6820E-BA70-453F-B7ED-F7D9F728EF4F}"/>
+                <a16:creationId xmlns:a16="http://schemas.microsoft.com/office/drawing/2014/main" id="{94BD03DC-19C0-42CA-9D39-3DB7A6821EEA}"/>
               </a:ext>
             </a:extLst>
           </p:cNvPr>
@@ -6729,7 +6796,7 @@
           <p:cNvPr id="81" name="mgmt-label-3">
             <a:extLst xmlns:a="http://schemas.openxmlformats.org/drawingml/2006/main">
               <a:ext uri="{FF2B5EF4-FFF2-40B4-BE49-F238E27FC236}">
-                <a16:creationId xmlns:a16="http://schemas.microsoft.com/office/drawing/2014/main" id="{F44A9C6C-7453-49CF-A2B5-93D31C32F8B6}"/>
+                <a16:creationId xmlns:a16="http://schemas.microsoft.com/office/drawing/2014/main" id="{7712DA1C-365D-40E1-98FF-8AF89476048D}"/>
               </a:ext>
             </a:extLst>
           </p:cNvPr>
@@ -6779,7 +6846,7 @@
           <p:cNvPr id="82" name="mgmt-body-3">
             <a:extLst xmlns:a="http://schemas.openxmlformats.org/drawingml/2006/main">
               <a:ext uri="{FF2B5EF4-FFF2-40B4-BE49-F238E27FC236}">
-                <a16:creationId xmlns:a16="http://schemas.microsoft.com/office/drawing/2014/main" id="{0670FCB6-76ED-45BD-8F37-08C8F5AEFDC1}"/>
+                <a16:creationId xmlns:a16="http://schemas.microsoft.com/office/drawing/2014/main" id="{859373C5-3E2C-418E-A041-8539A06F2746}"/>
               </a:ext>
             </a:extLst>
           </p:cNvPr>
@@ -6819,7 +6886,7 @@
                   <a:srgbClr val="CBD5E1"/>
                 </a:solidFill>
               </a:rPr>
-              <a:t>결함 우선순위와 수정 반영 추적</a:t>
+              <a:t>이슈 대응과 수정 반영 추적</a:t>
             </a:r>
           </a:p>
         </p:txBody>
@@ -6829,7 +6896,7 @@
           <p:cNvPr id="83" name="mgmt-card-4">
             <a:extLst xmlns:a="http://schemas.openxmlformats.org/drawingml/2006/main">
               <a:ext uri="{FF2B5EF4-FFF2-40B4-BE49-F238E27FC236}">
-                <a16:creationId xmlns:a16="http://schemas.microsoft.com/office/drawing/2014/main" id="{AC32FC36-E2E9-465C-B4E9-E56D3B3CE28C}"/>
+                <a16:creationId xmlns:a16="http://schemas.microsoft.com/office/drawing/2014/main" id="{38309886-AD96-4069-9518-C8F8BDB30675}"/>
               </a:ext>
             </a:extLst>
           </p:cNvPr>
@@ -6864,7 +6931,7 @@
           <p:cNvPr id="84" name="mgmt-bar-4">
             <a:extLst xmlns:a="http://schemas.openxmlformats.org/drawingml/2006/main">
               <a:ext uri="{FF2B5EF4-FFF2-40B4-BE49-F238E27FC236}">
-                <a16:creationId xmlns:a16="http://schemas.microsoft.com/office/drawing/2014/main" id="{A0A98AAA-F63F-4B49-8517-8F1EF20D850D}"/>
+                <a16:creationId xmlns:a16="http://schemas.microsoft.com/office/drawing/2014/main" id="{AA81157C-7363-426F-9EDD-131193BABEC3}"/>
               </a:ext>
             </a:extLst>
           </p:cNvPr>
@@ -6897,7 +6964,7 @@
           <p:cNvPr id="85" name="mgmt-label-4">
             <a:extLst xmlns:a="http://schemas.openxmlformats.org/drawingml/2006/main">
               <a:ext uri="{FF2B5EF4-FFF2-40B4-BE49-F238E27FC236}">
-                <a16:creationId xmlns:a16="http://schemas.microsoft.com/office/drawing/2014/main" id="{DAD6C970-B201-402B-9545-3B5D986ACEE1}"/>
+                <a16:creationId xmlns:a16="http://schemas.microsoft.com/office/drawing/2014/main" id="{DBFE5DAB-C994-46F2-A9AD-043F20682AD2}"/>
               </a:ext>
             </a:extLst>
           </p:cNvPr>
@@ -6937,7 +7004,7 @@
                   <a:srgbClr val="FFFFFF"/>
                 </a:solidFill>
               </a:rPr>
-              <a:t>커뮤니케이션</a:t>
+              <a:t>퍼블리셔 대응</a:t>
             </a:r>
           </a:p>
         </p:txBody>
@@ -6947,7 +7014,7 @@
           <p:cNvPr id="86" name="mgmt-body-4">
             <a:extLst xmlns:a="http://schemas.openxmlformats.org/drawingml/2006/main">
               <a:ext uri="{FF2B5EF4-FFF2-40B4-BE49-F238E27FC236}">
-                <a16:creationId xmlns:a16="http://schemas.microsoft.com/office/drawing/2014/main" id="{A08A694A-A422-4068-896D-4D2B709EF470}"/>
+                <a16:creationId xmlns:a16="http://schemas.microsoft.com/office/drawing/2014/main" id="{94101F82-460A-4F56-88F6-E90530C4CC7C}"/>
               </a:ext>
             </a:extLst>
           </p:cNvPr>
@@ -6987,7 +7054,7 @@
                   <a:srgbClr val="CBD5E1"/>
                 </a:solidFill>
               </a:rPr>
-              <a:t>개발·QA·퍼블리셔 의사결정 정리</a:t>
+              <a:t>협업 이슈와 의사결정 정리</a:t>
             </a:r>
           </a:p>
         </p:txBody>
@@ -6995,7 +7062,7 @@
     </p:spTree>
     <p:extLst>
       <p:ext uri="{BB962C8B-B14F-4D97-AF65-F5344CB8AC3E}">
-        <p14:creationId xmlns:p14="http://schemas.microsoft.com/office/powerpoint/2010/main" val="58456663"/>
+        <p14:creationId xmlns:p14="http://schemas.microsoft.com/office/powerpoint/2010/main" val="1115964379"/>
       </p:ext>
     </p:extLst>
   </p:cSld>
@@ -7026,7 +7093,7 @@
           <p:cNvPr id="1" name="top-accent">
             <a:extLst xmlns:a="http://schemas.openxmlformats.org/drawingml/2006/main">
               <a:ext uri="{FF2B5EF4-FFF2-40B4-BE49-F238E27FC236}">
-                <a16:creationId xmlns:a16="http://schemas.microsoft.com/office/drawing/2014/main" id="{F2C4A980-4570-4BB2-A38C-0D91B067527C}"/>
+                <a16:creationId xmlns:a16="http://schemas.microsoft.com/office/drawing/2014/main" id="{D46B4306-9D20-4336-A531-1C1A6DDD207A}"/>
               </a:ext>
             </a:extLst>
           </p:cNvPr>
@@ -7059,7 +7126,7 @@
           <p:cNvPr id="2" name="left-accent">
             <a:extLst xmlns:a="http://schemas.openxmlformats.org/drawingml/2006/main">
               <a:ext uri="{FF2B5EF4-FFF2-40B4-BE49-F238E27FC236}">
-                <a16:creationId xmlns:a16="http://schemas.microsoft.com/office/drawing/2014/main" id="{EA1F300C-3F46-41A4-9832-75643A9E0554}"/>
+                <a16:creationId xmlns:a16="http://schemas.microsoft.com/office/drawing/2014/main" id="{B4128A05-B984-4621-A74D-131000CA0555}"/>
               </a:ext>
             </a:extLst>
           </p:cNvPr>
@@ -7092,7 +7159,7 @@
           <p:cNvPr id="3" name="eyebrow">
             <a:extLst xmlns:a="http://schemas.openxmlformats.org/drawingml/2006/main">
               <a:ext uri="{FF2B5EF4-FFF2-40B4-BE49-F238E27FC236}">
-                <a16:creationId xmlns:a16="http://schemas.microsoft.com/office/drawing/2014/main" id="{7D982622-6C19-49FE-A7AF-7BB7007F7CC7}"/>
+                <a16:creationId xmlns:a16="http://schemas.microsoft.com/office/drawing/2014/main" id="{F08CE8A8-C31D-40E9-87BC-6F2489414B9E}"/>
               </a:ext>
             </a:extLst>
           </p:cNvPr>
@@ -7142,7 +7209,7 @@
           <p:cNvPr id="4" name="footer">
             <a:extLst xmlns:a="http://schemas.openxmlformats.org/drawingml/2006/main">
               <a:ext uri="{FF2B5EF4-FFF2-40B4-BE49-F238E27FC236}">
-                <a16:creationId xmlns:a16="http://schemas.microsoft.com/office/drawing/2014/main" id="{B3B15104-419C-4A4E-B3B5-7AAB760ADB9E}"/>
+                <a16:creationId xmlns:a16="http://schemas.microsoft.com/office/drawing/2014/main" id="{B8C3D7A1-E0C2-49E1-901E-2FA76B0F45F9}"/>
               </a:ext>
             </a:extLst>
           </p:cNvPr>
@@ -7192,7 +7259,7 @@
           <p:cNvPr id="5" name="page-no">
             <a:extLst xmlns:a="http://schemas.openxmlformats.org/drawingml/2006/main">
               <a:ext uri="{FF2B5EF4-FFF2-40B4-BE49-F238E27FC236}">
-                <a16:creationId xmlns:a16="http://schemas.microsoft.com/office/drawing/2014/main" id="{D32EA220-CEB8-4865-93D5-4B1A5DAEE738}"/>
+                <a16:creationId xmlns:a16="http://schemas.microsoft.com/office/drawing/2014/main" id="{26EE5217-6495-42F4-BE93-F02CA7431E84}"/>
               </a:ext>
             </a:extLst>
           </p:cNvPr>
@@ -7242,7 +7309,7 @@
           <p:cNvPr id="6" name="title-03">
             <a:extLst xmlns:a="http://schemas.openxmlformats.org/drawingml/2006/main">
               <a:ext uri="{FF2B5EF4-FFF2-40B4-BE49-F238E27FC236}">
-                <a16:creationId xmlns:a16="http://schemas.microsoft.com/office/drawing/2014/main" id="{77BFF889-8ACA-4062-8395-E09342248453}"/>
+                <a16:creationId xmlns:a16="http://schemas.microsoft.com/office/drawing/2014/main" id="{E3099A91-2E26-4554-A522-2D8D935322F5}"/>
               </a:ext>
             </a:extLst>
           </p:cNvPr>
@@ -7282,7 +7349,7 @@
                   <a:srgbClr val="FFFFFF"/>
                 </a:solidFill>
               </a:rPr>
-              <a:t>런칭 게이트는 일정이 아니라 통과 기준으로 관리합니다</a:t>
+              <a:t>마일스톤은 일정이 아니라 통과 기준으로 관리합니다</a:t>
             </a:r>
           </a:p>
         </p:txBody>
@@ -7292,7 +7359,7 @@
           <p:cNvPr id="7" name="subtitle-03">
             <a:extLst xmlns:a="http://schemas.openxmlformats.org/drawingml/2006/main">
               <a:ext uri="{FF2B5EF4-FFF2-40B4-BE49-F238E27FC236}">
-                <a16:creationId xmlns:a16="http://schemas.microsoft.com/office/drawing/2014/main" id="{C1665073-6F92-4F61-B6CD-36448A6CFFD7}"/>
+                <a16:creationId xmlns:a16="http://schemas.microsoft.com/office/drawing/2014/main" id="{784D9ACE-EA34-4E9C-AC21-2865A4634388}"/>
               </a:ext>
             </a:extLst>
           </p:cNvPr>
@@ -7332,7 +7399,7 @@
                   <a:srgbClr val="CBD5E1"/>
                 </a:solidFill>
               </a:rPr>
-              <a:t>월별 일정표만으로는 리스크가 숨기 쉽기 때문에, 범위·빌드·QA·검수 기준을 게이트로 묶어 판정합니다.</a:t>
+              <a:t>월별 일정표만으로는 리스크가 숨기 쉽기 때문에, 범위·빌드·버전·QA·퍼블리셔 기준을 함께 판정합니다.</a:t>
             </a:r>
           </a:p>
         </p:txBody>
@@ -7342,7 +7409,7 @@
           <p:cNvPr id="8" name="gate-section-title">
             <a:extLst xmlns:a="http://schemas.openxmlformats.org/drawingml/2006/main">
               <a:ext uri="{FF2B5EF4-FFF2-40B4-BE49-F238E27FC236}">
-                <a16:creationId xmlns:a16="http://schemas.microsoft.com/office/drawing/2014/main" id="{0FE4A4AF-373E-4940-BB4C-7F4C74238DA1}"/>
+                <a16:creationId xmlns:a16="http://schemas.microsoft.com/office/drawing/2014/main" id="{FDA28168-CCF0-4E29-9B23-022E05A5A742}"/>
               </a:ext>
             </a:extLst>
           </p:cNvPr>
@@ -7392,7 +7459,7 @@
           <p:cNvPr id="9" name="gate-card-1">
             <a:extLst xmlns:a="http://schemas.openxmlformats.org/drawingml/2006/main">
               <a:ext uri="{FF2B5EF4-FFF2-40B4-BE49-F238E27FC236}">
-                <a16:creationId xmlns:a16="http://schemas.microsoft.com/office/drawing/2014/main" id="{B3111E65-678B-433B-AF3A-81F7AA7B5A4B}"/>
+                <a16:creationId xmlns:a16="http://schemas.microsoft.com/office/drawing/2014/main" id="{7D19993D-E6B5-4344-926F-984B6D27425F}"/>
               </a:ext>
             </a:extLst>
           </p:cNvPr>
@@ -7427,7 +7494,7 @@
           <p:cNvPr id="10" name="gate-bar-1">
             <a:extLst xmlns:a="http://schemas.openxmlformats.org/drawingml/2006/main">
               <a:ext uri="{FF2B5EF4-FFF2-40B4-BE49-F238E27FC236}">
-                <a16:creationId xmlns:a16="http://schemas.microsoft.com/office/drawing/2014/main" id="{8A8850C3-9CB2-4977-AB96-79633811AB4D}"/>
+                <a16:creationId xmlns:a16="http://schemas.microsoft.com/office/drawing/2014/main" id="{46F831CF-0307-4F61-92A8-AE2B682C8730}"/>
               </a:ext>
             </a:extLst>
           </p:cNvPr>
@@ -7460,7 +7527,7 @@
           <p:cNvPr id="11" name="gate-phase-1">
             <a:extLst xmlns:a="http://schemas.openxmlformats.org/drawingml/2006/main">
               <a:ext uri="{FF2B5EF4-FFF2-40B4-BE49-F238E27FC236}">
-                <a16:creationId xmlns:a16="http://schemas.microsoft.com/office/drawing/2014/main" id="{84DD06CD-8B5F-4273-A5B5-179DED53871A}"/>
+                <a16:creationId xmlns:a16="http://schemas.microsoft.com/office/drawing/2014/main" id="{FC19F9D9-955D-46BF-B655-09CF7BE27047}"/>
               </a:ext>
             </a:extLst>
           </p:cNvPr>
@@ -7510,7 +7577,7 @@
           <p:cNvPr id="12" name="gate-title-1">
             <a:extLst xmlns:a="http://schemas.openxmlformats.org/drawingml/2006/main">
               <a:ext uri="{FF2B5EF4-FFF2-40B4-BE49-F238E27FC236}">
-                <a16:creationId xmlns:a16="http://schemas.microsoft.com/office/drawing/2014/main" id="{766CF535-C27B-4F6D-8F4A-D7D4A956B04B}"/>
+                <a16:creationId xmlns:a16="http://schemas.microsoft.com/office/drawing/2014/main" id="{27F803DD-0952-4D72-861C-F7F5AE048CFE}"/>
               </a:ext>
             </a:extLst>
           </p:cNvPr>
@@ -7560,7 +7627,7 @@
           <p:cNvPr id="13" name="gate-body-1">
             <a:extLst xmlns:a="http://schemas.openxmlformats.org/drawingml/2006/main">
               <a:ext uri="{FF2B5EF4-FFF2-40B4-BE49-F238E27FC236}">
-                <a16:creationId xmlns:a16="http://schemas.microsoft.com/office/drawing/2014/main" id="{EF0C9AD2-35DA-4C63-AE64-E7ADD496D969}"/>
+                <a16:creationId xmlns:a16="http://schemas.microsoft.com/office/drawing/2014/main" id="{D6E41A6B-72B9-4140-9002-ED8F685FFCC2}"/>
               </a:ext>
             </a:extLst>
           </p:cNvPr>
@@ -7600,7 +7667,7 @@
                   <a:srgbClr val="CBD5E1"/>
                 </a:solidFill>
               </a:rPr>
-              <a:t>일본 서비스 범위와 콘텐츠 기준을 확정하고, 변경 요청은 영향도 검토 후 반영합니다.</a:t>
+              <a:t>일본 서비스 범위와 마일스톤 기준을 확정하고, 변경 요청은 영향도 검토 후 반영합니다.</a:t>
             </a:r>
           </a:p>
         </p:txBody>
@@ -7610,7 +7677,7 @@
           <p:cNvPr id="14" name="gate-card-2">
             <a:extLst xmlns:a="http://schemas.openxmlformats.org/drawingml/2006/main">
               <a:ext uri="{FF2B5EF4-FFF2-40B4-BE49-F238E27FC236}">
-                <a16:creationId xmlns:a16="http://schemas.microsoft.com/office/drawing/2014/main" id="{3DE61C86-46EA-49A1-BE79-8C6EC96BDC57}"/>
+                <a16:creationId xmlns:a16="http://schemas.microsoft.com/office/drawing/2014/main" id="{A3AE2984-59B3-4320-85BF-DFB52EE9025B}"/>
               </a:ext>
             </a:extLst>
           </p:cNvPr>
@@ -7645,7 +7712,7 @@
           <p:cNvPr id="15" name="gate-bar-2">
             <a:extLst xmlns:a="http://schemas.openxmlformats.org/drawingml/2006/main">
               <a:ext uri="{FF2B5EF4-FFF2-40B4-BE49-F238E27FC236}">
-                <a16:creationId xmlns:a16="http://schemas.microsoft.com/office/drawing/2014/main" id="{308BA253-CF53-40C9-B876-518D53FF1B0A}"/>
+                <a16:creationId xmlns:a16="http://schemas.microsoft.com/office/drawing/2014/main" id="{FA8AD2D0-EEBE-4F9D-9DF4-E42660FEDB7B}"/>
               </a:ext>
             </a:extLst>
           </p:cNvPr>
@@ -7678,7 +7745,7 @@
           <p:cNvPr id="16" name="gate-phase-2">
             <a:extLst xmlns:a="http://schemas.openxmlformats.org/drawingml/2006/main">
               <a:ext uri="{FF2B5EF4-FFF2-40B4-BE49-F238E27FC236}">
-                <a16:creationId xmlns:a16="http://schemas.microsoft.com/office/drawing/2014/main" id="{CADFB0A6-10B6-4B08-9175-22D85E22B330}"/>
+                <a16:creationId xmlns:a16="http://schemas.microsoft.com/office/drawing/2014/main" id="{6C444459-AF88-4266-8B2F-CDAF117C7DC4}"/>
               </a:ext>
             </a:extLst>
           </p:cNvPr>
@@ -7728,7 +7795,7 @@
           <p:cNvPr id="17" name="gate-title-2">
             <a:extLst xmlns:a="http://schemas.openxmlformats.org/drawingml/2006/main">
               <a:ext uri="{FF2B5EF4-FFF2-40B4-BE49-F238E27FC236}">
-                <a16:creationId xmlns:a16="http://schemas.microsoft.com/office/drawing/2014/main" id="{7227540E-5488-441E-8B8D-D2D4E3BD7DF6}"/>
+                <a16:creationId xmlns:a16="http://schemas.microsoft.com/office/drawing/2014/main" id="{F2E6CAC6-313C-43C1-858A-E18C2CC72588}"/>
               </a:ext>
             </a:extLst>
           </p:cNvPr>
@@ -7768,7 +7835,7 @@
                   <a:srgbClr val="FFFFFF"/>
                 </a:solidFill>
               </a:rPr>
-              <a:t>검수 진입</a:t>
+              <a:t>QA·검수 진입</a:t>
             </a:r>
           </a:p>
         </p:txBody>
@@ -7778,7 +7845,7 @@
           <p:cNvPr id="18" name="gate-body-2">
             <a:extLst xmlns:a="http://schemas.openxmlformats.org/drawingml/2006/main">
               <a:ext uri="{FF2B5EF4-FFF2-40B4-BE49-F238E27FC236}">
-                <a16:creationId xmlns:a16="http://schemas.microsoft.com/office/drawing/2014/main" id="{4F9E845A-59D7-49F2-BEDB-FE5B7E20BF67}"/>
+                <a16:creationId xmlns:a16="http://schemas.microsoft.com/office/drawing/2014/main" id="{25422143-0984-4043-AD06-5BBF28838B20}"/>
               </a:ext>
             </a:extLst>
           </p:cNvPr>
@@ -7818,7 +7885,7 @@
                   <a:srgbClr val="CBD5E1"/>
                 </a:solidFill>
               </a:rPr>
-              <a:t>현지화 리소스와 주요 기능 반영 상태를 확인한 뒤 내부 QA와 퍼블리셔 검수에 진입합니다.</a:t>
+              <a:t>현지화 리소스와 빌드 반영 상태를 확인한 뒤 QA와 퍼블리셔 검수에 진입합니다.</a:t>
             </a:r>
           </a:p>
         </p:txBody>
@@ -7828,7 +7895,7 @@
           <p:cNvPr id="19" name="gate-card-3">
             <a:extLst xmlns:a="http://schemas.openxmlformats.org/drawingml/2006/main">
               <a:ext uri="{FF2B5EF4-FFF2-40B4-BE49-F238E27FC236}">
-                <a16:creationId xmlns:a16="http://schemas.microsoft.com/office/drawing/2014/main" id="{A5A89A7E-5FCA-41DC-9187-1D00D84EEB4D}"/>
+                <a16:creationId xmlns:a16="http://schemas.microsoft.com/office/drawing/2014/main" id="{B7F809EA-C6B0-4117-882B-476B2BA41A0D}"/>
               </a:ext>
             </a:extLst>
           </p:cNvPr>
@@ -7863,7 +7930,7 @@
           <p:cNvPr id="20" name="gate-bar-3">
             <a:extLst xmlns:a="http://schemas.openxmlformats.org/drawingml/2006/main">
               <a:ext uri="{FF2B5EF4-FFF2-40B4-BE49-F238E27FC236}">
-                <a16:creationId xmlns:a16="http://schemas.microsoft.com/office/drawing/2014/main" id="{E1475169-C584-4153-9783-4EB14A53593B}"/>
+                <a16:creationId xmlns:a16="http://schemas.microsoft.com/office/drawing/2014/main" id="{5BFE7A5F-F0F4-4950-B8F0-20139CDA088A}"/>
               </a:ext>
             </a:extLst>
           </p:cNvPr>
@@ -7896,7 +7963,7 @@
           <p:cNvPr id="21" name="gate-phase-3">
             <a:extLst xmlns:a="http://schemas.openxmlformats.org/drawingml/2006/main">
               <a:ext uri="{FF2B5EF4-FFF2-40B4-BE49-F238E27FC236}">
-                <a16:creationId xmlns:a16="http://schemas.microsoft.com/office/drawing/2014/main" id="{BBFD7033-5848-4B76-B68F-AB55B36F5916}"/>
+                <a16:creationId xmlns:a16="http://schemas.microsoft.com/office/drawing/2014/main" id="{1EBE3083-D550-451F-990A-0DE78BCE00DF}"/>
               </a:ext>
             </a:extLst>
           </p:cNvPr>
@@ -7946,7 +8013,7 @@
           <p:cNvPr id="22" name="gate-title-3">
             <a:extLst xmlns:a="http://schemas.openxmlformats.org/drawingml/2006/main">
               <a:ext uri="{FF2B5EF4-FFF2-40B4-BE49-F238E27FC236}">
-                <a16:creationId xmlns:a16="http://schemas.microsoft.com/office/drawing/2014/main" id="{F6027F08-AAD3-4A8F-9909-9F83CA3EF5D2}"/>
+                <a16:creationId xmlns:a16="http://schemas.microsoft.com/office/drawing/2014/main" id="{3EA761F6-CCC0-4DCC-866F-9B1D229D0706}"/>
               </a:ext>
             </a:extLst>
           </p:cNvPr>
@@ -7986,7 +8053,7 @@
                   <a:srgbClr val="FFFFFF"/>
                 </a:solidFill>
               </a:rPr>
-              <a:t>런칭 후보</a:t>
+              <a:t>릴리즈 후보</a:t>
             </a:r>
           </a:p>
         </p:txBody>
@@ -7996,7 +8063,7 @@
           <p:cNvPr id="23" name="gate-body-3">
             <a:extLst xmlns:a="http://schemas.openxmlformats.org/drawingml/2006/main">
               <a:ext uri="{FF2B5EF4-FFF2-40B4-BE49-F238E27FC236}">
-                <a16:creationId xmlns:a16="http://schemas.microsoft.com/office/drawing/2014/main" id="{A7C0D76F-0114-47D7-8A81-9F83B6DE3C4B}"/>
+                <a16:creationId xmlns:a16="http://schemas.microsoft.com/office/drawing/2014/main" id="{6CD3FBE4-73F7-41E5-980E-88B634501656}"/>
               </a:ext>
             </a:extLst>
           </p:cNvPr>
@@ -8036,7 +8103,7 @@
                   <a:srgbClr val="CBD5E1"/>
                 </a:solidFill>
               </a:rPr>
-              <a:t>치명 이슈와 잔여 리스크를 분리하고, 배포 가능한 후보 빌드 기준을 고정합니다.</a:t>
+              <a:t>주요 이슈와 잔여 리스크를 분리하고, 배포 가능한 후보 빌드 기준을 고정합니다.</a:t>
             </a:r>
           </a:p>
         </p:txBody>
@@ -8046,7 +8113,7 @@
           <p:cNvPr id="24" name="decision-title">
             <a:extLst xmlns:a="http://schemas.openxmlformats.org/drawingml/2006/main">
               <a:ext uri="{FF2B5EF4-FFF2-40B4-BE49-F238E27FC236}">
-                <a16:creationId xmlns:a16="http://schemas.microsoft.com/office/drawing/2014/main" id="{6D530ED2-89A2-475C-8FDB-9DB6A9222A9A}"/>
+                <a16:creationId xmlns:a16="http://schemas.microsoft.com/office/drawing/2014/main" id="{91BE98DA-DC8E-4009-B02C-74B589B9AF54}"/>
               </a:ext>
             </a:extLst>
           </p:cNvPr>
@@ -8096,7 +8163,7 @@
           <p:cNvPr id="25" name="decision-note">
             <a:extLst xmlns:a="http://schemas.openxmlformats.org/drawingml/2006/main">
               <a:ext uri="{FF2B5EF4-FFF2-40B4-BE49-F238E27FC236}">
-                <a16:creationId xmlns:a16="http://schemas.microsoft.com/office/drawing/2014/main" id="{39536B98-6D8E-4AE8-B165-087F2FB13BC8}"/>
+                <a16:creationId xmlns:a16="http://schemas.microsoft.com/office/drawing/2014/main" id="{FC2CAF70-273B-4045-8C06-94AD914701D6}"/>
               </a:ext>
             </a:extLst>
           </p:cNvPr>
@@ -8136,7 +8203,7 @@
                   <a:srgbClr val="94A3B8"/>
                 </a:solidFill>
               </a:rPr>
-              <a:t>각 항목은 완료 여부보다 다음 단계 진입 가능성을 기준으로 판단합니다.</a:t>
+              <a:t>각 항목은 다음 단계 진입 가능성을 기준으로 판단합니다.</a:t>
             </a:r>
           </a:p>
         </p:txBody>
@@ -8146,7 +8213,7 @@
           <p:cNvPr id="26" name="decision-header">
             <a:extLst xmlns:a="http://schemas.openxmlformats.org/drawingml/2006/main">
               <a:ext uri="{FF2B5EF4-FFF2-40B4-BE49-F238E27FC236}">
-                <a16:creationId xmlns:a16="http://schemas.microsoft.com/office/drawing/2014/main" id="{41D2B7DA-1D40-4D79-8371-8EAD20001EFB}"/>
+                <a16:creationId xmlns:a16="http://schemas.microsoft.com/office/drawing/2014/main" id="{C063CA54-1701-4D04-B059-83D47151CFA2}"/>
               </a:ext>
             </a:extLst>
           </p:cNvPr>
@@ -8179,7 +8246,7 @@
           <p:cNvPr id="27" name="decision-th-1">
             <a:extLst xmlns:a="http://schemas.openxmlformats.org/drawingml/2006/main">
               <a:ext uri="{FF2B5EF4-FFF2-40B4-BE49-F238E27FC236}">
-                <a16:creationId xmlns:a16="http://schemas.microsoft.com/office/drawing/2014/main" id="{5CE88542-8D22-4C90-B2B6-4E7E14F4B53E}"/>
+                <a16:creationId xmlns:a16="http://schemas.microsoft.com/office/drawing/2014/main" id="{B3C1901D-32D8-4B40-87D3-21D9037CC815}"/>
               </a:ext>
             </a:extLst>
           </p:cNvPr>
@@ -8229,7 +8296,7 @@
           <p:cNvPr id="28" name="decision-th-2">
             <a:extLst xmlns:a="http://schemas.openxmlformats.org/drawingml/2006/main">
               <a:ext uri="{FF2B5EF4-FFF2-40B4-BE49-F238E27FC236}">
-                <a16:creationId xmlns:a16="http://schemas.microsoft.com/office/drawing/2014/main" id="{76B20F2D-CE05-4AFA-B6CD-C63C544C76A1}"/>
+                <a16:creationId xmlns:a16="http://schemas.microsoft.com/office/drawing/2014/main" id="{45A0327C-AB85-4FCC-A1AE-EECEAEBABD26}"/>
               </a:ext>
             </a:extLst>
           </p:cNvPr>
@@ -8279,7 +8346,7 @@
           <p:cNvPr id="29" name="decision-th-3">
             <a:extLst xmlns:a="http://schemas.openxmlformats.org/drawingml/2006/main">
               <a:ext uri="{FF2B5EF4-FFF2-40B4-BE49-F238E27FC236}">
-                <a16:creationId xmlns:a16="http://schemas.microsoft.com/office/drawing/2014/main" id="{C86BD559-5D48-4873-A243-398D5833D104}"/>
+                <a16:creationId xmlns:a16="http://schemas.microsoft.com/office/drawing/2014/main" id="{BBD47427-C55A-4E20-9C9B-2BFBB2DBAC1F}"/>
               </a:ext>
             </a:extLst>
           </p:cNvPr>
@@ -8329,7 +8396,7 @@
           <p:cNvPr id="30" name="decision-row-1">
             <a:extLst xmlns:a="http://schemas.openxmlformats.org/drawingml/2006/main">
               <a:ext uri="{FF2B5EF4-FFF2-40B4-BE49-F238E27FC236}">
-                <a16:creationId xmlns:a16="http://schemas.microsoft.com/office/drawing/2014/main" id="{F8AE3080-F1FF-4475-9C7D-CC5961266049}"/>
+                <a16:creationId xmlns:a16="http://schemas.microsoft.com/office/drawing/2014/main" id="{3ED38D39-8961-47AC-A7FF-98E31DD4EB42}"/>
               </a:ext>
             </a:extLst>
           </p:cNvPr>
@@ -8362,7 +8429,7 @@
           <p:cNvPr id="31" name="decision-item-1">
             <a:extLst xmlns:a="http://schemas.openxmlformats.org/drawingml/2006/main">
               <a:ext uri="{FF2B5EF4-FFF2-40B4-BE49-F238E27FC236}">
-                <a16:creationId xmlns:a16="http://schemas.microsoft.com/office/drawing/2014/main" id="{93AF291A-E5D6-4568-B24F-32EE68EDC51D}"/>
+                <a16:creationId xmlns:a16="http://schemas.microsoft.com/office/drawing/2014/main" id="{3B808020-5681-4F4B-A862-31BD16C2E99B}"/>
               </a:ext>
             </a:extLst>
           </p:cNvPr>
@@ -8412,47 +8479,47 @@
           <p:cNvPr id="32" name="decision-gate-1">
             <a:extLst xmlns:a="http://schemas.openxmlformats.org/drawingml/2006/main">
               <a:ext uri="{FF2B5EF4-FFF2-40B4-BE49-F238E27FC236}">
-                <a16:creationId xmlns:a16="http://schemas.microsoft.com/office/drawing/2014/main" id="{F0A265BB-77A5-4636-AE83-9CC6FF767A5F}"/>
-              </a:ext>
-            </a:extLst>
-          </p:cNvPr>
-          <p:cNvSpPr>
-            <a:spLocks xmlns:a="http://schemas.openxmlformats.org/drawingml/2006/main" noGrp="1"/>
-          </p:cNvSpPr>
-          <p:nvPr/>
-        </p:nvSpPr>
-        <p:spPr>
-          <a:xfrm xmlns:a="http://schemas.openxmlformats.org/drawingml/2006/main">
-            <a:off x="6934200" y="2581275"/>
-            <a:ext cx="2857500" cy="285750"/>
-          </a:xfrm>
-          <a:prstGeom xmlns:a="http://schemas.openxmlformats.org/drawingml/2006/main" prst="rect">
-            <a:avLst/>
-          </a:prstGeom>
-          <a:noFill xmlns:a="http://schemas.openxmlformats.org/drawingml/2006/main"/>
-          <a:ln xmlns:a="http://schemas.openxmlformats.org/drawingml/2006/main" w="0">
-            <a:noFill/>
-            <a:prstDash val="solid"/>
-          </a:ln>
-        </p:spPr>
-        <p:txBody>
-          <a:bodyPr xmlns:a="http://schemas.openxmlformats.org/drawingml/2006/main"/>
-          <a:lstStyle xmlns:a="http://schemas.openxmlformats.org/drawingml/2006/main"/>
-          <a:p xmlns:a="http://schemas.openxmlformats.org/drawingml/2006/main">
-            <a:pPr>
-              <a:defRPr sz="1050">
+                <a16:creationId xmlns:a16="http://schemas.microsoft.com/office/drawing/2014/main" id="{EB88E084-E2CB-4FC1-BBCF-BF9209CB4F1D}"/>
+              </a:ext>
+            </a:extLst>
+          </p:cNvPr>
+          <p:cNvSpPr>
+            <a:spLocks xmlns:a="http://schemas.openxmlformats.org/drawingml/2006/main" noGrp="1"/>
+          </p:cNvSpPr>
+          <p:nvPr/>
+        </p:nvSpPr>
+        <p:spPr>
+          <a:xfrm xmlns:a="http://schemas.openxmlformats.org/drawingml/2006/main">
+            <a:off x="6934200" y="2571750"/>
+            <a:ext cx="2857500" cy="323850"/>
+          </a:xfrm>
+          <a:prstGeom xmlns:a="http://schemas.openxmlformats.org/drawingml/2006/main" prst="rect">
+            <a:avLst/>
+          </a:prstGeom>
+          <a:noFill xmlns:a="http://schemas.openxmlformats.org/drawingml/2006/main"/>
+          <a:ln xmlns:a="http://schemas.openxmlformats.org/drawingml/2006/main" w="0">
+            <a:noFill/>
+            <a:prstDash val="solid"/>
+          </a:ln>
+        </p:spPr>
+        <p:txBody>
+          <a:bodyPr xmlns:a="http://schemas.openxmlformats.org/drawingml/2006/main"/>
+          <a:lstStyle xmlns:a="http://schemas.openxmlformats.org/drawingml/2006/main"/>
+          <a:p xmlns:a="http://schemas.openxmlformats.org/drawingml/2006/main">
+            <a:pPr>
+              <a:defRPr sz="1013">
                 <a:solidFill>
                   <a:srgbClr val="FFFFFF"/>
                 </a:solidFill>
               </a:defRPr>
             </a:pPr>
             <a:r>
-              <a:rPr sz="1050">
+              <a:rPr sz="1013">
                 <a:solidFill>
                   <a:srgbClr val="FFFFFF"/>
                 </a:solidFill>
               </a:rPr>
-              <a:t>런칭 포함·제외 콘텐츠와 변경 승인 기준 확정</a:t>
+              <a:t>런칭 포함·제외 범위와 변경 승인 기준 확정</a:t>
             </a:r>
           </a:p>
         </p:txBody>
@@ -8462,7 +8529,7 @@
           <p:cNvPr id="33" name="decision-owner-1">
             <a:extLst xmlns:a="http://schemas.openxmlformats.org/drawingml/2006/main">
               <a:ext uri="{FF2B5EF4-FFF2-40B4-BE49-F238E27FC236}">
-                <a16:creationId xmlns:a16="http://schemas.microsoft.com/office/drawing/2014/main" id="{DB90D8E3-911E-42ED-B905-1D757A23A4AA}"/>
+                <a16:creationId xmlns:a16="http://schemas.microsoft.com/office/drawing/2014/main" id="{5EA37DA0-39F0-4B80-98A6-BAAE1391A657}"/>
               </a:ext>
             </a:extLst>
           </p:cNvPr>
@@ -8512,7 +8579,7 @@
           <p:cNvPr id="34" name="decision-row-2">
             <a:extLst xmlns:a="http://schemas.openxmlformats.org/drawingml/2006/main">
               <a:ext uri="{FF2B5EF4-FFF2-40B4-BE49-F238E27FC236}">
-                <a16:creationId xmlns:a16="http://schemas.microsoft.com/office/drawing/2014/main" id="{DA00C44D-5B34-446A-B3AE-29F6B3F684D2}"/>
+                <a16:creationId xmlns:a16="http://schemas.microsoft.com/office/drawing/2014/main" id="{7E765816-370C-497A-86E7-36371D74BF0A}"/>
               </a:ext>
             </a:extLst>
           </p:cNvPr>
@@ -8545,7 +8612,7 @@
           <p:cNvPr id="35" name="decision-item-2">
             <a:extLst xmlns:a="http://schemas.openxmlformats.org/drawingml/2006/main">
               <a:ext uri="{FF2B5EF4-FFF2-40B4-BE49-F238E27FC236}">
-                <a16:creationId xmlns:a16="http://schemas.microsoft.com/office/drawing/2014/main" id="{E3760915-D434-4E8B-AEAE-A1E1D56F976E}"/>
+                <a16:creationId xmlns:a16="http://schemas.microsoft.com/office/drawing/2014/main" id="{1313EDB3-5DB0-420E-9239-35D5648E257A}"/>
               </a:ext>
             </a:extLst>
           </p:cNvPr>
@@ -8585,7 +8652,7 @@
                   <a:srgbClr val="FF6B35"/>
                 </a:solidFill>
               </a:rPr>
-              <a:t>빌드 기준</a:t>
+              <a:t>빌드·버전</a:t>
             </a:r>
           </a:p>
         </p:txBody>
@@ -8595,47 +8662,47 @@
           <p:cNvPr id="36" name="decision-gate-2">
             <a:extLst xmlns:a="http://schemas.openxmlformats.org/drawingml/2006/main">
               <a:ext uri="{FF2B5EF4-FFF2-40B4-BE49-F238E27FC236}">
-                <a16:creationId xmlns:a16="http://schemas.microsoft.com/office/drawing/2014/main" id="{81E81F00-9AF0-43DB-9D93-F1215693AD5A}"/>
-              </a:ext>
-            </a:extLst>
-          </p:cNvPr>
-          <p:cNvSpPr>
-            <a:spLocks xmlns:a="http://schemas.openxmlformats.org/drawingml/2006/main" noGrp="1"/>
-          </p:cNvSpPr>
-          <p:nvPr/>
-        </p:nvSpPr>
-        <p:spPr>
-          <a:xfrm xmlns:a="http://schemas.openxmlformats.org/drawingml/2006/main">
-            <a:off x="6934200" y="3133725"/>
-            <a:ext cx="2857500" cy="285750"/>
-          </a:xfrm>
-          <a:prstGeom xmlns:a="http://schemas.openxmlformats.org/drawingml/2006/main" prst="rect">
-            <a:avLst/>
-          </a:prstGeom>
-          <a:noFill xmlns:a="http://schemas.openxmlformats.org/drawingml/2006/main"/>
-          <a:ln xmlns:a="http://schemas.openxmlformats.org/drawingml/2006/main" w="0">
-            <a:noFill/>
-            <a:prstDash val="solid"/>
-          </a:ln>
-        </p:spPr>
-        <p:txBody>
-          <a:bodyPr xmlns:a="http://schemas.openxmlformats.org/drawingml/2006/main"/>
-          <a:lstStyle xmlns:a="http://schemas.openxmlformats.org/drawingml/2006/main"/>
-          <a:p xmlns:a="http://schemas.openxmlformats.org/drawingml/2006/main">
-            <a:pPr>
-              <a:defRPr sz="1050">
+                <a16:creationId xmlns:a16="http://schemas.microsoft.com/office/drawing/2014/main" id="{EBED3E62-5C3F-44F3-B31D-188CFDDD7AE0}"/>
+              </a:ext>
+            </a:extLst>
+          </p:cNvPr>
+          <p:cNvSpPr>
+            <a:spLocks xmlns:a="http://schemas.openxmlformats.org/drawingml/2006/main" noGrp="1"/>
+          </p:cNvSpPr>
+          <p:nvPr/>
+        </p:nvSpPr>
+        <p:spPr>
+          <a:xfrm xmlns:a="http://schemas.openxmlformats.org/drawingml/2006/main">
+            <a:off x="6934200" y="3124200"/>
+            <a:ext cx="2857500" cy="323850"/>
+          </a:xfrm>
+          <a:prstGeom xmlns:a="http://schemas.openxmlformats.org/drawingml/2006/main" prst="rect">
+            <a:avLst/>
+          </a:prstGeom>
+          <a:noFill xmlns:a="http://schemas.openxmlformats.org/drawingml/2006/main"/>
+          <a:ln xmlns:a="http://schemas.openxmlformats.org/drawingml/2006/main" w="0">
+            <a:noFill/>
+            <a:prstDash val="solid"/>
+          </a:ln>
+        </p:spPr>
+        <p:txBody>
+          <a:bodyPr xmlns:a="http://schemas.openxmlformats.org/drawingml/2006/main"/>
+          <a:lstStyle xmlns:a="http://schemas.openxmlformats.org/drawingml/2006/main"/>
+          <a:p xmlns:a="http://schemas.openxmlformats.org/drawingml/2006/main">
+            <a:pPr>
+              <a:defRPr sz="1013">
                 <a:solidFill>
                   <a:srgbClr val="FFFFFF"/>
                 </a:solidFill>
               </a:defRPr>
             </a:pPr>
             <a:r>
-              <a:rPr sz="1050">
+              <a:rPr sz="1013">
                 <a:solidFill>
                   <a:srgbClr val="FFFFFF"/>
                 </a:solidFill>
               </a:rPr>
-              <a:t>Perforce 브랜치와 후보 빌드 태그 운영 기준 합의</a:t>
+              <a:t>Perforce 브랜치와 후보 빌드 태그 기준 합의</a:t>
             </a:r>
           </a:p>
         </p:txBody>
@@ -8645,7 +8712,7 @@
           <p:cNvPr id="37" name="decision-owner-2">
             <a:extLst xmlns:a="http://schemas.openxmlformats.org/drawingml/2006/main">
               <a:ext uri="{FF2B5EF4-FFF2-40B4-BE49-F238E27FC236}">
-                <a16:creationId xmlns:a16="http://schemas.microsoft.com/office/drawing/2014/main" id="{DA9AC35A-733C-4589-8D2E-A846E6E651D9}"/>
+                <a16:creationId xmlns:a16="http://schemas.microsoft.com/office/drawing/2014/main" id="{ED943F7E-2499-4806-872C-44A48CD45DA3}"/>
               </a:ext>
             </a:extLst>
           </p:cNvPr>
@@ -8695,7 +8762,7 @@
           <p:cNvPr id="38" name="decision-row-3">
             <a:extLst xmlns:a="http://schemas.openxmlformats.org/drawingml/2006/main">
               <a:ext uri="{FF2B5EF4-FFF2-40B4-BE49-F238E27FC236}">
-                <a16:creationId xmlns:a16="http://schemas.microsoft.com/office/drawing/2014/main" id="{5487862A-C0BE-4868-B70E-AFBCFC8549E3}"/>
+                <a16:creationId xmlns:a16="http://schemas.microsoft.com/office/drawing/2014/main" id="{133B6815-F68D-48EA-B870-1A8AACDD5CC8}"/>
               </a:ext>
             </a:extLst>
           </p:cNvPr>
@@ -8728,7 +8795,7 @@
           <p:cNvPr id="39" name="decision-item-3">
             <a:extLst xmlns:a="http://schemas.openxmlformats.org/drawingml/2006/main">
               <a:ext uri="{FF2B5EF4-FFF2-40B4-BE49-F238E27FC236}">
-                <a16:creationId xmlns:a16="http://schemas.microsoft.com/office/drawing/2014/main" id="{FDFE9D2A-B567-4244-BC99-56FB30F512A5}"/>
+                <a16:creationId xmlns:a16="http://schemas.microsoft.com/office/drawing/2014/main" id="{E75F62CA-379B-4333-A928-B0FBA23063B7}"/>
               </a:ext>
             </a:extLst>
           </p:cNvPr>
@@ -8778,47 +8845,47 @@
           <p:cNvPr id="40" name="decision-gate-3">
             <a:extLst xmlns:a="http://schemas.openxmlformats.org/drawingml/2006/main">
               <a:ext uri="{FF2B5EF4-FFF2-40B4-BE49-F238E27FC236}">
-                <a16:creationId xmlns:a16="http://schemas.microsoft.com/office/drawing/2014/main" id="{C30CBF68-52F3-422D-8E49-F3D8A1CD4407}"/>
-              </a:ext>
-            </a:extLst>
-          </p:cNvPr>
-          <p:cNvSpPr>
-            <a:spLocks xmlns:a="http://schemas.openxmlformats.org/drawingml/2006/main" noGrp="1"/>
-          </p:cNvSpPr>
-          <p:nvPr/>
-        </p:nvSpPr>
-        <p:spPr>
-          <a:xfrm xmlns:a="http://schemas.openxmlformats.org/drawingml/2006/main">
-            <a:off x="6934200" y="3686175"/>
-            <a:ext cx="2857500" cy="285750"/>
-          </a:xfrm>
-          <a:prstGeom xmlns:a="http://schemas.openxmlformats.org/drawingml/2006/main" prst="rect">
-            <a:avLst/>
-          </a:prstGeom>
-          <a:noFill xmlns:a="http://schemas.openxmlformats.org/drawingml/2006/main"/>
-          <a:ln xmlns:a="http://schemas.openxmlformats.org/drawingml/2006/main" w="0">
-            <a:noFill/>
-            <a:prstDash val="solid"/>
-          </a:ln>
-        </p:spPr>
-        <p:txBody>
-          <a:bodyPr xmlns:a="http://schemas.openxmlformats.org/drawingml/2006/main"/>
-          <a:lstStyle xmlns:a="http://schemas.openxmlformats.org/drawingml/2006/main"/>
-          <a:p xmlns:a="http://schemas.openxmlformats.org/drawingml/2006/main">
-            <a:pPr>
-              <a:defRPr sz="1050">
+                <a16:creationId xmlns:a16="http://schemas.microsoft.com/office/drawing/2014/main" id="{35D48100-3790-4EC2-AEFA-0C477444A252}"/>
+              </a:ext>
+            </a:extLst>
+          </p:cNvPr>
+          <p:cNvSpPr>
+            <a:spLocks xmlns:a="http://schemas.openxmlformats.org/drawingml/2006/main" noGrp="1"/>
+          </p:cNvSpPr>
+          <p:nvPr/>
+        </p:nvSpPr>
+        <p:spPr>
+          <a:xfrm xmlns:a="http://schemas.openxmlformats.org/drawingml/2006/main">
+            <a:off x="6934200" y="3676650"/>
+            <a:ext cx="2857500" cy="323850"/>
+          </a:xfrm>
+          <a:prstGeom xmlns:a="http://schemas.openxmlformats.org/drawingml/2006/main" prst="rect">
+            <a:avLst/>
+          </a:prstGeom>
+          <a:noFill xmlns:a="http://schemas.openxmlformats.org/drawingml/2006/main"/>
+          <a:ln xmlns:a="http://schemas.openxmlformats.org/drawingml/2006/main" w="0">
+            <a:noFill/>
+            <a:prstDash val="solid"/>
+          </a:ln>
+        </p:spPr>
+        <p:txBody>
+          <a:bodyPr xmlns:a="http://schemas.openxmlformats.org/drawingml/2006/main"/>
+          <a:lstStyle xmlns:a="http://schemas.openxmlformats.org/drawingml/2006/main"/>
+          <a:p xmlns:a="http://schemas.openxmlformats.org/drawingml/2006/main">
+            <a:pPr>
+              <a:defRPr sz="1013">
                 <a:solidFill>
                   <a:srgbClr val="FFFFFF"/>
                 </a:solidFill>
               </a:defRPr>
             </a:pPr>
             <a:r>
-              <a:rPr sz="1050">
+              <a:rPr sz="1013">
                 <a:solidFill>
                   <a:srgbClr val="FFFFFF"/>
                 </a:solidFill>
               </a:rPr>
-              <a:t>치명 이슈 0건, 주요 이슈 수정 계획과 잔여 리스크 공유</a:t>
+              <a:t>주요 이슈 수정 계획과 잔여 리스크 공유</a:t>
             </a:r>
           </a:p>
         </p:txBody>
@@ -8828,7 +8895,7 @@
           <p:cNvPr id="41" name="decision-owner-3">
             <a:extLst xmlns:a="http://schemas.openxmlformats.org/drawingml/2006/main">
               <a:ext uri="{FF2B5EF4-FFF2-40B4-BE49-F238E27FC236}">
-                <a16:creationId xmlns:a16="http://schemas.microsoft.com/office/drawing/2014/main" id="{CC23460F-80F8-4D1A-B797-3E178C412CFC}"/>
+                <a16:creationId xmlns:a16="http://schemas.microsoft.com/office/drawing/2014/main" id="{66DE90A7-5E34-45B5-BD3B-35AB284FAC92}"/>
               </a:ext>
             </a:extLst>
           </p:cNvPr>
@@ -8878,7 +8945,7 @@
           <p:cNvPr id="42" name="decision-row-4">
             <a:extLst xmlns:a="http://schemas.openxmlformats.org/drawingml/2006/main">
               <a:ext uri="{FF2B5EF4-FFF2-40B4-BE49-F238E27FC236}">
-                <a16:creationId xmlns:a16="http://schemas.microsoft.com/office/drawing/2014/main" id="{8511F758-BA17-42B9-94C8-1A04FCC2E5EE}"/>
+                <a16:creationId xmlns:a16="http://schemas.microsoft.com/office/drawing/2014/main" id="{6B0087D5-23CD-41CC-893C-08ACE8C3DF21}"/>
               </a:ext>
             </a:extLst>
           </p:cNvPr>
@@ -8911,7 +8978,7 @@
           <p:cNvPr id="43" name="decision-item-4">
             <a:extLst xmlns:a="http://schemas.openxmlformats.org/drawingml/2006/main">
               <a:ext uri="{FF2B5EF4-FFF2-40B4-BE49-F238E27FC236}">
-                <a16:creationId xmlns:a16="http://schemas.microsoft.com/office/drawing/2014/main" id="{F14DECFC-7F8D-45E6-B5EC-7ED25711BC91}"/>
+                <a16:creationId xmlns:a16="http://schemas.microsoft.com/office/drawing/2014/main" id="{6DBE7842-D2DA-4895-9349-5A40EBD686FA}"/>
               </a:ext>
             </a:extLst>
           </p:cNvPr>
@@ -8951,7 +9018,7 @@
                   <a:srgbClr val="8BD9E8"/>
                 </a:solidFill>
               </a:rPr>
-              <a:t>퍼블리셔 검수</a:t>
+              <a:t>퍼블리셔 대응</a:t>
             </a:r>
           </a:p>
         </p:txBody>
@@ -8961,47 +9028,47 @@
           <p:cNvPr id="44" name="decision-gate-4">
             <a:extLst xmlns:a="http://schemas.openxmlformats.org/drawingml/2006/main">
               <a:ext uri="{FF2B5EF4-FFF2-40B4-BE49-F238E27FC236}">
-                <a16:creationId xmlns:a16="http://schemas.microsoft.com/office/drawing/2014/main" id="{D1E17F3F-64A1-4AA5-B441-DFCF0531A7F7}"/>
-              </a:ext>
-            </a:extLst>
-          </p:cNvPr>
-          <p:cNvSpPr>
-            <a:spLocks xmlns:a="http://schemas.openxmlformats.org/drawingml/2006/main" noGrp="1"/>
-          </p:cNvSpPr>
-          <p:nvPr/>
-        </p:nvSpPr>
-        <p:spPr>
-          <a:xfrm xmlns:a="http://schemas.openxmlformats.org/drawingml/2006/main">
-            <a:off x="6934200" y="4238625"/>
-            <a:ext cx="2857500" cy="285750"/>
-          </a:xfrm>
-          <a:prstGeom xmlns:a="http://schemas.openxmlformats.org/drawingml/2006/main" prst="rect">
-            <a:avLst/>
-          </a:prstGeom>
-          <a:noFill xmlns:a="http://schemas.openxmlformats.org/drawingml/2006/main"/>
-          <a:ln xmlns:a="http://schemas.openxmlformats.org/drawingml/2006/main" w="0">
-            <a:noFill/>
-            <a:prstDash val="solid"/>
-          </a:ln>
-        </p:spPr>
-        <p:txBody>
-          <a:bodyPr xmlns:a="http://schemas.openxmlformats.org/drawingml/2006/main"/>
-          <a:lstStyle xmlns:a="http://schemas.openxmlformats.org/drawingml/2006/main"/>
-          <a:p xmlns:a="http://schemas.openxmlformats.org/drawingml/2006/main">
-            <a:pPr>
-              <a:defRPr sz="1050">
+                <a16:creationId xmlns:a16="http://schemas.microsoft.com/office/drawing/2014/main" id="{5A9E6EEA-2B1A-4A35-B570-DBEB7193C2B3}"/>
+              </a:ext>
+            </a:extLst>
+          </p:cNvPr>
+          <p:cNvSpPr>
+            <a:spLocks xmlns:a="http://schemas.openxmlformats.org/drawingml/2006/main" noGrp="1"/>
+          </p:cNvSpPr>
+          <p:nvPr/>
+        </p:nvSpPr>
+        <p:spPr>
+          <a:xfrm xmlns:a="http://schemas.openxmlformats.org/drawingml/2006/main">
+            <a:off x="6934200" y="4229100"/>
+            <a:ext cx="2857500" cy="323850"/>
+          </a:xfrm>
+          <a:prstGeom xmlns:a="http://schemas.openxmlformats.org/drawingml/2006/main" prst="rect">
+            <a:avLst/>
+          </a:prstGeom>
+          <a:noFill xmlns:a="http://schemas.openxmlformats.org/drawingml/2006/main"/>
+          <a:ln xmlns:a="http://schemas.openxmlformats.org/drawingml/2006/main" w="0">
+            <a:noFill/>
+            <a:prstDash val="solid"/>
+          </a:ln>
+        </p:spPr>
+        <p:txBody>
+          <a:bodyPr xmlns:a="http://schemas.openxmlformats.org/drawingml/2006/main"/>
+          <a:lstStyle xmlns:a="http://schemas.openxmlformats.org/drawingml/2006/main"/>
+          <a:p xmlns:a="http://schemas.openxmlformats.org/drawingml/2006/main">
+            <a:pPr>
+              <a:defRPr sz="1013">
                 <a:solidFill>
                   <a:srgbClr val="FFFFFF"/>
                 </a:solidFill>
               </a:defRPr>
             </a:pPr>
             <a:r>
-              <a:rPr sz="1050">
+              <a:rPr sz="1013">
                 <a:solidFill>
                   <a:srgbClr val="FFFFFF"/>
                 </a:solidFill>
               </a:rPr>
-              <a:t>검수 요청, 피드백, 재전달 일정이 추적 가능한 상태</a:t>
+              <a:t>검수 요청, 피드백, 재전달 일정 추적</a:t>
             </a:r>
           </a:p>
         </p:txBody>
@@ -9011,7 +9078,7 @@
           <p:cNvPr id="45" name="decision-owner-4">
             <a:extLst xmlns:a="http://schemas.openxmlformats.org/drawingml/2006/main">
               <a:ext uri="{FF2B5EF4-FFF2-40B4-BE49-F238E27FC236}">
-                <a16:creationId xmlns:a16="http://schemas.microsoft.com/office/drawing/2014/main" id="{BB4C2B74-D2E3-47A1-8209-696E666A33A1}"/>
+                <a16:creationId xmlns:a16="http://schemas.microsoft.com/office/drawing/2014/main" id="{438E4FAF-4E13-4C2D-A34C-CECEA7B593CA}"/>
               </a:ext>
             </a:extLst>
           </p:cNvPr>
@@ -9061,7 +9128,7 @@
           <p:cNvPr id="46" name="decision-row-5">
             <a:extLst xmlns:a="http://schemas.openxmlformats.org/drawingml/2006/main">
               <a:ext uri="{FF2B5EF4-FFF2-40B4-BE49-F238E27FC236}">
-                <a16:creationId xmlns:a16="http://schemas.microsoft.com/office/drawing/2014/main" id="{1C8981E7-03FE-4E62-9343-8D1E3A17B4B6}"/>
+                <a16:creationId xmlns:a16="http://schemas.microsoft.com/office/drawing/2014/main" id="{04225715-7089-4861-B6D1-DEA0CEFF3D01}"/>
               </a:ext>
             </a:extLst>
           </p:cNvPr>
@@ -9094,7 +9161,7 @@
           <p:cNvPr id="47" name="decision-item-5">
             <a:extLst xmlns:a="http://schemas.openxmlformats.org/drawingml/2006/main">
               <a:ext uri="{FF2B5EF4-FFF2-40B4-BE49-F238E27FC236}">
-                <a16:creationId xmlns:a16="http://schemas.microsoft.com/office/drawing/2014/main" id="{0AD55C7B-21E5-4802-A2AC-BE70FC586B63}"/>
+                <a16:creationId xmlns:a16="http://schemas.microsoft.com/office/drawing/2014/main" id="{C9675159-5B41-41D7-9A93-FA0F735E6630}"/>
               </a:ext>
             </a:extLst>
           </p:cNvPr>
@@ -9134,7 +9201,7 @@
                   <a:srgbClr val="FF6B35"/>
                 </a:solidFill>
               </a:rPr>
-              <a:t>배포 준비</a:t>
+              <a:t>Live 릴리즈</a:t>
             </a:r>
           </a:p>
         </p:txBody>
@@ -9144,47 +9211,47 @@
           <p:cNvPr id="48" name="decision-gate-5">
             <a:extLst xmlns:a="http://schemas.openxmlformats.org/drawingml/2006/main">
               <a:ext uri="{FF2B5EF4-FFF2-40B4-BE49-F238E27FC236}">
-                <a16:creationId xmlns:a16="http://schemas.microsoft.com/office/drawing/2014/main" id="{B280930C-024D-4D89-8184-525E6467912E}"/>
-              </a:ext>
-            </a:extLst>
-          </p:cNvPr>
-          <p:cNvSpPr>
-            <a:spLocks xmlns:a="http://schemas.openxmlformats.org/drawingml/2006/main" noGrp="1"/>
-          </p:cNvSpPr>
-          <p:nvPr/>
-        </p:nvSpPr>
-        <p:spPr>
-          <a:xfrm xmlns:a="http://schemas.openxmlformats.org/drawingml/2006/main">
-            <a:off x="6934200" y="4791075"/>
-            <a:ext cx="2857500" cy="285750"/>
-          </a:xfrm>
-          <a:prstGeom xmlns:a="http://schemas.openxmlformats.org/drawingml/2006/main" prst="rect">
-            <a:avLst/>
-          </a:prstGeom>
-          <a:noFill xmlns:a="http://schemas.openxmlformats.org/drawingml/2006/main"/>
-          <a:ln xmlns:a="http://schemas.openxmlformats.org/drawingml/2006/main" w="0">
-            <a:noFill/>
-            <a:prstDash val="solid"/>
-          </a:ln>
-        </p:spPr>
-        <p:txBody>
-          <a:bodyPr xmlns:a="http://schemas.openxmlformats.org/drawingml/2006/main"/>
-          <a:lstStyle xmlns:a="http://schemas.openxmlformats.org/drawingml/2006/main"/>
-          <a:p xmlns:a="http://schemas.openxmlformats.org/drawingml/2006/main">
-            <a:pPr>
-              <a:defRPr sz="1050">
+                <a16:creationId xmlns:a16="http://schemas.microsoft.com/office/drawing/2014/main" id="{8B84A2B6-A7A0-4EB8-854F-2B24B5414F78}"/>
+              </a:ext>
+            </a:extLst>
+          </p:cNvPr>
+          <p:cNvSpPr>
+            <a:spLocks xmlns:a="http://schemas.openxmlformats.org/drawingml/2006/main" noGrp="1"/>
+          </p:cNvSpPr>
+          <p:nvPr/>
+        </p:nvSpPr>
+        <p:spPr>
+          <a:xfrm xmlns:a="http://schemas.openxmlformats.org/drawingml/2006/main">
+            <a:off x="6934200" y="4781550"/>
+            <a:ext cx="2857500" cy="323850"/>
+          </a:xfrm>
+          <a:prstGeom xmlns:a="http://schemas.openxmlformats.org/drawingml/2006/main" prst="rect">
+            <a:avLst/>
+          </a:prstGeom>
+          <a:noFill xmlns:a="http://schemas.openxmlformats.org/drawingml/2006/main"/>
+          <a:ln xmlns:a="http://schemas.openxmlformats.org/drawingml/2006/main" w="0">
+            <a:noFill/>
+            <a:prstDash val="solid"/>
+          </a:ln>
+        </p:spPr>
+        <p:txBody>
+          <a:bodyPr xmlns:a="http://schemas.openxmlformats.org/drawingml/2006/main"/>
+          <a:lstStyle xmlns:a="http://schemas.openxmlformats.org/drawingml/2006/main"/>
+          <a:p xmlns:a="http://schemas.openxmlformats.org/drawingml/2006/main">
+            <a:pPr>
+              <a:defRPr sz="1013">
                 <a:solidFill>
                   <a:srgbClr val="FFFFFF"/>
                 </a:solidFill>
               </a:defRPr>
             </a:pPr>
             <a:r>
-              <a:rPr sz="1050">
+              <a:rPr sz="1013">
                 <a:solidFill>
                   <a:srgbClr val="FFFFFF"/>
                 </a:solidFill>
               </a:rPr>
-              <a:t>스토어·공지·장애 대응 플랜의 최종 담당자 확인</a:t>
+              <a:t>배포·공지·장애 대응 담당자 확인</a:t>
             </a:r>
           </a:p>
         </p:txBody>
@@ -9194,7 +9261,7 @@
           <p:cNvPr id="49" name="decision-owner-5">
             <a:extLst xmlns:a="http://schemas.openxmlformats.org/drawingml/2006/main">
               <a:ext uri="{FF2B5EF4-FFF2-40B4-BE49-F238E27FC236}">
-                <a16:creationId xmlns:a16="http://schemas.microsoft.com/office/drawing/2014/main" id="{C25E2986-0D1C-4E0E-B4A7-419E8D084F7D}"/>
+                <a16:creationId xmlns:a16="http://schemas.microsoft.com/office/drawing/2014/main" id="{B1FD36A6-41A5-4800-BB25-912BA864BA2C}"/>
               </a:ext>
             </a:extLst>
           </p:cNvPr>
@@ -9244,7 +9311,7 @@
           <p:cNvPr id="50" name="principle-panel">
             <a:extLst xmlns:a="http://schemas.openxmlformats.org/drawingml/2006/main">
               <a:ext uri="{FF2B5EF4-FFF2-40B4-BE49-F238E27FC236}">
-                <a16:creationId xmlns:a16="http://schemas.microsoft.com/office/drawing/2014/main" id="{21D4491B-93B1-4BE6-90D8-AFAC6F5BA384}"/>
+                <a16:creationId xmlns:a16="http://schemas.microsoft.com/office/drawing/2014/main" id="{8E22E816-F035-4E45-93BA-8627E00E2619}"/>
               </a:ext>
             </a:extLst>
           </p:cNvPr>
@@ -9279,7 +9346,7 @@
           <p:cNvPr id="51" name="principle-label">
             <a:extLst xmlns:a="http://schemas.openxmlformats.org/drawingml/2006/main">
               <a:ext uri="{FF2B5EF4-FFF2-40B4-BE49-F238E27FC236}">
-                <a16:creationId xmlns:a16="http://schemas.microsoft.com/office/drawing/2014/main" id="{9B217DDC-3F38-4CEF-A73A-AEEABAA14758}"/>
+                <a16:creationId xmlns:a16="http://schemas.microsoft.com/office/drawing/2014/main" id="{DEA8794B-D33A-4CAD-BD26-E3683F37E3B3}"/>
               </a:ext>
             </a:extLst>
           </p:cNvPr>
@@ -9329,7 +9396,7 @@
           <p:cNvPr id="52" name="principle-body">
             <a:extLst xmlns:a="http://schemas.openxmlformats.org/drawingml/2006/main">
               <a:ext uri="{FF2B5EF4-FFF2-40B4-BE49-F238E27FC236}">
-                <a16:creationId xmlns:a16="http://schemas.microsoft.com/office/drawing/2014/main" id="{9F9B4364-8B18-44B3-A579-B65AC8A5C124}"/>
+                <a16:creationId xmlns:a16="http://schemas.microsoft.com/office/drawing/2014/main" id="{1E3BB899-BF86-4040-B8FA-898FF5CB2E72}"/>
               </a:ext>
             </a:extLst>
           </p:cNvPr>
@@ -9369,7 +9436,7 @@
                   <a:srgbClr val="FFFFFF"/>
                 </a:solidFill>
               </a:rPr>
-              <a:t>게이트 미통과 항목은 일정 지연이 아니라 의사결정 이슈로 분리해, 영향도와 대안을 함께 보고합니다.</a:t>
+              <a:t>미통과 항목은 일정 지연이 아니라 의사결정 이슈로 분리해, 영향도와 대안을 함께 보고합니다.</a:t>
             </a:r>
           </a:p>
         </p:txBody>
@@ -9377,7 +9444,2631 @@
     </p:spTree>
     <p:extLst>
       <p:ext uri="{BB962C8B-B14F-4D97-AF65-F5344CB8AC3E}">
-        <p14:creationId xmlns:p14="http://schemas.microsoft.com/office/powerpoint/2010/main" val="535118993"/>
+        <p14:creationId xmlns:p14="http://schemas.microsoft.com/office/powerpoint/2010/main" val="1112216715"/>
+      </p:ext>
+    </p:extLst>
+  </p:cSld>
+</p:sld>
+</file>
+
+<file path=ppt/slides/slide4.xml><?xml version="1.0" encoding="utf-8"?>
+<p:sld xmlns:p="http://schemas.openxmlformats.org/presentationml/2006/main">
+  <p:cSld>
+    <p:bg>
+      <p:bgPr>
+        <a:solidFill xmlns:a="http://schemas.openxmlformats.org/drawingml/2006/main">
+          <a:srgbClr val="0B1020"/>
+        </a:solidFill>
+      </p:bgPr>
+    </p:bg>
+    <p:spTree>
+      <p:nvGrpSpPr>
+        <p:cNvPr id="1" name=""/>
+        <p:cNvGrpSpPr/>
+        <p:nvPr/>
+      </p:nvGrpSpPr>
+      <p:grpSpPr>
+        <a:xfrm xmlns:a="http://schemas.openxmlformats.org/drawingml/2006/main"/>
+      </p:grpSpPr>
+      <p:sp>
+        <p:nvSpPr>
+          <p:cNvPr id="1" name="top-accent">
+            <a:extLst xmlns:a="http://schemas.openxmlformats.org/drawingml/2006/main">
+              <a:ext uri="{FF2B5EF4-FFF2-40B4-BE49-F238E27FC236}">
+                <a16:creationId xmlns:a16="http://schemas.microsoft.com/office/drawing/2014/main" id="{39A0876D-8EB1-4BF0-9D87-DDA7C022946C}"/>
+              </a:ext>
+            </a:extLst>
+          </p:cNvPr>
+          <p:cNvSpPr>
+            <a:spLocks xmlns:a="http://schemas.openxmlformats.org/drawingml/2006/main" noGrp="1"/>
+          </p:cNvSpPr>
+          <p:nvPr/>
+        </p:nvSpPr>
+        <p:spPr>
+          <a:xfrm xmlns:a="http://schemas.openxmlformats.org/drawingml/2006/main">
+            <a:off x="0" y="0"/>
+            <a:ext cx="12192000" cy="95250"/>
+          </a:xfrm>
+          <a:prstGeom xmlns:a="http://schemas.openxmlformats.org/drawingml/2006/main" prst="rect">
+            <a:avLst/>
+          </a:prstGeom>
+          <a:solidFill xmlns:a="http://schemas.openxmlformats.org/drawingml/2006/main">
+            <a:srgbClr val="00B8D9"/>
+          </a:solidFill>
+          <a:ln xmlns:a="http://schemas.openxmlformats.org/drawingml/2006/main" w="0">
+            <a:solidFill>
+              <a:srgbClr val="00B8D9"/>
+            </a:solidFill>
+            <a:prstDash val="solid"/>
+          </a:ln>
+        </p:spPr>
+      </p:sp>
+      <p:sp>
+        <p:nvSpPr>
+          <p:cNvPr id="2" name="left-accent">
+            <a:extLst xmlns:a="http://schemas.openxmlformats.org/drawingml/2006/main">
+              <a:ext uri="{FF2B5EF4-FFF2-40B4-BE49-F238E27FC236}">
+                <a16:creationId xmlns:a16="http://schemas.microsoft.com/office/drawing/2014/main" id="{622C2192-D74E-48FA-A02B-967F7C51D43F}"/>
+              </a:ext>
+            </a:extLst>
+          </p:cNvPr>
+          <p:cNvSpPr>
+            <a:spLocks xmlns:a="http://schemas.openxmlformats.org/drawingml/2006/main" noGrp="1"/>
+          </p:cNvSpPr>
+          <p:nvPr/>
+        </p:nvSpPr>
+        <p:spPr>
+          <a:xfrm xmlns:a="http://schemas.openxmlformats.org/drawingml/2006/main">
+            <a:off x="0" y="0"/>
+            <a:ext cx="152400" cy="6858000"/>
+          </a:xfrm>
+          <a:prstGeom xmlns:a="http://schemas.openxmlformats.org/drawingml/2006/main" prst="rect">
+            <a:avLst/>
+          </a:prstGeom>
+          <a:solidFill xmlns:a="http://schemas.openxmlformats.org/drawingml/2006/main">
+            <a:srgbClr val="FF6B35"/>
+          </a:solidFill>
+          <a:ln xmlns:a="http://schemas.openxmlformats.org/drawingml/2006/main" w="0">
+            <a:solidFill>
+              <a:srgbClr val="FF6B35"/>
+            </a:solidFill>
+            <a:prstDash val="solid"/>
+          </a:ln>
+        </p:spPr>
+      </p:sp>
+      <p:sp>
+        <p:nvSpPr>
+          <p:cNvPr id="3" name="eyebrow">
+            <a:extLst xmlns:a="http://schemas.openxmlformats.org/drawingml/2006/main">
+              <a:ext uri="{FF2B5EF4-FFF2-40B4-BE49-F238E27FC236}">
+                <a16:creationId xmlns:a16="http://schemas.microsoft.com/office/drawing/2014/main" id="{A6A72702-4C1C-4910-91D1-2F11299136B0}"/>
+              </a:ext>
+            </a:extLst>
+          </p:cNvPr>
+          <p:cNvSpPr>
+            <a:spLocks xmlns:a="http://schemas.openxmlformats.org/drawingml/2006/main" noGrp="1"/>
+          </p:cNvSpPr>
+          <p:nvPr/>
+        </p:nvSpPr>
+        <p:spPr>
+          <a:xfrm xmlns:a="http://schemas.openxmlformats.org/drawingml/2006/main">
+            <a:off x="514350" y="361950"/>
+            <a:ext cx="5905500" cy="285750"/>
+          </a:xfrm>
+          <a:prstGeom xmlns:a="http://schemas.openxmlformats.org/drawingml/2006/main" prst="rect">
+            <a:avLst/>
+          </a:prstGeom>
+          <a:noFill xmlns:a="http://schemas.openxmlformats.org/drawingml/2006/main"/>
+          <a:ln xmlns:a="http://schemas.openxmlformats.org/drawingml/2006/main" w="0">
+            <a:noFill/>
+            <a:prstDash val="solid"/>
+          </a:ln>
+        </p:spPr>
+        <p:txBody>
+          <a:bodyPr xmlns:a="http://schemas.openxmlformats.org/drawingml/2006/main"/>
+          <a:lstStyle xmlns:a="http://schemas.openxmlformats.org/drawingml/2006/main"/>
+          <a:p xmlns:a="http://schemas.openxmlformats.org/drawingml/2006/main">
+            <a:pPr>
+              <a:defRPr sz="1125" b="1">
+                <a:solidFill>
+                  <a:srgbClr val="8BD9E8"/>
+                </a:solidFill>
+              </a:defRPr>
+            </a:pPr>
+            <a:r>
+              <a:rPr sz="1125" b="1">
+                <a:solidFill>
+                  <a:srgbClr val="8BD9E8"/>
+                </a:solidFill>
+              </a:rPr>
+              <a:t>RISK RESPONSE SYSTEM | PAGE 04</a:t>
+            </a:r>
+          </a:p>
+        </p:txBody>
+      </p:sp>
+      <p:sp>
+        <p:nvSpPr>
+          <p:cNvPr id="4" name="footer">
+            <a:extLst xmlns:a="http://schemas.openxmlformats.org/drawingml/2006/main">
+              <a:ext uri="{FF2B5EF4-FFF2-40B4-BE49-F238E27FC236}">
+                <a16:creationId xmlns:a16="http://schemas.microsoft.com/office/drawing/2014/main" id="{12782A95-2D81-44A5-8285-2F651828A5B5}"/>
+              </a:ext>
+            </a:extLst>
+          </p:cNvPr>
+          <p:cNvSpPr>
+            <a:spLocks xmlns:a="http://schemas.openxmlformats.org/drawingml/2006/main" noGrp="1"/>
+          </p:cNvSpPr>
+          <p:nvPr/>
+        </p:nvSpPr>
+        <p:spPr>
+          <a:xfrm xmlns:a="http://schemas.openxmlformats.org/drawingml/2006/main">
+            <a:off x="514350" y="6457950"/>
+            <a:ext cx="4953000" cy="266700"/>
+          </a:xfrm>
+          <a:prstGeom xmlns:a="http://schemas.openxmlformats.org/drawingml/2006/main" prst="rect">
+            <a:avLst/>
+          </a:prstGeom>
+          <a:noFill xmlns:a="http://schemas.openxmlformats.org/drawingml/2006/main"/>
+          <a:ln xmlns:a="http://schemas.openxmlformats.org/drawingml/2006/main" w="0">
+            <a:noFill/>
+            <a:prstDash val="solid"/>
+          </a:ln>
+        </p:spPr>
+        <p:txBody>
+          <a:bodyPr xmlns:a="http://schemas.openxmlformats.org/drawingml/2006/main"/>
+          <a:lstStyle xmlns:a="http://schemas.openxmlformats.org/drawingml/2006/main"/>
+          <a:p xmlns:a="http://schemas.openxmlformats.org/drawingml/2006/main">
+            <a:pPr>
+              <a:defRPr sz="1125">
+                <a:solidFill>
+                  <a:srgbClr val="94A3B8"/>
+                </a:solidFill>
+              </a:defRPr>
+            </a:pPr>
+            <a:r>
+              <a:rPr sz="1125">
+                <a:solidFill>
+                  <a:srgbClr val="94A3B8"/>
+                </a:solidFill>
+              </a:rPr>
+              <a:t>HIT2 일본 서비스 런칭 6개월 전 로드맵</a:t>
+            </a:r>
+          </a:p>
+        </p:txBody>
+      </p:sp>
+      <p:sp>
+        <p:nvSpPr>
+          <p:cNvPr id="5" name="page-no">
+            <a:extLst xmlns:a="http://schemas.openxmlformats.org/drawingml/2006/main">
+              <a:ext uri="{FF2B5EF4-FFF2-40B4-BE49-F238E27FC236}">
+                <a16:creationId xmlns:a16="http://schemas.microsoft.com/office/drawing/2014/main" id="{08EF888A-88F8-4CBB-A444-E4EFCCFF55D9}"/>
+              </a:ext>
+            </a:extLst>
+          </p:cNvPr>
+          <p:cNvSpPr>
+            <a:spLocks xmlns:a="http://schemas.openxmlformats.org/drawingml/2006/main" noGrp="1"/>
+          </p:cNvSpPr>
+          <p:nvPr/>
+        </p:nvSpPr>
+        <p:spPr>
+          <a:xfrm xmlns:a="http://schemas.openxmlformats.org/drawingml/2006/main">
+            <a:off x="10953750" y="6457950"/>
+            <a:ext cx="419100" cy="266700"/>
+          </a:xfrm>
+          <a:prstGeom xmlns:a="http://schemas.openxmlformats.org/drawingml/2006/main" prst="rect">
+            <a:avLst/>
+          </a:prstGeom>
+          <a:noFill xmlns:a="http://schemas.openxmlformats.org/drawingml/2006/main"/>
+          <a:ln xmlns:a="http://schemas.openxmlformats.org/drawingml/2006/main" w="0">
+            <a:noFill/>
+            <a:prstDash val="solid"/>
+          </a:ln>
+        </p:spPr>
+        <p:txBody>
+          <a:bodyPr xmlns:a="http://schemas.openxmlformats.org/drawingml/2006/main"/>
+          <a:lstStyle xmlns:a="http://schemas.openxmlformats.org/drawingml/2006/main"/>
+          <a:p xmlns:a="http://schemas.openxmlformats.org/drawingml/2006/main">
+            <a:pPr algn="r">
+              <a:defRPr sz="1200" b="1">
+                <a:solidFill>
+                  <a:srgbClr val="94A3B8"/>
+                </a:solidFill>
+              </a:defRPr>
+            </a:pPr>
+            <a:r>
+              <a:rPr sz="1200" b="1">
+                <a:solidFill>
+                  <a:srgbClr val="94A3B8"/>
+                </a:solidFill>
+              </a:rPr>
+              <a:t>04</a:t>
+            </a:r>
+          </a:p>
+        </p:txBody>
+      </p:sp>
+      <p:sp>
+        <p:nvSpPr>
+          <p:cNvPr id="6" name="title-04">
+            <a:extLst xmlns:a="http://schemas.openxmlformats.org/drawingml/2006/main">
+              <a:ext uri="{FF2B5EF4-FFF2-40B4-BE49-F238E27FC236}">
+                <a16:creationId xmlns:a16="http://schemas.microsoft.com/office/drawing/2014/main" id="{02E217CC-2544-41A1-B55F-552EA5F8EF73}"/>
+              </a:ext>
+            </a:extLst>
+          </p:cNvPr>
+          <p:cNvSpPr>
+            <a:spLocks xmlns:a="http://schemas.openxmlformats.org/drawingml/2006/main" noGrp="1"/>
+          </p:cNvSpPr>
+          <p:nvPr/>
+        </p:nvSpPr>
+        <p:spPr>
+          <a:xfrm xmlns:a="http://schemas.openxmlformats.org/drawingml/2006/main">
+            <a:off x="514350" y="781050"/>
+            <a:ext cx="10572750" cy="533400"/>
+          </a:xfrm>
+          <a:prstGeom xmlns:a="http://schemas.openxmlformats.org/drawingml/2006/main" prst="rect">
+            <a:avLst/>
+          </a:prstGeom>
+          <a:noFill xmlns:a="http://schemas.openxmlformats.org/drawingml/2006/main"/>
+          <a:ln xmlns:a="http://schemas.openxmlformats.org/drawingml/2006/main" w="0">
+            <a:noFill/>
+            <a:prstDash val="solid"/>
+          </a:ln>
+        </p:spPr>
+        <p:txBody>
+          <a:bodyPr xmlns:a="http://schemas.openxmlformats.org/drawingml/2006/main"/>
+          <a:lstStyle xmlns:a="http://schemas.openxmlformats.org/drawingml/2006/main"/>
+          <a:p xmlns:a="http://schemas.openxmlformats.org/drawingml/2006/main">
+            <a:pPr>
+              <a:defRPr sz="2550" b="1">
+                <a:solidFill>
+                  <a:srgbClr val="FFFFFF"/>
+                </a:solidFill>
+              </a:defRPr>
+            </a:pPr>
+            <a:r>
+              <a:rPr sz="2550" b="1">
+                <a:solidFill>
+                  <a:srgbClr val="FFFFFF"/>
+                </a:solidFill>
+              </a:rPr>
+              <a:t>런칭 리스크는 조기 분리와 이슈 대응으로 관리합니다</a:t>
+            </a:r>
+          </a:p>
+        </p:txBody>
+      </p:sp>
+      <p:sp>
+        <p:nvSpPr>
+          <p:cNvPr id="7" name="subtitle-04">
+            <a:extLst xmlns:a="http://schemas.openxmlformats.org/drawingml/2006/main">
+              <a:ext uri="{FF2B5EF4-FFF2-40B4-BE49-F238E27FC236}">
+                <a16:creationId xmlns:a16="http://schemas.microsoft.com/office/drawing/2014/main" id="{65806F9C-7D35-4E68-BBE5-B18366436C16}"/>
+              </a:ext>
+            </a:extLst>
+          </p:cNvPr>
+          <p:cNvSpPr>
+            <a:spLocks xmlns:a="http://schemas.openxmlformats.org/drawingml/2006/main" noGrp="1"/>
+          </p:cNvSpPr>
+          <p:nvPr/>
+        </p:nvSpPr>
+        <p:spPr>
+          <a:xfrm xmlns:a="http://schemas.openxmlformats.org/drawingml/2006/main">
+            <a:off x="533400" y="1371600"/>
+            <a:ext cx="10287000" cy="323850"/>
+          </a:xfrm>
+          <a:prstGeom xmlns:a="http://schemas.openxmlformats.org/drawingml/2006/main" prst="rect">
+            <a:avLst/>
+          </a:prstGeom>
+          <a:noFill xmlns:a="http://schemas.openxmlformats.org/drawingml/2006/main"/>
+          <a:ln xmlns:a="http://schemas.openxmlformats.org/drawingml/2006/main" w="0">
+            <a:noFill/>
+            <a:prstDash val="solid"/>
+          </a:ln>
+        </p:spPr>
+        <p:txBody>
+          <a:bodyPr xmlns:a="http://schemas.openxmlformats.org/drawingml/2006/main"/>
+          <a:lstStyle xmlns:a="http://schemas.openxmlformats.org/drawingml/2006/main"/>
+          <a:p xmlns:a="http://schemas.openxmlformats.org/drawingml/2006/main">
+            <a:pPr>
+              <a:defRPr sz="1275">
+                <a:solidFill>
+                  <a:srgbClr val="CBD5E1"/>
+                </a:solidFill>
+              </a:defRPr>
+            </a:pPr>
+            <a:r>
+              <a:rPr sz="1275">
+                <a:solidFill>
+                  <a:srgbClr val="CBD5E1"/>
+                </a:solidFill>
+              </a:rPr>
+              <a:t>일정·범위·빌드·버전·QA에 미치는 영향을 먼저 보이게 만들어야 의사결정이 빨라집니다.</a:t>
+            </a:r>
+          </a:p>
+        </p:txBody>
+      </p:sp>
+      <p:sp>
+        <p:nvSpPr>
+          <p:cNvPr id="8" name="risk-title">
+            <a:extLst xmlns:a="http://schemas.openxmlformats.org/drawingml/2006/main">
+              <a:ext uri="{FF2B5EF4-FFF2-40B4-BE49-F238E27FC236}">
+                <a16:creationId xmlns:a16="http://schemas.microsoft.com/office/drawing/2014/main" id="{A50D9908-FCE2-458C-9331-141D7CF89158}"/>
+              </a:ext>
+            </a:extLst>
+          </p:cNvPr>
+          <p:cNvSpPr>
+            <a:spLocks xmlns:a="http://schemas.openxmlformats.org/drawingml/2006/main" noGrp="1"/>
+          </p:cNvSpPr>
+          <p:nvPr/>
+        </p:nvSpPr>
+        <p:spPr>
+          <a:xfrm xmlns:a="http://schemas.openxmlformats.org/drawingml/2006/main">
+            <a:off x="514350" y="1752600"/>
+            <a:ext cx="2095500" cy="285750"/>
+          </a:xfrm>
+          <a:prstGeom xmlns:a="http://schemas.openxmlformats.org/drawingml/2006/main" prst="rect">
+            <a:avLst/>
+          </a:prstGeom>
+          <a:noFill xmlns:a="http://schemas.openxmlformats.org/drawingml/2006/main"/>
+          <a:ln xmlns:a="http://schemas.openxmlformats.org/drawingml/2006/main" w="0">
+            <a:noFill/>
+            <a:prstDash val="solid"/>
+          </a:ln>
+        </p:spPr>
+        <p:txBody>
+          <a:bodyPr xmlns:a="http://schemas.openxmlformats.org/drawingml/2006/main"/>
+          <a:lstStyle xmlns:a="http://schemas.openxmlformats.org/drawingml/2006/main"/>
+          <a:p xmlns:a="http://schemas.openxmlformats.org/drawingml/2006/main">
+            <a:pPr>
+              <a:defRPr sz="1650" b="1">
+                <a:solidFill>
+                  <a:srgbClr val="FFFFFF"/>
+                </a:solidFill>
+              </a:defRPr>
+            </a:pPr>
+            <a:r>
+              <a:rPr sz="1650" b="1">
+                <a:solidFill>
+                  <a:srgbClr val="FFFFFF"/>
+                </a:solidFill>
+              </a:rPr>
+              <a:t>주요 리스크</a:t>
+            </a:r>
+          </a:p>
+        </p:txBody>
+      </p:sp>
+      <p:sp>
+        <p:nvSpPr>
+          <p:cNvPr id="9" name="risk-header">
+            <a:extLst xmlns:a="http://schemas.openxmlformats.org/drawingml/2006/main">
+              <a:ext uri="{FF2B5EF4-FFF2-40B4-BE49-F238E27FC236}">
+                <a16:creationId xmlns:a16="http://schemas.microsoft.com/office/drawing/2014/main" id="{53971F05-0E1F-4858-B0CA-9DDC16E7E99A}"/>
+              </a:ext>
+            </a:extLst>
+          </p:cNvPr>
+          <p:cNvSpPr>
+            <a:spLocks xmlns:a="http://schemas.openxmlformats.org/drawingml/2006/main" noGrp="1"/>
+          </p:cNvSpPr>
+          <p:nvPr/>
+        </p:nvSpPr>
+        <p:spPr>
+          <a:xfrm xmlns:a="http://schemas.openxmlformats.org/drawingml/2006/main">
+            <a:off x="514350" y="2057400"/>
+            <a:ext cx="6572250" cy="247650"/>
+          </a:xfrm>
+          <a:prstGeom xmlns:a="http://schemas.openxmlformats.org/drawingml/2006/main" prst="rect">
+            <a:avLst/>
+          </a:prstGeom>
+          <a:solidFill xmlns:a="http://schemas.openxmlformats.org/drawingml/2006/main">
+            <a:srgbClr val="00B8D9"/>
+          </a:solidFill>
+          <a:ln xmlns:a="http://schemas.openxmlformats.org/drawingml/2006/main" w="0">
+            <a:solidFill>
+              <a:srgbClr val="00B8D9"/>
+            </a:solidFill>
+            <a:prstDash val="solid"/>
+          </a:ln>
+        </p:spPr>
+      </p:sp>
+      <p:sp>
+        <p:nvSpPr>
+          <p:cNvPr id="10" name="risk-th-1">
+            <a:extLst xmlns:a="http://schemas.openxmlformats.org/drawingml/2006/main">
+              <a:ext uri="{FF2B5EF4-FFF2-40B4-BE49-F238E27FC236}">
+                <a16:creationId xmlns:a16="http://schemas.microsoft.com/office/drawing/2014/main" id="{C647D4A6-393E-497B-BB6D-FCD1F53C9D8C}"/>
+              </a:ext>
+            </a:extLst>
+          </p:cNvPr>
+          <p:cNvSpPr>
+            <a:spLocks xmlns:a="http://schemas.openxmlformats.org/drawingml/2006/main" noGrp="1"/>
+          </p:cNvSpPr>
+          <p:nvPr/>
+        </p:nvSpPr>
+        <p:spPr>
+          <a:xfrm xmlns:a="http://schemas.openxmlformats.org/drawingml/2006/main">
+            <a:off x="742950" y="2105025"/>
+            <a:ext cx="1047750" cy="171450"/>
+          </a:xfrm>
+          <a:prstGeom xmlns:a="http://schemas.openxmlformats.org/drawingml/2006/main" prst="rect">
+            <a:avLst/>
+          </a:prstGeom>
+          <a:noFill xmlns:a="http://schemas.openxmlformats.org/drawingml/2006/main"/>
+          <a:ln xmlns:a="http://schemas.openxmlformats.org/drawingml/2006/main" w="0">
+            <a:noFill/>
+            <a:prstDash val="solid"/>
+          </a:ln>
+        </p:spPr>
+        <p:txBody>
+          <a:bodyPr xmlns:a="http://schemas.openxmlformats.org/drawingml/2006/main"/>
+          <a:lstStyle xmlns:a="http://schemas.openxmlformats.org/drawingml/2006/main"/>
+          <a:p xmlns:a="http://schemas.openxmlformats.org/drawingml/2006/main">
+            <a:pPr>
+              <a:defRPr sz="975" b="1">
+                <a:solidFill>
+                  <a:srgbClr val="06111F"/>
+                </a:solidFill>
+              </a:defRPr>
+            </a:pPr>
+            <a:r>
+              <a:rPr sz="975" b="1">
+                <a:solidFill>
+                  <a:srgbClr val="06111F"/>
+                </a:solidFill>
+              </a:rPr>
+              <a:t>리스크</a:t>
+            </a:r>
+          </a:p>
+        </p:txBody>
+      </p:sp>
+      <p:sp>
+        <p:nvSpPr>
+          <p:cNvPr id="11" name="risk-th-2">
+            <a:extLst xmlns:a="http://schemas.openxmlformats.org/drawingml/2006/main">
+              <a:ext uri="{FF2B5EF4-FFF2-40B4-BE49-F238E27FC236}">
+                <a16:creationId xmlns:a16="http://schemas.microsoft.com/office/drawing/2014/main" id="{4A489B56-9255-4125-8967-067B66508EAF}"/>
+              </a:ext>
+            </a:extLst>
+          </p:cNvPr>
+          <p:cNvSpPr>
+            <a:spLocks xmlns:a="http://schemas.openxmlformats.org/drawingml/2006/main" noGrp="1"/>
+          </p:cNvSpPr>
+          <p:nvPr/>
+        </p:nvSpPr>
+        <p:spPr>
+          <a:xfrm xmlns:a="http://schemas.openxmlformats.org/drawingml/2006/main">
+            <a:off x="2152650" y="2105025"/>
+            <a:ext cx="1143000" cy="171450"/>
+          </a:xfrm>
+          <a:prstGeom xmlns:a="http://schemas.openxmlformats.org/drawingml/2006/main" prst="rect">
+            <a:avLst/>
+          </a:prstGeom>
+          <a:noFill xmlns:a="http://schemas.openxmlformats.org/drawingml/2006/main"/>
+          <a:ln xmlns:a="http://schemas.openxmlformats.org/drawingml/2006/main" w="0">
+            <a:noFill/>
+            <a:prstDash val="solid"/>
+          </a:ln>
+        </p:spPr>
+        <p:txBody>
+          <a:bodyPr xmlns:a="http://schemas.openxmlformats.org/drawingml/2006/main"/>
+          <a:lstStyle xmlns:a="http://schemas.openxmlformats.org/drawingml/2006/main"/>
+          <a:p xmlns:a="http://schemas.openxmlformats.org/drawingml/2006/main">
+            <a:pPr>
+              <a:defRPr sz="975" b="1">
+                <a:solidFill>
+                  <a:srgbClr val="06111F"/>
+                </a:solidFill>
+              </a:defRPr>
+            </a:pPr>
+            <a:r>
+              <a:rPr sz="975" b="1">
+                <a:solidFill>
+                  <a:srgbClr val="06111F"/>
+                </a:solidFill>
+              </a:rPr>
+              <a:t>영향</a:t>
+            </a:r>
+          </a:p>
+        </p:txBody>
+      </p:sp>
+      <p:sp>
+        <p:nvSpPr>
+          <p:cNvPr id="12" name="risk-th-3">
+            <a:extLst xmlns:a="http://schemas.openxmlformats.org/drawingml/2006/main">
+              <a:ext uri="{FF2B5EF4-FFF2-40B4-BE49-F238E27FC236}">
+                <a16:creationId xmlns:a16="http://schemas.microsoft.com/office/drawing/2014/main" id="{8836B600-8042-40F5-959F-02189E2E3691}"/>
+              </a:ext>
+            </a:extLst>
+          </p:cNvPr>
+          <p:cNvSpPr>
+            <a:spLocks xmlns:a="http://schemas.openxmlformats.org/drawingml/2006/main" noGrp="1"/>
+          </p:cNvSpPr>
+          <p:nvPr/>
+        </p:nvSpPr>
+        <p:spPr>
+          <a:xfrm xmlns:a="http://schemas.openxmlformats.org/drawingml/2006/main">
+            <a:off x="4762500" y="2105025"/>
+            <a:ext cx="1143000" cy="171450"/>
+          </a:xfrm>
+          <a:prstGeom xmlns:a="http://schemas.openxmlformats.org/drawingml/2006/main" prst="rect">
+            <a:avLst/>
+          </a:prstGeom>
+          <a:noFill xmlns:a="http://schemas.openxmlformats.org/drawingml/2006/main"/>
+          <a:ln xmlns:a="http://schemas.openxmlformats.org/drawingml/2006/main" w="0">
+            <a:noFill/>
+            <a:prstDash val="solid"/>
+          </a:ln>
+        </p:spPr>
+        <p:txBody>
+          <a:bodyPr xmlns:a="http://schemas.openxmlformats.org/drawingml/2006/main"/>
+          <a:lstStyle xmlns:a="http://schemas.openxmlformats.org/drawingml/2006/main"/>
+          <a:p xmlns:a="http://schemas.openxmlformats.org/drawingml/2006/main">
+            <a:pPr>
+              <a:defRPr sz="975" b="1">
+                <a:solidFill>
+                  <a:srgbClr val="06111F"/>
+                </a:solidFill>
+              </a:defRPr>
+            </a:pPr>
+            <a:r>
+              <a:rPr sz="975" b="1">
+                <a:solidFill>
+                  <a:srgbClr val="06111F"/>
+                </a:solidFill>
+              </a:rPr>
+              <a:t>대응</a:t>
+            </a:r>
+          </a:p>
+        </p:txBody>
+      </p:sp>
+      <p:sp>
+        <p:nvSpPr>
+          <p:cNvPr id="13" name="risk-row-1">
+            <a:extLst xmlns:a="http://schemas.openxmlformats.org/drawingml/2006/main">
+              <a:ext uri="{FF2B5EF4-FFF2-40B4-BE49-F238E27FC236}">
+                <a16:creationId xmlns:a16="http://schemas.microsoft.com/office/drawing/2014/main" id="{93507CBD-58EB-473A-868E-D06A2634E88F}"/>
+              </a:ext>
+            </a:extLst>
+          </p:cNvPr>
+          <p:cNvSpPr>
+            <a:spLocks xmlns:a="http://schemas.openxmlformats.org/drawingml/2006/main" noGrp="1"/>
+          </p:cNvSpPr>
+          <p:nvPr/>
+        </p:nvSpPr>
+        <p:spPr>
+          <a:xfrm xmlns:a="http://schemas.openxmlformats.org/drawingml/2006/main">
+            <a:off x="514350" y="2305050"/>
+            <a:ext cx="6572250" cy="628650"/>
+          </a:xfrm>
+          <a:prstGeom xmlns:a="http://schemas.openxmlformats.org/drawingml/2006/main" prst="rect">
+            <a:avLst/>
+          </a:prstGeom>
+          <a:solidFill xmlns:a="http://schemas.openxmlformats.org/drawingml/2006/main">
+            <a:srgbClr val="151F34"/>
+          </a:solidFill>
+          <a:ln xmlns:a="http://schemas.openxmlformats.org/drawingml/2006/main" w="9525">
+            <a:solidFill>
+              <a:srgbClr val="2F3B55"/>
+            </a:solidFill>
+            <a:prstDash val="solid"/>
+          </a:ln>
+        </p:spPr>
+      </p:sp>
+      <p:sp>
+        <p:nvSpPr>
+          <p:cNvPr id="14" name="risk-name-1">
+            <a:extLst xmlns:a="http://schemas.openxmlformats.org/drawingml/2006/main">
+              <a:ext uri="{FF2B5EF4-FFF2-40B4-BE49-F238E27FC236}">
+                <a16:creationId xmlns:a16="http://schemas.microsoft.com/office/drawing/2014/main" id="{8AC7D2E4-F22A-4559-97B2-1EEECC4B8D2B}"/>
+              </a:ext>
+            </a:extLst>
+          </p:cNvPr>
+          <p:cNvSpPr>
+            <a:spLocks xmlns:a="http://schemas.openxmlformats.org/drawingml/2006/main" noGrp="1"/>
+          </p:cNvSpPr>
+          <p:nvPr/>
+        </p:nvSpPr>
+        <p:spPr>
+          <a:xfrm xmlns:a="http://schemas.openxmlformats.org/drawingml/2006/main">
+            <a:off x="742950" y="2495550"/>
+            <a:ext cx="1238250" cy="228600"/>
+          </a:xfrm>
+          <a:prstGeom xmlns:a="http://schemas.openxmlformats.org/drawingml/2006/main" prst="rect">
+            <a:avLst/>
+          </a:prstGeom>
+          <a:noFill xmlns:a="http://schemas.openxmlformats.org/drawingml/2006/main"/>
+          <a:ln xmlns:a="http://schemas.openxmlformats.org/drawingml/2006/main" w="0">
+            <a:noFill/>
+            <a:prstDash val="solid"/>
+          </a:ln>
+        </p:spPr>
+        <p:txBody>
+          <a:bodyPr xmlns:a="http://schemas.openxmlformats.org/drawingml/2006/main"/>
+          <a:lstStyle xmlns:a="http://schemas.openxmlformats.org/drawingml/2006/main"/>
+          <a:p xmlns:a="http://schemas.openxmlformats.org/drawingml/2006/main">
+            <a:pPr>
+              <a:defRPr sz="1125" b="1">
+                <a:solidFill>
+                  <a:srgbClr val="00B8D9"/>
+                </a:solidFill>
+              </a:defRPr>
+            </a:pPr>
+            <a:r>
+              <a:rPr sz="1125" b="1">
+                <a:solidFill>
+                  <a:srgbClr val="00B8D9"/>
+                </a:solidFill>
+              </a:rPr>
+              <a:t>현지화 지연</a:t>
+            </a:r>
+          </a:p>
+        </p:txBody>
+      </p:sp>
+      <p:sp>
+        <p:nvSpPr>
+          <p:cNvPr id="15" name="risk-impact-1">
+            <a:extLst xmlns:a="http://schemas.openxmlformats.org/drawingml/2006/main">
+              <a:ext uri="{FF2B5EF4-FFF2-40B4-BE49-F238E27FC236}">
+                <a16:creationId xmlns:a16="http://schemas.microsoft.com/office/drawing/2014/main" id="{0D9174B5-71CC-4883-ACA0-CD6FBABB6C9E}"/>
+              </a:ext>
+            </a:extLst>
+          </p:cNvPr>
+          <p:cNvSpPr>
+            <a:spLocks xmlns:a="http://schemas.openxmlformats.org/drawingml/2006/main" noGrp="1"/>
+          </p:cNvSpPr>
+          <p:nvPr/>
+        </p:nvSpPr>
+        <p:spPr>
+          <a:xfrm xmlns:a="http://schemas.openxmlformats.org/drawingml/2006/main">
+            <a:off x="2152650" y="2428875"/>
+            <a:ext cx="2381250" cy="361950"/>
+          </a:xfrm>
+          <a:prstGeom xmlns:a="http://schemas.openxmlformats.org/drawingml/2006/main" prst="rect">
+            <a:avLst/>
+          </a:prstGeom>
+          <a:noFill xmlns:a="http://schemas.openxmlformats.org/drawingml/2006/main"/>
+          <a:ln xmlns:a="http://schemas.openxmlformats.org/drawingml/2006/main" w="0">
+            <a:noFill/>
+            <a:prstDash val="solid"/>
+          </a:ln>
+        </p:spPr>
+        <p:txBody>
+          <a:bodyPr xmlns:a="http://schemas.openxmlformats.org/drawingml/2006/main"/>
+          <a:lstStyle xmlns:a="http://schemas.openxmlformats.org/drawingml/2006/main"/>
+          <a:p xmlns:a="http://schemas.openxmlformats.org/drawingml/2006/main">
+            <a:pPr>
+              <a:defRPr sz="975">
+                <a:solidFill>
+                  <a:srgbClr val="CBD5E1"/>
+                </a:solidFill>
+              </a:defRPr>
+            </a:pPr>
+            <a:r>
+              <a:rPr sz="975">
+                <a:solidFill>
+                  <a:srgbClr val="CBD5E1"/>
+                </a:solidFill>
+              </a:rPr>
+              <a:t>번역·리소스 반영 지연으로 검수 일정 압박</a:t>
+            </a:r>
+          </a:p>
+        </p:txBody>
+      </p:sp>
+      <p:sp>
+        <p:nvSpPr>
+          <p:cNvPr id="16" name="risk-response-1">
+            <a:extLst xmlns:a="http://schemas.openxmlformats.org/drawingml/2006/main">
+              <a:ext uri="{FF2B5EF4-FFF2-40B4-BE49-F238E27FC236}">
+                <a16:creationId xmlns:a16="http://schemas.microsoft.com/office/drawing/2014/main" id="{8F3096FA-1397-4C3A-9C64-B9A153F146FE}"/>
+              </a:ext>
+            </a:extLst>
+          </p:cNvPr>
+          <p:cNvSpPr>
+            <a:spLocks xmlns:a="http://schemas.openxmlformats.org/drawingml/2006/main" noGrp="1"/>
+          </p:cNvSpPr>
+          <p:nvPr/>
+        </p:nvSpPr>
+        <p:spPr>
+          <a:xfrm xmlns:a="http://schemas.openxmlformats.org/drawingml/2006/main">
+            <a:off x="4762500" y="2428875"/>
+            <a:ext cx="1809750" cy="361950"/>
+          </a:xfrm>
+          <a:prstGeom xmlns:a="http://schemas.openxmlformats.org/drawingml/2006/main" prst="rect">
+            <a:avLst/>
+          </a:prstGeom>
+          <a:noFill xmlns:a="http://schemas.openxmlformats.org/drawingml/2006/main"/>
+          <a:ln xmlns:a="http://schemas.openxmlformats.org/drawingml/2006/main" w="0">
+            <a:noFill/>
+            <a:prstDash val="solid"/>
+          </a:ln>
+        </p:spPr>
+        <p:txBody>
+          <a:bodyPr xmlns:a="http://schemas.openxmlformats.org/drawingml/2006/main"/>
+          <a:lstStyle xmlns:a="http://schemas.openxmlformats.org/drawingml/2006/main"/>
+          <a:p xmlns:a="http://schemas.openxmlformats.org/drawingml/2006/main">
+            <a:pPr>
+              <a:defRPr sz="975">
+                <a:solidFill>
+                  <a:srgbClr val="FFFFFF"/>
+                </a:solidFill>
+              </a:defRPr>
+            </a:pPr>
+            <a:r>
+              <a:rPr sz="975">
+                <a:solidFill>
+                  <a:srgbClr val="FFFFFF"/>
+                </a:solidFill>
+              </a:rPr>
+              <a:t>반영 범위와 우선순위 재정렬</a:t>
+            </a:r>
+          </a:p>
+        </p:txBody>
+      </p:sp>
+      <p:sp>
+        <p:nvSpPr>
+          <p:cNvPr id="17" name="risk-row-2">
+            <a:extLst xmlns:a="http://schemas.openxmlformats.org/drawingml/2006/main">
+              <a:ext uri="{FF2B5EF4-FFF2-40B4-BE49-F238E27FC236}">
+                <a16:creationId xmlns:a16="http://schemas.microsoft.com/office/drawing/2014/main" id="{22B574F3-663F-4C1E-A62B-0F376042CA9E}"/>
+              </a:ext>
+            </a:extLst>
+          </p:cNvPr>
+          <p:cNvSpPr>
+            <a:spLocks xmlns:a="http://schemas.openxmlformats.org/drawingml/2006/main" noGrp="1"/>
+          </p:cNvSpPr>
+          <p:nvPr/>
+        </p:nvSpPr>
+        <p:spPr>
+          <a:xfrm xmlns:a="http://schemas.openxmlformats.org/drawingml/2006/main">
+            <a:off x="514350" y="2933700"/>
+            <a:ext cx="6572250" cy="628650"/>
+          </a:xfrm>
+          <a:prstGeom xmlns:a="http://schemas.openxmlformats.org/drawingml/2006/main" prst="rect">
+            <a:avLst/>
+          </a:prstGeom>
+          <a:solidFill xmlns:a="http://schemas.openxmlformats.org/drawingml/2006/main">
+            <a:srgbClr val="111827"/>
+          </a:solidFill>
+          <a:ln xmlns:a="http://schemas.openxmlformats.org/drawingml/2006/main" w="9525">
+            <a:solidFill>
+              <a:srgbClr val="2F3B55"/>
+            </a:solidFill>
+            <a:prstDash val="solid"/>
+          </a:ln>
+        </p:spPr>
+      </p:sp>
+      <p:sp>
+        <p:nvSpPr>
+          <p:cNvPr id="18" name="risk-name-2">
+            <a:extLst xmlns:a="http://schemas.openxmlformats.org/drawingml/2006/main">
+              <a:ext uri="{FF2B5EF4-FFF2-40B4-BE49-F238E27FC236}">
+                <a16:creationId xmlns:a16="http://schemas.microsoft.com/office/drawing/2014/main" id="{A7A4FBD0-69B9-4DF1-8FBF-F1A4210C7403}"/>
+              </a:ext>
+            </a:extLst>
+          </p:cNvPr>
+          <p:cNvSpPr>
+            <a:spLocks xmlns:a="http://schemas.openxmlformats.org/drawingml/2006/main" noGrp="1"/>
+          </p:cNvSpPr>
+          <p:nvPr/>
+        </p:nvSpPr>
+        <p:spPr>
+          <a:xfrm xmlns:a="http://schemas.openxmlformats.org/drawingml/2006/main">
+            <a:off x="742950" y="3124200"/>
+            <a:ext cx="1238250" cy="228600"/>
+          </a:xfrm>
+          <a:prstGeom xmlns:a="http://schemas.openxmlformats.org/drawingml/2006/main" prst="rect">
+            <a:avLst/>
+          </a:prstGeom>
+          <a:noFill xmlns:a="http://schemas.openxmlformats.org/drawingml/2006/main"/>
+          <a:ln xmlns:a="http://schemas.openxmlformats.org/drawingml/2006/main" w="0">
+            <a:noFill/>
+            <a:prstDash val="solid"/>
+          </a:ln>
+        </p:spPr>
+        <p:txBody>
+          <a:bodyPr xmlns:a="http://schemas.openxmlformats.org/drawingml/2006/main"/>
+          <a:lstStyle xmlns:a="http://schemas.openxmlformats.org/drawingml/2006/main"/>
+          <a:p xmlns:a="http://schemas.openxmlformats.org/drawingml/2006/main">
+            <a:pPr>
+              <a:defRPr sz="1125" b="1">
+                <a:solidFill>
+                  <a:srgbClr val="FF6B35"/>
+                </a:solidFill>
+              </a:defRPr>
+            </a:pPr>
+            <a:r>
+              <a:rPr sz="1125" b="1">
+                <a:solidFill>
+                  <a:srgbClr val="FF6B35"/>
+                </a:solidFill>
+              </a:rPr>
+              <a:t>빌드 불안정</a:t>
+            </a:r>
+          </a:p>
+        </p:txBody>
+      </p:sp>
+      <p:sp>
+        <p:nvSpPr>
+          <p:cNvPr id="19" name="risk-impact-2">
+            <a:extLst xmlns:a="http://schemas.openxmlformats.org/drawingml/2006/main">
+              <a:ext uri="{FF2B5EF4-FFF2-40B4-BE49-F238E27FC236}">
+                <a16:creationId xmlns:a16="http://schemas.microsoft.com/office/drawing/2014/main" id="{2D87ABAF-6CB8-4DA7-88E6-9D954572536B}"/>
+              </a:ext>
+            </a:extLst>
+          </p:cNvPr>
+          <p:cNvSpPr>
+            <a:spLocks xmlns:a="http://schemas.openxmlformats.org/drawingml/2006/main" noGrp="1"/>
+          </p:cNvSpPr>
+          <p:nvPr/>
+        </p:nvSpPr>
+        <p:spPr>
+          <a:xfrm xmlns:a="http://schemas.openxmlformats.org/drawingml/2006/main">
+            <a:off x="2152650" y="3057525"/>
+            <a:ext cx="2381250" cy="361950"/>
+          </a:xfrm>
+          <a:prstGeom xmlns:a="http://schemas.openxmlformats.org/drawingml/2006/main" prst="rect">
+            <a:avLst/>
+          </a:prstGeom>
+          <a:noFill xmlns:a="http://schemas.openxmlformats.org/drawingml/2006/main"/>
+          <a:ln xmlns:a="http://schemas.openxmlformats.org/drawingml/2006/main" w="0">
+            <a:noFill/>
+            <a:prstDash val="solid"/>
+          </a:ln>
+        </p:spPr>
+        <p:txBody>
+          <a:bodyPr xmlns:a="http://schemas.openxmlformats.org/drawingml/2006/main"/>
+          <a:lstStyle xmlns:a="http://schemas.openxmlformats.org/drawingml/2006/main"/>
+          <a:p xmlns:a="http://schemas.openxmlformats.org/drawingml/2006/main">
+            <a:pPr>
+              <a:defRPr sz="975">
+                <a:solidFill>
+                  <a:srgbClr val="CBD5E1"/>
+                </a:solidFill>
+              </a:defRPr>
+            </a:pPr>
+            <a:r>
+              <a:rPr sz="975">
+                <a:solidFill>
+                  <a:srgbClr val="CBD5E1"/>
+                </a:solidFill>
+              </a:rPr>
+              <a:t>후보 빌드 기준 미고정과 긴급 수정 누적</a:t>
+            </a:r>
+          </a:p>
+        </p:txBody>
+      </p:sp>
+      <p:sp>
+        <p:nvSpPr>
+          <p:cNvPr id="20" name="risk-response-2">
+            <a:extLst xmlns:a="http://schemas.openxmlformats.org/drawingml/2006/main">
+              <a:ext uri="{FF2B5EF4-FFF2-40B4-BE49-F238E27FC236}">
+                <a16:creationId xmlns:a16="http://schemas.microsoft.com/office/drawing/2014/main" id="{3417579A-CE04-41C1-977A-DB1056926B87}"/>
+              </a:ext>
+            </a:extLst>
+          </p:cNvPr>
+          <p:cNvSpPr>
+            <a:spLocks xmlns:a="http://schemas.openxmlformats.org/drawingml/2006/main" noGrp="1"/>
+          </p:cNvSpPr>
+          <p:nvPr/>
+        </p:nvSpPr>
+        <p:spPr>
+          <a:xfrm xmlns:a="http://schemas.openxmlformats.org/drawingml/2006/main">
+            <a:off x="4762500" y="3057525"/>
+            <a:ext cx="1809750" cy="361950"/>
+          </a:xfrm>
+          <a:prstGeom xmlns:a="http://schemas.openxmlformats.org/drawingml/2006/main" prst="rect">
+            <a:avLst/>
+          </a:prstGeom>
+          <a:noFill xmlns:a="http://schemas.openxmlformats.org/drawingml/2006/main"/>
+          <a:ln xmlns:a="http://schemas.openxmlformats.org/drawingml/2006/main" w="0">
+            <a:noFill/>
+            <a:prstDash val="solid"/>
+          </a:ln>
+        </p:spPr>
+        <p:txBody>
+          <a:bodyPr xmlns:a="http://schemas.openxmlformats.org/drawingml/2006/main"/>
+          <a:lstStyle xmlns:a="http://schemas.openxmlformats.org/drawingml/2006/main"/>
+          <a:p xmlns:a="http://schemas.openxmlformats.org/drawingml/2006/main">
+            <a:pPr>
+              <a:defRPr sz="975">
+                <a:solidFill>
+                  <a:srgbClr val="FFFFFF"/>
+                </a:solidFill>
+              </a:defRPr>
+            </a:pPr>
+            <a:r>
+              <a:rPr sz="975">
+                <a:solidFill>
+                  <a:srgbClr val="FFFFFF"/>
+                </a:solidFill>
+              </a:rPr>
+              <a:t>브랜치·태그 기준 고정</a:t>
+            </a:r>
+          </a:p>
+        </p:txBody>
+      </p:sp>
+      <p:sp>
+        <p:nvSpPr>
+          <p:cNvPr id="21" name="risk-row-3">
+            <a:extLst xmlns:a="http://schemas.openxmlformats.org/drawingml/2006/main">
+              <a:ext uri="{FF2B5EF4-FFF2-40B4-BE49-F238E27FC236}">
+                <a16:creationId xmlns:a16="http://schemas.microsoft.com/office/drawing/2014/main" id="{268A2E18-532E-42C9-A2EC-9EF168E6D370}"/>
+              </a:ext>
+            </a:extLst>
+          </p:cNvPr>
+          <p:cNvSpPr>
+            <a:spLocks xmlns:a="http://schemas.openxmlformats.org/drawingml/2006/main" noGrp="1"/>
+          </p:cNvSpPr>
+          <p:nvPr/>
+        </p:nvSpPr>
+        <p:spPr>
+          <a:xfrm xmlns:a="http://schemas.openxmlformats.org/drawingml/2006/main">
+            <a:off x="514350" y="3562350"/>
+            <a:ext cx="6572250" cy="628650"/>
+          </a:xfrm>
+          <a:prstGeom xmlns:a="http://schemas.openxmlformats.org/drawingml/2006/main" prst="rect">
+            <a:avLst/>
+          </a:prstGeom>
+          <a:solidFill xmlns:a="http://schemas.openxmlformats.org/drawingml/2006/main">
+            <a:srgbClr val="151F34"/>
+          </a:solidFill>
+          <a:ln xmlns:a="http://schemas.openxmlformats.org/drawingml/2006/main" w="9525">
+            <a:solidFill>
+              <a:srgbClr val="2F3B55"/>
+            </a:solidFill>
+            <a:prstDash val="solid"/>
+          </a:ln>
+        </p:spPr>
+      </p:sp>
+      <p:sp>
+        <p:nvSpPr>
+          <p:cNvPr id="22" name="risk-name-3">
+            <a:extLst xmlns:a="http://schemas.openxmlformats.org/drawingml/2006/main">
+              <a:ext uri="{FF2B5EF4-FFF2-40B4-BE49-F238E27FC236}">
+                <a16:creationId xmlns:a16="http://schemas.microsoft.com/office/drawing/2014/main" id="{A7C85972-FB73-4108-AB59-E3AD2B6A4AD6}"/>
+              </a:ext>
+            </a:extLst>
+          </p:cNvPr>
+          <p:cNvSpPr>
+            <a:spLocks xmlns:a="http://schemas.openxmlformats.org/drawingml/2006/main" noGrp="1"/>
+          </p:cNvSpPr>
+          <p:nvPr/>
+        </p:nvSpPr>
+        <p:spPr>
+          <a:xfrm xmlns:a="http://schemas.openxmlformats.org/drawingml/2006/main">
+            <a:off x="742950" y="3752850"/>
+            <a:ext cx="1238250" cy="228600"/>
+          </a:xfrm>
+          <a:prstGeom xmlns:a="http://schemas.openxmlformats.org/drawingml/2006/main" prst="rect">
+            <a:avLst/>
+          </a:prstGeom>
+          <a:noFill xmlns:a="http://schemas.openxmlformats.org/drawingml/2006/main"/>
+          <a:ln xmlns:a="http://schemas.openxmlformats.org/drawingml/2006/main" w="0">
+            <a:noFill/>
+            <a:prstDash val="solid"/>
+          </a:ln>
+        </p:spPr>
+        <p:txBody>
+          <a:bodyPr xmlns:a="http://schemas.openxmlformats.org/drawingml/2006/main"/>
+          <a:lstStyle xmlns:a="http://schemas.openxmlformats.org/drawingml/2006/main"/>
+          <a:p xmlns:a="http://schemas.openxmlformats.org/drawingml/2006/main">
+            <a:pPr>
+              <a:defRPr sz="1125" b="1">
+                <a:solidFill>
+                  <a:srgbClr val="7C3AED"/>
+                </a:solidFill>
+              </a:defRPr>
+            </a:pPr>
+            <a:r>
+              <a:rPr sz="1125" b="1">
+                <a:solidFill>
+                  <a:srgbClr val="7C3AED"/>
+                </a:solidFill>
+              </a:rPr>
+              <a:t>QA 병목</a:t>
+            </a:r>
+          </a:p>
+        </p:txBody>
+      </p:sp>
+      <p:sp>
+        <p:nvSpPr>
+          <p:cNvPr id="23" name="risk-impact-3">
+            <a:extLst xmlns:a="http://schemas.openxmlformats.org/drawingml/2006/main">
+              <a:ext uri="{FF2B5EF4-FFF2-40B4-BE49-F238E27FC236}">
+                <a16:creationId xmlns:a16="http://schemas.microsoft.com/office/drawing/2014/main" id="{76A45D05-E701-41F9-802B-6A49F0A61A63}"/>
+              </a:ext>
+            </a:extLst>
+          </p:cNvPr>
+          <p:cNvSpPr>
+            <a:spLocks xmlns:a="http://schemas.openxmlformats.org/drawingml/2006/main" noGrp="1"/>
+          </p:cNvSpPr>
+          <p:nvPr/>
+        </p:nvSpPr>
+        <p:spPr>
+          <a:xfrm xmlns:a="http://schemas.openxmlformats.org/drawingml/2006/main">
+            <a:off x="2152650" y="3686175"/>
+            <a:ext cx="2381250" cy="361950"/>
+          </a:xfrm>
+          <a:prstGeom xmlns:a="http://schemas.openxmlformats.org/drawingml/2006/main" prst="rect">
+            <a:avLst/>
+          </a:prstGeom>
+          <a:noFill xmlns:a="http://schemas.openxmlformats.org/drawingml/2006/main"/>
+          <a:ln xmlns:a="http://schemas.openxmlformats.org/drawingml/2006/main" w="0">
+            <a:noFill/>
+            <a:prstDash val="solid"/>
+          </a:ln>
+        </p:spPr>
+        <p:txBody>
+          <a:bodyPr xmlns:a="http://schemas.openxmlformats.org/drawingml/2006/main"/>
+          <a:lstStyle xmlns:a="http://schemas.openxmlformats.org/drawingml/2006/main"/>
+          <a:p xmlns:a="http://schemas.openxmlformats.org/drawingml/2006/main">
+            <a:pPr>
+              <a:defRPr sz="975">
+                <a:solidFill>
+                  <a:srgbClr val="CBD5E1"/>
+                </a:solidFill>
+              </a:defRPr>
+            </a:pPr>
+            <a:r>
+              <a:rPr sz="975">
+                <a:solidFill>
+                  <a:srgbClr val="CBD5E1"/>
+                </a:solidFill>
+              </a:rPr>
+              <a:t>이슈 분류 지연과 수정 검증 대기 증가</a:t>
+            </a:r>
+          </a:p>
+        </p:txBody>
+      </p:sp>
+      <p:sp>
+        <p:nvSpPr>
+          <p:cNvPr id="24" name="risk-response-3">
+            <a:extLst xmlns:a="http://schemas.openxmlformats.org/drawingml/2006/main">
+              <a:ext uri="{FF2B5EF4-FFF2-40B4-BE49-F238E27FC236}">
+                <a16:creationId xmlns:a16="http://schemas.microsoft.com/office/drawing/2014/main" id="{CA4518BD-7A2A-436E-87AE-B436A1654CC0}"/>
+              </a:ext>
+            </a:extLst>
+          </p:cNvPr>
+          <p:cNvSpPr>
+            <a:spLocks xmlns:a="http://schemas.openxmlformats.org/drawingml/2006/main" noGrp="1"/>
+          </p:cNvSpPr>
+          <p:nvPr/>
+        </p:nvSpPr>
+        <p:spPr>
+          <a:xfrm xmlns:a="http://schemas.openxmlformats.org/drawingml/2006/main">
+            <a:off x="4762500" y="3686175"/>
+            <a:ext cx="1809750" cy="361950"/>
+          </a:xfrm>
+          <a:prstGeom xmlns:a="http://schemas.openxmlformats.org/drawingml/2006/main" prst="rect">
+            <a:avLst/>
+          </a:prstGeom>
+          <a:noFill xmlns:a="http://schemas.openxmlformats.org/drawingml/2006/main"/>
+          <a:ln xmlns:a="http://schemas.openxmlformats.org/drawingml/2006/main" w="0">
+            <a:noFill/>
+            <a:prstDash val="solid"/>
+          </a:ln>
+        </p:spPr>
+        <p:txBody>
+          <a:bodyPr xmlns:a="http://schemas.openxmlformats.org/drawingml/2006/main"/>
+          <a:lstStyle xmlns:a="http://schemas.openxmlformats.org/drawingml/2006/main"/>
+          <a:p xmlns:a="http://schemas.openxmlformats.org/drawingml/2006/main">
+            <a:pPr>
+              <a:defRPr sz="975">
+                <a:solidFill>
+                  <a:srgbClr val="FFFFFF"/>
+                </a:solidFill>
+              </a:defRPr>
+            </a:pPr>
+            <a:r>
+              <a:rPr sz="975">
+                <a:solidFill>
+                  <a:srgbClr val="FFFFFF"/>
+                </a:solidFill>
+              </a:rPr>
+              <a:t>재현 정보와 수정 일정 추적</a:t>
+            </a:r>
+          </a:p>
+        </p:txBody>
+      </p:sp>
+      <p:sp>
+        <p:nvSpPr>
+          <p:cNvPr id="25" name="risk-row-4">
+            <a:extLst xmlns:a="http://schemas.openxmlformats.org/drawingml/2006/main">
+              <a:ext uri="{FF2B5EF4-FFF2-40B4-BE49-F238E27FC236}">
+                <a16:creationId xmlns:a16="http://schemas.microsoft.com/office/drawing/2014/main" id="{9F34B709-23C2-4E70-8392-E6960C0F7423}"/>
+              </a:ext>
+            </a:extLst>
+          </p:cNvPr>
+          <p:cNvSpPr>
+            <a:spLocks xmlns:a="http://schemas.openxmlformats.org/drawingml/2006/main" noGrp="1"/>
+          </p:cNvSpPr>
+          <p:nvPr/>
+        </p:nvSpPr>
+        <p:spPr>
+          <a:xfrm xmlns:a="http://schemas.openxmlformats.org/drawingml/2006/main">
+            <a:off x="514350" y="4191000"/>
+            <a:ext cx="6572250" cy="628650"/>
+          </a:xfrm>
+          <a:prstGeom xmlns:a="http://schemas.openxmlformats.org/drawingml/2006/main" prst="rect">
+            <a:avLst/>
+          </a:prstGeom>
+          <a:solidFill xmlns:a="http://schemas.openxmlformats.org/drawingml/2006/main">
+            <a:srgbClr val="111827"/>
+          </a:solidFill>
+          <a:ln xmlns:a="http://schemas.openxmlformats.org/drawingml/2006/main" w="9525">
+            <a:solidFill>
+              <a:srgbClr val="2F3B55"/>
+            </a:solidFill>
+            <a:prstDash val="solid"/>
+          </a:ln>
+        </p:spPr>
+      </p:sp>
+      <p:sp>
+        <p:nvSpPr>
+          <p:cNvPr id="26" name="risk-name-4">
+            <a:extLst xmlns:a="http://schemas.openxmlformats.org/drawingml/2006/main">
+              <a:ext uri="{FF2B5EF4-FFF2-40B4-BE49-F238E27FC236}">
+                <a16:creationId xmlns:a16="http://schemas.microsoft.com/office/drawing/2014/main" id="{79282555-94FE-46C4-9553-10E1CB4AAF49}"/>
+              </a:ext>
+            </a:extLst>
+          </p:cNvPr>
+          <p:cNvSpPr>
+            <a:spLocks xmlns:a="http://schemas.openxmlformats.org/drawingml/2006/main" noGrp="1"/>
+          </p:cNvSpPr>
+          <p:nvPr/>
+        </p:nvSpPr>
+        <p:spPr>
+          <a:xfrm xmlns:a="http://schemas.openxmlformats.org/drawingml/2006/main">
+            <a:off x="742950" y="4381500"/>
+            <a:ext cx="1238250" cy="228600"/>
+          </a:xfrm>
+          <a:prstGeom xmlns:a="http://schemas.openxmlformats.org/drawingml/2006/main" prst="rect">
+            <a:avLst/>
+          </a:prstGeom>
+          <a:noFill xmlns:a="http://schemas.openxmlformats.org/drawingml/2006/main"/>
+          <a:ln xmlns:a="http://schemas.openxmlformats.org/drawingml/2006/main" w="0">
+            <a:noFill/>
+            <a:prstDash val="solid"/>
+          </a:ln>
+        </p:spPr>
+        <p:txBody>
+          <a:bodyPr xmlns:a="http://schemas.openxmlformats.org/drawingml/2006/main"/>
+          <a:lstStyle xmlns:a="http://schemas.openxmlformats.org/drawingml/2006/main"/>
+          <a:p xmlns:a="http://schemas.openxmlformats.org/drawingml/2006/main">
+            <a:pPr>
+              <a:defRPr sz="1125" b="1">
+                <a:solidFill>
+                  <a:srgbClr val="8BD9E8"/>
+                </a:solidFill>
+              </a:defRPr>
+            </a:pPr>
+            <a:r>
+              <a:rPr sz="1125" b="1">
+                <a:solidFill>
+                  <a:srgbClr val="8BD9E8"/>
+                </a:solidFill>
+              </a:rPr>
+              <a:t>피드백 지연</a:t>
+            </a:r>
+          </a:p>
+        </p:txBody>
+      </p:sp>
+      <p:sp>
+        <p:nvSpPr>
+          <p:cNvPr id="27" name="risk-impact-4">
+            <a:extLst xmlns:a="http://schemas.openxmlformats.org/drawingml/2006/main">
+              <a:ext uri="{FF2B5EF4-FFF2-40B4-BE49-F238E27FC236}">
+                <a16:creationId xmlns:a16="http://schemas.microsoft.com/office/drawing/2014/main" id="{4461E9A9-CD62-4FEE-9906-EFD5682946C4}"/>
+              </a:ext>
+            </a:extLst>
+          </p:cNvPr>
+          <p:cNvSpPr>
+            <a:spLocks xmlns:a="http://schemas.openxmlformats.org/drawingml/2006/main" noGrp="1"/>
+          </p:cNvSpPr>
+          <p:nvPr/>
+        </p:nvSpPr>
+        <p:spPr>
+          <a:xfrm xmlns:a="http://schemas.openxmlformats.org/drawingml/2006/main">
+            <a:off x="2152650" y="4314825"/>
+            <a:ext cx="2381250" cy="361950"/>
+          </a:xfrm>
+          <a:prstGeom xmlns:a="http://schemas.openxmlformats.org/drawingml/2006/main" prst="rect">
+            <a:avLst/>
+          </a:prstGeom>
+          <a:noFill xmlns:a="http://schemas.openxmlformats.org/drawingml/2006/main"/>
+          <a:ln xmlns:a="http://schemas.openxmlformats.org/drawingml/2006/main" w="0">
+            <a:noFill/>
+            <a:prstDash val="solid"/>
+          </a:ln>
+        </p:spPr>
+        <p:txBody>
+          <a:bodyPr xmlns:a="http://schemas.openxmlformats.org/drawingml/2006/main"/>
+          <a:lstStyle xmlns:a="http://schemas.openxmlformats.org/drawingml/2006/main"/>
+          <a:p xmlns:a="http://schemas.openxmlformats.org/drawingml/2006/main">
+            <a:pPr>
+              <a:defRPr sz="975">
+                <a:solidFill>
+                  <a:srgbClr val="CBD5E1"/>
+                </a:solidFill>
+              </a:defRPr>
+            </a:pPr>
+            <a:r>
+              <a:rPr sz="975">
+                <a:solidFill>
+                  <a:srgbClr val="CBD5E1"/>
+                </a:solidFill>
+              </a:rPr>
+              <a:t>퍼블리셔 검수 의견 회신과 재전달 일정 불명확</a:t>
+            </a:r>
+          </a:p>
+        </p:txBody>
+      </p:sp>
+      <p:sp>
+        <p:nvSpPr>
+          <p:cNvPr id="28" name="risk-response-4">
+            <a:extLst xmlns:a="http://schemas.openxmlformats.org/drawingml/2006/main">
+              <a:ext uri="{FF2B5EF4-FFF2-40B4-BE49-F238E27FC236}">
+                <a16:creationId xmlns:a16="http://schemas.microsoft.com/office/drawing/2014/main" id="{BC5103D7-B8E3-4BF2-B208-E019718BE190}"/>
+              </a:ext>
+            </a:extLst>
+          </p:cNvPr>
+          <p:cNvSpPr>
+            <a:spLocks xmlns:a="http://schemas.openxmlformats.org/drawingml/2006/main" noGrp="1"/>
+          </p:cNvSpPr>
+          <p:nvPr/>
+        </p:nvSpPr>
+        <p:spPr>
+          <a:xfrm xmlns:a="http://schemas.openxmlformats.org/drawingml/2006/main">
+            <a:off x="4762500" y="4314825"/>
+            <a:ext cx="1809750" cy="361950"/>
+          </a:xfrm>
+          <a:prstGeom xmlns:a="http://schemas.openxmlformats.org/drawingml/2006/main" prst="rect">
+            <a:avLst/>
+          </a:prstGeom>
+          <a:noFill xmlns:a="http://schemas.openxmlformats.org/drawingml/2006/main"/>
+          <a:ln xmlns:a="http://schemas.openxmlformats.org/drawingml/2006/main" w="0">
+            <a:noFill/>
+            <a:prstDash val="solid"/>
+          </a:ln>
+        </p:spPr>
+        <p:txBody>
+          <a:bodyPr xmlns:a="http://schemas.openxmlformats.org/drawingml/2006/main"/>
+          <a:lstStyle xmlns:a="http://schemas.openxmlformats.org/drawingml/2006/main"/>
+          <a:p xmlns:a="http://schemas.openxmlformats.org/drawingml/2006/main">
+            <a:pPr>
+              <a:defRPr sz="975">
+                <a:solidFill>
+                  <a:srgbClr val="FFFFFF"/>
+                </a:solidFill>
+              </a:defRPr>
+            </a:pPr>
+            <a:r>
+              <a:rPr sz="975">
+                <a:solidFill>
+                  <a:srgbClr val="FFFFFF"/>
+                </a:solidFill>
+              </a:rPr>
+              <a:t>요청·회신·재전달 상태 관리</a:t>
+            </a:r>
+          </a:p>
+        </p:txBody>
+      </p:sp>
+      <p:sp>
+        <p:nvSpPr>
+          <p:cNvPr id="29" name="risk-row-5">
+            <a:extLst xmlns:a="http://schemas.openxmlformats.org/drawingml/2006/main">
+              <a:ext uri="{FF2B5EF4-FFF2-40B4-BE49-F238E27FC236}">
+                <a16:creationId xmlns:a16="http://schemas.microsoft.com/office/drawing/2014/main" id="{FBE01808-DA87-46C9-B5E2-BEB2C1CB5060}"/>
+              </a:ext>
+            </a:extLst>
+          </p:cNvPr>
+          <p:cNvSpPr>
+            <a:spLocks xmlns:a="http://schemas.openxmlformats.org/drawingml/2006/main" noGrp="1"/>
+          </p:cNvSpPr>
+          <p:nvPr/>
+        </p:nvSpPr>
+        <p:spPr>
+          <a:xfrm xmlns:a="http://schemas.openxmlformats.org/drawingml/2006/main">
+            <a:off x="514350" y="4819650"/>
+            <a:ext cx="6572250" cy="628650"/>
+          </a:xfrm>
+          <a:prstGeom xmlns:a="http://schemas.openxmlformats.org/drawingml/2006/main" prst="rect">
+            <a:avLst/>
+          </a:prstGeom>
+          <a:solidFill xmlns:a="http://schemas.openxmlformats.org/drawingml/2006/main">
+            <a:srgbClr val="151F34"/>
+          </a:solidFill>
+          <a:ln xmlns:a="http://schemas.openxmlformats.org/drawingml/2006/main" w="9525">
+            <a:solidFill>
+              <a:srgbClr val="2F3B55"/>
+            </a:solidFill>
+            <a:prstDash val="solid"/>
+          </a:ln>
+        </p:spPr>
+      </p:sp>
+      <p:sp>
+        <p:nvSpPr>
+          <p:cNvPr id="30" name="risk-name-5">
+            <a:extLst xmlns:a="http://schemas.openxmlformats.org/drawingml/2006/main">
+              <a:ext uri="{FF2B5EF4-FFF2-40B4-BE49-F238E27FC236}">
+                <a16:creationId xmlns:a16="http://schemas.microsoft.com/office/drawing/2014/main" id="{9C8A501E-EAE5-40BF-8A11-2EDDE292ABBB}"/>
+              </a:ext>
+            </a:extLst>
+          </p:cNvPr>
+          <p:cNvSpPr>
+            <a:spLocks xmlns:a="http://schemas.openxmlformats.org/drawingml/2006/main" noGrp="1"/>
+          </p:cNvSpPr>
+          <p:nvPr/>
+        </p:nvSpPr>
+        <p:spPr>
+          <a:xfrm xmlns:a="http://schemas.openxmlformats.org/drawingml/2006/main">
+            <a:off x="742950" y="5010150"/>
+            <a:ext cx="1238250" cy="228600"/>
+          </a:xfrm>
+          <a:prstGeom xmlns:a="http://schemas.openxmlformats.org/drawingml/2006/main" prst="rect">
+            <a:avLst/>
+          </a:prstGeom>
+          <a:noFill xmlns:a="http://schemas.openxmlformats.org/drawingml/2006/main"/>
+          <a:ln xmlns:a="http://schemas.openxmlformats.org/drawingml/2006/main" w="0">
+            <a:noFill/>
+            <a:prstDash val="solid"/>
+          </a:ln>
+        </p:spPr>
+        <p:txBody>
+          <a:bodyPr xmlns:a="http://schemas.openxmlformats.org/drawingml/2006/main"/>
+          <a:lstStyle xmlns:a="http://schemas.openxmlformats.org/drawingml/2006/main"/>
+          <a:p xmlns:a="http://schemas.openxmlformats.org/drawingml/2006/main">
+            <a:pPr>
+              <a:defRPr sz="1125" b="1">
+                <a:solidFill>
+                  <a:srgbClr val="FF6B35"/>
+                </a:solidFill>
+              </a:defRPr>
+            </a:pPr>
+            <a:r>
+              <a:rPr sz="1125" b="1">
+                <a:solidFill>
+                  <a:srgbClr val="FF6B35"/>
+                </a:solidFill>
+              </a:rPr>
+              <a:t>직전 변경</a:t>
+            </a:r>
+          </a:p>
+        </p:txBody>
+      </p:sp>
+      <p:sp>
+        <p:nvSpPr>
+          <p:cNvPr id="31" name="risk-impact-5">
+            <a:extLst xmlns:a="http://schemas.openxmlformats.org/drawingml/2006/main">
+              <a:ext uri="{FF2B5EF4-FFF2-40B4-BE49-F238E27FC236}">
+                <a16:creationId xmlns:a16="http://schemas.microsoft.com/office/drawing/2014/main" id="{0AA21A79-AE73-4EE4-802E-BA69370F6707}"/>
+              </a:ext>
+            </a:extLst>
+          </p:cNvPr>
+          <p:cNvSpPr>
+            <a:spLocks xmlns:a="http://schemas.openxmlformats.org/drawingml/2006/main" noGrp="1"/>
+          </p:cNvSpPr>
+          <p:nvPr/>
+        </p:nvSpPr>
+        <p:spPr>
+          <a:xfrm xmlns:a="http://schemas.openxmlformats.org/drawingml/2006/main">
+            <a:off x="2152650" y="4943475"/>
+            <a:ext cx="2381250" cy="361950"/>
+          </a:xfrm>
+          <a:prstGeom xmlns:a="http://schemas.openxmlformats.org/drawingml/2006/main" prst="rect">
+            <a:avLst/>
+          </a:prstGeom>
+          <a:noFill xmlns:a="http://schemas.openxmlformats.org/drawingml/2006/main"/>
+          <a:ln xmlns:a="http://schemas.openxmlformats.org/drawingml/2006/main" w="0">
+            <a:noFill/>
+            <a:prstDash val="solid"/>
+          </a:ln>
+        </p:spPr>
+        <p:txBody>
+          <a:bodyPr xmlns:a="http://schemas.openxmlformats.org/drawingml/2006/main"/>
+          <a:lstStyle xmlns:a="http://schemas.openxmlformats.org/drawingml/2006/main"/>
+          <a:p xmlns:a="http://schemas.openxmlformats.org/drawingml/2006/main">
+            <a:pPr>
+              <a:defRPr sz="975">
+                <a:solidFill>
+                  <a:srgbClr val="CBD5E1"/>
+                </a:solidFill>
+              </a:defRPr>
+            </a:pPr>
+            <a:r>
+              <a:rPr sz="975">
+                <a:solidFill>
+                  <a:srgbClr val="CBD5E1"/>
+                </a:solidFill>
+              </a:rPr>
+              <a:t>서비스 범위와 운영 정책 변경으로 품질 흔들림</a:t>
+            </a:r>
+          </a:p>
+        </p:txBody>
+      </p:sp>
+      <p:sp>
+        <p:nvSpPr>
+          <p:cNvPr id="32" name="risk-response-5">
+            <a:extLst xmlns:a="http://schemas.openxmlformats.org/drawingml/2006/main">
+              <a:ext uri="{FF2B5EF4-FFF2-40B4-BE49-F238E27FC236}">
+                <a16:creationId xmlns:a16="http://schemas.microsoft.com/office/drawing/2014/main" id="{BCD13F04-70D9-4FC0-B8E6-F5CE575A48C6}"/>
+              </a:ext>
+            </a:extLst>
+          </p:cNvPr>
+          <p:cNvSpPr>
+            <a:spLocks xmlns:a="http://schemas.openxmlformats.org/drawingml/2006/main" noGrp="1"/>
+          </p:cNvSpPr>
+          <p:nvPr/>
+        </p:nvSpPr>
+        <p:spPr>
+          <a:xfrm xmlns:a="http://schemas.openxmlformats.org/drawingml/2006/main">
+            <a:off x="4762500" y="4943475"/>
+            <a:ext cx="1809750" cy="361950"/>
+          </a:xfrm>
+          <a:prstGeom xmlns:a="http://schemas.openxmlformats.org/drawingml/2006/main" prst="rect">
+            <a:avLst/>
+          </a:prstGeom>
+          <a:noFill xmlns:a="http://schemas.openxmlformats.org/drawingml/2006/main"/>
+          <a:ln xmlns:a="http://schemas.openxmlformats.org/drawingml/2006/main" w="0">
+            <a:noFill/>
+            <a:prstDash val="solid"/>
+          </a:ln>
+        </p:spPr>
+        <p:txBody>
+          <a:bodyPr xmlns:a="http://schemas.openxmlformats.org/drawingml/2006/main"/>
+          <a:lstStyle xmlns:a="http://schemas.openxmlformats.org/drawingml/2006/main"/>
+          <a:p xmlns:a="http://schemas.openxmlformats.org/drawingml/2006/main">
+            <a:pPr>
+              <a:defRPr sz="975">
+                <a:solidFill>
+                  <a:srgbClr val="FFFFFF"/>
+                </a:solidFill>
+              </a:defRPr>
+            </a:pPr>
+            <a:r>
+              <a:rPr sz="975">
+                <a:solidFill>
+                  <a:srgbClr val="FFFFFF"/>
+                </a:solidFill>
+              </a:rPr>
+              <a:t>영향도 검토 후 반영·보류 결정</a:t>
+            </a:r>
+          </a:p>
+        </p:txBody>
+      </p:sp>
+      <p:sp>
+        <p:nvSpPr>
+          <p:cNvPr id="33" name="process-title">
+            <a:extLst xmlns:a="http://schemas.openxmlformats.org/drawingml/2006/main">
+              <a:ext uri="{FF2B5EF4-FFF2-40B4-BE49-F238E27FC236}">
+                <a16:creationId xmlns:a16="http://schemas.microsoft.com/office/drawing/2014/main" id="{B5107125-E0BE-4968-B698-4F923A4E15D5}"/>
+              </a:ext>
+            </a:extLst>
+          </p:cNvPr>
+          <p:cNvSpPr>
+            <a:spLocks xmlns:a="http://schemas.openxmlformats.org/drawingml/2006/main" noGrp="1"/>
+          </p:cNvSpPr>
+          <p:nvPr/>
+        </p:nvSpPr>
+        <p:spPr>
+          <a:xfrm xmlns:a="http://schemas.openxmlformats.org/drawingml/2006/main">
+            <a:off x="7620000" y="1752600"/>
+            <a:ext cx="2286000" cy="285750"/>
+          </a:xfrm>
+          <a:prstGeom xmlns:a="http://schemas.openxmlformats.org/drawingml/2006/main" prst="rect">
+            <a:avLst/>
+          </a:prstGeom>
+          <a:noFill xmlns:a="http://schemas.openxmlformats.org/drawingml/2006/main"/>
+          <a:ln xmlns:a="http://schemas.openxmlformats.org/drawingml/2006/main" w="0">
+            <a:noFill/>
+            <a:prstDash val="solid"/>
+          </a:ln>
+        </p:spPr>
+        <p:txBody>
+          <a:bodyPr xmlns:a="http://schemas.openxmlformats.org/drawingml/2006/main"/>
+          <a:lstStyle xmlns:a="http://schemas.openxmlformats.org/drawingml/2006/main"/>
+          <a:p xmlns:a="http://schemas.openxmlformats.org/drawingml/2006/main">
+            <a:pPr>
+              <a:defRPr sz="1650" b="1">
+                <a:solidFill>
+                  <a:srgbClr val="FFFFFF"/>
+                </a:solidFill>
+              </a:defRPr>
+            </a:pPr>
+            <a:r>
+              <a:rPr sz="1650" b="1">
+                <a:solidFill>
+                  <a:srgbClr val="FFFFFF"/>
+                </a:solidFill>
+              </a:rPr>
+              <a:t>대응 프로세스</a:t>
+            </a:r>
+          </a:p>
+        </p:txBody>
+      </p:sp>
+      <p:sp>
+        <p:nvSpPr>
+          <p:cNvPr id="34" name="process-note">
+            <a:extLst xmlns:a="http://schemas.openxmlformats.org/drawingml/2006/main">
+              <a:ext uri="{FF2B5EF4-FFF2-40B4-BE49-F238E27FC236}">
+                <a16:creationId xmlns:a16="http://schemas.microsoft.com/office/drawing/2014/main" id="{032563F5-12B6-4E82-8A7F-008800CEADB6}"/>
+              </a:ext>
+            </a:extLst>
+          </p:cNvPr>
+          <p:cNvSpPr>
+            <a:spLocks xmlns:a="http://schemas.openxmlformats.org/drawingml/2006/main" noGrp="1"/>
+          </p:cNvSpPr>
+          <p:nvPr/>
+        </p:nvSpPr>
+        <p:spPr>
+          <a:xfrm xmlns:a="http://schemas.openxmlformats.org/drawingml/2006/main">
+            <a:off x="9429750" y="1809750"/>
+            <a:ext cx="2095500" cy="209550"/>
+          </a:xfrm>
+          <a:prstGeom xmlns:a="http://schemas.openxmlformats.org/drawingml/2006/main" prst="rect">
+            <a:avLst/>
+          </a:prstGeom>
+          <a:noFill xmlns:a="http://schemas.openxmlformats.org/drawingml/2006/main"/>
+          <a:ln xmlns:a="http://schemas.openxmlformats.org/drawingml/2006/main" w="0">
+            <a:noFill/>
+            <a:prstDash val="solid"/>
+          </a:ln>
+        </p:spPr>
+        <p:txBody>
+          <a:bodyPr xmlns:a="http://schemas.openxmlformats.org/drawingml/2006/main"/>
+          <a:lstStyle xmlns:a="http://schemas.openxmlformats.org/drawingml/2006/main"/>
+          <a:p xmlns:a="http://schemas.openxmlformats.org/drawingml/2006/main">
+            <a:pPr>
+              <a:defRPr sz="975">
+                <a:solidFill>
+                  <a:srgbClr val="94A3B8"/>
+                </a:solidFill>
+              </a:defRPr>
+            </a:pPr>
+            <a:r>
+              <a:rPr sz="975">
+                <a:solidFill>
+                  <a:srgbClr val="94A3B8"/>
+                </a:solidFill>
+              </a:rPr>
+              <a:t>먼저 분류·담당을 잡습니다.</a:t>
+            </a:r>
+          </a:p>
+        </p:txBody>
+      </p:sp>
+      <p:sp>
+        <p:nvSpPr>
+          <p:cNvPr id="35" name="process-step-1">
+            <a:extLst xmlns:a="http://schemas.openxmlformats.org/drawingml/2006/main">
+              <a:ext uri="{FF2B5EF4-FFF2-40B4-BE49-F238E27FC236}">
+                <a16:creationId xmlns:a16="http://schemas.microsoft.com/office/drawing/2014/main" id="{1E2BF19E-623C-4F31-B490-F48BD5CF7C13}"/>
+              </a:ext>
+            </a:extLst>
+          </p:cNvPr>
+          <p:cNvSpPr>
+            <a:spLocks xmlns:a="http://schemas.openxmlformats.org/drawingml/2006/main" noGrp="1"/>
+          </p:cNvSpPr>
+          <p:nvPr/>
+        </p:nvSpPr>
+        <p:spPr>
+          <a:xfrm xmlns:a="http://schemas.openxmlformats.org/drawingml/2006/main">
+            <a:off x="7620000" y="2247900"/>
+            <a:ext cx="3714750" cy="704850"/>
+          </a:xfrm>
+          <a:prstGeom xmlns:a="http://schemas.openxmlformats.org/drawingml/2006/main" prst="roundRect">
+            <a:avLst>
+              <a:gd name="adj" fmla="val 10811"/>
+            </a:avLst>
+          </a:prstGeom>
+          <a:solidFill xmlns:a="http://schemas.openxmlformats.org/drawingml/2006/main">
+            <a:srgbClr val="111827"/>
+          </a:solidFill>
+          <a:ln xmlns:a="http://schemas.openxmlformats.org/drawingml/2006/main" w="9525">
+            <a:solidFill>
+              <a:srgbClr val="2F3B55"/>
+            </a:solidFill>
+            <a:prstDash val="solid"/>
+          </a:ln>
+        </p:spPr>
+      </p:sp>
+      <p:sp>
+        <p:nvSpPr>
+          <p:cNvPr id="36" name="process-step-bar-1">
+            <a:extLst xmlns:a="http://schemas.openxmlformats.org/drawingml/2006/main">
+              <a:ext uri="{FF2B5EF4-FFF2-40B4-BE49-F238E27FC236}">
+                <a16:creationId xmlns:a16="http://schemas.microsoft.com/office/drawing/2014/main" id="{2044ACCD-7C49-4A62-8690-82A907B04775}"/>
+              </a:ext>
+            </a:extLst>
+          </p:cNvPr>
+          <p:cNvSpPr>
+            <a:spLocks xmlns:a="http://schemas.openxmlformats.org/drawingml/2006/main" noGrp="1"/>
+          </p:cNvSpPr>
+          <p:nvPr/>
+        </p:nvSpPr>
+        <p:spPr>
+          <a:xfrm xmlns:a="http://schemas.openxmlformats.org/drawingml/2006/main">
+            <a:off x="7620000" y="2247900"/>
+            <a:ext cx="57150" cy="704850"/>
+          </a:xfrm>
+          <a:prstGeom xmlns:a="http://schemas.openxmlformats.org/drawingml/2006/main" prst="rect">
+            <a:avLst/>
+          </a:prstGeom>
+          <a:solidFill xmlns:a="http://schemas.openxmlformats.org/drawingml/2006/main">
+            <a:srgbClr val="00B8D9"/>
+          </a:solidFill>
+          <a:ln xmlns:a="http://schemas.openxmlformats.org/drawingml/2006/main" w="0">
+            <a:solidFill>
+              <a:srgbClr val="00B8D9"/>
+            </a:solidFill>
+            <a:prstDash val="solid"/>
+          </a:ln>
+        </p:spPr>
+      </p:sp>
+      <p:sp>
+        <p:nvSpPr>
+          <p:cNvPr id="37" name="process-step-no-1">
+            <a:extLst xmlns:a="http://schemas.openxmlformats.org/drawingml/2006/main">
+              <a:ext uri="{FF2B5EF4-FFF2-40B4-BE49-F238E27FC236}">
+                <a16:creationId xmlns:a16="http://schemas.microsoft.com/office/drawing/2014/main" id="{3AD6421B-B48D-4183-96AB-3B199DF5B24A}"/>
+              </a:ext>
+            </a:extLst>
+          </p:cNvPr>
+          <p:cNvSpPr>
+            <a:spLocks xmlns:a="http://schemas.openxmlformats.org/drawingml/2006/main" noGrp="1"/>
+          </p:cNvSpPr>
+          <p:nvPr/>
+        </p:nvSpPr>
+        <p:spPr>
+          <a:xfrm xmlns:a="http://schemas.openxmlformats.org/drawingml/2006/main">
+            <a:off x="7848600" y="2419350"/>
+            <a:ext cx="552450" cy="323850"/>
+          </a:xfrm>
+          <a:prstGeom xmlns:a="http://schemas.openxmlformats.org/drawingml/2006/main" prst="roundRect">
+            <a:avLst>
+              <a:gd name="adj" fmla="val 23529"/>
+            </a:avLst>
+          </a:prstGeom>
+          <a:solidFill xmlns:a="http://schemas.openxmlformats.org/drawingml/2006/main">
+            <a:srgbClr val="00B8D9"/>
+          </a:solidFill>
+          <a:ln xmlns:a="http://schemas.openxmlformats.org/drawingml/2006/main" w="9525">
+            <a:solidFill>
+              <a:srgbClr val="00B8D9"/>
+            </a:solidFill>
+            <a:prstDash val="solid"/>
+          </a:ln>
+        </p:spPr>
+        <p:txBody>
+          <a:bodyPr xmlns:a="http://schemas.openxmlformats.org/drawingml/2006/main"/>
+          <a:lstStyle xmlns:a="http://schemas.openxmlformats.org/drawingml/2006/main"/>
+          <a:p xmlns:a="http://schemas.openxmlformats.org/drawingml/2006/main">
+            <a:pPr algn="ctr">
+              <a:defRPr sz="1125" b="1">
+                <a:solidFill>
+                  <a:srgbClr val="06111F"/>
+                </a:solidFill>
+              </a:defRPr>
+            </a:pPr>
+            <a:r>
+              <a:rPr sz="1125" b="1">
+                <a:solidFill>
+                  <a:srgbClr val="06111F"/>
+                </a:solidFill>
+              </a:rPr>
+              <a:t>01</a:t>
+            </a:r>
+          </a:p>
+        </p:txBody>
+      </p:sp>
+      <p:sp>
+        <p:nvSpPr>
+          <p:cNvPr id="38" name="process-step-title-1">
+            <a:extLst xmlns:a="http://schemas.openxmlformats.org/drawingml/2006/main">
+              <a:ext uri="{FF2B5EF4-FFF2-40B4-BE49-F238E27FC236}">
+                <a16:creationId xmlns:a16="http://schemas.microsoft.com/office/drawing/2014/main" id="{65C72DE7-0046-44DB-8E3C-17DE26760D42}"/>
+              </a:ext>
+            </a:extLst>
+          </p:cNvPr>
+          <p:cNvSpPr>
+            <a:spLocks xmlns:a="http://schemas.openxmlformats.org/drawingml/2006/main" noGrp="1"/>
+          </p:cNvSpPr>
+          <p:nvPr/>
+        </p:nvSpPr>
+        <p:spPr>
+          <a:xfrm xmlns:a="http://schemas.openxmlformats.org/drawingml/2006/main">
+            <a:off x="8591550" y="2362200"/>
+            <a:ext cx="2095500" cy="228600"/>
+          </a:xfrm>
+          <a:prstGeom xmlns:a="http://schemas.openxmlformats.org/drawingml/2006/main" prst="rect">
+            <a:avLst/>
+          </a:prstGeom>
+          <a:noFill xmlns:a="http://schemas.openxmlformats.org/drawingml/2006/main"/>
+          <a:ln xmlns:a="http://schemas.openxmlformats.org/drawingml/2006/main" w="0">
+            <a:noFill/>
+            <a:prstDash val="solid"/>
+          </a:ln>
+        </p:spPr>
+        <p:txBody>
+          <a:bodyPr xmlns:a="http://schemas.openxmlformats.org/drawingml/2006/main"/>
+          <a:lstStyle xmlns:a="http://schemas.openxmlformats.org/drawingml/2006/main"/>
+          <a:p xmlns:a="http://schemas.openxmlformats.org/drawingml/2006/main">
+            <a:pPr>
+              <a:defRPr sz="1350" b="1">
+                <a:solidFill>
+                  <a:srgbClr val="FFFFFF"/>
+                </a:solidFill>
+              </a:defRPr>
+            </a:pPr>
+            <a:r>
+              <a:rPr sz="1350" b="1">
+                <a:solidFill>
+                  <a:srgbClr val="FFFFFF"/>
+                </a:solidFill>
+              </a:rPr>
+              <a:t>이슈 등록</a:t>
+            </a:r>
+          </a:p>
+        </p:txBody>
+      </p:sp>
+      <p:sp>
+        <p:nvSpPr>
+          <p:cNvPr id="39" name="process-step-body-1">
+            <a:extLst xmlns:a="http://schemas.openxmlformats.org/drawingml/2006/main">
+              <a:ext uri="{FF2B5EF4-FFF2-40B4-BE49-F238E27FC236}">
+                <a16:creationId xmlns:a16="http://schemas.microsoft.com/office/drawing/2014/main" id="{6EE4C32B-4C91-4A1B-939F-A3093548CFA6}"/>
+              </a:ext>
+            </a:extLst>
+          </p:cNvPr>
+          <p:cNvSpPr>
+            <a:spLocks xmlns:a="http://schemas.openxmlformats.org/drawingml/2006/main" noGrp="1"/>
+          </p:cNvSpPr>
+          <p:nvPr/>
+        </p:nvSpPr>
+        <p:spPr>
+          <a:xfrm xmlns:a="http://schemas.openxmlformats.org/drawingml/2006/main">
+            <a:off x="8591550" y="2619375"/>
+            <a:ext cx="2381250" cy="266700"/>
+          </a:xfrm>
+          <a:prstGeom xmlns:a="http://schemas.openxmlformats.org/drawingml/2006/main" prst="rect">
+            <a:avLst/>
+          </a:prstGeom>
+          <a:noFill xmlns:a="http://schemas.openxmlformats.org/drawingml/2006/main"/>
+          <a:ln xmlns:a="http://schemas.openxmlformats.org/drawingml/2006/main" w="0">
+            <a:noFill/>
+            <a:prstDash val="solid"/>
+          </a:ln>
+        </p:spPr>
+        <p:txBody>
+          <a:bodyPr xmlns:a="http://schemas.openxmlformats.org/drawingml/2006/main"/>
+          <a:lstStyle xmlns:a="http://schemas.openxmlformats.org/drawingml/2006/main"/>
+          <a:p xmlns:a="http://schemas.openxmlformats.org/drawingml/2006/main">
+            <a:pPr>
+              <a:defRPr sz="938">
+                <a:solidFill>
+                  <a:srgbClr val="CBD5E1"/>
+                </a:solidFill>
+              </a:defRPr>
+            </a:pPr>
+            <a:r>
+              <a:rPr sz="938">
+                <a:solidFill>
+                  <a:srgbClr val="CBD5E1"/>
+                </a:solidFill>
+              </a:rPr>
+              <a:t>일정·빌드·QA·퍼블리셔 항목 분류</a:t>
+            </a:r>
+          </a:p>
+        </p:txBody>
+      </p:sp>
+      <p:sp>
+        <p:nvSpPr>
+          <p:cNvPr id="40" name="process-step-2">
+            <a:extLst xmlns:a="http://schemas.openxmlformats.org/drawingml/2006/main">
+              <a:ext uri="{FF2B5EF4-FFF2-40B4-BE49-F238E27FC236}">
+                <a16:creationId xmlns:a16="http://schemas.microsoft.com/office/drawing/2014/main" id="{0843C6C3-C3E5-42FB-80E5-EF0EC09175E0}"/>
+              </a:ext>
+            </a:extLst>
+          </p:cNvPr>
+          <p:cNvSpPr>
+            <a:spLocks xmlns:a="http://schemas.openxmlformats.org/drawingml/2006/main" noGrp="1"/>
+          </p:cNvSpPr>
+          <p:nvPr/>
+        </p:nvSpPr>
+        <p:spPr>
+          <a:xfrm xmlns:a="http://schemas.openxmlformats.org/drawingml/2006/main">
+            <a:off x="7620000" y="3067050"/>
+            <a:ext cx="3714750" cy="704850"/>
+          </a:xfrm>
+          <a:prstGeom xmlns:a="http://schemas.openxmlformats.org/drawingml/2006/main" prst="roundRect">
+            <a:avLst>
+              <a:gd name="adj" fmla="val 10811"/>
+            </a:avLst>
+          </a:prstGeom>
+          <a:solidFill xmlns:a="http://schemas.openxmlformats.org/drawingml/2006/main">
+            <a:srgbClr val="111827"/>
+          </a:solidFill>
+          <a:ln xmlns:a="http://schemas.openxmlformats.org/drawingml/2006/main" w="9525">
+            <a:solidFill>
+              <a:srgbClr val="2F3B55"/>
+            </a:solidFill>
+            <a:prstDash val="solid"/>
+          </a:ln>
+        </p:spPr>
+      </p:sp>
+      <p:sp>
+        <p:nvSpPr>
+          <p:cNvPr id="41" name="process-step-bar-2">
+            <a:extLst xmlns:a="http://schemas.openxmlformats.org/drawingml/2006/main">
+              <a:ext uri="{FF2B5EF4-FFF2-40B4-BE49-F238E27FC236}">
+                <a16:creationId xmlns:a16="http://schemas.microsoft.com/office/drawing/2014/main" id="{A80D8D44-E243-41CA-A4E4-DD81CA5192B6}"/>
+              </a:ext>
+            </a:extLst>
+          </p:cNvPr>
+          <p:cNvSpPr>
+            <a:spLocks xmlns:a="http://schemas.openxmlformats.org/drawingml/2006/main" noGrp="1"/>
+          </p:cNvSpPr>
+          <p:nvPr/>
+        </p:nvSpPr>
+        <p:spPr>
+          <a:xfrm xmlns:a="http://schemas.openxmlformats.org/drawingml/2006/main">
+            <a:off x="7620000" y="3067050"/>
+            <a:ext cx="57150" cy="704850"/>
+          </a:xfrm>
+          <a:prstGeom xmlns:a="http://schemas.openxmlformats.org/drawingml/2006/main" prst="rect">
+            <a:avLst/>
+          </a:prstGeom>
+          <a:solidFill xmlns:a="http://schemas.openxmlformats.org/drawingml/2006/main">
+            <a:srgbClr val="FF6B35"/>
+          </a:solidFill>
+          <a:ln xmlns:a="http://schemas.openxmlformats.org/drawingml/2006/main" w="0">
+            <a:solidFill>
+              <a:srgbClr val="FF6B35"/>
+            </a:solidFill>
+            <a:prstDash val="solid"/>
+          </a:ln>
+        </p:spPr>
+      </p:sp>
+      <p:sp>
+        <p:nvSpPr>
+          <p:cNvPr id="42" name="process-step-no-2">
+            <a:extLst xmlns:a="http://schemas.openxmlformats.org/drawingml/2006/main">
+              <a:ext uri="{FF2B5EF4-FFF2-40B4-BE49-F238E27FC236}">
+                <a16:creationId xmlns:a16="http://schemas.microsoft.com/office/drawing/2014/main" id="{72A1295D-C6B6-4393-BE39-73D24CF06D50}"/>
+              </a:ext>
+            </a:extLst>
+          </p:cNvPr>
+          <p:cNvSpPr>
+            <a:spLocks xmlns:a="http://schemas.openxmlformats.org/drawingml/2006/main" noGrp="1"/>
+          </p:cNvSpPr>
+          <p:nvPr/>
+        </p:nvSpPr>
+        <p:spPr>
+          <a:xfrm xmlns:a="http://schemas.openxmlformats.org/drawingml/2006/main">
+            <a:off x="7848600" y="3238500"/>
+            <a:ext cx="552450" cy="323850"/>
+          </a:xfrm>
+          <a:prstGeom xmlns:a="http://schemas.openxmlformats.org/drawingml/2006/main" prst="roundRect">
+            <a:avLst>
+              <a:gd name="adj" fmla="val 23529"/>
+            </a:avLst>
+          </a:prstGeom>
+          <a:solidFill xmlns:a="http://schemas.openxmlformats.org/drawingml/2006/main">
+            <a:srgbClr val="FF6B35"/>
+          </a:solidFill>
+          <a:ln xmlns:a="http://schemas.openxmlformats.org/drawingml/2006/main" w="9525">
+            <a:solidFill>
+              <a:srgbClr val="FF6B35"/>
+            </a:solidFill>
+            <a:prstDash val="solid"/>
+          </a:ln>
+        </p:spPr>
+        <p:txBody>
+          <a:bodyPr xmlns:a="http://schemas.openxmlformats.org/drawingml/2006/main"/>
+          <a:lstStyle xmlns:a="http://schemas.openxmlformats.org/drawingml/2006/main"/>
+          <a:p xmlns:a="http://schemas.openxmlformats.org/drawingml/2006/main">
+            <a:pPr algn="ctr">
+              <a:defRPr sz="1125" b="1">
+                <a:solidFill>
+                  <a:srgbClr val="FFFFFF"/>
+                </a:solidFill>
+              </a:defRPr>
+            </a:pPr>
+            <a:r>
+              <a:rPr sz="1125" b="1">
+                <a:solidFill>
+                  <a:srgbClr val="FFFFFF"/>
+                </a:solidFill>
+              </a:rPr>
+              <a:t>02</a:t>
+            </a:r>
+          </a:p>
+        </p:txBody>
+      </p:sp>
+      <p:sp>
+        <p:nvSpPr>
+          <p:cNvPr id="43" name="process-step-title-2">
+            <a:extLst xmlns:a="http://schemas.openxmlformats.org/drawingml/2006/main">
+              <a:ext uri="{FF2B5EF4-FFF2-40B4-BE49-F238E27FC236}">
+                <a16:creationId xmlns:a16="http://schemas.microsoft.com/office/drawing/2014/main" id="{06758EF0-4849-45F1-BB65-2BC49EA0ACFB}"/>
+              </a:ext>
+            </a:extLst>
+          </p:cNvPr>
+          <p:cNvSpPr>
+            <a:spLocks xmlns:a="http://schemas.openxmlformats.org/drawingml/2006/main" noGrp="1"/>
+          </p:cNvSpPr>
+          <p:nvPr/>
+        </p:nvSpPr>
+        <p:spPr>
+          <a:xfrm xmlns:a="http://schemas.openxmlformats.org/drawingml/2006/main">
+            <a:off x="8591550" y="3181350"/>
+            <a:ext cx="2095500" cy="228600"/>
+          </a:xfrm>
+          <a:prstGeom xmlns:a="http://schemas.openxmlformats.org/drawingml/2006/main" prst="rect">
+            <a:avLst/>
+          </a:prstGeom>
+          <a:noFill xmlns:a="http://schemas.openxmlformats.org/drawingml/2006/main"/>
+          <a:ln xmlns:a="http://schemas.openxmlformats.org/drawingml/2006/main" w="0">
+            <a:noFill/>
+            <a:prstDash val="solid"/>
+          </a:ln>
+        </p:spPr>
+        <p:txBody>
+          <a:bodyPr xmlns:a="http://schemas.openxmlformats.org/drawingml/2006/main"/>
+          <a:lstStyle xmlns:a="http://schemas.openxmlformats.org/drawingml/2006/main"/>
+          <a:p xmlns:a="http://schemas.openxmlformats.org/drawingml/2006/main">
+            <a:pPr>
+              <a:defRPr sz="1350" b="1">
+                <a:solidFill>
+                  <a:srgbClr val="FFFFFF"/>
+                </a:solidFill>
+              </a:defRPr>
+            </a:pPr>
+            <a:r>
+              <a:rPr sz="1350" b="1">
+                <a:solidFill>
+                  <a:srgbClr val="FFFFFF"/>
+                </a:solidFill>
+              </a:rPr>
+              <a:t>영향도 판단</a:t>
+            </a:r>
+          </a:p>
+        </p:txBody>
+      </p:sp>
+      <p:sp>
+        <p:nvSpPr>
+          <p:cNvPr id="44" name="process-step-body-2">
+            <a:extLst xmlns:a="http://schemas.openxmlformats.org/drawingml/2006/main">
+              <a:ext uri="{FF2B5EF4-FFF2-40B4-BE49-F238E27FC236}">
+                <a16:creationId xmlns:a16="http://schemas.microsoft.com/office/drawing/2014/main" id="{4D73D3B8-2FBA-4D28-882A-29464555190B}"/>
+              </a:ext>
+            </a:extLst>
+          </p:cNvPr>
+          <p:cNvSpPr>
+            <a:spLocks xmlns:a="http://schemas.openxmlformats.org/drawingml/2006/main" noGrp="1"/>
+          </p:cNvSpPr>
+          <p:nvPr/>
+        </p:nvSpPr>
+        <p:spPr>
+          <a:xfrm xmlns:a="http://schemas.openxmlformats.org/drawingml/2006/main">
+            <a:off x="8591550" y="3438525"/>
+            <a:ext cx="2381250" cy="266700"/>
+          </a:xfrm>
+          <a:prstGeom xmlns:a="http://schemas.openxmlformats.org/drawingml/2006/main" prst="rect">
+            <a:avLst/>
+          </a:prstGeom>
+          <a:noFill xmlns:a="http://schemas.openxmlformats.org/drawingml/2006/main"/>
+          <a:ln xmlns:a="http://schemas.openxmlformats.org/drawingml/2006/main" w="0">
+            <a:noFill/>
+            <a:prstDash val="solid"/>
+          </a:ln>
+        </p:spPr>
+        <p:txBody>
+          <a:bodyPr xmlns:a="http://schemas.openxmlformats.org/drawingml/2006/main"/>
+          <a:lstStyle xmlns:a="http://schemas.openxmlformats.org/drawingml/2006/main"/>
+          <a:p xmlns:a="http://schemas.openxmlformats.org/drawingml/2006/main">
+            <a:pPr>
+              <a:defRPr sz="938">
+                <a:solidFill>
+                  <a:srgbClr val="CBD5E1"/>
+                </a:solidFill>
+              </a:defRPr>
+            </a:pPr>
+            <a:r>
+              <a:rPr sz="938">
+                <a:solidFill>
+                  <a:srgbClr val="CBD5E1"/>
+                </a:solidFill>
+              </a:rPr>
+              <a:t>일정·범위·품질 영향도 확인</a:t>
+            </a:r>
+          </a:p>
+        </p:txBody>
+      </p:sp>
+      <p:sp>
+        <p:nvSpPr>
+          <p:cNvPr id="45" name="process-step-3">
+            <a:extLst xmlns:a="http://schemas.openxmlformats.org/drawingml/2006/main">
+              <a:ext uri="{FF2B5EF4-FFF2-40B4-BE49-F238E27FC236}">
+                <a16:creationId xmlns:a16="http://schemas.microsoft.com/office/drawing/2014/main" id="{3C282961-8379-4729-BF6F-53B53D173ECB}"/>
+              </a:ext>
+            </a:extLst>
+          </p:cNvPr>
+          <p:cNvSpPr>
+            <a:spLocks xmlns:a="http://schemas.openxmlformats.org/drawingml/2006/main" noGrp="1"/>
+          </p:cNvSpPr>
+          <p:nvPr/>
+        </p:nvSpPr>
+        <p:spPr>
+          <a:xfrm xmlns:a="http://schemas.openxmlformats.org/drawingml/2006/main">
+            <a:off x="7620000" y="3886200"/>
+            <a:ext cx="3714750" cy="704850"/>
+          </a:xfrm>
+          <a:prstGeom xmlns:a="http://schemas.openxmlformats.org/drawingml/2006/main" prst="roundRect">
+            <a:avLst>
+              <a:gd name="adj" fmla="val 10811"/>
+            </a:avLst>
+          </a:prstGeom>
+          <a:solidFill xmlns:a="http://schemas.openxmlformats.org/drawingml/2006/main">
+            <a:srgbClr val="111827"/>
+          </a:solidFill>
+          <a:ln xmlns:a="http://schemas.openxmlformats.org/drawingml/2006/main" w="9525">
+            <a:solidFill>
+              <a:srgbClr val="2F3B55"/>
+            </a:solidFill>
+            <a:prstDash val="solid"/>
+          </a:ln>
+        </p:spPr>
+      </p:sp>
+      <p:sp>
+        <p:nvSpPr>
+          <p:cNvPr id="46" name="process-step-bar-3">
+            <a:extLst xmlns:a="http://schemas.openxmlformats.org/drawingml/2006/main">
+              <a:ext uri="{FF2B5EF4-FFF2-40B4-BE49-F238E27FC236}">
+                <a16:creationId xmlns:a16="http://schemas.microsoft.com/office/drawing/2014/main" id="{8F5E6589-7A82-48D8-BC4D-84C278D13749}"/>
+              </a:ext>
+            </a:extLst>
+          </p:cNvPr>
+          <p:cNvSpPr>
+            <a:spLocks xmlns:a="http://schemas.openxmlformats.org/drawingml/2006/main" noGrp="1"/>
+          </p:cNvSpPr>
+          <p:nvPr/>
+        </p:nvSpPr>
+        <p:spPr>
+          <a:xfrm xmlns:a="http://schemas.openxmlformats.org/drawingml/2006/main">
+            <a:off x="7620000" y="3886200"/>
+            <a:ext cx="57150" cy="704850"/>
+          </a:xfrm>
+          <a:prstGeom xmlns:a="http://schemas.openxmlformats.org/drawingml/2006/main" prst="rect">
+            <a:avLst/>
+          </a:prstGeom>
+          <a:solidFill xmlns:a="http://schemas.openxmlformats.org/drawingml/2006/main">
+            <a:srgbClr val="7C3AED"/>
+          </a:solidFill>
+          <a:ln xmlns:a="http://schemas.openxmlformats.org/drawingml/2006/main" w="0">
+            <a:solidFill>
+              <a:srgbClr val="7C3AED"/>
+            </a:solidFill>
+            <a:prstDash val="solid"/>
+          </a:ln>
+        </p:spPr>
+      </p:sp>
+      <p:sp>
+        <p:nvSpPr>
+          <p:cNvPr id="47" name="process-step-no-3">
+            <a:extLst xmlns:a="http://schemas.openxmlformats.org/drawingml/2006/main">
+              <a:ext uri="{FF2B5EF4-FFF2-40B4-BE49-F238E27FC236}">
+                <a16:creationId xmlns:a16="http://schemas.microsoft.com/office/drawing/2014/main" id="{23707AA8-D05B-4F71-9317-3F7640B23CB9}"/>
+              </a:ext>
+            </a:extLst>
+          </p:cNvPr>
+          <p:cNvSpPr>
+            <a:spLocks xmlns:a="http://schemas.openxmlformats.org/drawingml/2006/main" noGrp="1"/>
+          </p:cNvSpPr>
+          <p:nvPr/>
+        </p:nvSpPr>
+        <p:spPr>
+          <a:xfrm xmlns:a="http://schemas.openxmlformats.org/drawingml/2006/main">
+            <a:off x="7848600" y="4057650"/>
+            <a:ext cx="552450" cy="323850"/>
+          </a:xfrm>
+          <a:prstGeom xmlns:a="http://schemas.openxmlformats.org/drawingml/2006/main" prst="roundRect">
+            <a:avLst>
+              <a:gd name="adj" fmla="val 23529"/>
+            </a:avLst>
+          </a:prstGeom>
+          <a:solidFill xmlns:a="http://schemas.openxmlformats.org/drawingml/2006/main">
+            <a:srgbClr val="7C3AED"/>
+          </a:solidFill>
+          <a:ln xmlns:a="http://schemas.openxmlformats.org/drawingml/2006/main" w="9525">
+            <a:solidFill>
+              <a:srgbClr val="7C3AED"/>
+            </a:solidFill>
+            <a:prstDash val="solid"/>
+          </a:ln>
+        </p:spPr>
+        <p:txBody>
+          <a:bodyPr xmlns:a="http://schemas.openxmlformats.org/drawingml/2006/main"/>
+          <a:lstStyle xmlns:a="http://schemas.openxmlformats.org/drawingml/2006/main"/>
+          <a:p xmlns:a="http://schemas.openxmlformats.org/drawingml/2006/main">
+            <a:pPr algn="ctr">
+              <a:defRPr sz="1125" b="1">
+                <a:solidFill>
+                  <a:srgbClr val="FFFFFF"/>
+                </a:solidFill>
+              </a:defRPr>
+            </a:pPr>
+            <a:r>
+              <a:rPr sz="1125" b="1">
+                <a:solidFill>
+                  <a:srgbClr val="FFFFFF"/>
+                </a:solidFill>
+              </a:rPr>
+              <a:t>03</a:t>
+            </a:r>
+          </a:p>
+        </p:txBody>
+      </p:sp>
+      <p:sp>
+        <p:nvSpPr>
+          <p:cNvPr id="48" name="process-step-title-3">
+            <a:extLst xmlns:a="http://schemas.openxmlformats.org/drawingml/2006/main">
+              <a:ext uri="{FF2B5EF4-FFF2-40B4-BE49-F238E27FC236}">
+                <a16:creationId xmlns:a16="http://schemas.microsoft.com/office/drawing/2014/main" id="{3C77EEDA-1980-49E6-ACD3-77A8005A4188}"/>
+              </a:ext>
+            </a:extLst>
+          </p:cNvPr>
+          <p:cNvSpPr>
+            <a:spLocks xmlns:a="http://schemas.openxmlformats.org/drawingml/2006/main" noGrp="1"/>
+          </p:cNvSpPr>
+          <p:nvPr/>
+        </p:nvSpPr>
+        <p:spPr>
+          <a:xfrm xmlns:a="http://schemas.openxmlformats.org/drawingml/2006/main">
+            <a:off x="8591550" y="4000500"/>
+            <a:ext cx="2095500" cy="228600"/>
+          </a:xfrm>
+          <a:prstGeom xmlns:a="http://schemas.openxmlformats.org/drawingml/2006/main" prst="rect">
+            <a:avLst/>
+          </a:prstGeom>
+          <a:noFill xmlns:a="http://schemas.openxmlformats.org/drawingml/2006/main"/>
+          <a:ln xmlns:a="http://schemas.openxmlformats.org/drawingml/2006/main" w="0">
+            <a:noFill/>
+            <a:prstDash val="solid"/>
+          </a:ln>
+        </p:spPr>
+        <p:txBody>
+          <a:bodyPr xmlns:a="http://schemas.openxmlformats.org/drawingml/2006/main"/>
+          <a:lstStyle xmlns:a="http://schemas.openxmlformats.org/drawingml/2006/main"/>
+          <a:p xmlns:a="http://schemas.openxmlformats.org/drawingml/2006/main">
+            <a:pPr>
+              <a:defRPr sz="1350" b="1">
+                <a:solidFill>
+                  <a:srgbClr val="FFFFFF"/>
+                </a:solidFill>
+              </a:defRPr>
+            </a:pPr>
+            <a:r>
+              <a:rPr sz="1350" b="1">
+                <a:solidFill>
+                  <a:srgbClr val="FFFFFF"/>
+                </a:solidFill>
+              </a:rPr>
+              <a:t>담당·기한 지정</a:t>
+            </a:r>
+          </a:p>
+        </p:txBody>
+      </p:sp>
+      <p:sp>
+        <p:nvSpPr>
+          <p:cNvPr id="49" name="process-step-body-3">
+            <a:extLst xmlns:a="http://schemas.openxmlformats.org/drawingml/2006/main">
+              <a:ext uri="{FF2B5EF4-FFF2-40B4-BE49-F238E27FC236}">
+                <a16:creationId xmlns:a16="http://schemas.microsoft.com/office/drawing/2014/main" id="{C059B267-FBCE-4BF0-BF7E-89FFA9805957}"/>
+              </a:ext>
+            </a:extLst>
+          </p:cNvPr>
+          <p:cNvSpPr>
+            <a:spLocks xmlns:a="http://schemas.openxmlformats.org/drawingml/2006/main" noGrp="1"/>
+          </p:cNvSpPr>
+          <p:nvPr/>
+        </p:nvSpPr>
+        <p:spPr>
+          <a:xfrm xmlns:a="http://schemas.openxmlformats.org/drawingml/2006/main">
+            <a:off x="8591550" y="4257675"/>
+            <a:ext cx="2381250" cy="266700"/>
+          </a:xfrm>
+          <a:prstGeom xmlns:a="http://schemas.openxmlformats.org/drawingml/2006/main" prst="rect">
+            <a:avLst/>
+          </a:prstGeom>
+          <a:noFill xmlns:a="http://schemas.openxmlformats.org/drawingml/2006/main"/>
+          <a:ln xmlns:a="http://schemas.openxmlformats.org/drawingml/2006/main" w="0">
+            <a:noFill/>
+            <a:prstDash val="solid"/>
+          </a:ln>
+        </p:spPr>
+        <p:txBody>
+          <a:bodyPr xmlns:a="http://schemas.openxmlformats.org/drawingml/2006/main"/>
+          <a:lstStyle xmlns:a="http://schemas.openxmlformats.org/drawingml/2006/main"/>
+          <a:p xmlns:a="http://schemas.openxmlformats.org/drawingml/2006/main">
+            <a:pPr>
+              <a:defRPr sz="938">
+                <a:solidFill>
+                  <a:srgbClr val="CBD5E1"/>
+                </a:solidFill>
+              </a:defRPr>
+            </a:pPr>
+            <a:r>
+              <a:rPr sz="938">
+                <a:solidFill>
+                  <a:srgbClr val="CBD5E1"/>
+                </a:solidFill>
+              </a:rPr>
+              <a:t>개발·QA·퍼블리셔 담당 확정</a:t>
+            </a:r>
+          </a:p>
+        </p:txBody>
+      </p:sp>
+      <p:sp>
+        <p:nvSpPr>
+          <p:cNvPr id="50" name="process-step-4">
+            <a:extLst xmlns:a="http://schemas.openxmlformats.org/drawingml/2006/main">
+              <a:ext uri="{FF2B5EF4-FFF2-40B4-BE49-F238E27FC236}">
+                <a16:creationId xmlns:a16="http://schemas.microsoft.com/office/drawing/2014/main" id="{43B09CBB-AF12-488C-AFFC-C3BCC49D9BB6}"/>
+              </a:ext>
+            </a:extLst>
+          </p:cNvPr>
+          <p:cNvSpPr>
+            <a:spLocks xmlns:a="http://schemas.openxmlformats.org/drawingml/2006/main" noGrp="1"/>
+          </p:cNvSpPr>
+          <p:nvPr/>
+        </p:nvSpPr>
+        <p:spPr>
+          <a:xfrm xmlns:a="http://schemas.openxmlformats.org/drawingml/2006/main">
+            <a:off x="7620000" y="4705350"/>
+            <a:ext cx="3714750" cy="704850"/>
+          </a:xfrm>
+          <a:prstGeom xmlns:a="http://schemas.openxmlformats.org/drawingml/2006/main" prst="roundRect">
+            <a:avLst>
+              <a:gd name="adj" fmla="val 10811"/>
+            </a:avLst>
+          </a:prstGeom>
+          <a:solidFill xmlns:a="http://schemas.openxmlformats.org/drawingml/2006/main">
+            <a:srgbClr val="111827"/>
+          </a:solidFill>
+          <a:ln xmlns:a="http://schemas.openxmlformats.org/drawingml/2006/main" w="9525">
+            <a:solidFill>
+              <a:srgbClr val="2F3B55"/>
+            </a:solidFill>
+            <a:prstDash val="solid"/>
+          </a:ln>
+        </p:spPr>
+      </p:sp>
+      <p:sp>
+        <p:nvSpPr>
+          <p:cNvPr id="51" name="process-step-bar-4">
+            <a:extLst xmlns:a="http://schemas.openxmlformats.org/drawingml/2006/main">
+              <a:ext uri="{FF2B5EF4-FFF2-40B4-BE49-F238E27FC236}">
+                <a16:creationId xmlns:a16="http://schemas.microsoft.com/office/drawing/2014/main" id="{4D0D22F9-D61C-4405-9677-EB6E61EA7517}"/>
+              </a:ext>
+            </a:extLst>
+          </p:cNvPr>
+          <p:cNvSpPr>
+            <a:spLocks xmlns:a="http://schemas.openxmlformats.org/drawingml/2006/main" noGrp="1"/>
+          </p:cNvSpPr>
+          <p:nvPr/>
+        </p:nvSpPr>
+        <p:spPr>
+          <a:xfrm xmlns:a="http://schemas.openxmlformats.org/drawingml/2006/main">
+            <a:off x="7620000" y="4705350"/>
+            <a:ext cx="57150" cy="704850"/>
+          </a:xfrm>
+          <a:prstGeom xmlns:a="http://schemas.openxmlformats.org/drawingml/2006/main" prst="rect">
+            <a:avLst/>
+          </a:prstGeom>
+          <a:solidFill xmlns:a="http://schemas.openxmlformats.org/drawingml/2006/main">
+            <a:srgbClr val="8BD9E8"/>
+          </a:solidFill>
+          <a:ln xmlns:a="http://schemas.openxmlformats.org/drawingml/2006/main" w="0">
+            <a:solidFill>
+              <a:srgbClr val="8BD9E8"/>
+            </a:solidFill>
+            <a:prstDash val="solid"/>
+          </a:ln>
+        </p:spPr>
+      </p:sp>
+      <p:sp>
+        <p:nvSpPr>
+          <p:cNvPr id="52" name="process-step-no-4">
+            <a:extLst xmlns:a="http://schemas.openxmlformats.org/drawingml/2006/main">
+              <a:ext uri="{FF2B5EF4-FFF2-40B4-BE49-F238E27FC236}">
+                <a16:creationId xmlns:a16="http://schemas.microsoft.com/office/drawing/2014/main" id="{ED85CB50-CACA-41A3-B24E-ABCF8ACA5FAE}"/>
+              </a:ext>
+            </a:extLst>
+          </p:cNvPr>
+          <p:cNvSpPr>
+            <a:spLocks xmlns:a="http://schemas.openxmlformats.org/drawingml/2006/main" noGrp="1"/>
+          </p:cNvSpPr>
+          <p:nvPr/>
+        </p:nvSpPr>
+        <p:spPr>
+          <a:xfrm xmlns:a="http://schemas.openxmlformats.org/drawingml/2006/main">
+            <a:off x="7848600" y="4876800"/>
+            <a:ext cx="552450" cy="323850"/>
+          </a:xfrm>
+          <a:prstGeom xmlns:a="http://schemas.openxmlformats.org/drawingml/2006/main" prst="roundRect">
+            <a:avLst>
+              <a:gd name="adj" fmla="val 23529"/>
+            </a:avLst>
+          </a:prstGeom>
+          <a:solidFill xmlns:a="http://schemas.openxmlformats.org/drawingml/2006/main">
+            <a:srgbClr val="8BD9E8"/>
+          </a:solidFill>
+          <a:ln xmlns:a="http://schemas.openxmlformats.org/drawingml/2006/main" w="9525">
+            <a:solidFill>
+              <a:srgbClr val="8BD9E8"/>
+            </a:solidFill>
+            <a:prstDash val="solid"/>
+          </a:ln>
+        </p:spPr>
+        <p:txBody>
+          <a:bodyPr xmlns:a="http://schemas.openxmlformats.org/drawingml/2006/main"/>
+          <a:lstStyle xmlns:a="http://schemas.openxmlformats.org/drawingml/2006/main"/>
+          <a:p xmlns:a="http://schemas.openxmlformats.org/drawingml/2006/main">
+            <a:pPr algn="ctr">
+              <a:defRPr sz="1125" b="1">
+                <a:solidFill>
+                  <a:srgbClr val="FFFFFF"/>
+                </a:solidFill>
+              </a:defRPr>
+            </a:pPr>
+            <a:r>
+              <a:rPr sz="1125" b="1">
+                <a:solidFill>
+                  <a:srgbClr val="FFFFFF"/>
+                </a:solidFill>
+              </a:rPr>
+              <a:t>04</a:t>
+            </a:r>
+          </a:p>
+        </p:txBody>
+      </p:sp>
+      <p:sp>
+        <p:nvSpPr>
+          <p:cNvPr id="53" name="process-step-title-4">
+            <a:extLst xmlns:a="http://schemas.openxmlformats.org/drawingml/2006/main">
+              <a:ext uri="{FF2B5EF4-FFF2-40B4-BE49-F238E27FC236}">
+                <a16:creationId xmlns:a16="http://schemas.microsoft.com/office/drawing/2014/main" id="{8A04F538-988F-4067-956C-9C9A927CBAF1}"/>
+              </a:ext>
+            </a:extLst>
+          </p:cNvPr>
+          <p:cNvSpPr>
+            <a:spLocks xmlns:a="http://schemas.openxmlformats.org/drawingml/2006/main" noGrp="1"/>
+          </p:cNvSpPr>
+          <p:nvPr/>
+        </p:nvSpPr>
+        <p:spPr>
+          <a:xfrm xmlns:a="http://schemas.openxmlformats.org/drawingml/2006/main">
+            <a:off x="8591550" y="4819650"/>
+            <a:ext cx="2095500" cy="228600"/>
+          </a:xfrm>
+          <a:prstGeom xmlns:a="http://schemas.openxmlformats.org/drawingml/2006/main" prst="rect">
+            <a:avLst/>
+          </a:prstGeom>
+          <a:noFill xmlns:a="http://schemas.openxmlformats.org/drawingml/2006/main"/>
+          <a:ln xmlns:a="http://schemas.openxmlformats.org/drawingml/2006/main" w="0">
+            <a:noFill/>
+            <a:prstDash val="solid"/>
+          </a:ln>
+        </p:spPr>
+        <p:txBody>
+          <a:bodyPr xmlns:a="http://schemas.openxmlformats.org/drawingml/2006/main"/>
+          <a:lstStyle xmlns:a="http://schemas.openxmlformats.org/drawingml/2006/main"/>
+          <a:p xmlns:a="http://schemas.openxmlformats.org/drawingml/2006/main">
+            <a:pPr>
+              <a:defRPr sz="1350" b="1">
+                <a:solidFill>
+                  <a:srgbClr val="FFFFFF"/>
+                </a:solidFill>
+              </a:defRPr>
+            </a:pPr>
+            <a:r>
+              <a:rPr sz="1350" b="1">
+                <a:solidFill>
+                  <a:srgbClr val="FFFFFF"/>
+                </a:solidFill>
+              </a:rPr>
+              <a:t>마일스톤 재판정</a:t>
+            </a:r>
+          </a:p>
+        </p:txBody>
+      </p:sp>
+      <p:sp>
+        <p:nvSpPr>
+          <p:cNvPr id="54" name="process-step-body-4">
+            <a:extLst xmlns:a="http://schemas.openxmlformats.org/drawingml/2006/main">
+              <a:ext uri="{FF2B5EF4-FFF2-40B4-BE49-F238E27FC236}">
+                <a16:creationId xmlns:a16="http://schemas.microsoft.com/office/drawing/2014/main" id="{3D7D4080-A6BA-471A-9FD8-748A4521D512}"/>
+              </a:ext>
+            </a:extLst>
+          </p:cNvPr>
+          <p:cNvSpPr>
+            <a:spLocks xmlns:a="http://schemas.openxmlformats.org/drawingml/2006/main" noGrp="1"/>
+          </p:cNvSpPr>
+          <p:nvPr/>
+        </p:nvSpPr>
+        <p:spPr>
+          <a:xfrm xmlns:a="http://schemas.openxmlformats.org/drawingml/2006/main">
+            <a:off x="8591550" y="5076825"/>
+            <a:ext cx="2381250" cy="266700"/>
+          </a:xfrm>
+          <a:prstGeom xmlns:a="http://schemas.openxmlformats.org/drawingml/2006/main" prst="rect">
+            <a:avLst/>
+          </a:prstGeom>
+          <a:noFill xmlns:a="http://schemas.openxmlformats.org/drawingml/2006/main"/>
+          <a:ln xmlns:a="http://schemas.openxmlformats.org/drawingml/2006/main" w="0">
+            <a:noFill/>
+            <a:prstDash val="solid"/>
+          </a:ln>
+        </p:spPr>
+        <p:txBody>
+          <a:bodyPr xmlns:a="http://schemas.openxmlformats.org/drawingml/2006/main"/>
+          <a:lstStyle xmlns:a="http://schemas.openxmlformats.org/drawingml/2006/main"/>
+          <a:p xmlns:a="http://schemas.openxmlformats.org/drawingml/2006/main">
+            <a:pPr>
+              <a:defRPr sz="938">
+                <a:solidFill>
+                  <a:srgbClr val="CBD5E1"/>
+                </a:solidFill>
+              </a:defRPr>
+            </a:pPr>
+            <a:r>
+              <a:rPr sz="938">
+                <a:solidFill>
+                  <a:srgbClr val="CBD5E1"/>
+                </a:solidFill>
+              </a:rPr>
+              <a:t>해결·보류·제외 기준 정리</a:t>
+            </a:r>
+          </a:p>
+        </p:txBody>
+      </p:sp>
+      <p:sp>
+        <p:nvSpPr>
+          <p:cNvPr id="55" name="risk-principle-panel">
+            <a:extLst xmlns:a="http://schemas.openxmlformats.org/drawingml/2006/main">
+              <a:ext uri="{FF2B5EF4-FFF2-40B4-BE49-F238E27FC236}">
+                <a16:creationId xmlns:a16="http://schemas.microsoft.com/office/drawing/2014/main" id="{7FFE48EA-70D0-46E9-BAD0-D27FA47B54F8}"/>
+              </a:ext>
+            </a:extLst>
+          </p:cNvPr>
+          <p:cNvSpPr>
+            <a:spLocks xmlns:a="http://schemas.openxmlformats.org/drawingml/2006/main" noGrp="1"/>
+          </p:cNvSpPr>
+          <p:nvPr/>
+        </p:nvSpPr>
+        <p:spPr>
+          <a:xfrm xmlns:a="http://schemas.openxmlformats.org/drawingml/2006/main">
+            <a:off x="514350" y="5791200"/>
+            <a:ext cx="10877550" cy="419100"/>
+          </a:xfrm>
+          <a:prstGeom xmlns:a="http://schemas.openxmlformats.org/drawingml/2006/main" prst="roundRect">
+            <a:avLst>
+              <a:gd name="adj" fmla="val 18182"/>
+            </a:avLst>
+          </a:prstGeom>
+          <a:solidFill xmlns:a="http://schemas.openxmlformats.org/drawingml/2006/main">
+            <a:srgbClr val="10192E"/>
+          </a:solidFill>
+          <a:ln xmlns:a="http://schemas.openxmlformats.org/drawingml/2006/main" w="9525">
+            <a:solidFill>
+              <a:srgbClr val="22304E"/>
+            </a:solidFill>
+            <a:prstDash val="solid"/>
+          </a:ln>
+        </p:spPr>
+      </p:sp>
+      <p:sp>
+        <p:nvSpPr>
+          <p:cNvPr id="56" name="risk-principle-label">
+            <a:extLst xmlns:a="http://schemas.openxmlformats.org/drawingml/2006/main">
+              <a:ext uri="{FF2B5EF4-FFF2-40B4-BE49-F238E27FC236}">
+                <a16:creationId xmlns:a16="http://schemas.microsoft.com/office/drawing/2014/main" id="{C722B008-8634-43F1-89FC-CA63AB240F71}"/>
+              </a:ext>
+            </a:extLst>
+          </p:cNvPr>
+          <p:cNvSpPr>
+            <a:spLocks xmlns:a="http://schemas.openxmlformats.org/drawingml/2006/main" noGrp="1"/>
+          </p:cNvSpPr>
+          <p:nvPr/>
+        </p:nvSpPr>
+        <p:spPr>
+          <a:xfrm xmlns:a="http://schemas.openxmlformats.org/drawingml/2006/main">
+            <a:off x="781050" y="5905500"/>
+            <a:ext cx="1143000" cy="209550"/>
+          </a:xfrm>
+          <a:prstGeom xmlns:a="http://schemas.openxmlformats.org/drawingml/2006/main" prst="rect">
+            <a:avLst/>
+          </a:prstGeom>
+          <a:noFill xmlns:a="http://schemas.openxmlformats.org/drawingml/2006/main"/>
+          <a:ln xmlns:a="http://schemas.openxmlformats.org/drawingml/2006/main" w="0">
+            <a:noFill/>
+            <a:prstDash val="solid"/>
+          </a:ln>
+        </p:spPr>
+        <p:txBody>
+          <a:bodyPr xmlns:a="http://schemas.openxmlformats.org/drawingml/2006/main"/>
+          <a:lstStyle xmlns:a="http://schemas.openxmlformats.org/drawingml/2006/main"/>
+          <a:p xmlns:a="http://schemas.openxmlformats.org/drawingml/2006/main">
+            <a:pPr>
+              <a:defRPr sz="1200" b="1">
+                <a:solidFill>
+                  <a:srgbClr val="8BD9E8"/>
+                </a:solidFill>
+              </a:defRPr>
+            </a:pPr>
+            <a:r>
+              <a:rPr sz="1200" b="1">
+                <a:solidFill>
+                  <a:srgbClr val="8BD9E8"/>
+                </a:solidFill>
+              </a:rPr>
+              <a:t>PM 역할</a:t>
+            </a:r>
+          </a:p>
+        </p:txBody>
+      </p:sp>
+      <p:sp>
+        <p:nvSpPr>
+          <p:cNvPr id="57" name="risk-principle-body">
+            <a:extLst xmlns:a="http://schemas.openxmlformats.org/drawingml/2006/main">
+              <a:ext uri="{FF2B5EF4-FFF2-40B4-BE49-F238E27FC236}">
+                <a16:creationId xmlns:a16="http://schemas.microsoft.com/office/drawing/2014/main" id="{9B515F3A-9ABC-42BC-BBEA-78033A6B69E7}"/>
+              </a:ext>
+            </a:extLst>
+          </p:cNvPr>
+          <p:cNvSpPr>
+            <a:spLocks xmlns:a="http://schemas.openxmlformats.org/drawingml/2006/main" noGrp="1"/>
+          </p:cNvSpPr>
+          <p:nvPr/>
+        </p:nvSpPr>
+        <p:spPr>
+          <a:xfrm xmlns:a="http://schemas.openxmlformats.org/drawingml/2006/main">
+            <a:off x="1962150" y="5905500"/>
+            <a:ext cx="8096250" cy="209550"/>
+          </a:xfrm>
+          <a:prstGeom xmlns:a="http://schemas.openxmlformats.org/drawingml/2006/main" prst="rect">
+            <a:avLst/>
+          </a:prstGeom>
+          <a:noFill xmlns:a="http://schemas.openxmlformats.org/drawingml/2006/main"/>
+          <a:ln xmlns:a="http://schemas.openxmlformats.org/drawingml/2006/main" w="0">
+            <a:noFill/>
+            <a:prstDash val="solid"/>
+          </a:ln>
+        </p:spPr>
+        <p:txBody>
+          <a:bodyPr xmlns:a="http://schemas.openxmlformats.org/drawingml/2006/main"/>
+          <a:lstStyle xmlns:a="http://schemas.openxmlformats.org/drawingml/2006/main"/>
+          <a:p xmlns:a="http://schemas.openxmlformats.org/drawingml/2006/main">
+            <a:pPr>
+              <a:defRPr sz="1125">
+                <a:solidFill>
+                  <a:srgbClr val="FFFFFF"/>
+                </a:solidFill>
+              </a:defRPr>
+            </a:pPr>
+            <a:r>
+              <a:rPr sz="1125">
+                <a:solidFill>
+                  <a:srgbClr val="FFFFFF"/>
+                </a:solidFill>
+              </a:rPr>
+              <a:t>리스크를 직접 해결하기보다, 일정·버전·이슈를 의사결정 가능한 상태로 정리하는 것이 핵심입니다.</a:t>
+            </a:r>
+          </a:p>
+        </p:txBody>
+      </p:sp>
+    </p:spTree>
+    <p:extLst>
+      <p:ext uri="{BB962C8B-B14F-4D97-AF65-F5344CB8AC3E}">
+        <p14:creationId xmlns:p14="http://schemas.microsoft.com/office/powerpoint/2010/main" val="907856749"/>
       </p:ext>
     </p:extLst>
   </p:cSld>

</xml_diff>